<commit_message>
Drop the Pong0 and MGCB lines from the Pong deck
Co-Authored-By: Claude Opus 5.5 <noreply@anthropic.com>
Claude-Session: https://claude.ai/code/session_01Dn9nPg71YkakBQxbh71S3f
</commit_message>
<xml_diff>
--- a/slides/01 Pong.pptx
+++ b/slides/01 Pong.pptx
@@ -9966,23 +9966,6 @@
             </a:r>
             <a:endParaRPr/>
           </a:p>
-          <a:p>
-            <a:pPr indent="-317500" lvl="1" marL="914400" rtl="0" algn="l">
-              <a:spcBef>
-                <a:spcPts val="0"/>
-              </a:spcBef>
-              <a:spcAft>
-                <a:spcPts val="0"/>
-              </a:spcAft>
-              <a:buSzPts val="1400"/>
-              <a:buChar char="○"/>
-            </a:pPr>
-            <a:r>
-              <a:rPr lang="en"/>
-              <a:t>Pong0 is an empty MonoGame game to start from</a:t>
-            </a:r>
-            <a:endParaRPr/>
-          </a:p>
         </p:txBody>
       </p:sp>
     </p:spTree>
@@ -11459,51 +11442,6 @@
                 </a:solidFill>
               </a:rPr>
               <a:t>At runtime</a:t>
-            </a:r>
-          </a:p>
-        </p:txBody>
-      </p:sp>
-      <p:sp>
-        <p:nvSpPr>
-          <p:cNvPr id="175" name="TextBox 174"/>
-          <p:cNvSpPr txBox="1"/>
-          <p:nvPr/>
-        </p:nvSpPr>
-        <p:spPr>
-          <a:xfrm>
-            <a:off x="342900" y="3429000"/>
-            <a:ext cx="8458200" cy="731520"/>
-          </a:xfrm>
-          <a:prstGeom prst="rect">
-            <a:avLst/>
-          </a:prstGeom>
-          <a:noFill/>
-        </p:spPr>
-        <p:txBody>
-          <a:bodyPr wrap="square" anchor="ctr" lIns="45720" rIns="45720">
-            <a:spAutoFit/>
-          </a:bodyPr>
-          <a:lstStyle/>
-          <a:p>
-            <a:pPr algn="ctr"/>
-            <a:r>
-              <a:rPr sz="1400" b="0">
-                <a:solidFill>
-                  <a:srgbClr val="FFFFFF"/>
-                </a:solidFill>
-              </a:rPr>
-              <a:t>No .mgcb file and no MGCB Editor (MonoGame 3.8.5+):</a:t>
-            </a:r>
-          </a:p>
-          <a:p>
-            <a:pPr algn="ctr"/>
-            <a:r>
-              <a:rPr sz="1400" b="0">
-                <a:solidFill>
-                  <a:srgbClr val="FFFFFF"/>
-                </a:solidFill>
-              </a:rPr>
-              <a:t>what to build, and how, is ordinary C# code</a:t>
             </a:r>
           </a:p>
         </p:txBody>

</xml_diff>

<commit_message>
Cover the game loop, Update Method and Singleton in the decks
- Pong deck: Update vs. Draw (with double buffering), fixed vs. variable
  timestep, and the Update Method in Pong6's code
- Flappy deck and page: Audio in Flappy12 is now a Singleton, contrasted
  with the static Art class
- Instructor notes: drop the two resolved TODOs

Co-Authored-By: Claude Opus 5.5 <noreply@anthropic.com>
</commit_message>
<xml_diff>
--- a/slides/01 Pong.pptx
+++ b/slides/01 Pong.pptx
@@ -28,6 +28,8 @@
     <p:sldId id="273" r:id="rId23"/>
     <p:sldId id="274" r:id="rId24"/>
     <p:sldId id="275" r:id="rId25"/>
+    <p:sldId id="301" r:id="rId60"/>
+    <p:sldId id="302" r:id="rId61"/>
     <p:sldId id="276" r:id="rId26"/>
     <p:sldId id="277" r:id="rId27"/>
     <p:sldId id="278" r:id="rId28"/>
@@ -42,6 +44,7 @@
     <p:sldId id="287" r:id="rId37"/>
     <p:sldId id="288" r:id="rId38"/>
     <p:sldId id="289" r:id="rId39"/>
+    <p:sldId id="303" r:id="rId62"/>
     <p:sldId id="290" r:id="rId40"/>
     <p:sldId id="291" r:id="rId41"/>
     <p:sldId id="292" r:id="rId42"/>
@@ -9426,7 +9429,7 @@
             </a:pPr>
             <a:r>
               <a:rPr lang="en"/>
-              <a:t>Encapsulation</a:t>
+              <a:t>Encapsulation &amp; the Update Method Pattern</a:t>
             </a:r>
             <a:endParaRPr/>
           </a:p>
@@ -19087,6 +19090,1241 @@
           </a:ln>
         </p:spPr>
       </p:pic>
+    </p:spTree>
+  </p:cSld>
+  <p:clrMapOvr>
+    <a:masterClrMapping/>
+  </p:clrMapOvr>
+</p:sld>
+</file>
+
+<file path=ppt/slides/slide46.xml><?xml version="1.0" encoding="utf-8"?>
+<p:sld xmlns:a="http://schemas.openxmlformats.org/drawingml/2006/main" xmlns:p="http://schemas.openxmlformats.org/presentationml/2006/main" xmlns:r="http://schemas.openxmlformats.org/officeDocument/2006/relationships">
+  <p:cSld>
+    <p:spTree>
+      <p:nvGrpSpPr>
+        <p:cNvPr id="1" name=""/>
+        <p:cNvGrpSpPr/>
+        <p:nvPr/>
+      </p:nvGrpSpPr>
+      <p:grpSpPr/>
+      <p:sp>
+        <p:nvSpPr>
+          <p:cNvPr id="299" name="Google Shape;299;p50"/>
+          <p:cNvSpPr txBox="1"/>
+          <p:nvPr>
+            <p:ph type="title"/>
+          </p:nvPr>
+        </p:nvSpPr>
+        <p:spPr>
+          <a:xfrm>
+            <a:off x="311700" y="195615"/>
+            <a:ext cx="8520600" cy="572700"/>
+          </a:xfrm>
+          <a:prstGeom prst="rect">
+            <a:avLst/>
+          </a:prstGeom>
+        </p:spPr>
+        <p:txBody>
+          <a:bodyPr anchorCtr="0" anchor="t" bIns="91425" lIns="91425" spcFirstLastPara="1" rIns="91425" wrap="square" tIns="91425">
+            <a:normAutofit fontScale="90000"/>
+          </a:bodyPr>
+          <a:lstStyle/>
+          <a:p>
+            <a:pPr indent="0" lvl="0" marL="0" rtl="0" algn="l">
+              <a:spcBef>
+                <a:spcPts val="0"/>
+              </a:spcBef>
+              <a:spcAft>
+                <a:spcPts val="0"/>
+              </a:spcAft>
+              <a:buNone/>
+            </a:pPr>
+            <a:r>
+              <a:rPr lang="en"/>
+              <a:t>Update vs. Draw</a:t>
+            </a:r>
+            <a:endParaRPr/>
+          </a:p>
+        </p:txBody>
+      </p:sp>
+      <p:sp>
+        <p:nvSpPr>
+          <p:cNvPr id="300" name="Google Shape;300;p50"/>
+          <p:cNvSpPr txBox="1"/>
+          <p:nvPr>
+            <p:ph idx="1" type="body"/>
+          </p:nvPr>
+        </p:nvSpPr>
+        <p:spPr>
+          <a:xfrm>
+            <a:off x="311700" y="885950"/>
+            <a:ext cx="8520600" cy="4023300"/>
+          </a:xfrm>
+          <a:prstGeom prst="rect">
+            <a:avLst/>
+          </a:prstGeom>
+        </p:spPr>
+        <p:txBody>
+          <a:bodyPr anchorCtr="0" anchor="t" bIns="91425" lIns="91425" spcFirstLastPara="1" rIns="91425" wrap="square" tIns="91425">
+            <a:normAutofit/>
+          </a:bodyPr>
+          <a:lstStyle/>
+          <a:p>
+            <a:pPr indent="-330200" lvl="0" marL="457200" rtl="0" algn="l">
+              <a:spcBef>
+                <a:spcPts val="0"/>
+              </a:spcBef>
+              <a:spcAft>
+                <a:spcPts val="0"/>
+              </a:spcAft>
+              <a:buSzPts val="1600"/>
+              <a:buChar char="●"/>
+            </a:pPr>
+            <a:r>
+              <a:rPr lang="en"/>
+              <a:t>Update changes the state of the world</a:t>
+            </a:r>
+            <a:endParaRPr/>
+          </a:p>
+          <a:p>
+            <a:pPr indent="-317500" lvl="1" marL="914400" rtl="0" algn="l">
+              <a:spcBef>
+                <a:spcPts val="0"/>
+              </a:spcBef>
+              <a:spcAft>
+                <a:spcPts val="0"/>
+              </a:spcAft>
+              <a:buSzPts val="1400"/>
+              <a:buChar char="○"/>
+            </a:pPr>
+            <a:r>
+              <a:rPr lang="en"/>
+              <a:t>Input, movement, collisions, game rules</a:t>
+            </a:r>
+            <a:endParaRPr/>
+          </a:p>
+          <a:p>
+            <a:pPr indent="-330200" lvl="0" marL="457200" rtl="0" algn="l">
+              <a:spcBef>
+                <a:spcPts val="0"/>
+              </a:spcBef>
+              <a:spcAft>
+                <a:spcPts val="0"/>
+              </a:spcAft>
+              <a:buSzPts val="1600"/>
+              <a:buChar char="●"/>
+            </a:pPr>
+            <a:r>
+              <a:rPr lang="en"/>
+              <a:t>Draw only reads that state and renders it</a:t>
+            </a:r>
+            <a:endParaRPr/>
+          </a:p>
+          <a:p>
+            <a:pPr indent="-317500" lvl="1" marL="914400" rtl="0" algn="l">
+              <a:spcBef>
+                <a:spcPts val="0"/>
+              </a:spcBef>
+              <a:spcAft>
+                <a:spcPts val="0"/>
+              </a:spcAft>
+              <a:buSzPts val="1400"/>
+              <a:buChar char="○"/>
+            </a:pPr>
+            <a:r>
+              <a:rPr lang="en"/>
+              <a:t>Never change game state in Draw</a:t>
+            </a:r>
+            <a:endParaRPr/>
+          </a:p>
+          <a:p>
+            <a:pPr indent="-330200" lvl="0" marL="457200" rtl="0" algn="l">
+              <a:spcBef>
+                <a:spcPts val="0"/>
+              </a:spcBef>
+              <a:spcAft>
+                <a:spcPts val="0"/>
+              </a:spcAft>
+              <a:buSzPts val="1600"/>
+              <a:buChar char="●"/>
+            </a:pPr>
+            <a:r>
+              <a:rPr lang="en"/>
+              <a:t>Keeping them apart lets the simulation and the rendering run at different rates</a:t>
+            </a:r>
+            <a:endParaRPr/>
+          </a:p>
+          <a:p>
+            <a:pPr indent="-330200" lvl="0" marL="457200" rtl="0" algn="l">
+              <a:spcBef>
+                <a:spcPts val="0"/>
+              </a:spcBef>
+              <a:spcAft>
+                <a:spcPts val="0"/>
+              </a:spcAft>
+              <a:buSzPts val="1600"/>
+              <a:buChar char="●"/>
+            </a:pPr>
+            <a:r>
+              <a:rPr lang="en"/>
+              <a:t>Double buffer</a:t>
+            </a:r>
+            <a:endParaRPr/>
+          </a:p>
+          <a:p>
+            <a:pPr indent="-317500" lvl="1" marL="914400" rtl="0" algn="l">
+              <a:spcBef>
+                <a:spcPts val="0"/>
+              </a:spcBef>
+              <a:spcAft>
+                <a:spcPts val="0"/>
+              </a:spcAft>
+              <a:buSzPts val="1400"/>
+              <a:buChar char="○"/>
+            </a:pPr>
+            <a:r>
+              <a:rPr lang="en"/>
+              <a:t>We draw into a back buffer that isn't visible</a:t>
+            </a:r>
+            <a:endParaRPr/>
+          </a:p>
+          <a:p>
+            <a:pPr indent="-317500" lvl="1" marL="914400" rtl="0" algn="l">
+              <a:spcBef>
+                <a:spcPts val="0"/>
+              </a:spcBef>
+              <a:spcAft>
+                <a:spcPts val="0"/>
+              </a:spcAft>
+              <a:buSzPts val="1400"/>
+              <a:buChar char="○"/>
+            </a:pPr>
+            <a:r>
+              <a:rPr lang="en"/>
+              <a:t>At the end of Draw, MonoGame presents it: the player never sees a half-drawn frame</a:t>
+            </a:r>
+            <a:endParaRPr/>
+          </a:p>
+        </p:txBody>
+      </p:sp>
+    </p:spTree>
+  </p:cSld>
+  <p:clrMapOvr>
+    <a:masterClrMapping/>
+  </p:clrMapOvr>
+</p:sld>
+</file>
+
+<file path=ppt/slides/slide47.xml><?xml version="1.0" encoding="utf-8"?>
+<p:sld xmlns:a="http://schemas.openxmlformats.org/drawingml/2006/main" xmlns:p="http://schemas.openxmlformats.org/presentationml/2006/main" xmlns:r="http://schemas.openxmlformats.org/officeDocument/2006/relationships">
+  <p:cSld>
+    <p:spTree>
+      <p:nvGrpSpPr>
+        <p:cNvPr id="1" name=""/>
+        <p:cNvGrpSpPr/>
+        <p:nvPr/>
+      </p:nvGrpSpPr>
+      <p:grpSpPr/>
+      <p:sp>
+        <p:nvSpPr>
+          <p:cNvPr id="299" name="Google Shape;299;p50"/>
+          <p:cNvSpPr txBox="1"/>
+          <p:nvPr>
+            <p:ph type="title"/>
+          </p:nvPr>
+        </p:nvSpPr>
+        <p:spPr>
+          <a:xfrm>
+            <a:off x="311700" y="195615"/>
+            <a:ext cx="8520600" cy="572700"/>
+          </a:xfrm>
+          <a:prstGeom prst="rect">
+            <a:avLst/>
+          </a:prstGeom>
+        </p:spPr>
+        <p:txBody>
+          <a:bodyPr anchorCtr="0" anchor="t" bIns="91425" lIns="91425" spcFirstLastPara="1" rIns="91425" wrap="square" tIns="91425">
+            <a:normAutofit fontScale="90000"/>
+          </a:bodyPr>
+          <a:lstStyle/>
+          <a:p>
+            <a:pPr indent="0" lvl="0" marL="0" rtl="0" algn="l">
+              <a:spcBef>
+                <a:spcPts val="0"/>
+              </a:spcBef>
+              <a:spcAft>
+                <a:spcPts val="0"/>
+              </a:spcAft>
+              <a:buNone/>
+            </a:pPr>
+            <a:r>
+              <a:rPr lang="en"/>
+              <a:t>Fixed vs. Variable Timestep</a:t>
+            </a:r>
+            <a:endParaRPr/>
+          </a:p>
+        </p:txBody>
+      </p:sp>
+      <p:sp>
+        <p:nvSpPr>
+          <p:cNvPr id="300" name="Google Shape;300;p50"/>
+          <p:cNvSpPr txBox="1"/>
+          <p:nvPr>
+            <p:ph idx="1" type="body"/>
+          </p:nvPr>
+        </p:nvSpPr>
+        <p:spPr>
+          <a:xfrm>
+            <a:off x="311700" y="885950"/>
+            <a:ext cx="8520600" cy="4023300"/>
+          </a:xfrm>
+          <a:prstGeom prst="rect">
+            <a:avLst/>
+          </a:prstGeom>
+        </p:spPr>
+        <p:txBody>
+          <a:bodyPr anchorCtr="0" anchor="t" bIns="91425" lIns="91425" spcFirstLastPara="1" rIns="91425" wrap="square" tIns="91425">
+            <a:normAutofit/>
+          </a:bodyPr>
+          <a:lstStyle/>
+          <a:p>
+            <a:pPr indent="-330200" lvl="0" marL="457200" rtl="0" algn="l">
+              <a:spcBef>
+                <a:spcPts val="0"/>
+              </a:spcBef>
+              <a:spcAft>
+                <a:spcPts val="0"/>
+              </a:spcAft>
+              <a:buSzPts val="1600"/>
+              <a:buChar char="●"/>
+            </a:pPr>
+            <a:r>
+              <a:rPr lang="en"/>
+              <a:t>Variable timestep</a:t>
+            </a:r>
+            <a:endParaRPr/>
+          </a:p>
+          <a:p>
+            <a:pPr indent="-317500" lvl="1" marL="914400" rtl="0" algn="l">
+              <a:spcBef>
+                <a:spcPts val="0"/>
+              </a:spcBef>
+              <a:spcAft>
+                <a:spcPts val="0"/>
+              </a:spcAft>
+              <a:buSzPts val="1400"/>
+              <a:buChar char="○"/>
+            </a:pPr>
+            <a:r>
+              <a:rPr lang="en"/>
+              <a:t>One Update per rendered frame, movement scaled by deltaTime</a:t>
+            </a:r>
+            <a:endParaRPr/>
+          </a:p>
+          <a:p>
+            <a:pPr indent="-317500" lvl="1" marL="914400" rtl="0" algn="l">
+              <a:spcBef>
+                <a:spcPts val="0"/>
+              </a:spcBef>
+              <a:spcAft>
+                <a:spcPts val="0"/>
+              </a:spcAft>
+              <a:buSzPts val="1400"/>
+              <a:buChar char="○"/>
+            </a:pPr>
+            <a:r>
+              <a:rPr lang="en"/>
+              <a:t>Simple, but the simulation behaves slightly differently at different frame rates</a:t>
+            </a:r>
+            <a:endParaRPr/>
+          </a:p>
+          <a:p>
+            <a:pPr indent="-330200" lvl="0" marL="457200" rtl="0" algn="l">
+              <a:spcBef>
+                <a:spcPts val="0"/>
+              </a:spcBef>
+              <a:spcAft>
+                <a:spcPts val="0"/>
+              </a:spcAft>
+              <a:buSzPts val="1600"/>
+              <a:buChar char="●"/>
+            </a:pPr>
+            <a:r>
+              <a:rPr lang="en"/>
+              <a:t>Fixed timestep</a:t>
+            </a:r>
+            <a:endParaRPr/>
+          </a:p>
+          <a:p>
+            <a:pPr indent="-317500" lvl="1" marL="914400" rtl="0" algn="l">
+              <a:spcBef>
+                <a:spcPts val="0"/>
+              </a:spcBef>
+              <a:spcAft>
+                <a:spcPts val="0"/>
+              </a:spcAft>
+              <a:buSzPts val="1400"/>
+              <a:buChar char="○"/>
+            </a:pPr>
+            <a:r>
+              <a:rPr lang="en"/>
+              <a:t>Update in fixed-size steps (e.g. 60 per second): zero, one or several per frame</a:t>
+            </a:r>
+            <a:endParaRPr/>
+          </a:p>
+          <a:p>
+            <a:pPr indent="-317500" lvl="1" marL="914400" rtl="0" algn="l">
+              <a:spcBef>
+                <a:spcPts val="0"/>
+              </a:spcBef>
+              <a:spcAft>
+                <a:spcPts val="0"/>
+              </a:spcAft>
+              <a:buSzPts val="1400"/>
+              <a:buChar char="○"/>
+            </a:pPr>
+            <a:r>
+              <a:rPr lang="en"/>
+              <a:t>Deterministic and stable, at the cost of some complexity</a:t>
+            </a:r>
+            <a:endParaRPr/>
+          </a:p>
+          <a:p>
+            <a:pPr indent="-330200" lvl="0" marL="457200" rtl="0" algn="l">
+              <a:spcBef>
+                <a:spcPts val="0"/>
+              </a:spcBef>
+              <a:spcAft>
+                <a:spcPts val="0"/>
+              </a:spcAft>
+              <a:buSzPts val="1600"/>
+              <a:buChar char="●"/>
+            </a:pPr>
+            <a:r>
+              <a:rPr lang="en"/>
+              <a:t>MonoGame uses a fixed timestep by default (IsFixedTimeStep = true)</a:t>
+            </a:r>
+            <a:endParaRPr/>
+          </a:p>
+          <a:p>
+            <a:pPr indent="-330200" lvl="0" marL="457200" rtl="0" algn="l">
+              <a:spcBef>
+                <a:spcPts val="0"/>
+              </a:spcBef>
+              <a:spcAft>
+                <a:spcPts val="0"/>
+              </a:spcAft>
+              <a:buSzPts val="1600"/>
+              <a:buChar char="●"/>
+            </a:pPr>
+            <a:r>
+              <a:rPr lang="en"/>
+              <a:t>Try it: the game loop demo on the course site</a:t>
+            </a:r>
+            <a:endParaRPr/>
+          </a:p>
+        </p:txBody>
+      </p:sp>
+    </p:spTree>
+  </p:cSld>
+  <p:clrMapOvr>
+    <a:masterClrMapping/>
+  </p:clrMapOvr>
+</p:sld>
+</file>
+
+<file path=ppt/slides/slide48.xml><?xml version="1.0" encoding="utf-8"?>
+<p:sld xmlns:a="http://schemas.openxmlformats.org/drawingml/2006/main" xmlns:p="http://schemas.openxmlformats.org/presentationml/2006/main" xmlns:r="http://schemas.openxmlformats.org/officeDocument/2006/relationships">
+  <p:cSld>
+    <p:spTree>
+      <p:nvGrpSpPr>
+        <p:cNvPr id="1" name=""/>
+        <p:cNvGrpSpPr/>
+        <p:nvPr/>
+      </p:nvGrpSpPr>
+      <p:grpSpPr/>
+      <p:sp>
+        <p:nvSpPr>
+          <p:cNvPr id="258" name="Google Shape;258;p44"/>
+          <p:cNvSpPr txBox="1"/>
+          <p:nvPr>
+            <p:ph type="title"/>
+          </p:nvPr>
+        </p:nvSpPr>
+        <p:spPr>
+          <a:xfrm>
+            <a:off x="311700" y="195615"/>
+            <a:ext cx="8520600" cy="572700"/>
+          </a:xfrm>
+          <a:prstGeom prst="rect">
+            <a:avLst/>
+          </a:prstGeom>
+        </p:spPr>
+        <p:txBody>
+          <a:bodyPr anchorCtr="0" anchor="t" bIns="91425" lIns="91425" spcFirstLastPara="1" rIns="91425" wrap="square" tIns="91425">
+            <a:normAutofit fontScale="90000"/>
+          </a:bodyPr>
+          <a:lstStyle/>
+          <a:p>
+            <a:pPr indent="0" lvl="0" marL="0" rtl="0" algn="l">
+              <a:spcBef>
+                <a:spcPts val="0"/>
+              </a:spcBef>
+              <a:spcAft>
+                <a:spcPts val="0"/>
+              </a:spcAft>
+              <a:buNone/>
+            </a:pPr>
+            <a:r>
+              <a:rPr lang="en"/>
+              <a:t>Update Method in Pong</a:t>
+            </a:r>
+            <a:endParaRPr/>
+          </a:p>
+        </p:txBody>
+      </p:sp>
+      <p:sp>
+        <p:nvSpPr>
+          <p:cNvPr id="300" name="Google Shape;300;p50"/>
+          <p:cNvSpPr txBox="1"/>
+          <p:nvPr>
+            <p:ph idx="1" type="body"/>
+          </p:nvPr>
+        </p:nvSpPr>
+        <p:spPr>
+          <a:xfrm>
+            <a:off x="311700" y="1152475"/>
+            <a:ext cx="3900000" cy="3400000"/>
+          </a:xfrm>
+          <a:prstGeom prst="rect">
+            <a:avLst/>
+          </a:prstGeom>
+        </p:spPr>
+        <p:txBody>
+          <a:bodyPr anchorCtr="0" anchor="t" bIns="91425" lIns="91425" spcFirstLastPara="1" rIns="91425" wrap="square" tIns="91425">
+            <a:normAutofit/>
+          </a:bodyPr>
+          <a:lstStyle/>
+          <a:p>
+            <a:pPr indent="-330200" lvl="0" marL="457200" rtl="0" algn="l">
+              <a:spcBef>
+                <a:spcPts val="0"/>
+              </a:spcBef>
+              <a:spcAft>
+                <a:spcPts val="0"/>
+              </a:spcAft>
+              <a:buSzPts val="1600"/>
+              <a:buChar char="●"/>
+            </a:pPr>
+            <a:r>
+              <a:rPr lang="en"/>
+              <a:t>Each object simulates one frame of its own behaviour</a:t>
+            </a:r>
+            <a:endParaRPr/>
+          </a:p>
+          <a:p>
+            <a:pPr indent="-330200" lvl="0" marL="457200" rtl="0" algn="l">
+              <a:spcBef>
+                <a:spcPts val="0"/>
+              </a:spcBef>
+              <a:spcAft>
+                <a:spcPts val="0"/>
+              </a:spcAft>
+              <a:buSzPts val="1600"/>
+              <a:buChar char="●"/>
+            </a:pPr>
+            <a:r>
+              <a:rPr lang="en"/>
+              <a:t>Paddle and Ball each get Update and Draw</a:t>
+            </a:r>
+            <a:endParaRPr/>
+          </a:p>
+          <a:p>
+            <a:pPr indent="-330200" lvl="0" marL="457200" rtl="0" algn="l">
+              <a:spcBef>
+                <a:spcPts val="0"/>
+              </a:spcBef>
+              <a:spcAft>
+                <a:spcPts val="0"/>
+              </a:spcAft>
+              <a:buSzPts val="1600"/>
+              <a:buChar char="●"/>
+            </a:pPr>
+            <a:r>
+              <a:rPr lang="en"/>
+              <a:t>Game1 just calls them</a:t>
+            </a:r>
+            <a:endParaRPr/>
+          </a:p>
+          <a:p>
+            <a:pPr indent="-317500" lvl="1" marL="914400" rtl="0" algn="l">
+              <a:spcBef>
+                <a:spcPts val="0"/>
+              </a:spcBef>
+              <a:spcAft>
+                <a:spcPts val="0"/>
+              </a:spcAft>
+              <a:buSzPts val="1400"/>
+              <a:buChar char="○"/>
+            </a:pPr>
+            <a:r>
+              <a:rPr lang="en"/>
+              <a:t>Its Update and Draw stay short as the game grows</a:t>
+            </a:r>
+            <a:endParaRPr/>
+          </a:p>
+          <a:p>
+            <a:pPr indent="-330200" lvl="0" marL="457200" rtl="0" algn="l">
+              <a:spcBef>
+                <a:spcPts val="0"/>
+              </a:spcBef>
+              <a:spcAft>
+                <a:spcPts val="0"/>
+              </a:spcAft>
+              <a:buSzPts val="1600"/>
+              <a:buChar char="●"/>
+            </a:pPr>
+            <a:r>
+              <a:rPr lang="en"/>
+              <a:t>Step: Pong6</a:t>
+            </a:r>
+            <a:endParaRPr/>
+          </a:p>
+        </p:txBody>
+      </p:sp>
+      <p:sp>
+        <p:nvSpPr>
+          <p:cNvPr id="259" name="Google Shape;259;p44"/>
+          <p:cNvSpPr txBox="1"/>
+          <p:nvPr>
+            <p:ph idx="2" type="body"/>
+          </p:nvPr>
+        </p:nvSpPr>
+        <p:spPr>
+          <a:xfrm>
+            <a:off x="4500000" y="1152475"/>
+            <a:ext cx="4400000" cy="3600000"/>
+          </a:xfrm>
+          <a:prstGeom prst="rect">
+            <a:avLst/>
+          </a:prstGeom>
+        </p:spPr>
+        <p:txBody>
+          <a:bodyPr anchorCtr="0" anchor="t" bIns="91425" lIns="91425" spcFirstLastPara="1" rIns="91425" wrap="square" tIns="91425">
+            <a:noAutofit/>
+          </a:bodyPr>
+          <a:lstStyle/>
+          <a:p>
+            <a:pPr indent="0" lvl="0" marL="0" rtl="0" algn="l">
+              <a:lnSpc>
+                <a:spcPct val="115000"/>
+              </a:lnSpc>
+              <a:spcBef>
+                <a:spcPts val="0"/>
+              </a:spcBef>
+              <a:spcAft>
+                <a:spcPts val="0"/>
+              </a:spcAft>
+              <a:buNone/>
+            </a:pPr>
+            <a:r>
+              <a:rPr lang="en" sz="1000">
+                <a:highlight>
+                  <a:srgbClr val="1F1F1F"/>
+                </a:highlight>
+                <a:latin typeface="Consolas"/>
+                <a:ea typeface="Consolas"/>
+                <a:cs typeface="Consolas"/>
+                <a:sym typeface="Consolas"/>
+              </a:rPr>
+              <a:t>// Game1</a:t>
+            </a:r>
+            <a:endParaRPr sz="1000">
+              <a:solidFill>
+                <a:srgbClr val="CCCCCC"/>
+              </a:solidFill>
+              <a:highlight>
+                <a:srgbClr val="1F1F1F"/>
+              </a:highlight>
+              <a:latin typeface="Consolas"/>
+              <a:ea typeface="Consolas"/>
+              <a:cs typeface="Consolas"/>
+              <a:sym typeface="Consolas"/>
+            </a:endParaRPr>
+          </a:p>
+          <a:p>
+            <a:pPr indent="0" lvl="0" marL="0" rtl="0" algn="l">
+              <a:lnSpc>
+                <a:spcPct val="115000"/>
+              </a:lnSpc>
+              <a:spcBef>
+                <a:spcPts val="0"/>
+              </a:spcBef>
+              <a:spcAft>
+                <a:spcPts val="0"/>
+              </a:spcAft>
+              <a:buNone/>
+            </a:pPr>
+            <a:r>
+              <a:rPr lang="en" sz="1000">
+                <a:highlight>
+                  <a:srgbClr val="1F1F1F"/>
+                </a:highlight>
+                <a:latin typeface="Consolas"/>
+                <a:ea typeface="Consolas"/>
+                <a:cs typeface="Consolas"/>
+                <a:sym typeface="Consolas"/>
+              </a:rPr>
+              <a:t>protected override void Update(GameTime gameTime)</a:t>
+            </a:r>
+            <a:endParaRPr sz="1000">
+              <a:solidFill>
+                <a:srgbClr val="CCCCCC"/>
+              </a:solidFill>
+              <a:highlight>
+                <a:srgbClr val="1F1F1F"/>
+              </a:highlight>
+              <a:latin typeface="Consolas"/>
+              <a:ea typeface="Consolas"/>
+              <a:cs typeface="Consolas"/>
+              <a:sym typeface="Consolas"/>
+            </a:endParaRPr>
+          </a:p>
+          <a:p>
+            <a:pPr indent="0" lvl="0" marL="0" rtl="0" algn="l">
+              <a:lnSpc>
+                <a:spcPct val="115000"/>
+              </a:lnSpc>
+              <a:spcBef>
+                <a:spcPts val="0"/>
+              </a:spcBef>
+              <a:spcAft>
+                <a:spcPts val="0"/>
+              </a:spcAft>
+              <a:buNone/>
+            </a:pPr>
+            <a:r>
+              <a:rPr lang="en" sz="1000">
+                <a:highlight>
+                  <a:srgbClr val="1F1F1F"/>
+                </a:highlight>
+                <a:latin typeface="Consolas"/>
+                <a:ea typeface="Consolas"/>
+                <a:cs typeface="Consolas"/>
+                <a:sym typeface="Consolas"/>
+              </a:rPr>
+              <a:t>{</a:t>
+            </a:r>
+            <a:endParaRPr sz="1000">
+              <a:solidFill>
+                <a:srgbClr val="CCCCCC"/>
+              </a:solidFill>
+              <a:highlight>
+                <a:srgbClr val="1F1F1F"/>
+              </a:highlight>
+              <a:latin typeface="Consolas"/>
+              <a:ea typeface="Consolas"/>
+              <a:cs typeface="Consolas"/>
+              <a:sym typeface="Consolas"/>
+            </a:endParaRPr>
+          </a:p>
+          <a:p>
+            <a:pPr indent="0" lvl="0" marL="0" rtl="0" algn="l">
+              <a:lnSpc>
+                <a:spcPct val="115000"/>
+              </a:lnSpc>
+              <a:spcBef>
+                <a:spcPts val="0"/>
+              </a:spcBef>
+              <a:spcAft>
+                <a:spcPts val="0"/>
+              </a:spcAft>
+              <a:buNone/>
+            </a:pPr>
+            <a:r>
+              <a:rPr lang="en" sz="1000">
+                <a:highlight>
+                  <a:srgbClr val="1F1F1F"/>
+                </a:highlight>
+                <a:latin typeface="Consolas"/>
+                <a:ea typeface="Consolas"/>
+                <a:cs typeface="Consolas"/>
+                <a:sym typeface="Consolas"/>
+              </a:rPr>
+              <a:t>    _ball.Update(gameTime);</a:t>
+            </a:r>
+            <a:endParaRPr sz="1000">
+              <a:solidFill>
+                <a:srgbClr val="CCCCCC"/>
+              </a:solidFill>
+              <a:highlight>
+                <a:srgbClr val="1F1F1F"/>
+              </a:highlight>
+              <a:latin typeface="Consolas"/>
+              <a:ea typeface="Consolas"/>
+              <a:cs typeface="Consolas"/>
+              <a:sym typeface="Consolas"/>
+            </a:endParaRPr>
+          </a:p>
+          <a:p>
+            <a:pPr indent="0" lvl="0" marL="0" rtl="0" algn="l">
+              <a:lnSpc>
+                <a:spcPct val="115000"/>
+              </a:lnSpc>
+              <a:spcBef>
+                <a:spcPts val="0"/>
+              </a:spcBef>
+              <a:spcAft>
+                <a:spcPts val="0"/>
+              </a:spcAft>
+              <a:buNone/>
+            </a:pPr>
+            <a:r>
+              <a:rPr lang="en" sz="1000">
+                <a:highlight>
+                  <a:srgbClr val="1F1F1F"/>
+                </a:highlight>
+                <a:latin typeface="Consolas"/>
+                <a:ea typeface="Consolas"/>
+                <a:cs typeface="Consolas"/>
+                <a:sym typeface="Consolas"/>
+              </a:rPr>
+              <a:t>    _paddle1.Update(gameTime);</a:t>
+            </a:r>
+            <a:endParaRPr sz="1000">
+              <a:solidFill>
+                <a:srgbClr val="CCCCCC"/>
+              </a:solidFill>
+              <a:highlight>
+                <a:srgbClr val="1F1F1F"/>
+              </a:highlight>
+              <a:latin typeface="Consolas"/>
+              <a:ea typeface="Consolas"/>
+              <a:cs typeface="Consolas"/>
+              <a:sym typeface="Consolas"/>
+            </a:endParaRPr>
+          </a:p>
+          <a:p>
+            <a:pPr indent="0" lvl="0" marL="0" rtl="0" algn="l">
+              <a:lnSpc>
+                <a:spcPct val="115000"/>
+              </a:lnSpc>
+              <a:spcBef>
+                <a:spcPts val="0"/>
+              </a:spcBef>
+              <a:spcAft>
+                <a:spcPts val="0"/>
+              </a:spcAft>
+              <a:buNone/>
+            </a:pPr>
+            <a:r>
+              <a:rPr lang="en" sz="1000">
+                <a:highlight>
+                  <a:srgbClr val="1F1F1F"/>
+                </a:highlight>
+                <a:latin typeface="Consolas"/>
+                <a:ea typeface="Consolas"/>
+                <a:cs typeface="Consolas"/>
+                <a:sym typeface="Consolas"/>
+              </a:rPr>
+              <a:t>    _paddle2.Update(gameTime);</a:t>
+            </a:r>
+            <a:endParaRPr sz="1000">
+              <a:solidFill>
+                <a:srgbClr val="CCCCCC"/>
+              </a:solidFill>
+              <a:highlight>
+                <a:srgbClr val="1F1F1F"/>
+              </a:highlight>
+              <a:latin typeface="Consolas"/>
+              <a:ea typeface="Consolas"/>
+              <a:cs typeface="Consolas"/>
+              <a:sym typeface="Consolas"/>
+            </a:endParaRPr>
+          </a:p>
+          <a:p>
+            <a:pPr indent="0" lvl="0" marL="0" rtl="0" algn="l">
+              <a:lnSpc>
+                <a:spcPct val="115000"/>
+              </a:lnSpc>
+              <a:spcBef>
+                <a:spcPts val="0"/>
+              </a:spcBef>
+              <a:spcAft>
+                <a:spcPts val="0"/>
+              </a:spcAft>
+              <a:buNone/>
+            </a:pPr>
+            <a:r>
+              <a:rPr lang="en" sz="1000">
+                <a:highlight>
+                  <a:srgbClr val="1F1F1F"/>
+                </a:highlight>
+                <a:latin typeface="Consolas"/>
+                <a:ea typeface="Consolas"/>
+                <a:cs typeface="Consolas"/>
+                <a:sym typeface="Consolas"/>
+              </a:rPr>
+              <a:t>}</a:t>
+            </a:r>
+            <a:endParaRPr sz="1000">
+              <a:solidFill>
+                <a:srgbClr val="CCCCCC"/>
+              </a:solidFill>
+              <a:highlight>
+                <a:srgbClr val="1F1F1F"/>
+              </a:highlight>
+              <a:latin typeface="Consolas"/>
+              <a:ea typeface="Consolas"/>
+              <a:cs typeface="Consolas"/>
+              <a:sym typeface="Consolas"/>
+            </a:endParaRPr>
+          </a:p>
+          <a:p>
+            <a:pPr indent="0" lvl="0" marL="0" rtl="0" algn="l">
+              <a:lnSpc>
+                <a:spcPct val="115000"/>
+              </a:lnSpc>
+              <a:spcBef>
+                <a:spcPts val="0"/>
+              </a:spcBef>
+              <a:spcAft>
+                <a:spcPts val="0"/>
+              </a:spcAft>
+              <a:buNone/>
+            </a:pPr>
+            <a:r>
+              <a:rPr lang="en" sz="1000">
+                <a:highlight>
+                  <a:srgbClr val="1F1F1F"/>
+                </a:highlight>
+                <a:latin typeface="Consolas"/>
+                <a:ea typeface="Consolas"/>
+                <a:cs typeface="Consolas"/>
+                <a:sym typeface="Consolas"/>
+              </a:rPr>
+              <a:t/>
+            </a:r>
+            <a:endParaRPr sz="1000">
+              <a:solidFill>
+                <a:srgbClr val="CCCCCC"/>
+              </a:solidFill>
+              <a:highlight>
+                <a:srgbClr val="1F1F1F"/>
+              </a:highlight>
+              <a:latin typeface="Consolas"/>
+              <a:ea typeface="Consolas"/>
+              <a:cs typeface="Consolas"/>
+              <a:sym typeface="Consolas"/>
+            </a:endParaRPr>
+          </a:p>
+          <a:p>
+            <a:pPr indent="0" lvl="0" marL="0" rtl="0" algn="l">
+              <a:lnSpc>
+                <a:spcPct val="115000"/>
+              </a:lnSpc>
+              <a:spcBef>
+                <a:spcPts val="0"/>
+              </a:spcBef>
+              <a:spcAft>
+                <a:spcPts val="0"/>
+              </a:spcAft>
+              <a:buNone/>
+            </a:pPr>
+            <a:r>
+              <a:rPr lang="en" sz="1000">
+                <a:highlight>
+                  <a:srgbClr val="1F1F1F"/>
+                </a:highlight>
+                <a:latin typeface="Consolas"/>
+                <a:ea typeface="Consolas"/>
+                <a:cs typeface="Consolas"/>
+                <a:sym typeface="Consolas"/>
+              </a:rPr>
+              <a:t>protected override void Draw(GameTime gameTime)</a:t>
+            </a:r>
+            <a:endParaRPr sz="1000">
+              <a:solidFill>
+                <a:srgbClr val="CCCCCC"/>
+              </a:solidFill>
+              <a:highlight>
+                <a:srgbClr val="1F1F1F"/>
+              </a:highlight>
+              <a:latin typeface="Consolas"/>
+              <a:ea typeface="Consolas"/>
+              <a:cs typeface="Consolas"/>
+              <a:sym typeface="Consolas"/>
+            </a:endParaRPr>
+          </a:p>
+          <a:p>
+            <a:pPr indent="0" lvl="0" marL="0" rtl="0" algn="l">
+              <a:lnSpc>
+                <a:spcPct val="115000"/>
+              </a:lnSpc>
+              <a:spcBef>
+                <a:spcPts val="0"/>
+              </a:spcBef>
+              <a:spcAft>
+                <a:spcPts val="0"/>
+              </a:spcAft>
+              <a:buNone/>
+            </a:pPr>
+            <a:r>
+              <a:rPr lang="en" sz="1000">
+                <a:highlight>
+                  <a:srgbClr val="1F1F1F"/>
+                </a:highlight>
+                <a:latin typeface="Consolas"/>
+                <a:ea typeface="Consolas"/>
+                <a:cs typeface="Consolas"/>
+                <a:sym typeface="Consolas"/>
+              </a:rPr>
+              <a:t>{</a:t>
+            </a:r>
+            <a:endParaRPr sz="1000">
+              <a:solidFill>
+                <a:srgbClr val="CCCCCC"/>
+              </a:solidFill>
+              <a:highlight>
+                <a:srgbClr val="1F1F1F"/>
+              </a:highlight>
+              <a:latin typeface="Consolas"/>
+              <a:ea typeface="Consolas"/>
+              <a:cs typeface="Consolas"/>
+              <a:sym typeface="Consolas"/>
+            </a:endParaRPr>
+          </a:p>
+          <a:p>
+            <a:pPr indent="0" lvl="0" marL="0" rtl="0" algn="l">
+              <a:lnSpc>
+                <a:spcPct val="115000"/>
+              </a:lnSpc>
+              <a:spcBef>
+                <a:spcPts val="0"/>
+              </a:spcBef>
+              <a:spcAft>
+                <a:spcPts val="0"/>
+              </a:spcAft>
+              <a:buNone/>
+            </a:pPr>
+            <a:r>
+              <a:rPr lang="en" sz="1000">
+                <a:highlight>
+                  <a:srgbClr val="1F1F1F"/>
+                </a:highlight>
+                <a:latin typeface="Consolas"/>
+                <a:ea typeface="Consolas"/>
+                <a:cs typeface="Consolas"/>
+                <a:sym typeface="Consolas"/>
+              </a:rPr>
+              <a:t>    _spriteBatch.Begin();</a:t>
+            </a:r>
+            <a:endParaRPr sz="1000">
+              <a:solidFill>
+                <a:srgbClr val="CCCCCC"/>
+              </a:solidFill>
+              <a:highlight>
+                <a:srgbClr val="1F1F1F"/>
+              </a:highlight>
+              <a:latin typeface="Consolas"/>
+              <a:ea typeface="Consolas"/>
+              <a:cs typeface="Consolas"/>
+              <a:sym typeface="Consolas"/>
+            </a:endParaRPr>
+          </a:p>
+          <a:p>
+            <a:pPr indent="0" lvl="0" marL="0" rtl="0" algn="l">
+              <a:lnSpc>
+                <a:spcPct val="115000"/>
+              </a:lnSpc>
+              <a:spcBef>
+                <a:spcPts val="0"/>
+              </a:spcBef>
+              <a:spcAft>
+                <a:spcPts val="0"/>
+              </a:spcAft>
+              <a:buNone/>
+            </a:pPr>
+            <a:r>
+              <a:rPr lang="en" sz="1000">
+                <a:highlight>
+                  <a:srgbClr val="1F1F1F"/>
+                </a:highlight>
+                <a:latin typeface="Consolas"/>
+                <a:ea typeface="Consolas"/>
+                <a:cs typeface="Consolas"/>
+                <a:sym typeface="Consolas"/>
+              </a:rPr>
+              <a:t>    _paddle1.Draw(_spriteBatch);</a:t>
+            </a:r>
+            <a:endParaRPr sz="1000">
+              <a:solidFill>
+                <a:srgbClr val="CCCCCC"/>
+              </a:solidFill>
+              <a:highlight>
+                <a:srgbClr val="1F1F1F"/>
+              </a:highlight>
+              <a:latin typeface="Consolas"/>
+              <a:ea typeface="Consolas"/>
+              <a:cs typeface="Consolas"/>
+              <a:sym typeface="Consolas"/>
+            </a:endParaRPr>
+          </a:p>
+          <a:p>
+            <a:pPr indent="0" lvl="0" marL="0" rtl="0" algn="l">
+              <a:lnSpc>
+                <a:spcPct val="115000"/>
+              </a:lnSpc>
+              <a:spcBef>
+                <a:spcPts val="0"/>
+              </a:spcBef>
+              <a:spcAft>
+                <a:spcPts val="0"/>
+              </a:spcAft>
+              <a:buNone/>
+            </a:pPr>
+            <a:r>
+              <a:rPr lang="en" sz="1000">
+                <a:highlight>
+                  <a:srgbClr val="1F1F1F"/>
+                </a:highlight>
+                <a:latin typeface="Consolas"/>
+                <a:ea typeface="Consolas"/>
+                <a:cs typeface="Consolas"/>
+                <a:sym typeface="Consolas"/>
+              </a:rPr>
+              <a:t>    _paddle2.Draw(_spriteBatch);</a:t>
+            </a:r>
+            <a:endParaRPr sz="1000">
+              <a:solidFill>
+                <a:srgbClr val="CCCCCC"/>
+              </a:solidFill>
+              <a:highlight>
+                <a:srgbClr val="1F1F1F"/>
+              </a:highlight>
+              <a:latin typeface="Consolas"/>
+              <a:ea typeface="Consolas"/>
+              <a:cs typeface="Consolas"/>
+              <a:sym typeface="Consolas"/>
+            </a:endParaRPr>
+          </a:p>
+          <a:p>
+            <a:pPr indent="0" lvl="0" marL="0" rtl="0" algn="l">
+              <a:lnSpc>
+                <a:spcPct val="115000"/>
+              </a:lnSpc>
+              <a:spcBef>
+                <a:spcPts val="0"/>
+              </a:spcBef>
+              <a:spcAft>
+                <a:spcPts val="0"/>
+              </a:spcAft>
+              <a:buNone/>
+            </a:pPr>
+            <a:r>
+              <a:rPr lang="en" sz="1000">
+                <a:highlight>
+                  <a:srgbClr val="1F1F1F"/>
+                </a:highlight>
+                <a:latin typeface="Consolas"/>
+                <a:ea typeface="Consolas"/>
+                <a:cs typeface="Consolas"/>
+                <a:sym typeface="Consolas"/>
+              </a:rPr>
+              <a:t>    _ball.Draw(_spriteBatch);</a:t>
+            </a:r>
+            <a:endParaRPr sz="1000">
+              <a:solidFill>
+                <a:srgbClr val="CCCCCC"/>
+              </a:solidFill>
+              <a:highlight>
+                <a:srgbClr val="1F1F1F"/>
+              </a:highlight>
+              <a:latin typeface="Consolas"/>
+              <a:ea typeface="Consolas"/>
+              <a:cs typeface="Consolas"/>
+              <a:sym typeface="Consolas"/>
+            </a:endParaRPr>
+          </a:p>
+          <a:p>
+            <a:pPr indent="0" lvl="0" marL="0" rtl="0" algn="l">
+              <a:lnSpc>
+                <a:spcPct val="115000"/>
+              </a:lnSpc>
+              <a:spcBef>
+                <a:spcPts val="0"/>
+              </a:spcBef>
+              <a:spcAft>
+                <a:spcPts val="0"/>
+              </a:spcAft>
+              <a:buNone/>
+            </a:pPr>
+            <a:r>
+              <a:rPr lang="en" sz="1000">
+                <a:highlight>
+                  <a:srgbClr val="1F1F1F"/>
+                </a:highlight>
+                <a:latin typeface="Consolas"/>
+                <a:ea typeface="Consolas"/>
+                <a:cs typeface="Consolas"/>
+                <a:sym typeface="Consolas"/>
+              </a:rPr>
+              <a:t>    _spriteBatch.End();</a:t>
+            </a:r>
+            <a:endParaRPr sz="1000">
+              <a:solidFill>
+                <a:srgbClr val="CCCCCC"/>
+              </a:solidFill>
+              <a:highlight>
+                <a:srgbClr val="1F1F1F"/>
+              </a:highlight>
+              <a:latin typeface="Consolas"/>
+              <a:ea typeface="Consolas"/>
+              <a:cs typeface="Consolas"/>
+              <a:sym typeface="Consolas"/>
+            </a:endParaRPr>
+          </a:p>
+          <a:p>
+            <a:pPr indent="0" lvl="0" marL="0" rtl="0" algn="l">
+              <a:lnSpc>
+                <a:spcPct val="115000"/>
+              </a:lnSpc>
+              <a:spcBef>
+                <a:spcPts val="0"/>
+              </a:spcBef>
+              <a:spcAft>
+                <a:spcPts val="0"/>
+              </a:spcAft>
+              <a:buNone/>
+            </a:pPr>
+            <a:r>
+              <a:rPr lang="en" sz="1000">
+                <a:highlight>
+                  <a:srgbClr val="1F1F1F"/>
+                </a:highlight>
+                <a:latin typeface="Consolas"/>
+                <a:ea typeface="Consolas"/>
+                <a:cs typeface="Consolas"/>
+                <a:sym typeface="Consolas"/>
+              </a:rPr>
+              <a:t>}</a:t>
+            </a:r>
+            <a:endParaRPr sz="1000">
+              <a:solidFill>
+                <a:srgbClr val="CCCCCC"/>
+              </a:solidFill>
+              <a:highlight>
+                <a:srgbClr val="1F1F1F"/>
+              </a:highlight>
+              <a:latin typeface="Consolas"/>
+              <a:ea typeface="Consolas"/>
+              <a:cs typeface="Consolas"/>
+              <a:sym typeface="Consolas"/>
+            </a:endParaRPr>
+          </a:p>
+        </p:txBody>
+      </p:sp>
     </p:spTree>
   </p:cSld>
   <p:clrMapOvr>

</xml_diff>

<commit_message>
Point everything at the gar-games repository
The games now live in one repository, gar-games, with one folder per
game. Session pages, the exam page, the decks and the instructor notes
link to its folders, and the GMDCore check moved there
(tools/check.py). Also drops a stray http://readme.md link from the
Geometry Wars deck.

Co-Authored-By: Claude Opus 5.5 <noreply@anthropic.com>
</commit_message>
<xml_diff>
--- a/slides/01 Pong.pptx
+++ b/slides/01 Pong.pptx
@@ -8975,6 +8975,7 @@
               <a:buNone/>
             </a:pPr>
             <a:r>
+              <a:rPr/>
               <a:t/>
             </a:r>
             <a:endParaRPr/>
@@ -9965,7 +9966,7 @@
             </a:pPr>
             <a:r>
               <a:rPr lang="en"/>
-              <a:t>The course repositories on GitHub (Metamate/gmd2-*)</a:t>
+              <a:t>The course games on GitHub: Metamate/gar-games</a:t>
             </a:r>
             <a:endParaRPr/>
           </a:p>
@@ -10093,7 +10094,7 @@
                 </a:solidFill>
                 <a:hlinkClick r:id="rId3"/>
               </a:rPr>
-              <a:t>https://github.com/Metamate/gmd2-pong</a:t>
+              <a:t>https://github.com/Metamate/gar-games/tree/main/01-pong</a:t>
             </a:r>
             <a:endParaRPr/>
           </a:p>
@@ -10266,7 +10267,7 @@
             </a:pPr>
             <a:r>
               <a:rPr lang="en"/>
-              <a:t>Clone the course repository and open Pong0</a:t>
+              <a:t>Clone gar-games and open 01-pong/Pong0</a:t>
             </a:r>
             <a:endParaRPr/>
           </a:p>
@@ -10300,7 +10301,7 @@
             </a:pPr>
             <a:r>
               <a:rPr lang="en"/>
-              <a:t>Run the game: dotnet run --project Pong0</a:t>
+              <a:t>Run it from the 01-pong folder: dotnet run --project Pong0</a:t>
             </a:r>
             <a:endParaRPr/>
           </a:p>
@@ -10589,6 +10590,7 @@
               <a:buNone/>
             </a:pPr>
             <a:r>
+              <a:rPr/>
               <a:t/>
             </a:r>
             <a:endParaRPr/>
@@ -10628,6 +10630,7 @@
               <a:buNone/>
             </a:pPr>
             <a:r>
+              <a:rPr/>
               <a:t/>
             </a:r>
             <a:endParaRPr/>
@@ -12500,6 +12503,7 @@
               <a:buNone/>
             </a:pPr>
             <a:r>
+              <a:rPr/>
               <a:t/>
             </a:r>
             <a:endParaRPr/>
@@ -12666,6 +12670,7 @@
               <a:buNone/>
             </a:pPr>
             <a:r>
+              <a:rPr/>
               <a:t/>
             </a:r>
             <a:endParaRPr/>
@@ -13179,6 +13184,7 @@
               <a:buNone/>
             </a:pPr>
             <a:r>
+              <a:rPr/>
               <a:t/>
             </a:r>
             <a:endParaRPr/>
@@ -14525,6 +14531,7 @@
               <a:buNone/>
             </a:pPr>
             <a:r>
+              <a:rPr/>
               <a:t/>
             </a:r>
             <a:endParaRPr sz="1000">
@@ -14554,6 +14561,7 @@
               <a:buNone/>
             </a:pPr>
             <a:r>
+              <a:rPr/>
               <a:t/>
             </a:r>
             <a:endParaRPr sz="1000">
@@ -14583,6 +14591,7 @@
               <a:buNone/>
             </a:pPr>
             <a:r>
+              <a:rPr/>
               <a:t/>
             </a:r>
             <a:endParaRPr sz="1000">
@@ -14612,6 +14621,7 @@
               <a:buNone/>
             </a:pPr>
             <a:r>
+              <a:rPr/>
               <a:t/>
             </a:r>
             <a:endParaRPr sz="1000">
@@ -14641,6 +14651,7 @@
               <a:buNone/>
             </a:pPr>
             <a:r>
+              <a:rPr/>
               <a:t/>
             </a:r>
             <a:endParaRPr sz="1000">
@@ -14670,6 +14681,7 @@
               <a:buNone/>
             </a:pPr>
             <a:r>
+              <a:rPr/>
               <a:t/>
             </a:r>
             <a:endParaRPr sz="1000">
@@ -14948,6 +14960,7 @@
               <a:buNone/>
             </a:pPr>
             <a:r>
+              <a:rPr/>
               <a:t/>
             </a:r>
             <a:endParaRPr/>
@@ -14980,6 +14993,7 @@
               <a:buNone/>
             </a:pPr>
             <a:r>
+              <a:rPr/>
               <a:t/>
             </a:r>
             <a:endParaRPr/>
@@ -15885,6 +15899,7 @@
               <a:buNone/>
             </a:pPr>
             <a:r>
+              <a:rPr/>
               <a:t/>
             </a:r>
             <a:endParaRPr/>
@@ -16199,6 +16214,7 @@
               <a:buNone/>
             </a:pPr>
             <a:r>
+              <a:rPr/>
               <a:t/>
             </a:r>
             <a:endParaRPr/>
@@ -16331,6 +16347,7 @@
               <a:buNone/>
             </a:pPr>
             <a:r>
+              <a:rPr/>
               <a:t/>
             </a:r>
             <a:endParaRPr/>
@@ -18988,6 +19005,7 @@
               <a:buNone/>
             </a:pPr>
             <a:r>
+              <a:rPr/>
               <a:t/>
             </a:r>
             <a:endParaRPr/>
@@ -19003,6 +19021,7 @@
               <a:buNone/>
             </a:pPr>
             <a:r>
+              <a:rPr/>
               <a:t/>
             </a:r>
             <a:endParaRPr/>
@@ -19396,6 +19415,7 @@
               <a:buNone/>
             </a:pPr>
             <a:r>
+              <a:rPr/>
               <a:t/>
             </a:r>
             <a:endParaRPr/>
@@ -19411,6 +19431,7 @@
               <a:buNone/>
             </a:pPr>
             <a:r>
+              <a:rPr/>
               <a:t/>
             </a:r>
             <a:endParaRPr/>
@@ -20620,6 +20641,7 @@
               <a:buNone/>
             </a:pPr>
             <a:r>
+              <a:rPr/>
               <a:t/>
             </a:r>
             <a:endParaRPr b="1" i="1">

</xml_diff>

<commit_message>
Consistency pass over the site and decks
- Exam: every question's "Covered in" matches the pages that link to it
- Pong and Flappy Bird pages get step tables and Apply It to Your Project
- Vampire Survivors gets a class diagram; recap adds DI, Spatial Partition
  and Data Locality, and fixes stale entries
- Schedule, descriptions and course notes match what the games now teach
- Older decks end like the newer ones: Apply It to Your Project and the
  course-project milestone; a typo in the Mario deck

Co-Authored-By: Claude Opus 5.5 <noreply@anthropic.com>
Claude-Session: https://claude.ai/code/session_012sjsUQBbC7zon57rWHoo9d
</commit_message>
<xml_diff>
--- a/slides/01 Pong.pptx
+++ b/slides/01 Pong.pptx
@@ -55,6 +55,8 @@
     <p:sldId id="297" r:id="rId47"/>
     <p:sldId id="298" r:id="rId48"/>
     <p:sldId id="299" r:id="rId49"/>
+    <p:sldId id="304" r:id="rId63"/>
+    <p:sldId id="305" r:id="rId64"/>
     <p:sldId id="300" r:id="rId50"/>
   </p:sldIdLst>
   <p:sldSz cy="5143500" cx="9144000"/>
@@ -20354,6 +20356,156 @@
 </p:sld>
 </file>
 
+<file path=ppt/slides/slide49.xml><?xml version="1.0" encoding="utf-8"?>
+<p:sld xmlns:a="http://schemas.openxmlformats.org/drawingml/2006/main" xmlns:p="http://schemas.openxmlformats.org/presentationml/2006/main" xmlns:r="http://schemas.openxmlformats.org/officeDocument/2006/relationships">
+  <p:cSld>
+    <p:spTree>
+      <p:nvGrpSpPr>
+        <p:cNvPr id="1" name=""/>
+        <p:cNvGrpSpPr/>
+        <p:nvPr/>
+      </p:nvGrpSpPr>
+      <p:grpSpPr/>
+      <p:sp>
+        <p:nvSpPr>
+          <p:cNvPr id="76" name="Google Shape;76;p15"/>
+          <p:cNvSpPr txBox="1"/>
+          <p:nvPr>
+            <p:ph type="title"/>
+          </p:nvPr>
+        </p:nvSpPr>
+        <p:spPr>
+          <a:xfrm>
+            <a:off x="311700" y="195615"/>
+            <a:ext cx="8520600" cy="572700"/>
+          </a:xfrm>
+          <a:prstGeom prst="rect">
+            <a:avLst/>
+          </a:prstGeom>
+        </p:spPr>
+        <p:txBody>
+          <a:bodyPr anchorCtr="0" anchor="t" bIns="91425" lIns="91425" spcFirstLastPara="1" rIns="91425" wrap="square" tIns="91425">
+            <a:normAutofit fontScale="90000"/>
+          </a:bodyPr>
+          <a:lstStyle/>
+          <a:p>
+            <a:pPr indent="0" lvl="0" marL="0" rtl="0" algn="l">
+              <a:spcBef>
+                <a:spcPts val="0"/>
+              </a:spcBef>
+              <a:spcAft>
+                <a:spcPts val="0"/>
+              </a:spcAft>
+              <a:buNone/>
+            </a:pPr>
+            <a:r>
+              <a:rPr lang="en"/>
+              <a:t>Apply It to Your Project</a:t>
+            </a:r>
+            <a:endParaRPr/>
+          </a:p>
+        </p:txBody>
+      </p:sp>
+      <p:sp>
+        <p:nvSpPr>
+          <p:cNvPr id="77" name="Google Shape;77;p15"/>
+          <p:cNvSpPr txBox="1"/>
+          <p:nvPr>
+            <p:ph idx="1" type="body"/>
+          </p:nvPr>
+        </p:nvSpPr>
+        <p:spPr>
+          <a:xfrm>
+            <a:off x="311700" y="885950"/>
+            <a:ext cx="8520600" cy="4023300"/>
+          </a:xfrm>
+          <a:prstGeom prst="rect">
+            <a:avLst/>
+          </a:prstGeom>
+        </p:spPr>
+        <p:txBody>
+          <a:bodyPr anchorCtr="0" anchor="t" bIns="91425" lIns="91425" spcFirstLastPara="1" rIns="91425" wrap="square" tIns="91425">
+            <a:normAutofit/>
+          </a:bodyPr>
+          <a:lstStyle/>
+          <a:p>
+            <a:pPr indent="-330200" lvl="0" marL="457200" rtl="0" algn="l">
+              <a:spcBef>
+                <a:spcPts val="0"/>
+              </a:spcBef>
+              <a:spcAft>
+                <a:spcPts val="0"/>
+              </a:spcAft>
+              <a:buSzPts val="1600"/>
+              <a:buChar char="●"/>
+            </a:pPr>
+            <a:r>
+              <a:rPr lang="en"/>
+              <a:t>Which games would you like to make? Pick two or three candidates</a:t>
+            </a:r>
+            <a:endParaRPr/>
+          </a:p>
+          <a:p>
+            <a:pPr indent="-330200" lvl="0" marL="457200" rtl="0" algn="l">
+              <a:spcBef>
+                <a:spcPts val="0"/>
+              </a:spcBef>
+              <a:spcAft>
+                <a:spcPts val="0"/>
+              </a:spcAft>
+              <a:buSzPts val="1600"/>
+              <a:buChar char="●"/>
+            </a:pPr>
+            <a:r>
+              <a:rPr lang="en"/>
+              <a:t>For each: what updates every frame, and what is drawn?</a:t>
+            </a:r>
+            <a:endParaRPr/>
+          </a:p>
+          <a:p>
+            <a:pPr indent="-317500" lvl="1" marL="914400" rtl="0" algn="l">
+              <a:spcBef>
+                <a:spcPts val="0"/>
+              </a:spcBef>
+              <a:spcAft>
+                <a:spcPts val="0"/>
+              </a:spcAft>
+              <a:buSzPts val="1400"/>
+              <a:buChar char="○"/>
+            </a:pPr>
+            <a:r>
+              <a:rPr lang="en"/>
+              <a:t>That’s its game loop</a:t>
+            </a:r>
+            <a:endParaRPr/>
+          </a:p>
+          <a:p>
+            <a:pPr indent="-330200" lvl="0" marL="457200" rtl="0" algn="l">
+              <a:spcBef>
+                <a:spcPts val="0"/>
+              </a:spcBef>
+              <a:spcAft>
+                <a:spcPts val="0"/>
+              </a:spcAft>
+              <a:buSzPts val="1600"/>
+              <a:buChar char="●"/>
+            </a:pPr>
+            <a:r>
+              <a:rPr lang="en"/>
+              <a:t>Could you build a naive prototype of the core idea first, like this Pong?</a:t>
+            </a:r>
+            <a:endParaRPr/>
+          </a:p>
+        </p:txBody>
+      </p:sp>
+    </p:spTree>
+  </p:cSld>
+  <p:clrMapOvr>
+    <a:masterClrMapping/>
+  </p:clrMapOvr>
+</p:sld>
+</file>
+
 <file path=ppt/slides/slide5.xml><?xml version="1.0" encoding="utf-8"?>
 <p:sld xmlns:a="http://schemas.openxmlformats.org/drawingml/2006/main" xmlns:r="http://schemas.openxmlformats.org/officeDocument/2006/relationships" xmlns:mc="http://schemas.openxmlformats.org/markup-compatibility/2006" xmlns:mv="urn:schemas-microsoft-com:mac:vml" xmlns:p="http://schemas.openxmlformats.org/presentationml/2006/main" xmlns:c="http://schemas.openxmlformats.org/drawingml/2006/chart" xmlns:dgm="http://schemas.openxmlformats.org/drawingml/2006/diagram" xmlns:o="urn:schemas-microsoft-com:office:office" xmlns:v="urn:schemas-microsoft-com:vml" xmlns:pvml="urn:schemas-microsoft-com:office:powerpoint" xmlns:com="http://schemas.openxmlformats.org/drawingml/2006/compatibility" xmlns:p14="http://schemas.microsoft.com/office/powerpoint/2010/main" xmlns:p15="http://schemas.microsoft.com/office/powerpoint/2012/main" xmlns:ahyp="http://schemas.microsoft.com/office/drawing/2018/hyperlinkcolor">
   <p:cSld>
@@ -20480,6 +20632,190 @@
               <a:t>and learn at the same time</a:t>
             </a:r>
             <a:endParaRPr sz="2400"/>
+          </a:p>
+        </p:txBody>
+      </p:sp>
+    </p:spTree>
+  </p:cSld>
+  <p:clrMapOvr>
+    <a:masterClrMapping/>
+  </p:clrMapOvr>
+</p:sld>
+</file>
+
+<file path=ppt/slides/slide50.xml><?xml version="1.0" encoding="utf-8"?>
+<p:sld xmlns:a="http://schemas.openxmlformats.org/drawingml/2006/main" xmlns:p="http://schemas.openxmlformats.org/presentationml/2006/main" xmlns:r="http://schemas.openxmlformats.org/officeDocument/2006/relationships">
+  <p:cSld>
+    <p:spTree>
+      <p:nvGrpSpPr>
+        <p:cNvPr id="1" name=""/>
+        <p:cNvGrpSpPr/>
+        <p:nvPr/>
+      </p:nvGrpSpPr>
+      <p:grpSpPr/>
+      <p:sp>
+        <p:nvSpPr>
+          <p:cNvPr id="76" name="Google Shape;76;p15"/>
+          <p:cNvSpPr txBox="1"/>
+          <p:nvPr>
+            <p:ph type="title"/>
+          </p:nvPr>
+        </p:nvSpPr>
+        <p:spPr>
+          <a:xfrm>
+            <a:off x="311700" y="195615"/>
+            <a:ext cx="8520600" cy="572700"/>
+          </a:xfrm>
+          <a:prstGeom prst="rect">
+            <a:avLst/>
+          </a:prstGeom>
+        </p:spPr>
+        <p:txBody>
+          <a:bodyPr anchorCtr="0" anchor="t" bIns="91425" lIns="91425" spcFirstLastPara="1" rIns="91425" wrap="square" tIns="91425">
+            <a:normAutofit fontScale="90000"/>
+          </a:bodyPr>
+          <a:lstStyle/>
+          <a:p>
+            <a:pPr indent="0" lvl="0" marL="0" rtl="0" algn="l">
+              <a:spcBef>
+                <a:spcPts val="0"/>
+              </a:spcBef>
+              <a:spcAft>
+                <a:spcPts val="0"/>
+              </a:spcAft>
+              <a:buNone/>
+            </a:pPr>
+            <a:r>
+              <a:rPr lang="en"/>
+              <a:t>Your Course Project</a:t>
+            </a:r>
+            <a:endParaRPr/>
+          </a:p>
+        </p:txBody>
+      </p:sp>
+      <p:sp>
+        <p:nvSpPr>
+          <p:cNvPr id="77" name="Google Shape;77;p15"/>
+          <p:cNvSpPr txBox="1"/>
+          <p:nvPr>
+            <p:ph idx="1" type="body"/>
+          </p:nvPr>
+        </p:nvSpPr>
+        <p:spPr>
+          <a:xfrm>
+            <a:off x="311700" y="885950"/>
+            <a:ext cx="8520600" cy="4023300"/>
+          </a:xfrm>
+          <a:prstGeom prst="rect">
+            <a:avLst/>
+          </a:prstGeom>
+        </p:spPr>
+        <p:txBody>
+          <a:bodyPr anchorCtr="0" anchor="t" bIns="91425" lIns="91425" spcFirstLastPara="1" rIns="91425" wrap="square" tIns="91425">
+            <a:normAutofit/>
+          </a:bodyPr>
+          <a:lstStyle/>
+          <a:p>
+            <a:pPr indent="-330200" lvl="0" marL="457200" rtl="0" algn="l">
+              <a:spcBef>
+                <a:spcPts val="0"/>
+              </a:spcBef>
+              <a:spcAft>
+                <a:spcPts val="0"/>
+              </a:spcAft>
+              <a:buSzPts val="1600"/>
+              <a:buChar char="●"/>
+            </a:pPr>
+            <a:r>
+              <a:rPr lang="en"/>
+              <a:t>Form groups of 1–3 students</a:t>
+            </a:r>
+            <a:endParaRPr/>
+          </a:p>
+          <a:p>
+            <a:pPr indent="-330200" lvl="0" marL="457200" rtl="0" algn="l">
+              <a:spcBef>
+                <a:spcPts val="0"/>
+              </a:spcBef>
+              <a:spcAft>
+                <a:spcPts val="0"/>
+              </a:spcAft>
+              <a:buSzPts val="1600"/>
+              <a:buChar char="●"/>
+            </a:pPr>
+            <a:r>
+              <a:rPr lang="en"/>
+              <a:t>Think of a game you want to create</a:t>
+            </a:r>
+            <a:endParaRPr/>
+          </a:p>
+          <a:p>
+            <a:pPr indent="-317500" lvl="1" marL="914400" rtl="0" algn="l">
+              <a:spcBef>
+                <a:spcPts val="0"/>
+              </a:spcBef>
+              <a:spcAft>
+                <a:spcPts val="0"/>
+              </a:spcAft>
+              <a:buSzPts val="1400"/>
+              <a:buChar char="○"/>
+            </a:pPr>
+            <a:r>
+              <a:rPr lang="en"/>
+              <a:t>Take inspiration from classic games!</a:t>
+            </a:r>
+            <a:endParaRPr/>
+          </a:p>
+          <a:p>
+            <a:pPr indent="-317500" lvl="1" marL="914400" rtl="0" algn="l">
+              <a:spcBef>
+                <a:spcPts val="0"/>
+              </a:spcBef>
+              <a:spcAft>
+                <a:spcPts val="0"/>
+              </a:spcAft>
+              <a:buSzPts val="1400"/>
+              <a:buChar char="○"/>
+            </a:pPr>
+            <a:r>
+              <a:rPr lang="en"/>
+              <a:t>Be mindful of scope (creep)</a:t>
+            </a:r>
+            <a:endParaRPr/>
+          </a:p>
+          <a:p>
+            <a:pPr indent="-330200" lvl="0" marL="457200" rtl="0" algn="l">
+              <a:spcBef>
+                <a:spcPts val="0"/>
+              </a:spcBef>
+              <a:spcAft>
+                <a:spcPts val="0"/>
+              </a:spcAft>
+              <a:buSzPts val="1600"/>
+              <a:buChar char="●"/>
+            </a:pPr>
+            <a:r>
+              <a:rPr lang="en"/>
+              <a:t>First milestone, by session 04</a:t>
+            </a:r>
+            <a:endParaRPr/>
+          </a:p>
+          <a:p>
+            <a:pPr indent="-317500" lvl="1" marL="914400" rtl="0" algn="l">
+              <a:spcBef>
+                <a:spcPts val="0"/>
+              </a:spcBef>
+              <a:spcAft>
+                <a:spcPts val="0"/>
+              </a:spcAft>
+              <a:buSzPts val="1400"/>
+              <a:buChar char="○"/>
+            </a:pPr>
+            <a:r>
+              <a:rPr lang="en"/>
+              <a:t>Groups formed, game concept written, repository created</a:t>
+            </a:r>
+            <a:endParaRPr/>
           </a:p>
         </p:txBody>
       </p:sp>

</xml_diff>

<commit_message>
Decks and site show the new art
Real screenshots and GIFs of the restyled games replace the old art:
"Today's Goal" in every deck, Pong's step screenshots, Snake's atlas,
tileset and animation slides (no more Mario sheet), the platformer's
tilesets, levels, hitbox diagrams, entities and extra assets (now the
repo's power-up sheet instead of a shared drive), Zelda's assets and
tooling, and Pokemon's sheets. Unused images are dropped, so the decks
are smaller too.

Co-Authored-By: Claude Opus 5.5 <noreply@anthropic.com>
Claude-Session: https://claude.ai/code/session_012sjsUQBbC7zon57rWHoo9d
</commit_message>
<xml_diff>
--- a/slides/01 Pong.pptx
+++ b/slides/01 Pong.pptx
@@ -9204,30 +9204,26 @@
       </p:sp>
       <p:pic>
         <p:nvPicPr>
-          <p:cNvPr id="107" name="Google Shape;107;p20" title="pong.gif"/>
-          <p:cNvPicPr preferRelativeResize="0"/>
+          <p:cNvPr id="107" name="Picture 107" descr="gif-pong.gif"/>
+          <p:cNvPicPr>
+            <a:picLocks noChangeAspect="1"/>
+          </p:cNvPicPr>
           <p:nvPr/>
         </p:nvPicPr>
         <p:blipFill>
-          <a:blip r:embed="rId3">
-            <a:alphaModFix/>
-          </a:blip>
+          <a:blip r:embed="rId4"/>
           <a:stretch>
             <a:fillRect/>
           </a:stretch>
         </p:blipFill>
         <p:spPr>
           <a:xfrm>
-            <a:off x="1533525" y="1281973"/>
-            <a:ext cx="6076950" cy="3409950"/>
+            <a:off x="1540933" y="1281973"/>
+            <a:ext cx="6062133" cy="3409950"/>
           </a:xfrm>
           <a:prstGeom prst="rect">
             <a:avLst/>
           </a:prstGeom>
-          <a:noFill/>
-          <a:ln>
-            <a:noFill/>
-          </a:ln>
         </p:spPr>
       </p:pic>
     </p:spTree>
@@ -13403,30 +13399,26 @@
       </p:sp>
       <p:pic>
         <p:nvPicPr>
-          <p:cNvPr id="201" name="Google Shape;201;p35"/>
-          <p:cNvPicPr preferRelativeResize="0"/>
+          <p:cNvPr id="201" name="Picture 201" descr="pong3.png"/>
+          <p:cNvPicPr>
+            <a:picLocks noChangeAspect="1"/>
+          </p:cNvPicPr>
           <p:nvPr/>
         </p:nvPicPr>
         <p:blipFill>
-          <a:blip r:embed="rId4">
-            <a:alphaModFix/>
-          </a:blip>
+          <a:blip r:embed="rId5"/>
           <a:stretch>
             <a:fillRect/>
           </a:stretch>
         </p:blipFill>
         <p:spPr>
           <a:xfrm>
-            <a:off x="2393662" y="2353700"/>
-            <a:ext cx="4356675" cy="2555550"/>
+            <a:off x="2393662" y="2406160"/>
+            <a:ext cx="4356675" cy="2450629"/>
           </a:xfrm>
           <a:prstGeom prst="rect">
             <a:avLst/>
           </a:prstGeom>
-          <a:noFill/>
-          <a:ln>
-            <a:noFill/>
-          </a:ln>
         </p:spPr>
       </p:pic>
     </p:spTree>
@@ -15169,30 +15161,26 @@
       </p:sp>
       <p:pic>
         <p:nvPicPr>
-          <p:cNvPr id="220" name="Google Shape;220;p38"/>
-          <p:cNvPicPr preferRelativeResize="0"/>
+          <p:cNvPr id="220" name="Picture 220" descr="pong4.png"/>
+          <p:cNvPicPr>
+            <a:picLocks noChangeAspect="1"/>
+          </p:cNvPicPr>
           <p:nvPr/>
         </p:nvPicPr>
         <p:blipFill>
-          <a:blip r:embed="rId3">
-            <a:alphaModFix/>
-          </a:blip>
+          <a:blip r:embed="rId4"/>
           <a:stretch>
             <a:fillRect/>
           </a:stretch>
         </p:blipFill>
         <p:spPr>
           <a:xfrm>
-            <a:off x="2542227" y="2527975"/>
-            <a:ext cx="4059549" cy="2381276"/>
+            <a:off x="2542227" y="2576865"/>
+            <a:ext cx="4059549" cy="2283496"/>
           </a:xfrm>
           <a:prstGeom prst="rect">
             <a:avLst/>
           </a:prstGeom>
-          <a:noFill/>
-          <a:ln>
-            <a:noFill/>
-          </a:ln>
         </p:spPr>
       </p:pic>
     </p:spTree>
@@ -16092,30 +16080,26 @@
       </p:sp>
       <p:pic>
         <p:nvPicPr>
-          <p:cNvPr id="233" name="Google Shape;233;p40"/>
-          <p:cNvPicPr preferRelativeResize="0"/>
+          <p:cNvPr id="233" name="Picture 233" descr="pong5.png"/>
+          <p:cNvPicPr>
+            <a:picLocks noChangeAspect="1"/>
+          </p:cNvPicPr>
           <p:nvPr/>
         </p:nvPicPr>
         <p:blipFill>
-          <a:blip r:embed="rId3">
-            <a:alphaModFix/>
-          </a:blip>
+          <a:blip r:embed="rId4"/>
           <a:stretch>
             <a:fillRect/>
           </a:stretch>
         </p:blipFill>
         <p:spPr>
           <a:xfrm>
-            <a:off x="2579537" y="2571750"/>
-            <a:ext cx="3984937" cy="2337500"/>
+            <a:off x="2579537" y="2619736"/>
+            <a:ext cx="3984937" cy="2241527"/>
           </a:xfrm>
           <a:prstGeom prst="rect">
             <a:avLst/>
           </a:prstGeom>
-          <a:noFill/>
-          <a:ln>
-            <a:noFill/>
-          </a:ln>
         </p:spPr>
       </p:pic>
     </p:spTree>
@@ -19032,30 +19016,26 @@
       </p:sp>
       <p:pic>
         <p:nvPicPr>
-          <p:cNvPr id="273" name="Google Shape;273;p46"/>
-          <p:cNvPicPr preferRelativeResize="0"/>
+          <p:cNvPr id="273" name="Picture 273" descr="pong8.png"/>
+          <p:cNvPicPr>
+            <a:picLocks noChangeAspect="1"/>
+          </p:cNvPicPr>
           <p:nvPr/>
         </p:nvPicPr>
         <p:blipFill>
-          <a:blip r:embed="rId3">
-            <a:alphaModFix/>
-          </a:blip>
+          <a:blip r:embed="rId4"/>
           <a:stretch>
             <a:fillRect/>
           </a:stretch>
         </p:blipFill>
         <p:spPr>
           <a:xfrm>
-            <a:off x="2120062" y="1975400"/>
-            <a:ext cx="4903894" cy="2876550"/>
+            <a:off x="2120062" y="2034455"/>
+            <a:ext cx="4903894" cy="2758440"/>
           </a:xfrm>
           <a:prstGeom prst="rect">
             <a:avLst/>
           </a:prstGeom>
-          <a:noFill/>
-          <a:ln>
-            <a:noFill/>
-          </a:ln>
         </p:spPr>
       </p:pic>
     </p:spTree>
@@ -19442,30 +19422,26 @@
       </p:sp>
       <p:pic>
         <p:nvPicPr>
-          <p:cNvPr id="287" name="Google Shape;287;p48"/>
-          <p:cNvPicPr preferRelativeResize="0"/>
+          <p:cNvPr id="287" name="Picture 287" descr="pong9.png"/>
+          <p:cNvPicPr>
+            <a:picLocks noChangeAspect="1"/>
+          </p:cNvPicPr>
           <p:nvPr/>
         </p:nvPicPr>
         <p:blipFill>
-          <a:blip r:embed="rId3">
-            <a:alphaModFix/>
-          </a:blip>
+          <a:blip r:embed="rId4"/>
           <a:stretch>
             <a:fillRect/>
           </a:stretch>
         </p:blipFill>
         <p:spPr>
           <a:xfrm>
-            <a:off x="2721375" y="2738150"/>
-            <a:ext cx="3701249" cy="2171099"/>
+            <a:off x="2721375" y="2782723"/>
+            <a:ext cx="3701249" cy="2081952"/>
           </a:xfrm>
           <a:prstGeom prst="rect">
             <a:avLst/>
           </a:prstGeom>
-          <a:noFill/>
-          <a:ln>
-            <a:noFill/>
-          </a:ln>
         </p:spPr>
       </p:pic>
     </p:spTree>
@@ -19601,30 +19577,26 @@
       </p:sp>
       <p:pic>
         <p:nvPicPr>
-          <p:cNvPr id="294" name="Google Shape;294;p49"/>
-          <p:cNvPicPr preferRelativeResize="0"/>
+          <p:cNvPr id="294" name="Picture 294" descr="pong10.png"/>
+          <p:cNvPicPr>
+            <a:picLocks noChangeAspect="1"/>
+          </p:cNvPicPr>
           <p:nvPr/>
         </p:nvPicPr>
         <p:blipFill>
-          <a:blip r:embed="rId3">
-            <a:alphaModFix/>
-          </a:blip>
+          <a:blip r:embed="rId4"/>
           <a:stretch>
             <a:fillRect/>
           </a:stretch>
         </p:blipFill>
         <p:spPr>
           <a:xfrm>
-            <a:off x="2027855" y="1877150"/>
-            <a:ext cx="5088300" cy="2984726"/>
+            <a:off x="2027855" y="1938429"/>
+            <a:ext cx="5088300" cy="2862168"/>
           </a:xfrm>
           <a:prstGeom prst="rect">
             <a:avLst/>
           </a:prstGeom>
-          <a:noFill/>
-          <a:ln>
-            <a:noFill/>
-          </a:ln>
         </p:spPr>
       </p:pic>
     </p:spTree>
@@ -20224,25 +20196,18 @@
 </file>
 
 <file path=ppt/slides/slide48.xml><?xml version="1.0" encoding="utf-8"?>
-<p:sld xmlns:a="http://schemas.openxmlformats.org/drawingml/2006/main" xmlns:r="http://schemas.openxmlformats.org/officeDocument/2006/relationships" xmlns:mc="http://schemas.openxmlformats.org/markup-compatibility/2006" xmlns:mv="urn:schemas-microsoft-com:mac:vml" xmlns:p="http://schemas.openxmlformats.org/presentationml/2006/main" xmlns:c="http://schemas.openxmlformats.org/drawingml/2006/chart" xmlns:dgm="http://schemas.openxmlformats.org/drawingml/2006/diagram" xmlns:o="urn:schemas-microsoft-com:office:office" xmlns:v="urn:schemas-microsoft-com:vml" xmlns:pvml="urn:schemas-microsoft-com:office:powerpoint" xmlns:com="http://schemas.openxmlformats.org/drawingml/2006/compatibility" xmlns:p14="http://schemas.microsoft.com/office/powerpoint/2010/main" xmlns:p15="http://schemas.microsoft.com/office/powerpoint/2012/main" xmlns:ahyp="http://schemas.microsoft.com/office/drawing/2018/hyperlinkcolor">
+<p:sld xmlns:a="http://schemas.openxmlformats.org/drawingml/2006/main" xmlns:p="http://schemas.openxmlformats.org/presentationml/2006/main" xmlns:r="http://schemas.openxmlformats.org/officeDocument/2006/relationships">
   <p:cSld>
     <p:spTree>
       <p:nvGrpSpPr>
-        <p:cNvPr id="317" name="Shape 317"/>
+        <p:cNvPr id="1" name=""/>
         <p:cNvGrpSpPr/>
         <p:nvPr/>
       </p:nvGrpSpPr>
-      <p:grpSpPr>
-        <a:xfrm>
-          <a:off x="0" y="0"/>
-          <a:ext cx="0" cy="0"/>
-          <a:chOff x="0" y="0"/>
-          <a:chExt cx="0" cy="0"/>
-        </a:xfrm>
-      </p:grpSpPr>
+      <p:grpSpPr/>
       <p:sp>
         <p:nvSpPr>
-          <p:cNvPr id="318" name="Google Shape;318;p53"/>
+          <p:cNvPr id="76" name="Google Shape;76;p15"/>
           <p:cNvSpPr txBox="1"/>
           <p:nvPr>
             <p:ph type="title"/>
@@ -20274,7 +20239,7 @@
             </a:pPr>
             <a:r>
               <a:rPr lang="en"/>
-              <a:t>You Made it!</a:t>
+              <a:t>Apply It to Your Project</a:t>
             </a:r>
             <a:endParaRPr/>
           </a:p>
@@ -20282,7 +20247,7 @@
       </p:sp>
       <p:sp>
         <p:nvSpPr>
-          <p:cNvPr id="319" name="Google Shape;319;p53"/>
+          <p:cNvPr id="77" name="Google Shape;77;p15"/>
           <p:cNvSpPr txBox="1"/>
           <p:nvPr>
             <p:ph idx="1" type="body"/>
@@ -20303,51 +20268,75 @@
           </a:bodyPr>
           <a:lstStyle/>
           <a:p>
-            <a:pPr indent="0" lvl="0" marL="0" rtl="0" algn="l">
-              <a:spcBef>
-                <a:spcPts val="0"/>
-              </a:spcBef>
-              <a:spcAft>
-                <a:spcPts val="1200"/>
-              </a:spcAft>
-              <a:buNone/>
+            <a:pPr indent="-330200" lvl="0" marL="457200" rtl="0" algn="l">
+              <a:spcBef>
+                <a:spcPts val="0"/>
+              </a:spcBef>
+              <a:spcAft>
+                <a:spcPts val="0"/>
+              </a:spcAft>
+              <a:buSzPts val="1600"/>
+              <a:buChar char="●"/>
             </a:pPr>
             <a:r>
               <a:rPr lang="en"/>
-              <a:t>Congratulations! You now have your very own working Pong Game made with MonoGame.</a:t>
+              <a:t>Which games would you like to make? Pick two or three candidates</a:t>
+            </a:r>
+            <a:endParaRPr/>
+          </a:p>
+          <a:p>
+            <a:pPr indent="-330200" lvl="0" marL="457200" rtl="0" algn="l">
+              <a:spcBef>
+                <a:spcPts val="0"/>
+              </a:spcBef>
+              <a:spcAft>
+                <a:spcPts val="0"/>
+              </a:spcAft>
+              <a:buSzPts val="1600"/>
+              <a:buChar char="●"/>
+            </a:pPr>
+            <a:r>
+              <a:rPr lang="en"/>
+              <a:t>For each: what updates every frame, and what is drawn?</a:t>
+            </a:r>
+            <a:endParaRPr/>
+          </a:p>
+          <a:p>
+            <a:pPr indent="-317500" lvl="1" marL="914400" rtl="0" algn="l">
+              <a:spcBef>
+                <a:spcPts val="0"/>
+              </a:spcBef>
+              <a:spcAft>
+                <a:spcPts val="0"/>
+              </a:spcAft>
+              <a:buSzPts val="1400"/>
+              <a:buChar char="○"/>
+            </a:pPr>
+            <a:r>
+              <a:rPr lang="en"/>
+              <a:t>That’s its game loop</a:t>
+            </a:r>
+            <a:endParaRPr/>
+          </a:p>
+          <a:p>
+            <a:pPr indent="-330200" lvl="0" marL="457200" rtl="0" algn="l">
+              <a:spcBef>
+                <a:spcPts val="0"/>
+              </a:spcBef>
+              <a:spcAft>
+                <a:spcPts val="0"/>
+              </a:spcAft>
+              <a:buSzPts val="1600"/>
+              <a:buChar char="●"/>
+            </a:pPr>
+            <a:r>
+              <a:rPr lang="en"/>
+              <a:t>Could you build a naive prototype of the core idea first, like this Pong?</a:t>
             </a:r>
             <a:endParaRPr/>
           </a:p>
         </p:txBody>
       </p:sp>
-      <p:pic>
-        <p:nvPicPr>
-          <p:cNvPr id="320" name="Google Shape;320;p53"/>
-          <p:cNvPicPr preferRelativeResize="0"/>
-          <p:nvPr/>
-        </p:nvPicPr>
-        <p:blipFill>
-          <a:blip r:embed="rId3">
-            <a:alphaModFix/>
-          </a:blip>
-          <a:stretch>
-            <a:fillRect/>
-          </a:stretch>
-        </p:blipFill>
-        <p:spPr>
-          <a:xfrm>
-            <a:off x="1066538" y="2195848"/>
-            <a:ext cx="7010925" cy="1403500"/>
-          </a:xfrm>
-          <a:prstGeom prst="rect">
-            <a:avLst/>
-          </a:prstGeom>
-          <a:noFill/>
-          <a:ln>
-            <a:noFill/>
-          </a:ln>
-        </p:spPr>
-      </p:pic>
     </p:spTree>
   </p:cSld>
   <p:clrMapOvr>
@@ -20400,7 +20389,7 @@
             </a:pPr>
             <a:r>
               <a:rPr lang="en"/>
-              <a:t>Apply It to Your Project</a:t>
+              <a:t>Your Course Project</a:t>
             </a:r>
             <a:endParaRPr/>
           </a:p>
@@ -20441,7 +20430,7 @@
             </a:pPr>
             <a:r>
               <a:rPr lang="en"/>
-              <a:t>Which games would you like to make? Pick two or three candidates</a:t>
+              <a:t>Form groups of 1–3 students</a:t>
             </a:r>
             <a:endParaRPr/>
           </a:p>
@@ -20458,7 +20447,7 @@
             </a:pPr>
             <a:r>
               <a:rPr lang="en"/>
-              <a:t>For each: what updates every frame, and what is drawn?</a:t>
+              <a:t>Think of a game you want to create</a:t>
             </a:r>
             <a:endParaRPr/>
           </a:p>
@@ -20475,7 +20464,24 @@
             </a:pPr>
             <a:r>
               <a:rPr lang="en"/>
-              <a:t>That’s its game loop</a:t>
+              <a:t>Take inspiration from classic games!</a:t>
+            </a:r>
+            <a:endParaRPr/>
+          </a:p>
+          <a:p>
+            <a:pPr indent="-317500" lvl="1" marL="914400" rtl="0" algn="l">
+              <a:spcBef>
+                <a:spcPts val="0"/>
+              </a:spcBef>
+              <a:spcAft>
+                <a:spcPts val="0"/>
+              </a:spcAft>
+              <a:buSzPts val="1400"/>
+              <a:buChar char="○"/>
+            </a:pPr>
+            <a:r>
+              <a:rPr lang="en"/>
+              <a:t>Be mindful of scope (creep)</a:t>
             </a:r>
             <a:endParaRPr/>
           </a:p>
@@ -20492,7 +20498,24 @@
             </a:pPr>
             <a:r>
               <a:rPr lang="en"/>
-              <a:t>Could you build a naive prototype of the core idea first, like this Pong?</a:t>
+              <a:t>First milestone, by session 04</a:t>
+            </a:r>
+            <a:endParaRPr/>
+          </a:p>
+          <a:p>
+            <a:pPr indent="-317500" lvl="1" marL="914400" rtl="0" algn="l">
+              <a:spcBef>
+                <a:spcPts val="0"/>
+              </a:spcBef>
+              <a:spcAft>
+                <a:spcPts val="0"/>
+              </a:spcAft>
+              <a:buSzPts val="1400"/>
+              <a:buChar char="○"/>
+            </a:pPr>
+            <a:r>
+              <a:rPr lang="en"/>
+              <a:t>Groups formed, game concept written, repository created</a:t>
             </a:r>
             <a:endParaRPr/>
           </a:p>
@@ -20644,18 +20667,25 @@
 </file>
 
 <file path=ppt/slides/slide50.xml><?xml version="1.0" encoding="utf-8"?>
-<p:sld xmlns:a="http://schemas.openxmlformats.org/drawingml/2006/main" xmlns:p="http://schemas.openxmlformats.org/presentationml/2006/main" xmlns:r="http://schemas.openxmlformats.org/officeDocument/2006/relationships">
+<p:sld xmlns:a="http://schemas.openxmlformats.org/drawingml/2006/main" xmlns:r="http://schemas.openxmlformats.org/officeDocument/2006/relationships" xmlns:mc="http://schemas.openxmlformats.org/markup-compatibility/2006" xmlns:mv="urn:schemas-microsoft-com:mac:vml" xmlns:p="http://schemas.openxmlformats.org/presentationml/2006/main" xmlns:c="http://schemas.openxmlformats.org/drawingml/2006/chart" xmlns:dgm="http://schemas.openxmlformats.org/drawingml/2006/diagram" xmlns:o="urn:schemas-microsoft-com:office:office" xmlns:v="urn:schemas-microsoft-com:vml" xmlns:pvml="urn:schemas-microsoft-com:office:powerpoint" xmlns:com="http://schemas.openxmlformats.org/drawingml/2006/compatibility" xmlns:p14="http://schemas.microsoft.com/office/powerpoint/2010/main" xmlns:p15="http://schemas.microsoft.com/office/powerpoint/2012/main" xmlns:ahyp="http://schemas.microsoft.com/office/drawing/2018/hyperlinkcolor">
   <p:cSld>
     <p:spTree>
       <p:nvGrpSpPr>
-        <p:cNvPr id="1" name=""/>
+        <p:cNvPr id="317" name="Shape 317"/>
         <p:cNvGrpSpPr/>
         <p:nvPr/>
       </p:nvGrpSpPr>
-      <p:grpSpPr/>
+      <p:grpSpPr>
+        <a:xfrm>
+          <a:off x="0" y="0"/>
+          <a:ext cx="0" cy="0"/>
+          <a:chOff x="0" y="0"/>
+          <a:chExt cx="0" cy="0"/>
+        </a:xfrm>
+      </p:grpSpPr>
       <p:sp>
         <p:nvSpPr>
-          <p:cNvPr id="76" name="Google Shape;76;p15"/>
+          <p:cNvPr id="318" name="Google Shape;318;p53"/>
           <p:cNvSpPr txBox="1"/>
           <p:nvPr>
             <p:ph type="title"/>
@@ -20687,7 +20717,7 @@
             </a:pPr>
             <a:r>
               <a:rPr lang="en"/>
-              <a:t>Your Course Project</a:t>
+              <a:t>You Made it!</a:t>
             </a:r>
             <a:endParaRPr/>
           </a:p>
@@ -20695,7 +20725,7 @@
       </p:sp>
       <p:sp>
         <p:nvSpPr>
-          <p:cNvPr id="77" name="Google Shape;77;p15"/>
+          <p:cNvPr id="319" name="Google Shape;319;p53"/>
           <p:cNvSpPr txBox="1"/>
           <p:nvPr>
             <p:ph idx="1" type="body"/>
@@ -20716,109 +20746,51 @@
           </a:bodyPr>
           <a:lstStyle/>
           <a:p>
-            <a:pPr indent="-330200" lvl="0" marL="457200" rtl="0" algn="l">
-              <a:spcBef>
-                <a:spcPts val="0"/>
-              </a:spcBef>
-              <a:spcAft>
-                <a:spcPts val="0"/>
-              </a:spcAft>
-              <a:buSzPts val="1600"/>
-              <a:buChar char="●"/>
+            <a:pPr indent="0" lvl="0" marL="0" rtl="0" algn="l">
+              <a:spcBef>
+                <a:spcPts val="0"/>
+              </a:spcBef>
+              <a:spcAft>
+                <a:spcPts val="1200"/>
+              </a:spcAft>
+              <a:buNone/>
             </a:pPr>
             <a:r>
               <a:rPr lang="en"/>
-              <a:t>Form groups of 1–3 students</a:t>
-            </a:r>
-            <a:endParaRPr/>
-          </a:p>
-          <a:p>
-            <a:pPr indent="-330200" lvl="0" marL="457200" rtl="0" algn="l">
-              <a:spcBef>
-                <a:spcPts val="0"/>
-              </a:spcBef>
-              <a:spcAft>
-                <a:spcPts val="0"/>
-              </a:spcAft>
-              <a:buSzPts val="1600"/>
-              <a:buChar char="●"/>
-            </a:pPr>
-            <a:r>
-              <a:rPr lang="en"/>
-              <a:t>Think of a game you want to create</a:t>
-            </a:r>
-            <a:endParaRPr/>
-          </a:p>
-          <a:p>
-            <a:pPr indent="-317500" lvl="1" marL="914400" rtl="0" algn="l">
-              <a:spcBef>
-                <a:spcPts val="0"/>
-              </a:spcBef>
-              <a:spcAft>
-                <a:spcPts val="0"/>
-              </a:spcAft>
-              <a:buSzPts val="1400"/>
-              <a:buChar char="○"/>
-            </a:pPr>
-            <a:r>
-              <a:rPr lang="en"/>
-              <a:t>Take inspiration from classic games!</a:t>
-            </a:r>
-            <a:endParaRPr/>
-          </a:p>
-          <a:p>
-            <a:pPr indent="-317500" lvl="1" marL="914400" rtl="0" algn="l">
-              <a:spcBef>
-                <a:spcPts val="0"/>
-              </a:spcBef>
-              <a:spcAft>
-                <a:spcPts val="0"/>
-              </a:spcAft>
-              <a:buSzPts val="1400"/>
-              <a:buChar char="○"/>
-            </a:pPr>
-            <a:r>
-              <a:rPr lang="en"/>
-              <a:t>Be mindful of scope (creep)</a:t>
-            </a:r>
-            <a:endParaRPr/>
-          </a:p>
-          <a:p>
-            <a:pPr indent="-330200" lvl="0" marL="457200" rtl="0" algn="l">
-              <a:spcBef>
-                <a:spcPts val="0"/>
-              </a:spcBef>
-              <a:spcAft>
-                <a:spcPts val="0"/>
-              </a:spcAft>
-              <a:buSzPts val="1600"/>
-              <a:buChar char="●"/>
-            </a:pPr>
-            <a:r>
-              <a:rPr lang="en"/>
-              <a:t>First milestone, by session 04</a:t>
-            </a:r>
-            <a:endParaRPr/>
-          </a:p>
-          <a:p>
-            <a:pPr indent="-317500" lvl="1" marL="914400" rtl="0" algn="l">
-              <a:spcBef>
-                <a:spcPts val="0"/>
-              </a:spcBef>
-              <a:spcAft>
-                <a:spcPts val="0"/>
-              </a:spcAft>
-              <a:buSzPts val="1400"/>
-              <a:buChar char="○"/>
-            </a:pPr>
-            <a:r>
-              <a:rPr lang="en"/>
-              <a:t>Groups formed, game concept written, repository created</a:t>
+              <a:t>Congratulations! You now have your very own working Pong Game made with MonoGame.</a:t>
             </a:r>
             <a:endParaRPr/>
           </a:p>
         </p:txBody>
       </p:sp>
+      <p:pic>
+        <p:nvPicPr>
+          <p:cNvPr id="320" name="Google Shape;320;p53"/>
+          <p:cNvPicPr preferRelativeResize="0"/>
+          <p:nvPr/>
+        </p:nvPicPr>
+        <p:blipFill>
+          <a:blip r:embed="rId3">
+            <a:alphaModFix/>
+          </a:blip>
+          <a:stretch>
+            <a:fillRect/>
+          </a:stretch>
+        </p:blipFill>
+        <p:spPr>
+          <a:xfrm>
+            <a:off x="1066538" y="2195848"/>
+            <a:ext cx="7010925" cy="1403500"/>
+          </a:xfrm>
+          <a:prstGeom prst="rect">
+            <a:avLst/>
+          </a:prstGeom>
+          <a:noFill/>
+          <a:ln>
+            <a:noFill/>
+          </a:ln>
+        </p:spPr>
+      </p:pic>
     </p:spTree>
   </p:cSld>
   <p:clrMapOvr>

</xml_diff>

<commit_message>
Pong and Flappy Bird decks: same essentials, different form
Pong: MonoGame as boxes and a question, Update vs. Draw as a diagram,
the two timesteps side by side, the serve state as a state diagram,
SoundEffect vs. Song, the exam as a flow. Flappy Bird: every exercise
slide becomes a goal, a hint and a screenshot of the step's result,
the bird's texture becomes a design question with four options, and
the input classes a diagram. The old text is in the speaker notes;
both decks end with the site's Check yourself questions.

Co-Authored-By: Claude Opus 5.5 <noreply@anthropic.com>
Claude-Session: https://claude.ai/code/session_012sjsUQBbC7zon57rWHoo9d
</commit_message>
<xml_diff>
--- a/slides/01 Pong.pptx
+++ b/slides/01 Pong.pptx
@@ -55,6 +55,7 @@
     <p:sldId id="297" r:id="rId47"/>
     <p:sldId id="298" r:id="rId48"/>
     <p:sldId id="299" r:id="rId49"/>
+    <p:sldId id="306" r:id="rId65"/>
     <p:sldId id="304" r:id="rId63"/>
     <p:sldId id="305" r:id="rId64"/>
     <p:sldId id="300" r:id="rId50"/>
@@ -929,19 +930,19 @@
           </a:bodyPr>
           <a:lstStyle/>
           <a:p>
-            <a:pPr indent="0" lvl="0" marL="0" rtl="0" algn="l">
-              <a:spcBef>
-                <a:spcPts val="0"/>
-              </a:spcBef>
-              <a:spcAft>
-                <a:spcPts val="0"/>
-              </a:spcAft>
-              <a:buNone/>
-            </a:pPr>
-            <a:r>
-              <a:t/>
-            </a:r>
-            <a:endParaRPr/>
+            <a:r>
+              <a:t>Talking points:</a:t>
+            </a:r>
+          </a:p>
+          <a:p>
+            <a:r>
+              <a:t>- The goal of the project is to create a simple 2D game that uses best practices for organizing and architecting a game project. That is, the project must include gameplay systems and design elements solved through patterns and principles taught in the course.</a:t>
+            </a:r>
+          </a:p>
+          <a:p>
+            <a:r>
+              <a:t>- Details on the course website</a:t>
+            </a:r>
           </a:p>
         </p:txBody>
       </p:sp>
@@ -1028,19 +1029,24 @@
           </a:bodyPr>
           <a:lstStyle/>
           <a:p>
-            <a:pPr indent="0" lvl="0" marL="0" rtl="0" algn="l">
-              <a:spcBef>
-                <a:spcPts val="0"/>
-              </a:spcBef>
-              <a:spcAft>
-                <a:spcPts val="0"/>
-              </a:spcAft>
-              <a:buNone/>
-            </a:pPr>
-            <a:r>
-              <a:t/>
-            </a:r>
-            <a:endParaRPr/>
+            <a:r>
+              <a:t>Talking points:</a:t>
+            </a:r>
+          </a:p>
+          <a:p>
+            <a:r>
+              <a:t>- Individual oral exam, 20 minutes, without preparation.</a:t>
+            </a:r>
+          </a:p>
+          <a:p>
+            <a:r>
+              <a:t>- The student will draw from a pool of known questions and is expected to reference their course project as part of the answer. This involves analyzing source code, as well as potentially writing or modifying source code during the exam. The final grade will be based on an overall assessment of the project presented and the oral examination.</a:t>
+            </a:r>
+          </a:p>
+          <a:p>
+            <a:r>
+              <a:t>- Internal assessment.</a:t>
+            </a:r>
           </a:p>
         </p:txBody>
       </p:sp>
@@ -1424,19 +1430,64 @@
           </a:bodyPr>
           <a:lstStyle/>
           <a:p>
-            <a:pPr indent="0" lvl="0" marL="0" rtl="0" algn="l">
-              <a:spcBef>
-                <a:spcPts val="0"/>
-              </a:spcBef>
-              <a:spcAft>
-                <a:spcPts val="0"/>
-              </a:spcAft>
-              <a:buNone/>
-            </a:pPr>
-            <a:r>
-              <a:t/>
-            </a:r>
-            <a:endParaRPr/>
+            <a:r>
+              <a:t>Talking points:</a:t>
+            </a:r>
+          </a:p>
+          <a:p>
+            <a:r>
+              <a:t>- At its core, MonoGame offers a set of libraries and APIs to handle common game development tasks</a:t>
+            </a:r>
+          </a:p>
+          <a:p>
+            <a:r>
+              <a:t>- Graphics Rendering</a:t>
+            </a:r>
+          </a:p>
+          <a:p>
+            <a:r>
+              <a:t>  - 2D and 3D rendering are supported through the graphics API offered by MonoGame</a:t>
+            </a:r>
+          </a:p>
+          <a:p>
+            <a:r>
+              <a:t>- Input Handling</a:t>
+            </a:r>
+          </a:p>
+          <a:p>
+            <a:r>
+              <a:t>  - Input from keyboard, mouse, gamepads, and touchscreens is supported</a:t>
+            </a:r>
+          </a:p>
+          <a:p>
+            <a:r>
+              <a:t>- Audio</a:t>
+            </a:r>
+          </a:p>
+          <a:p>
+            <a:r>
+              <a:t>  - A comprehensive audio system that can be used to create sound effects as well as play music</a:t>
+            </a:r>
+          </a:p>
+          <a:p>
+            <a:r>
+              <a:t>- Content Pipeline</a:t>
+            </a:r>
+          </a:p>
+          <a:p>
+            <a:r>
+              <a:t>  - An out-of-the-box workflow for importing and processing game assets</a:t>
+            </a:r>
+          </a:p>
+          <a:p>
+            <a:r>
+              <a:t>- Math Library</a:t>
+            </a:r>
+          </a:p>
+          <a:p>
+            <a:r>
+              <a:t>  - A math library specifically optimized for game development</a:t>
+            </a:r>
           </a:p>
         </p:txBody>
       </p:sp>
@@ -4196,19 +4247,39 @@
           </a:bodyPr>
           <a:lstStyle/>
           <a:p>
-            <a:pPr indent="0" lvl="0" marL="0" rtl="0" algn="l">
-              <a:spcBef>
-                <a:spcPts val="0"/>
-              </a:spcBef>
-              <a:spcAft>
-                <a:spcPts val="0"/>
-              </a:spcAft>
-              <a:buNone/>
-            </a:pPr>
-            <a:r>
-              <a:t/>
-            </a:r>
-            <a:endParaRPr/>
+            <a:r>
+              <a:t>Talking points:</a:t>
+            </a:r>
+          </a:p>
+          <a:p>
+            <a:r>
+              <a:t>- Add a new Serve state to the game</a:t>
+            </a:r>
+          </a:p>
+          <a:p>
+            <a:r>
+              <a:t>  - When a player is serving, they send the ball towards the other player</a:t>
+            </a:r>
+          </a:p>
+          <a:p>
+            <a:r>
+              <a:t>  - The player who was last scored on gets to serve (random player at game start)</a:t>
+            </a:r>
+          </a:p>
+          <a:p>
+            <a:r>
+              <a:t>  - We transition from “play” to “serve” state when scoring</a:t>
+            </a:r>
+          </a:p>
+          <a:p>
+            <a:r>
+              <a:t>  - And from “serve” state to “play” state when pressing “Enter”</a:t>
+            </a:r>
+          </a:p>
+          <a:p>
+            <a:r>
+              <a:t>  - The game begins in the “start” state and transitions to the “serve” state by pressing “Enter”</a:t>
+            </a:r>
           </a:p>
         </p:txBody>
       </p:sp>
@@ -4394,19 +4465,44 @@
           </a:bodyPr>
           <a:lstStyle/>
           <a:p>
-            <a:pPr indent="0" lvl="0" marL="0" rtl="0" algn="l">
-              <a:spcBef>
-                <a:spcPts val="0"/>
-              </a:spcBef>
-              <a:spcAft>
-                <a:spcPts val="0"/>
-              </a:spcAft>
-              <a:buNone/>
-            </a:pPr>
-            <a:r>
-              <a:t/>
-            </a:r>
-            <a:endParaRPr/>
+            <a:r>
+              <a:t>Talking points:</a:t>
+            </a:r>
+          </a:p>
+          <a:p>
+            <a:r>
+              <a:t>- The SoundEffect class handles short audio clips</a:t>
+            </a:r>
+          </a:p>
+          <a:p>
+            <a:r>
+              <a:t>  - collisions, jumping, shooting, button clicks, footsteps, ambient sounds, etc.</a:t>
+            </a:r>
+          </a:p>
+          <a:p>
+            <a:r>
+              <a:t>- The key characteristics of sound effects are</a:t>
+            </a:r>
+          </a:p>
+          <a:p>
+            <a:r>
+              <a:t>- Loaded entirely into memory for quick access</a:t>
+            </a:r>
+          </a:p>
+          <a:p>
+            <a:r>
+              <a:t>- Can play multiple instances simultaneously</a:t>
+            </a:r>
+          </a:p>
+          <a:p>
+            <a:r>
+              <a:t>- Individual volume control per instance</a:t>
+            </a:r>
+          </a:p>
+          <a:p>
+            <a:r>
+              <a:t>- For longer playing audio, the Song class is used (but not today…)</a:t>
+            </a:r>
           </a:p>
         </p:txBody>
       </p:sp>
@@ -4704,6 +4800,260 @@
               <a:t/>
             </a:r>
             <a:endParaRPr/>
+          </a:p>
+        </p:txBody>
+      </p:sp>
+    </p:spTree>
+  </p:cSld>
+  <p:clrMapOvr>
+    <a:masterClrMapping/>
+  </p:clrMapOvr>
+</p:notes>
+</file>
+
+<file path=ppt/notesSlides/notesSlide46.xml><?xml version="1.0" encoding="utf-8"?>
+<p:notes xmlns:a="http://schemas.openxmlformats.org/drawingml/2006/main" xmlns:p="http://schemas.openxmlformats.org/presentationml/2006/main" xmlns:r="http://schemas.openxmlformats.org/officeDocument/2006/relationships">
+  <p:cSld>
+    <p:spTree>
+      <p:nvGrpSpPr>
+        <p:cNvPr id="1" name=""/>
+        <p:cNvGrpSpPr/>
+        <p:nvPr/>
+      </p:nvGrpSpPr>
+      <p:grpSpPr>
+        <a:xfrm>
+          <a:off x="0" y="0"/>
+          <a:ext cx="0" cy="0"/>
+          <a:chOff x="0" y="0"/>
+          <a:chExt cx="0" cy="0"/>
+        </a:xfrm>
+      </p:grpSpPr>
+      <p:sp>
+        <p:nvSpPr>
+          <p:cNvPr id="2" name="Slide Image Placeholder 1"/>
+          <p:cNvSpPr>
+            <a:spLocks noGrp="1"/>
+          </p:cNvSpPr>
+          <p:nvPr>
+            <p:ph type="sldImg" idx="2"/>
+          </p:nvPr>
+        </p:nvSpPr>
+        <p:spPr/>
+      </p:sp>
+      <p:sp>
+        <p:nvSpPr>
+          <p:cNvPr id="3" name="Notes Placeholder 2"/>
+          <p:cNvSpPr>
+            <a:spLocks noGrp="1"/>
+          </p:cNvSpPr>
+          <p:nvPr>
+            <p:ph type="body" idx="1"/>
+          </p:nvPr>
+        </p:nvSpPr>
+        <p:spPr/>
+        <p:txBody>
+          <a:bodyPr/>
+          <a:lstStyle/>
+          <a:p>
+            <a:r>
+              <a:t>Talking points:</a:t>
+            </a:r>
+          </a:p>
+          <a:p>
+            <a:r>
+              <a:t>- Update changes the state of the world</a:t>
+            </a:r>
+          </a:p>
+          <a:p>
+            <a:r>
+              <a:t>  - Input, movement, collisions, game rules</a:t>
+            </a:r>
+          </a:p>
+          <a:p>
+            <a:r>
+              <a:t>- Draw only reads that state and renders it</a:t>
+            </a:r>
+          </a:p>
+          <a:p>
+            <a:r>
+              <a:t>  - Never change game state in Draw</a:t>
+            </a:r>
+          </a:p>
+          <a:p>
+            <a:r>
+              <a:t>- Keeping them apart lets the simulation and the rendering run at different rates</a:t>
+            </a:r>
+          </a:p>
+          <a:p>
+            <a:r>
+              <a:t>- Double buffer</a:t>
+            </a:r>
+          </a:p>
+          <a:p>
+            <a:r>
+              <a:t>  - We draw into a back buffer that isn't visible</a:t>
+            </a:r>
+          </a:p>
+          <a:p>
+            <a:r>
+              <a:t>  - At the end of Draw, MonoGame presents it: the player never sees a half-drawn frame</a:t>
+            </a:r>
+          </a:p>
+        </p:txBody>
+      </p:sp>
+    </p:spTree>
+  </p:cSld>
+  <p:clrMapOvr>
+    <a:masterClrMapping/>
+  </p:clrMapOvr>
+</p:notes>
+</file>
+
+<file path=ppt/notesSlides/notesSlide47.xml><?xml version="1.0" encoding="utf-8"?>
+<p:notes xmlns:a="http://schemas.openxmlformats.org/drawingml/2006/main" xmlns:p="http://schemas.openxmlformats.org/presentationml/2006/main" xmlns:r="http://schemas.openxmlformats.org/officeDocument/2006/relationships">
+  <p:cSld>
+    <p:spTree>
+      <p:nvGrpSpPr>
+        <p:cNvPr id="1" name=""/>
+        <p:cNvGrpSpPr/>
+        <p:nvPr/>
+      </p:nvGrpSpPr>
+      <p:grpSpPr>
+        <a:xfrm>
+          <a:off x="0" y="0"/>
+          <a:ext cx="0" cy="0"/>
+          <a:chOff x="0" y="0"/>
+          <a:chExt cx="0" cy="0"/>
+        </a:xfrm>
+      </p:grpSpPr>
+      <p:sp>
+        <p:nvSpPr>
+          <p:cNvPr id="2" name="Slide Image Placeholder 1"/>
+          <p:cNvSpPr>
+            <a:spLocks noGrp="1"/>
+          </p:cNvSpPr>
+          <p:nvPr>
+            <p:ph type="sldImg" idx="2"/>
+          </p:nvPr>
+        </p:nvSpPr>
+        <p:spPr/>
+      </p:sp>
+      <p:sp>
+        <p:nvSpPr>
+          <p:cNvPr id="3" name="Notes Placeholder 2"/>
+          <p:cNvSpPr>
+            <a:spLocks noGrp="1"/>
+          </p:cNvSpPr>
+          <p:nvPr>
+            <p:ph type="body" idx="1"/>
+          </p:nvPr>
+        </p:nvSpPr>
+        <p:spPr/>
+        <p:txBody>
+          <a:bodyPr/>
+          <a:lstStyle/>
+          <a:p>
+            <a:r>
+              <a:t>Talking points:</a:t>
+            </a:r>
+          </a:p>
+          <a:p>
+            <a:r>
+              <a:t>- Variable timestep</a:t>
+            </a:r>
+          </a:p>
+          <a:p>
+            <a:r>
+              <a:t>  - One Update per rendered frame, movement scaled by deltaTime</a:t>
+            </a:r>
+          </a:p>
+          <a:p>
+            <a:r>
+              <a:t>  - Simple, but the simulation behaves slightly differently at different frame rates</a:t>
+            </a:r>
+          </a:p>
+          <a:p>
+            <a:r>
+              <a:t>- Fixed timestep</a:t>
+            </a:r>
+          </a:p>
+          <a:p>
+            <a:r>
+              <a:t>  - Update in fixed-size steps (e.g. 60 per second): zero, one or several per frame</a:t>
+            </a:r>
+          </a:p>
+          <a:p>
+            <a:r>
+              <a:t>  - Deterministic and stable, at the cost of some complexity</a:t>
+            </a:r>
+          </a:p>
+          <a:p>
+            <a:r>
+              <a:t>- MonoGame uses a fixed timestep by default (IsFixedTimeStep = true)</a:t>
+            </a:r>
+          </a:p>
+          <a:p>
+            <a:r>
+              <a:t>- Try it: the game loop demo on the course site</a:t>
+            </a:r>
+          </a:p>
+        </p:txBody>
+      </p:sp>
+    </p:spTree>
+  </p:cSld>
+  <p:clrMapOvr>
+    <a:masterClrMapping/>
+  </p:clrMapOvr>
+</p:notes>
+</file>
+
+<file path=ppt/notesSlides/notesSlide48.xml><?xml version="1.0" encoding="utf-8"?>
+<p:notes xmlns:a="http://schemas.openxmlformats.org/drawingml/2006/main" xmlns:p="http://schemas.openxmlformats.org/presentationml/2006/main" xmlns:r="http://schemas.openxmlformats.org/officeDocument/2006/relationships">
+  <p:cSld>
+    <p:spTree>
+      <p:nvGrpSpPr>
+        <p:cNvPr id="1" name=""/>
+        <p:cNvGrpSpPr/>
+        <p:nvPr/>
+      </p:nvGrpSpPr>
+      <p:grpSpPr>
+        <a:xfrm>
+          <a:off x="0" y="0"/>
+          <a:ext cx="0" cy="0"/>
+          <a:chOff x="0" y="0"/>
+          <a:chExt cx="0" cy="0"/>
+        </a:xfrm>
+      </p:grpSpPr>
+      <p:sp>
+        <p:nvSpPr>
+          <p:cNvPr id="2" name="Slide Image Placeholder 1"/>
+          <p:cNvSpPr>
+            <a:spLocks noGrp="1"/>
+          </p:cNvSpPr>
+          <p:nvPr>
+            <p:ph type="sldImg" idx="2"/>
+          </p:nvPr>
+        </p:nvSpPr>
+        <p:spPr/>
+      </p:sp>
+      <p:sp>
+        <p:nvSpPr>
+          <p:cNvPr id="3" name="Notes Placeholder 2"/>
+          <p:cNvSpPr>
+            <a:spLocks noGrp="1"/>
+          </p:cNvSpPr>
+          <p:nvPr>
+            <p:ph type="body" idx="1"/>
+          </p:nvPr>
+        </p:nvSpPr>
+        <p:spPr/>
+        <p:txBody>
+          <a:bodyPr/>
+          <a:lstStyle/>
+          <a:p>
+            <a:r>
+              <a:t>Ask, let them answer in pairs for a minute, then take a few answers. These are the site’s Check yourself questions.</a:t>
+            </a:r>
           </a:p>
         </p:txBody>
       </p:sp>
@@ -8939,7 +9289,7 @@
         <p:spPr>
           <a:xfrm>
             <a:off x="311700" y="885950"/>
-            <a:ext cx="8520600" cy="4023300"/>
+            <a:ext cx="8520600" cy="905256"/>
           </a:xfrm>
           <a:prstGeom prst="rect">
             <a:avLst/>
@@ -8951,50 +9301,36 @@
           </a:bodyPr>
           <a:lstStyle/>
           <a:p>
-            <a:pPr indent="0" lvl="0" marL="0" rtl="0" algn="l">
-              <a:spcBef>
-                <a:spcPts val="0"/>
-              </a:spcBef>
-              <a:spcAft>
-                <a:spcPts val="0"/>
-              </a:spcAft>
-              <a:buNone/>
+            <a:pPr indent="-330200" lvl="0" marL="457200" rtl="0" algn="l">
+              <a:spcBef>
+                <a:spcPts val="0"/>
+              </a:spcBef>
+              <a:spcAft>
+                <a:spcPts val="0"/>
+              </a:spcAft>
+              <a:buSzPts val="1600"/>
+              <a:buChar char="●"/>
             </a:pPr>
             <a:r>
               <a:rPr lang="en"/>
-              <a:t>The goal of the project is to create a simple 2D game that uses best practices for organizing and architecting a game project. That is, the project must include gameplay systems and design elements solved through patterns and principles taught in the course.</a:t>
+              <a:t>Build a simple 2D game, organized with the course’s patterns and principles.</a:t>
             </a:r>
             <a:endParaRPr/>
           </a:p>
           <a:p>
-            <a:pPr indent="0" lvl="0" marL="0" rtl="0" algn="l">
-              <a:spcBef>
-                <a:spcPts val="1200"/>
-              </a:spcBef>
-              <a:spcAft>
-                <a:spcPts val="0"/>
-              </a:spcAft>
-              <a:buNone/>
-            </a:pPr>
-            <a:r>
-              <a:rPr/>
-              <a:t/>
-            </a:r>
-            <a:endParaRPr/>
-          </a:p>
-          <a:p>
-            <a:pPr indent="0" lvl="0" marL="0" rtl="0" algn="l">
-              <a:spcBef>
-                <a:spcPts val="1200"/>
-              </a:spcBef>
-              <a:spcAft>
-                <a:spcPts val="1200"/>
-              </a:spcAft>
-              <a:buNone/>
+            <a:pPr indent="-330200" lvl="0" marL="457200" rtl="0" algn="l">
+              <a:spcBef>
+                <a:spcPts val="0"/>
+              </a:spcBef>
+              <a:spcAft>
+                <a:spcPts val="0"/>
+              </a:spcAft>
+              <a:buSzPts val="1600"/>
+              <a:buChar char="●"/>
             </a:pPr>
             <a:r>
               <a:rPr lang="en"/>
-              <a:t>Details on the course website</a:t>
+              <a:t>Groups, milestones and the requirements: on the course site.</a:t>
             </a:r>
             <a:endParaRPr/>
           </a:p>
@@ -9076,7 +9412,7 @@
         <p:spPr>
           <a:xfrm>
             <a:off x="311700" y="885950"/>
-            <a:ext cx="8520600" cy="4023300"/>
+            <a:ext cx="8520600" cy="905256"/>
           </a:xfrm>
           <a:prstGeom prst="rect">
             <a:avLst/>
@@ -9088,52 +9424,398 @@
           </a:bodyPr>
           <a:lstStyle/>
           <a:p>
-            <a:pPr indent="0" lvl="0" marL="0" rtl="0" algn="l">
-              <a:spcBef>
-                <a:spcPts val="0"/>
-              </a:spcBef>
-              <a:spcAft>
-                <a:spcPts val="0"/>
-              </a:spcAft>
-              <a:buNone/>
+            <a:pPr indent="-330200" lvl="0" marL="457200" rtl="0" algn="l">
+              <a:spcBef>
+                <a:spcPts val="0"/>
+              </a:spcBef>
+              <a:spcAft>
+                <a:spcPts val="0"/>
+              </a:spcAft>
+              <a:buSzPts val="1600"/>
+              <a:buChar char="●"/>
             </a:pPr>
             <a:r>
               <a:rPr lang="en"/>
-              <a:t>Individual oral exam, 20 minutes, without preparation.</a:t>
+              <a:t>Oral exam, 20 minutes: draw a question from a known pool.</a:t>
             </a:r>
             <a:endParaRPr/>
           </a:p>
           <a:p>
-            <a:pPr indent="0" lvl="0" marL="0" rtl="0" algn="l">
-              <a:spcBef>
-                <a:spcPts val="1200"/>
-              </a:spcBef>
-              <a:spcAft>
-                <a:spcPts val="0"/>
-              </a:spcAft>
-              <a:buNone/>
+            <a:pPr indent="-330200" lvl="0" marL="457200" rtl="0" algn="l">
+              <a:spcBef>
+                <a:spcPts val="0"/>
+              </a:spcBef>
+              <a:spcAft>
+                <a:spcPts val="0"/>
+              </a:spcAft>
+              <a:buSzPts val="1600"/>
+              <a:buChar char="●"/>
             </a:pPr>
             <a:r>
               <a:rPr lang="en"/>
-              <a:t>The student will draw from a pool of known questions and is expected to reference their course project as part of the answer. This involves analyzing source code, as well as potentially writing or modifying source code during the exam. The final grade will be based on an overall assessment of the project presented and the oral examination.</a:t>
+              <a:t>Answer it with your own project: read, explain and change its code.</a:t>
             </a:r>
             <a:endParaRPr/>
           </a:p>
-          <a:p>
-            <a:pPr indent="0" lvl="0" marL="0" rtl="0" algn="l">
-              <a:spcBef>
-                <a:spcPts val="1200"/>
-              </a:spcBef>
-              <a:spcAft>
-                <a:spcPts val="1200"/>
-              </a:spcAft>
-              <a:buNone/>
-            </a:pPr>
-            <a:r>
-              <a:rPr lang="en"/>
-              <a:t>Internal assessment.</a:t>
-            </a:r>
-            <a:endParaRPr/>
+        </p:txBody>
+      </p:sp>
+      <p:sp>
+        <p:nvSpPr>
+          <p:cNvPr id="102" name="Rounded Rectangle 101"/>
+          <p:cNvSpPr/>
+          <p:nvPr/>
+        </p:nvSpPr>
+        <p:spPr>
+          <a:xfrm>
+            <a:off x="411480" y="2011680"/>
+            <a:ext cx="1874519" cy="685800"/>
+          </a:xfrm>
+          <a:prstGeom prst="roundRect">
+            <a:avLst>
+              <a:gd name="adj" fmla="val 12000"/>
+            </a:avLst>
+          </a:prstGeom>
+          <a:solidFill>
+            <a:srgbClr val="2E3338"/>
+          </a:solidFill>
+          <a:ln w="25400">
+            <a:solidFill>
+              <a:srgbClr val="D45D35"/>
+            </a:solidFill>
+          </a:ln>
+          <a:effectLst/>
+        </p:spPr>
+        <p:style>
+          <a:lnRef idx="1">
+            <a:schemeClr val="accent1"/>
+          </a:lnRef>
+          <a:fillRef idx="3">
+            <a:schemeClr val="accent1"/>
+          </a:fillRef>
+          <a:effectRef idx="2">
+            <a:schemeClr val="accent1"/>
+          </a:effectRef>
+          <a:fontRef idx="minor">
+            <a:schemeClr val="lt1"/>
+          </a:fontRef>
+        </p:style>
+        <p:txBody>
+          <a:bodyPr rtlCol="0" anchor="ctr" wrap="square" lIns="73152" rIns="73152"/>
+          <a:lstStyle/>
+          <a:p>
+            <a:pPr algn="ctr"/>
+            <a:r>
+              <a:rPr sz="1400" b="1">
+                <a:solidFill>
+                  <a:srgbClr val="DEE2E6"/>
+                </a:solidFill>
+              </a:rPr>
+              <a:t>Draw a question</a:t>
+            </a:r>
+          </a:p>
+        </p:txBody>
+      </p:sp>
+      <p:cxnSp>
+        <p:nvCxnSpPr>
+          <p:cNvPr id="103" name="Connector 102"/>
+          <p:cNvCxnSpPr/>
+          <p:nvPr/>
+        </p:nvCxnSpPr>
+        <p:spPr>
+          <a:xfrm>
+            <a:off x="2304288" y="2354580"/>
+            <a:ext cx="237744" cy="0"/>
+          </a:xfrm>
+          <a:prstGeom prst="line">
+            <a:avLst/>
+          </a:prstGeom>
+          <a:ln w="25400">
+            <a:solidFill>
+              <a:srgbClr val="9AA3AB"/>
+            </a:solidFill>
+            <a:tailEnd type="triangle"/>
+          </a:ln>
+        </p:spPr>
+        <p:style>
+          <a:lnRef idx="2">
+            <a:schemeClr val="accent1"/>
+          </a:lnRef>
+          <a:fillRef idx="0">
+            <a:schemeClr val="accent1"/>
+          </a:fillRef>
+          <a:effectRef idx="1">
+            <a:schemeClr val="accent1"/>
+          </a:effectRef>
+          <a:fontRef idx="minor">
+            <a:schemeClr val="tx1"/>
+          </a:fontRef>
+        </p:style>
+      </p:cxnSp>
+      <p:sp>
+        <p:nvSpPr>
+          <p:cNvPr id="104" name="Rounded Rectangle 103"/>
+          <p:cNvSpPr/>
+          <p:nvPr/>
+        </p:nvSpPr>
+        <p:spPr>
+          <a:xfrm>
+            <a:off x="2560320" y="2011680"/>
+            <a:ext cx="1874519" cy="685800"/>
+          </a:xfrm>
+          <a:prstGeom prst="roundRect">
+            <a:avLst>
+              <a:gd name="adj" fmla="val 12000"/>
+            </a:avLst>
+          </a:prstGeom>
+          <a:solidFill>
+            <a:srgbClr val="2E3338"/>
+          </a:solidFill>
+          <a:ln>
+            <a:noFill/>
+          </a:ln>
+          <a:effectLst/>
+        </p:spPr>
+        <p:style>
+          <a:lnRef idx="1">
+            <a:schemeClr val="accent1"/>
+          </a:lnRef>
+          <a:fillRef idx="3">
+            <a:schemeClr val="accent1"/>
+          </a:fillRef>
+          <a:effectRef idx="2">
+            <a:schemeClr val="accent1"/>
+          </a:effectRef>
+          <a:fontRef idx="minor">
+            <a:schemeClr val="lt1"/>
+          </a:fontRef>
+        </p:style>
+        <p:txBody>
+          <a:bodyPr rtlCol="0" anchor="ctr" wrap="square" lIns="73152" rIns="73152"/>
+          <a:lstStyle/>
+          <a:p>
+            <a:pPr algn="ctr"/>
+            <a:r>
+              <a:rPr sz="1400" b="1">
+                <a:solidFill>
+                  <a:srgbClr val="DEE2E6"/>
+                </a:solidFill>
+              </a:rPr>
+              <a:t>Explain the idea</a:t>
+            </a:r>
+          </a:p>
+        </p:txBody>
+      </p:sp>
+      <p:cxnSp>
+        <p:nvCxnSpPr>
+          <p:cNvPr id="105" name="Connector 104"/>
+          <p:cNvCxnSpPr/>
+          <p:nvPr/>
+        </p:nvCxnSpPr>
+        <p:spPr>
+          <a:xfrm>
+            <a:off x="4453127" y="2354580"/>
+            <a:ext cx="237745" cy="0"/>
+          </a:xfrm>
+          <a:prstGeom prst="line">
+            <a:avLst/>
+          </a:prstGeom>
+          <a:ln w="25400">
+            <a:solidFill>
+              <a:srgbClr val="9AA3AB"/>
+            </a:solidFill>
+            <a:tailEnd type="triangle"/>
+          </a:ln>
+        </p:spPr>
+        <p:style>
+          <a:lnRef idx="2">
+            <a:schemeClr val="accent1"/>
+          </a:lnRef>
+          <a:fillRef idx="0">
+            <a:schemeClr val="accent1"/>
+          </a:fillRef>
+          <a:effectRef idx="1">
+            <a:schemeClr val="accent1"/>
+          </a:effectRef>
+          <a:fontRef idx="minor">
+            <a:schemeClr val="tx1"/>
+          </a:fontRef>
+        </p:style>
+      </p:cxnSp>
+      <p:sp>
+        <p:nvSpPr>
+          <p:cNvPr id="106" name="Rounded Rectangle 105"/>
+          <p:cNvSpPr/>
+          <p:nvPr/>
+        </p:nvSpPr>
+        <p:spPr>
+          <a:xfrm>
+            <a:off x="4709159" y="2011680"/>
+            <a:ext cx="1874519" cy="685800"/>
+          </a:xfrm>
+          <a:prstGeom prst="roundRect">
+            <a:avLst>
+              <a:gd name="adj" fmla="val 12000"/>
+            </a:avLst>
+          </a:prstGeom>
+          <a:solidFill>
+            <a:srgbClr val="2E3338"/>
+          </a:solidFill>
+          <a:ln>
+            <a:noFill/>
+          </a:ln>
+          <a:effectLst/>
+        </p:spPr>
+        <p:style>
+          <a:lnRef idx="1">
+            <a:schemeClr val="accent1"/>
+          </a:lnRef>
+          <a:fillRef idx="3">
+            <a:schemeClr val="accent1"/>
+          </a:fillRef>
+          <a:effectRef idx="2">
+            <a:schemeClr val="accent1"/>
+          </a:effectRef>
+          <a:fontRef idx="minor">
+            <a:schemeClr val="lt1"/>
+          </a:fontRef>
+        </p:style>
+        <p:txBody>
+          <a:bodyPr rtlCol="0" anchor="ctr" wrap="square" lIns="73152" rIns="73152"/>
+          <a:lstStyle/>
+          <a:p>
+            <a:pPr algn="ctr"/>
+            <a:r>
+              <a:rPr sz="1400" b="1">
+                <a:solidFill>
+                  <a:srgbClr val="DEE2E6"/>
+                </a:solidFill>
+              </a:rPr>
+              <a:t>Show it in your project</a:t>
+            </a:r>
+          </a:p>
+        </p:txBody>
+      </p:sp>
+      <p:cxnSp>
+        <p:nvCxnSpPr>
+          <p:cNvPr id="107" name="Connector 106"/>
+          <p:cNvCxnSpPr/>
+          <p:nvPr/>
+        </p:nvCxnSpPr>
+        <p:spPr>
+          <a:xfrm>
+            <a:off x="6601967" y="2354580"/>
+            <a:ext cx="237745" cy="0"/>
+          </a:xfrm>
+          <a:prstGeom prst="line">
+            <a:avLst/>
+          </a:prstGeom>
+          <a:ln w="25400">
+            <a:solidFill>
+              <a:srgbClr val="9AA3AB"/>
+            </a:solidFill>
+            <a:tailEnd type="triangle"/>
+          </a:ln>
+        </p:spPr>
+        <p:style>
+          <a:lnRef idx="2">
+            <a:schemeClr val="accent1"/>
+          </a:lnRef>
+          <a:fillRef idx="0">
+            <a:schemeClr val="accent1"/>
+          </a:fillRef>
+          <a:effectRef idx="1">
+            <a:schemeClr val="accent1"/>
+          </a:effectRef>
+          <a:fontRef idx="minor">
+            <a:schemeClr val="tx1"/>
+          </a:fontRef>
+        </p:style>
+      </p:cxnSp>
+      <p:sp>
+        <p:nvSpPr>
+          <p:cNvPr id="108" name="Rounded Rectangle 107"/>
+          <p:cNvSpPr/>
+          <p:nvPr/>
+        </p:nvSpPr>
+        <p:spPr>
+          <a:xfrm>
+            <a:off x="6857999" y="2011680"/>
+            <a:ext cx="1874519" cy="685800"/>
+          </a:xfrm>
+          <a:prstGeom prst="roundRect">
+            <a:avLst>
+              <a:gd name="adj" fmla="val 12000"/>
+            </a:avLst>
+          </a:prstGeom>
+          <a:solidFill>
+            <a:srgbClr val="2E3338"/>
+          </a:solidFill>
+          <a:ln>
+            <a:noFill/>
+          </a:ln>
+          <a:effectLst/>
+        </p:spPr>
+        <p:style>
+          <a:lnRef idx="1">
+            <a:schemeClr val="accent1"/>
+          </a:lnRef>
+          <a:fillRef idx="3">
+            <a:schemeClr val="accent1"/>
+          </a:fillRef>
+          <a:effectRef idx="2">
+            <a:schemeClr val="accent1"/>
+          </a:effectRef>
+          <a:fontRef idx="minor">
+            <a:schemeClr val="lt1"/>
+          </a:fontRef>
+        </p:style>
+        <p:txBody>
+          <a:bodyPr rtlCol="0" anchor="ctr" wrap="square" lIns="73152" rIns="73152"/>
+          <a:lstStyle/>
+          <a:p>
+            <a:pPr algn="ctr"/>
+            <a:r>
+              <a:rPr sz="1400" b="1">
+                <a:solidFill>
+                  <a:srgbClr val="DEE2E6"/>
+                </a:solidFill>
+              </a:rPr>
+              <a:t>Change the code live</a:t>
+            </a:r>
+          </a:p>
+        </p:txBody>
+      </p:sp>
+      <p:sp>
+        <p:nvSpPr>
+          <p:cNvPr id="109" name="TextBox 108"/>
+          <p:cNvSpPr txBox="1"/>
+          <p:nvPr/>
+        </p:nvSpPr>
+        <p:spPr>
+          <a:xfrm>
+            <a:off x="411480" y="3017520"/>
+            <a:ext cx="8321040" cy="457200"/>
+          </a:xfrm>
+          <a:prstGeom prst="rect">
+            <a:avLst/>
+          </a:prstGeom>
+          <a:noFill/>
+        </p:spPr>
+        <p:txBody>
+          <a:bodyPr wrap="square">
+            <a:spAutoFit/>
+          </a:bodyPr>
+          <a:lstStyle/>
+          <a:p>
+            <a:pPr algn="ctr"/>
+            <a:r>
+              <a:rPr sz="1400" b="0" i="0">
+                <a:solidFill>
+                  <a:srgbClr val="9AA3AB"/>
+                </a:solidFill>
+              </a:rPr>
+              <a:t>The questions are on the course site, from today.</a:t>
+            </a:r>
           </a:p>
         </p:txBody>
       </p:sp>
@@ -9597,7 +10279,7 @@
         <p:spPr>
           <a:xfrm>
             <a:off x="311700" y="885950"/>
-            <a:ext cx="8520600" cy="4023300"/>
+            <a:ext cx="8520600" cy="521208"/>
           </a:xfrm>
           <a:prstGeom prst="rect">
             <a:avLst/>
@@ -9609,25 +10291,9 @@
           </a:bodyPr>
           <a:lstStyle/>
           <a:p>
-            <a:pPr indent="0" lvl="0" marL="0" rtl="0" algn="l">
-              <a:spcBef>
-                <a:spcPts val="0"/>
-              </a:spcBef>
-              <a:spcAft>
-                <a:spcPts val="0"/>
-              </a:spcAft>
-              <a:buNone/>
-            </a:pPr>
-            <a:r>
-              <a:rPr lang="en"/>
-              <a:t>At its core, MonoGame offers a set of libraries and APIs to handle common game development tasks</a:t>
-            </a:r>
-            <a:endParaRPr/>
-          </a:p>
-          <a:p>
             <a:pPr indent="-330200" lvl="0" marL="457200" rtl="0" algn="l">
               <a:spcBef>
-                <a:spcPts val="1200"/>
+                <a:spcPts val="0"/>
               </a:spcBef>
               <a:spcAft>
                 <a:spcPts val="0"/>
@@ -9637,162 +10303,368 @@
             </a:pPr>
             <a:r>
               <a:rPr lang="en"/>
-              <a:t>Graphics Rendering</a:t>
+              <a:t>A framework, not an engine: libraries, but no editor, no scenes, no entities.</a:t>
             </a:r>
             <a:endParaRPr/>
           </a:p>
-          <a:p>
-            <a:pPr indent="-317500" lvl="1" marL="914400" rtl="0" algn="l">
-              <a:spcBef>
-                <a:spcPts val="0"/>
-              </a:spcBef>
-              <a:spcAft>
-                <a:spcPts val="0"/>
-              </a:spcAft>
-              <a:buSzPts val="1400"/>
-              <a:buChar char="○"/>
-            </a:pPr>
-            <a:r>
-              <a:rPr lang="en"/>
-              <a:t>2D and 3D rendering are supported through the graphics API offered by MonoGame</a:t>
-            </a:r>
-            <a:endParaRPr/>
-          </a:p>
-          <a:p>
-            <a:pPr indent="-330200" lvl="0" marL="457200" rtl="0" algn="l">
-              <a:spcBef>
-                <a:spcPts val="0"/>
-              </a:spcBef>
-              <a:spcAft>
-                <a:spcPts val="0"/>
-              </a:spcAft>
-              <a:buSzPts val="1600"/>
-              <a:buChar char="●"/>
-            </a:pPr>
-            <a:r>
-              <a:rPr lang="en"/>
-              <a:t>Input Handling</a:t>
-            </a:r>
-            <a:endParaRPr/>
-          </a:p>
-          <a:p>
-            <a:pPr indent="-317500" lvl="1" marL="914400" rtl="0" algn="l">
-              <a:spcBef>
-                <a:spcPts val="0"/>
-              </a:spcBef>
-              <a:spcAft>
-                <a:spcPts val="0"/>
-              </a:spcAft>
-              <a:buSzPts val="1400"/>
-              <a:buChar char="○"/>
-            </a:pPr>
-            <a:r>
-              <a:rPr lang="en"/>
-              <a:t>Input from keyboard, mouse, gamepads, and touchscreens is supported</a:t>
-            </a:r>
-            <a:endParaRPr/>
-          </a:p>
-          <a:p>
-            <a:pPr indent="-330200" lvl="0" marL="457200" rtl="0" algn="l">
-              <a:spcBef>
-                <a:spcPts val="0"/>
-              </a:spcBef>
-              <a:spcAft>
-                <a:spcPts val="0"/>
-              </a:spcAft>
-              <a:buSzPts val="1600"/>
-              <a:buChar char="●"/>
-            </a:pPr>
-            <a:r>
-              <a:rPr lang="en"/>
+        </p:txBody>
+      </p:sp>
+      <p:sp>
+        <p:nvSpPr>
+          <p:cNvPr id="125" name="Rounded Rectangle 124"/>
+          <p:cNvSpPr/>
+          <p:nvPr/>
+        </p:nvSpPr>
+        <p:spPr>
+          <a:xfrm>
+            <a:off x="411480" y="1463040"/>
+            <a:ext cx="1554480" cy="822960"/>
+          </a:xfrm>
+          <a:prstGeom prst="roundRect">
+            <a:avLst>
+              <a:gd name="adj" fmla="val 12000"/>
+            </a:avLst>
+          </a:prstGeom>
+          <a:solidFill>
+            <a:srgbClr val="2E3338"/>
+          </a:solidFill>
+          <a:ln>
+            <a:noFill/>
+          </a:ln>
+          <a:effectLst/>
+        </p:spPr>
+        <p:style>
+          <a:lnRef idx="1">
+            <a:schemeClr val="accent1"/>
+          </a:lnRef>
+          <a:fillRef idx="3">
+            <a:schemeClr val="accent1"/>
+          </a:fillRef>
+          <a:effectRef idx="2">
+            <a:schemeClr val="accent1"/>
+          </a:effectRef>
+          <a:fontRef idx="minor">
+            <a:schemeClr val="lt1"/>
+          </a:fontRef>
+        </p:style>
+        <p:txBody>
+          <a:bodyPr rtlCol="0" anchor="ctr" wrap="square" lIns="73152" rIns="73152"/>
+          <a:lstStyle/>
+          <a:p>
+            <a:pPr algn="ctr"/>
+            <a:r>
+              <a:rPr sz="1500" b="1">
+                <a:solidFill>
+                  <a:srgbClr val="DEE2E6"/>
+                </a:solidFill>
+              </a:rPr>
+              <a:t>Graphics</a:t>
+            </a:r>
+          </a:p>
+          <a:p>
+            <a:pPr algn="ctr"/>
+            <a:r>
+              <a:rPr sz="1300" b="0">
+                <a:solidFill>
+                  <a:srgbClr val="9AA3AB"/>
+                </a:solidFill>
+              </a:rPr>
+              <a:t>2D and 3D drawing</a:t>
+            </a:r>
+          </a:p>
+        </p:txBody>
+      </p:sp>
+      <p:sp>
+        <p:nvSpPr>
+          <p:cNvPr id="126" name="Rounded Rectangle 125"/>
+          <p:cNvSpPr/>
+          <p:nvPr/>
+        </p:nvSpPr>
+        <p:spPr>
+          <a:xfrm>
+            <a:off x="2093976" y="1463040"/>
+            <a:ext cx="1554480" cy="822960"/>
+          </a:xfrm>
+          <a:prstGeom prst="roundRect">
+            <a:avLst>
+              <a:gd name="adj" fmla="val 12000"/>
+            </a:avLst>
+          </a:prstGeom>
+          <a:solidFill>
+            <a:srgbClr val="2E3338"/>
+          </a:solidFill>
+          <a:ln>
+            <a:noFill/>
+          </a:ln>
+          <a:effectLst/>
+        </p:spPr>
+        <p:style>
+          <a:lnRef idx="1">
+            <a:schemeClr val="accent1"/>
+          </a:lnRef>
+          <a:fillRef idx="3">
+            <a:schemeClr val="accent1"/>
+          </a:fillRef>
+          <a:effectRef idx="2">
+            <a:schemeClr val="accent1"/>
+          </a:effectRef>
+          <a:fontRef idx="minor">
+            <a:schemeClr val="lt1"/>
+          </a:fontRef>
+        </p:style>
+        <p:txBody>
+          <a:bodyPr rtlCol="0" anchor="ctr" wrap="square" lIns="73152" rIns="73152"/>
+          <a:lstStyle/>
+          <a:p>
+            <a:pPr algn="ctr"/>
+            <a:r>
+              <a:rPr sz="1500" b="1">
+                <a:solidFill>
+                  <a:srgbClr val="DEE2E6"/>
+                </a:solidFill>
+              </a:rPr>
+              <a:t>Input</a:t>
+            </a:r>
+          </a:p>
+          <a:p>
+            <a:pPr algn="ctr"/>
+            <a:r>
+              <a:rPr sz="1300" b="0">
+                <a:solidFill>
+                  <a:srgbClr val="9AA3AB"/>
+                </a:solidFill>
+              </a:rPr>
+              <a:t>keys, mouse, pads, touch</a:t>
+            </a:r>
+          </a:p>
+        </p:txBody>
+      </p:sp>
+      <p:sp>
+        <p:nvSpPr>
+          <p:cNvPr id="127" name="Rounded Rectangle 126"/>
+          <p:cNvSpPr/>
+          <p:nvPr/>
+        </p:nvSpPr>
+        <p:spPr>
+          <a:xfrm>
+            <a:off x="3776472" y="1463040"/>
+            <a:ext cx="1554480" cy="822960"/>
+          </a:xfrm>
+          <a:prstGeom prst="roundRect">
+            <a:avLst>
+              <a:gd name="adj" fmla="val 12000"/>
+            </a:avLst>
+          </a:prstGeom>
+          <a:solidFill>
+            <a:srgbClr val="2E3338"/>
+          </a:solidFill>
+          <a:ln>
+            <a:noFill/>
+          </a:ln>
+          <a:effectLst/>
+        </p:spPr>
+        <p:style>
+          <a:lnRef idx="1">
+            <a:schemeClr val="accent1"/>
+          </a:lnRef>
+          <a:fillRef idx="3">
+            <a:schemeClr val="accent1"/>
+          </a:fillRef>
+          <a:effectRef idx="2">
+            <a:schemeClr val="accent1"/>
+          </a:effectRef>
+          <a:fontRef idx="minor">
+            <a:schemeClr val="lt1"/>
+          </a:fontRef>
+        </p:style>
+        <p:txBody>
+          <a:bodyPr rtlCol="0" anchor="ctr" wrap="square" lIns="73152" rIns="73152"/>
+          <a:lstStyle/>
+          <a:p>
+            <a:pPr algn="ctr"/>
+            <a:r>
+              <a:rPr sz="1500" b="1">
+                <a:solidFill>
+                  <a:srgbClr val="DEE2E6"/>
+                </a:solidFill>
+              </a:rPr>
               <a:t>Audio</a:t>
             </a:r>
-            <a:endParaRPr/>
-          </a:p>
-          <a:p>
-            <a:pPr indent="-317500" lvl="1" marL="914400" rtl="0" algn="l">
-              <a:spcBef>
-                <a:spcPts val="0"/>
-              </a:spcBef>
-              <a:spcAft>
-                <a:spcPts val="0"/>
-              </a:spcAft>
-              <a:buSzPts val="1400"/>
-              <a:buChar char="○"/>
-            </a:pPr>
-            <a:r>
-              <a:rPr lang="en"/>
-              <a:t>A comprehensive audio system that can be used to create sound effects as well as play music</a:t>
-            </a:r>
-            <a:endParaRPr/>
-          </a:p>
-          <a:p>
-            <a:pPr indent="-330200" lvl="0" marL="457200" rtl="0" algn="l">
-              <a:spcBef>
-                <a:spcPts val="0"/>
-              </a:spcBef>
-              <a:spcAft>
-                <a:spcPts val="0"/>
-              </a:spcAft>
-              <a:buSzPts val="1600"/>
-              <a:buChar char="●"/>
-            </a:pPr>
-            <a:r>
-              <a:rPr lang="en"/>
-              <a:t>Content Pipeline</a:t>
-            </a:r>
-            <a:endParaRPr/>
-          </a:p>
-          <a:p>
-            <a:pPr indent="-317500" lvl="1" marL="914400" rtl="0" algn="l">
-              <a:spcBef>
-                <a:spcPts val="0"/>
-              </a:spcBef>
-              <a:spcAft>
-                <a:spcPts val="0"/>
-              </a:spcAft>
-              <a:buSzPts val="1400"/>
-              <a:buChar char="○"/>
-            </a:pPr>
-            <a:r>
-              <a:rPr lang="en"/>
-              <a:t>An out-of-the-box workflow for importing and processing game assets</a:t>
-            </a:r>
-            <a:endParaRPr/>
-          </a:p>
-          <a:p>
-            <a:pPr indent="-330200" lvl="0" marL="457200" rtl="0" algn="l">
-              <a:spcBef>
-                <a:spcPts val="0"/>
-              </a:spcBef>
-              <a:spcAft>
-                <a:spcPts val="0"/>
-              </a:spcAft>
-              <a:buSzPts val="1600"/>
-              <a:buChar char="●"/>
-            </a:pPr>
-            <a:r>
-              <a:rPr lang="en"/>
-              <a:t>Math Library</a:t>
-            </a:r>
-            <a:endParaRPr/>
-          </a:p>
-          <a:p>
-            <a:pPr indent="-317500" lvl="1" marL="914400" rtl="0" algn="l">
-              <a:spcBef>
-                <a:spcPts val="0"/>
-              </a:spcBef>
-              <a:spcAft>
-                <a:spcPts val="0"/>
-              </a:spcAft>
-              <a:buSzPts val="1400"/>
-              <a:buChar char="○"/>
-            </a:pPr>
-            <a:r>
-              <a:rPr lang="en"/>
-              <a:t>A math library specifically optimized for game development</a:t>
-            </a:r>
-            <a:endParaRPr/>
+          </a:p>
+          <a:p>
+            <a:pPr algn="ctr"/>
+            <a:r>
+              <a:rPr sz="1300" b="0">
+                <a:solidFill>
+                  <a:srgbClr val="9AA3AB"/>
+                </a:solidFill>
+              </a:rPr>
+              <a:t>sounds and music</a:t>
+            </a:r>
+          </a:p>
+        </p:txBody>
+      </p:sp>
+      <p:sp>
+        <p:nvSpPr>
+          <p:cNvPr id="128" name="Rounded Rectangle 127"/>
+          <p:cNvSpPr/>
+          <p:nvPr/>
+        </p:nvSpPr>
+        <p:spPr>
+          <a:xfrm>
+            <a:off x="5458968" y="1463040"/>
+            <a:ext cx="1554480" cy="822960"/>
+          </a:xfrm>
+          <a:prstGeom prst="roundRect">
+            <a:avLst>
+              <a:gd name="adj" fmla="val 12000"/>
+            </a:avLst>
+          </a:prstGeom>
+          <a:solidFill>
+            <a:srgbClr val="2E3338"/>
+          </a:solidFill>
+          <a:ln>
+            <a:noFill/>
+          </a:ln>
+          <a:effectLst/>
+        </p:spPr>
+        <p:style>
+          <a:lnRef idx="1">
+            <a:schemeClr val="accent1"/>
+          </a:lnRef>
+          <a:fillRef idx="3">
+            <a:schemeClr val="accent1"/>
+          </a:fillRef>
+          <a:effectRef idx="2">
+            <a:schemeClr val="accent1"/>
+          </a:effectRef>
+          <a:fontRef idx="minor">
+            <a:schemeClr val="lt1"/>
+          </a:fontRef>
+        </p:style>
+        <p:txBody>
+          <a:bodyPr rtlCol="0" anchor="ctr" wrap="square" lIns="73152" rIns="73152"/>
+          <a:lstStyle/>
+          <a:p>
+            <a:pPr algn="ctr"/>
+            <a:r>
+              <a:rPr sz="1500" b="1">
+                <a:solidFill>
+                  <a:srgbClr val="DEE2E6"/>
+                </a:solidFill>
+              </a:rPr>
+              <a:t>Content</a:t>
+            </a:r>
+          </a:p>
+          <a:p>
+            <a:pPr algn="ctr"/>
+            <a:r>
+              <a:rPr sz="1300" b="0">
+                <a:solidFill>
+                  <a:srgbClr val="9AA3AB"/>
+                </a:solidFill>
+              </a:rPr>
+              <a:t>importing assets</a:t>
+            </a:r>
+          </a:p>
+        </p:txBody>
+      </p:sp>
+      <p:sp>
+        <p:nvSpPr>
+          <p:cNvPr id="129" name="Rounded Rectangle 128"/>
+          <p:cNvSpPr/>
+          <p:nvPr/>
+        </p:nvSpPr>
+        <p:spPr>
+          <a:xfrm>
+            <a:off x="7141464" y="1463040"/>
+            <a:ext cx="1554480" cy="822960"/>
+          </a:xfrm>
+          <a:prstGeom prst="roundRect">
+            <a:avLst>
+              <a:gd name="adj" fmla="val 12000"/>
+            </a:avLst>
+          </a:prstGeom>
+          <a:solidFill>
+            <a:srgbClr val="2E3338"/>
+          </a:solidFill>
+          <a:ln>
+            <a:noFill/>
+          </a:ln>
+          <a:effectLst/>
+        </p:spPr>
+        <p:style>
+          <a:lnRef idx="1">
+            <a:schemeClr val="accent1"/>
+          </a:lnRef>
+          <a:fillRef idx="3">
+            <a:schemeClr val="accent1"/>
+          </a:fillRef>
+          <a:effectRef idx="2">
+            <a:schemeClr val="accent1"/>
+          </a:effectRef>
+          <a:fontRef idx="minor">
+            <a:schemeClr val="lt1"/>
+          </a:fontRef>
+        </p:style>
+        <p:txBody>
+          <a:bodyPr rtlCol="0" anchor="ctr" wrap="square" lIns="73152" rIns="73152"/>
+          <a:lstStyle/>
+          <a:p>
+            <a:pPr algn="ctr"/>
+            <a:r>
+              <a:rPr sz="1500" b="1">
+                <a:solidFill>
+                  <a:srgbClr val="DEE2E6"/>
+                </a:solidFill>
+              </a:rPr>
+              <a:t>Math</a:t>
+            </a:r>
+          </a:p>
+          <a:p>
+            <a:pPr algn="ctr"/>
+            <a:r>
+              <a:rPr sz="1300" b="0">
+                <a:solidFill>
+                  <a:srgbClr val="9AA3AB"/>
+                </a:solidFill>
+              </a:rPr>
+              <a:t>vectors, matrices</a:t>
+            </a:r>
+          </a:p>
+        </p:txBody>
+      </p:sp>
+      <p:sp>
+        <p:nvSpPr>
+          <p:cNvPr id="130" name="TextBox 129"/>
+          <p:cNvSpPr txBox="1"/>
+          <p:nvPr/>
+        </p:nvSpPr>
+        <p:spPr>
+          <a:xfrm>
+            <a:off x="457200" y="2743200"/>
+            <a:ext cx="8229600" cy="731520"/>
+          </a:xfrm>
+          <a:prstGeom prst="rect">
+            <a:avLst/>
+          </a:prstGeom>
+          <a:noFill/>
+        </p:spPr>
+        <p:txBody>
+          <a:bodyPr wrap="square">
+            <a:spAutoFit/>
+          </a:bodyPr>
+          <a:lstStyle/>
+          <a:p>
+            <a:pPr algn="ctr"/>
+            <a:r>
+              <a:rPr sz="1800" b="1" i="0">
+                <a:solidFill>
+                  <a:srgbClr val="DEE2E6"/>
+                </a:solidFill>
+              </a:rPr>
+              <a:t>So who writes the game loop, the scenes and the entities?</a:t>
+            </a:r>
           </a:p>
         </p:txBody>
       </p:sp>
@@ -10825,7 +11697,7 @@
         <p:spPr>
           <a:xfrm>
             <a:off x="311700" y="885950"/>
-            <a:ext cx="8520600" cy="4023300"/>
+            <a:ext cx="8520600" cy="521208"/>
           </a:xfrm>
           <a:prstGeom prst="rect">
             <a:avLst/>
@@ -10849,128 +11721,425 @@
             </a:pPr>
             <a:r>
               <a:rPr lang="en"/>
-              <a:t>Update changes the state of the world</a:t>
+              <a:t>Update changes the world; Draw only reads it.</a:t>
             </a:r>
             <a:endParaRPr/>
           </a:p>
-          <a:p>
-            <a:pPr indent="-317500" lvl="1" marL="914400" rtl="0" algn="l">
-              <a:spcBef>
-                <a:spcPts val="0"/>
-              </a:spcBef>
-              <a:spcAft>
-                <a:spcPts val="0"/>
-              </a:spcAft>
-              <a:buSzPts val="1400"/>
-              <a:buChar char="○"/>
-            </a:pPr>
-            <a:r>
-              <a:rPr lang="en"/>
-              <a:t>Input, movement, collisions, game rules</a:t>
-            </a:r>
-            <a:endParaRPr/>
-          </a:p>
-          <a:p>
-            <a:pPr indent="-330200" lvl="0" marL="457200" rtl="0" algn="l">
-              <a:spcBef>
-                <a:spcPts val="0"/>
-              </a:spcBef>
-              <a:spcAft>
-                <a:spcPts val="0"/>
-              </a:spcAft>
-              <a:buSzPts val="1600"/>
-              <a:buChar char="●"/>
-            </a:pPr>
-            <a:r>
-              <a:rPr lang="en"/>
-              <a:t>Draw only reads that state and renders it</a:t>
-            </a:r>
-            <a:endParaRPr/>
-          </a:p>
-          <a:p>
-            <a:pPr indent="-317500" lvl="1" marL="914400" rtl="0" algn="l">
-              <a:spcBef>
-                <a:spcPts val="0"/>
-              </a:spcBef>
-              <a:spcAft>
-                <a:spcPts val="0"/>
-              </a:spcAft>
-              <a:buSzPts val="1400"/>
-              <a:buChar char="○"/>
-            </a:pPr>
-            <a:r>
-              <a:rPr lang="en"/>
-              <a:t>Never change game state in Draw</a:t>
-            </a:r>
-            <a:endParaRPr/>
-          </a:p>
-          <a:p>
-            <a:pPr indent="-330200" lvl="0" marL="457200" rtl="0" algn="l">
-              <a:spcBef>
-                <a:spcPts val="0"/>
-              </a:spcBef>
-              <a:spcAft>
-                <a:spcPts val="0"/>
-              </a:spcAft>
-              <a:buSzPts val="1600"/>
-              <a:buChar char="●"/>
-            </a:pPr>
-            <a:r>
-              <a:rPr lang="en"/>
-              <a:t>Keeping them apart lets the simulation and the rendering run at different rates</a:t>
-            </a:r>
-            <a:endParaRPr/>
-          </a:p>
-          <a:p>
-            <a:pPr indent="-330200" lvl="0" marL="457200" rtl="0" algn="l">
-              <a:spcBef>
-                <a:spcPts val="0"/>
-              </a:spcBef>
-              <a:spcAft>
-                <a:spcPts val="0"/>
-              </a:spcAft>
-              <a:buSzPts val="1600"/>
-              <a:buChar char="●"/>
-            </a:pPr>
-            <a:r>
-              <a:rPr lang="en"/>
-              <a:t>Double buffer</a:t>
-            </a:r>
-            <a:endParaRPr/>
-          </a:p>
-          <a:p>
-            <a:pPr indent="-317500" lvl="1" marL="914400" rtl="0" algn="l">
-              <a:spcBef>
-                <a:spcPts val="0"/>
-              </a:spcBef>
-              <a:spcAft>
-                <a:spcPts val="0"/>
-              </a:spcAft>
-              <a:buSzPts val="1400"/>
-              <a:buChar char="○"/>
-            </a:pPr>
-            <a:r>
-              <a:rPr lang="en"/>
-              <a:t>We draw into a back buffer that isn't visible</a:t>
-            </a:r>
-            <a:endParaRPr/>
-          </a:p>
-          <a:p>
-            <a:pPr indent="-317500" lvl="1" marL="914400" rtl="0" algn="l">
-              <a:spcBef>
-                <a:spcPts val="0"/>
-              </a:spcBef>
-              <a:spcAft>
-                <a:spcPts val="0"/>
-              </a:spcAft>
-              <a:buSzPts val="1400"/>
-              <a:buChar char="○"/>
-            </a:pPr>
-            <a:r>
-              <a:rPr lang="en"/>
-              <a:t>At the end of Draw, MonoGame presents it: the player never sees a half-drawn frame</a:t>
-            </a:r>
-            <a:endParaRPr/>
+        </p:txBody>
+      </p:sp>
+      <p:sp>
+        <p:nvSpPr>
+          <p:cNvPr id="301" name="Rounded Rectangle 300"/>
+          <p:cNvSpPr/>
+          <p:nvPr/>
+        </p:nvSpPr>
+        <p:spPr>
+          <a:xfrm>
+            <a:off x="731520" y="1554480"/>
+            <a:ext cx="2377440" cy="822960"/>
+          </a:xfrm>
+          <a:prstGeom prst="roundRect">
+            <a:avLst>
+              <a:gd name="adj" fmla="val 12000"/>
+            </a:avLst>
+          </a:prstGeom>
+          <a:solidFill>
+            <a:srgbClr val="2E3338"/>
+          </a:solidFill>
+          <a:ln w="25400">
+            <a:solidFill>
+              <a:srgbClr val="D45D35"/>
+            </a:solidFill>
+          </a:ln>
+          <a:effectLst/>
+        </p:spPr>
+        <p:style>
+          <a:lnRef idx="1">
+            <a:schemeClr val="accent1"/>
+          </a:lnRef>
+          <a:fillRef idx="3">
+            <a:schemeClr val="accent1"/>
+          </a:fillRef>
+          <a:effectRef idx="2">
+            <a:schemeClr val="accent1"/>
+          </a:effectRef>
+          <a:fontRef idx="minor">
+            <a:schemeClr val="lt1"/>
+          </a:fontRef>
+        </p:style>
+        <p:txBody>
+          <a:bodyPr rtlCol="0" anchor="ctr" wrap="square" lIns="73152" rIns="73152"/>
+          <a:lstStyle/>
+          <a:p>
+            <a:pPr algn="ctr"/>
+            <a:r>
+              <a:rPr sz="1600" b="1">
+                <a:solidFill>
+                  <a:srgbClr val="DEE2E6"/>
+                </a:solidFill>
+              </a:rPr>
+              <a:t>Update</a:t>
+            </a:r>
+          </a:p>
+          <a:p>
+            <a:pPr algn="ctr"/>
+            <a:r>
+              <a:rPr sz="1400" b="0">
+                <a:solidFill>
+                  <a:srgbClr val="9AA3AB"/>
+                </a:solidFill>
+              </a:rPr>
+              <a:t>input, movement, collisions, rules</a:t>
+            </a:r>
+          </a:p>
+        </p:txBody>
+      </p:sp>
+      <p:sp>
+        <p:nvSpPr>
+          <p:cNvPr id="302" name="Rounded Rectangle 301"/>
+          <p:cNvSpPr/>
+          <p:nvPr/>
+        </p:nvSpPr>
+        <p:spPr>
+          <a:xfrm>
+            <a:off x="3566160" y="1554480"/>
+            <a:ext cx="2011680" cy="822960"/>
+          </a:xfrm>
+          <a:prstGeom prst="roundRect">
+            <a:avLst>
+              <a:gd name="adj" fmla="val 12000"/>
+            </a:avLst>
+          </a:prstGeom>
+          <a:solidFill>
+            <a:srgbClr val="2E3338"/>
+          </a:solidFill>
+          <a:ln>
+            <a:noFill/>
+          </a:ln>
+          <a:effectLst/>
+        </p:spPr>
+        <p:style>
+          <a:lnRef idx="1">
+            <a:schemeClr val="accent1"/>
+          </a:lnRef>
+          <a:fillRef idx="3">
+            <a:schemeClr val="accent1"/>
+          </a:fillRef>
+          <a:effectRef idx="2">
+            <a:schemeClr val="accent1"/>
+          </a:effectRef>
+          <a:fontRef idx="minor">
+            <a:schemeClr val="lt1"/>
+          </a:fontRef>
+        </p:style>
+        <p:txBody>
+          <a:bodyPr rtlCol="0" anchor="ctr" wrap="square" lIns="73152" rIns="73152"/>
+          <a:lstStyle/>
+          <a:p>
+            <a:pPr algn="ctr"/>
+            <a:r>
+              <a:rPr sz="1600" b="1">
+                <a:solidFill>
+                  <a:srgbClr val="DEE2E6"/>
+                </a:solidFill>
+              </a:rPr>
+              <a:t>The game state</a:t>
+            </a:r>
+          </a:p>
+          <a:p>
+            <a:pPr algn="ctr"/>
+            <a:r>
+              <a:rPr sz="1400" b="0">
+                <a:solidFill>
+                  <a:srgbClr val="9AA3AB"/>
+                </a:solidFill>
+              </a:rPr>
+              <a:t>positions, scores, ...</a:t>
+            </a:r>
+          </a:p>
+        </p:txBody>
+      </p:sp>
+      <p:sp>
+        <p:nvSpPr>
+          <p:cNvPr id="303" name="Rounded Rectangle 302"/>
+          <p:cNvSpPr/>
+          <p:nvPr/>
+        </p:nvSpPr>
+        <p:spPr>
+          <a:xfrm>
+            <a:off x="6035040" y="1554480"/>
+            <a:ext cx="2377440" cy="822960"/>
+          </a:xfrm>
+          <a:prstGeom prst="roundRect">
+            <a:avLst>
+              <a:gd name="adj" fmla="val 12000"/>
+            </a:avLst>
+          </a:prstGeom>
+          <a:solidFill>
+            <a:srgbClr val="2E3338"/>
+          </a:solidFill>
+          <a:ln>
+            <a:noFill/>
+          </a:ln>
+          <a:effectLst/>
+        </p:spPr>
+        <p:style>
+          <a:lnRef idx="1">
+            <a:schemeClr val="accent1"/>
+          </a:lnRef>
+          <a:fillRef idx="3">
+            <a:schemeClr val="accent1"/>
+          </a:fillRef>
+          <a:effectRef idx="2">
+            <a:schemeClr val="accent1"/>
+          </a:effectRef>
+          <a:fontRef idx="minor">
+            <a:schemeClr val="lt1"/>
+          </a:fontRef>
+        </p:style>
+        <p:txBody>
+          <a:bodyPr rtlCol="0" anchor="ctr" wrap="square" lIns="73152" rIns="73152"/>
+          <a:lstStyle/>
+          <a:p>
+            <a:pPr algn="ctr"/>
+            <a:r>
+              <a:rPr sz="1600" b="1">
+                <a:solidFill>
+                  <a:srgbClr val="DEE2E6"/>
+                </a:solidFill>
+              </a:rPr>
+              <a:t>Draw</a:t>
+            </a:r>
+          </a:p>
+          <a:p>
+            <a:pPr algn="ctr"/>
+            <a:r>
+              <a:rPr sz="1400" b="0">
+                <a:solidFill>
+                  <a:srgbClr val="9AA3AB"/>
+                </a:solidFill>
+              </a:rPr>
+              <a:t>renders what it reads</a:t>
+            </a:r>
+          </a:p>
+        </p:txBody>
+      </p:sp>
+      <p:cxnSp>
+        <p:nvCxnSpPr>
+          <p:cNvPr id="304" name="Connector 303"/>
+          <p:cNvCxnSpPr/>
+          <p:nvPr/>
+        </p:nvCxnSpPr>
+        <p:spPr>
+          <a:xfrm>
+            <a:off x="3127248" y="1965960"/>
+            <a:ext cx="420624" cy="0"/>
+          </a:xfrm>
+          <a:prstGeom prst="line">
+            <a:avLst/>
+          </a:prstGeom>
+          <a:ln w="25400">
+            <a:solidFill>
+              <a:srgbClr val="D45D35"/>
+            </a:solidFill>
+            <a:tailEnd type="triangle"/>
+          </a:ln>
+        </p:spPr>
+        <p:style>
+          <a:lnRef idx="2">
+            <a:schemeClr val="accent1"/>
+          </a:lnRef>
+          <a:fillRef idx="0">
+            <a:schemeClr val="accent1"/>
+          </a:fillRef>
+          <a:effectRef idx="1">
+            <a:schemeClr val="accent1"/>
+          </a:effectRef>
+          <a:fontRef idx="minor">
+            <a:schemeClr val="tx1"/>
+          </a:fontRef>
+        </p:style>
+      </p:cxnSp>
+      <p:sp>
+        <p:nvSpPr>
+          <p:cNvPr id="305" name="TextBox 304"/>
+          <p:cNvSpPr txBox="1"/>
+          <p:nvPr/>
+        </p:nvSpPr>
+        <p:spPr>
+          <a:xfrm>
+            <a:off x="2944368" y="1673351"/>
+            <a:ext cx="786384" cy="274320"/>
+          </a:xfrm>
+          <a:prstGeom prst="rect">
+            <a:avLst/>
+          </a:prstGeom>
+          <a:noFill/>
+        </p:spPr>
+        <p:txBody>
+          <a:bodyPr wrap="square">
+            <a:spAutoFit/>
+          </a:bodyPr>
+          <a:lstStyle/>
+          <a:p>
+            <a:pPr algn="ctr"/>
+            <a:r>
+              <a:rPr sz="1100" b="0" i="0">
+                <a:solidFill>
+                  <a:srgbClr val="9AA3AB"/>
+                </a:solidFill>
+              </a:rPr>
+              <a:t>writes</a:t>
+            </a:r>
+          </a:p>
+        </p:txBody>
+      </p:sp>
+      <p:cxnSp>
+        <p:nvCxnSpPr>
+          <p:cNvPr id="306" name="Connector 305"/>
+          <p:cNvCxnSpPr/>
+          <p:nvPr/>
+        </p:nvCxnSpPr>
+        <p:spPr>
+          <a:xfrm flipH="1">
+            <a:off x="5596128" y="1965960"/>
+            <a:ext cx="420624" cy="0"/>
+          </a:xfrm>
+          <a:prstGeom prst="line">
+            <a:avLst/>
+          </a:prstGeom>
+          <a:ln w="25400">
+            <a:solidFill>
+              <a:srgbClr val="9AA3AB"/>
+            </a:solidFill>
+            <a:tailEnd type="triangle"/>
+          </a:ln>
+        </p:spPr>
+        <p:style>
+          <a:lnRef idx="2">
+            <a:schemeClr val="accent1"/>
+          </a:lnRef>
+          <a:fillRef idx="0">
+            <a:schemeClr val="accent1"/>
+          </a:fillRef>
+          <a:effectRef idx="1">
+            <a:schemeClr val="accent1"/>
+          </a:effectRef>
+          <a:fontRef idx="minor">
+            <a:schemeClr val="tx1"/>
+          </a:fontRef>
+        </p:style>
+      </p:cxnSp>
+      <p:sp>
+        <p:nvSpPr>
+          <p:cNvPr id="307" name="TextBox 306"/>
+          <p:cNvSpPr txBox="1"/>
+          <p:nvPr/>
+        </p:nvSpPr>
+        <p:spPr>
+          <a:xfrm>
+            <a:off x="5413248" y="1673351"/>
+            <a:ext cx="786384" cy="274320"/>
+          </a:xfrm>
+          <a:prstGeom prst="rect">
+            <a:avLst/>
+          </a:prstGeom>
+          <a:noFill/>
+        </p:spPr>
+        <p:txBody>
+          <a:bodyPr wrap="square">
+            <a:spAutoFit/>
+          </a:bodyPr>
+          <a:lstStyle/>
+          <a:p>
+            <a:pPr algn="ctr"/>
+            <a:r>
+              <a:rPr sz="1100" b="0" i="0">
+                <a:solidFill>
+                  <a:srgbClr val="9AA3AB"/>
+                </a:solidFill>
+              </a:rPr>
+              <a:t>reads</a:t>
+            </a:r>
+          </a:p>
+        </p:txBody>
+      </p:sp>
+      <p:sp>
+        <p:nvSpPr>
+          <p:cNvPr id="308" name="TextBox 307"/>
+          <p:cNvSpPr txBox="1"/>
+          <p:nvPr/>
+        </p:nvSpPr>
+        <p:spPr>
+          <a:xfrm>
+            <a:off x="731520" y="2697480"/>
+            <a:ext cx="7680960" cy="822960"/>
+          </a:xfrm>
+          <a:prstGeom prst="rect">
+            <a:avLst/>
+          </a:prstGeom>
+          <a:noFill/>
+        </p:spPr>
+        <p:txBody>
+          <a:bodyPr wrap="square">
+            <a:spAutoFit/>
+          </a:bodyPr>
+          <a:lstStyle/>
+          <a:p>
+            <a:pPr algn="ctr"/>
+            <a:r>
+              <a:rPr sz="1300" b="0" i="0">
+                <a:solidFill>
+                  <a:srgbClr val="9AA3AB"/>
+                </a:solidFill>
+              </a:rPr>
+              <a:t>Draw goes to a hidden back buffer; MonoGame shows it when Draw is done,</a:t>
+            </a:r>
+          </a:p>
+          <a:p>
+            <a:pPr algn="ctr"/>
+            <a:r>
+              <a:rPr sz="1300" b="0" i="0">
+                <a:solidFill>
+                  <a:srgbClr val="9AA3AB"/>
+                </a:solidFill>
+              </a:rPr>
+              <a:t>so the player never sees a half-drawn frame.</a:t>
+            </a:r>
+          </a:p>
+        </p:txBody>
+      </p:sp>
+      <p:sp>
+        <p:nvSpPr>
+          <p:cNvPr id="309" name="TextBox 308"/>
+          <p:cNvSpPr txBox="1"/>
+          <p:nvPr/>
+        </p:nvSpPr>
+        <p:spPr>
+          <a:xfrm>
+            <a:off x="457200" y="3566160"/>
+            <a:ext cx="8229600" cy="731520"/>
+          </a:xfrm>
+          <a:prstGeom prst="rect">
+            <a:avLst/>
+          </a:prstGeom>
+          <a:noFill/>
+        </p:spPr>
+        <p:txBody>
+          <a:bodyPr wrap="square">
+            <a:spAutoFit/>
+          </a:bodyPr>
+          <a:lstStyle/>
+          <a:p>
+            <a:pPr algn="ctr"/>
+            <a:r>
+              <a:rPr sz="1800" b="1" i="0">
+                <a:solidFill>
+                  <a:srgbClr val="DEE2E6"/>
+                </a:solidFill>
+              </a:rPr>
+              <a:t>What goes wrong if Draw moves the ball?</a:t>
+            </a:r>
           </a:p>
         </p:txBody>
       </p:sp>
@@ -11043,7 +12212,7 @@
         <p:spPr>
           <a:xfrm>
             <a:off x="311700" y="885950"/>
-            <a:ext cx="8520600" cy="4023300"/>
+            <a:ext cx="8520600" cy="521208"/>
           </a:xfrm>
           <a:prstGeom prst="rect">
             <a:avLst/>
@@ -11067,128 +12236,230 @@
             </a:pPr>
             <a:r>
               <a:rPr lang="en"/>
+              <a:t>Variable: one update per frame, scaled by delta time. Fixed: always the same step.</a:t>
+            </a:r>
+            <a:endParaRPr/>
+          </a:p>
+        </p:txBody>
+      </p:sp>
+      <p:sp>
+        <p:nvSpPr>
+          <p:cNvPr id="301" name="Rounded Rectangle 300"/>
+          <p:cNvSpPr/>
+          <p:nvPr/>
+        </p:nvSpPr>
+        <p:spPr>
+          <a:xfrm>
+            <a:off x="548640" y="1463040"/>
+            <a:ext cx="3749039" cy="1463040"/>
+          </a:xfrm>
+          <a:prstGeom prst="roundRect">
+            <a:avLst>
+              <a:gd name="adj" fmla="val 12000"/>
+            </a:avLst>
+          </a:prstGeom>
+          <a:solidFill>
+            <a:srgbClr val="2E3338"/>
+          </a:solidFill>
+          <a:ln>
+            <a:noFill/>
+          </a:ln>
+          <a:effectLst/>
+        </p:spPr>
+        <p:style>
+          <a:lnRef idx="1">
+            <a:schemeClr val="accent1"/>
+          </a:lnRef>
+          <a:fillRef idx="3">
+            <a:schemeClr val="accent1"/>
+          </a:fillRef>
+          <a:effectRef idx="2">
+            <a:schemeClr val="accent1"/>
+          </a:effectRef>
+          <a:fontRef idx="minor">
+            <a:schemeClr val="lt1"/>
+          </a:fontRef>
+        </p:style>
+        <p:txBody>
+          <a:bodyPr rtlCol="0" anchor="ctr" wrap="square" lIns="73152" rIns="73152"/>
+          <a:lstStyle/>
+          <a:p>
+            <a:pPr algn="ctr"/>
+            <a:r>
+              <a:rPr sz="1600" b="1">
+                <a:solidFill>
+                  <a:srgbClr val="DEE2E6"/>
+                </a:solidFill>
+              </a:rPr>
               <a:t>Variable timestep</a:t>
             </a:r>
-            <a:endParaRPr/>
-          </a:p>
-          <a:p>
-            <a:pPr indent="-317500" lvl="1" marL="914400" rtl="0" algn="l">
-              <a:spcBef>
-                <a:spcPts val="0"/>
-              </a:spcBef>
-              <a:spcAft>
-                <a:spcPts val="0"/>
-              </a:spcAft>
-              <a:buSzPts val="1400"/>
-              <a:buChar char="○"/>
-            </a:pPr>
-            <a:r>
-              <a:rPr lang="en"/>
-              <a:t>One Update per rendered frame, movement scaled by deltaTime</a:t>
-            </a:r>
-            <a:endParaRPr/>
-          </a:p>
-          <a:p>
-            <a:pPr indent="-317500" lvl="1" marL="914400" rtl="0" algn="l">
-              <a:spcBef>
-                <a:spcPts val="0"/>
-              </a:spcBef>
-              <a:spcAft>
-                <a:spcPts val="0"/>
-              </a:spcAft>
-              <a:buSzPts val="1400"/>
-              <a:buChar char="○"/>
-            </a:pPr>
-            <a:r>
-              <a:rPr lang="en"/>
-              <a:t>Simple, but the simulation behaves slightly differently at different frame rates</a:t>
-            </a:r>
-            <a:endParaRPr/>
-          </a:p>
-          <a:p>
-            <a:pPr indent="-330200" lvl="0" marL="457200" rtl="0" algn="l">
-              <a:spcBef>
-                <a:spcPts val="0"/>
-              </a:spcBef>
-              <a:spcAft>
-                <a:spcPts val="0"/>
-              </a:spcAft>
-              <a:buSzPts val="1600"/>
-              <a:buChar char="●"/>
-            </a:pPr>
-            <a:r>
-              <a:rPr lang="en"/>
+          </a:p>
+          <a:p>
+            <a:pPr algn="ctr"/>
+            <a:r>
+              <a:rPr sz="1400" b="0">
+                <a:solidFill>
+                  <a:srgbClr val="9AA3AB"/>
+                </a:solidFill>
+              </a:rPr>
+              <a:t>one Update per frame, × deltaTime</a:t>
+            </a:r>
+          </a:p>
+          <a:p>
+            <a:pPr algn="ctr"/>
+            <a:r>
+              <a:rPr sz="1400" b="0">
+                <a:solidFill>
+                  <a:srgbClr val="9AA3AB"/>
+                </a:solidFill>
+              </a:rPr>
+              <a:t>simple, but slightly different</a:t>
+            </a:r>
+          </a:p>
+          <a:p>
+            <a:pPr algn="ctr"/>
+            <a:r>
+              <a:rPr sz="1400" b="0">
+                <a:solidFill>
+                  <a:srgbClr val="9AA3AB"/>
+                </a:solidFill>
+              </a:rPr>
+              <a:t>at every frame rate</a:t>
+            </a:r>
+          </a:p>
+        </p:txBody>
+      </p:sp>
+      <p:sp>
+        <p:nvSpPr>
+          <p:cNvPr id="302" name="Rounded Rectangle 301"/>
+          <p:cNvSpPr/>
+          <p:nvPr/>
+        </p:nvSpPr>
+        <p:spPr>
+          <a:xfrm>
+            <a:off x="4846320" y="1463040"/>
+            <a:ext cx="3749039" cy="1463040"/>
+          </a:xfrm>
+          <a:prstGeom prst="roundRect">
+            <a:avLst>
+              <a:gd name="adj" fmla="val 12000"/>
+            </a:avLst>
+          </a:prstGeom>
+          <a:solidFill>
+            <a:srgbClr val="2E3338"/>
+          </a:solidFill>
+          <a:ln w="25400">
+            <a:solidFill>
+              <a:srgbClr val="D45D35"/>
+            </a:solidFill>
+          </a:ln>
+          <a:effectLst/>
+        </p:spPr>
+        <p:style>
+          <a:lnRef idx="1">
+            <a:schemeClr val="accent1"/>
+          </a:lnRef>
+          <a:fillRef idx="3">
+            <a:schemeClr val="accent1"/>
+          </a:fillRef>
+          <a:effectRef idx="2">
+            <a:schemeClr val="accent1"/>
+          </a:effectRef>
+          <a:fontRef idx="minor">
+            <a:schemeClr val="lt1"/>
+          </a:fontRef>
+        </p:style>
+        <p:txBody>
+          <a:bodyPr rtlCol="0" anchor="ctr" wrap="square" lIns="73152" rIns="73152"/>
+          <a:lstStyle/>
+          <a:p>
+            <a:pPr algn="ctr"/>
+            <a:r>
+              <a:rPr sz="1600" b="1">
+                <a:solidFill>
+                  <a:srgbClr val="DEE2E6"/>
+                </a:solidFill>
+              </a:rPr>
               <a:t>Fixed timestep</a:t>
             </a:r>
-            <a:endParaRPr/>
-          </a:p>
-          <a:p>
-            <a:pPr indent="-317500" lvl="1" marL="914400" rtl="0" algn="l">
-              <a:spcBef>
-                <a:spcPts val="0"/>
-              </a:spcBef>
-              <a:spcAft>
-                <a:spcPts val="0"/>
-              </a:spcAft>
-              <a:buSzPts val="1400"/>
-              <a:buChar char="○"/>
-            </a:pPr>
-            <a:r>
-              <a:rPr lang="en"/>
-              <a:t>Update in fixed-size steps (e.g. 60 per second): zero, one or several per frame</a:t>
-            </a:r>
-            <a:endParaRPr/>
-          </a:p>
-          <a:p>
-            <a:pPr indent="-317500" lvl="1" marL="914400" rtl="0" algn="l">
-              <a:spcBef>
-                <a:spcPts val="0"/>
-              </a:spcBef>
-              <a:spcAft>
-                <a:spcPts val="0"/>
-              </a:spcAft>
-              <a:buSzPts val="1400"/>
-              <a:buChar char="○"/>
-            </a:pPr>
-            <a:r>
-              <a:rPr lang="en"/>
-              <a:t>Deterministic and stable, at the cost of some complexity</a:t>
-            </a:r>
-            <a:endParaRPr/>
-          </a:p>
-          <a:p>
-            <a:pPr indent="-330200" lvl="0" marL="457200" rtl="0" algn="l">
-              <a:spcBef>
-                <a:spcPts val="0"/>
-              </a:spcBef>
-              <a:spcAft>
-                <a:spcPts val="0"/>
-              </a:spcAft>
-              <a:buSzPts val="1600"/>
-              <a:buChar char="●"/>
-            </a:pPr>
-            <a:r>
-              <a:rPr lang="en"/>
-              <a:t>MonoGame uses a fixed timestep by default (IsFixedTimeStep = true)</a:t>
-            </a:r>
-            <a:endParaRPr/>
-          </a:p>
-          <a:p>
-            <a:pPr indent="-330200" lvl="0" marL="457200" rtl="0" algn="l">
-              <a:spcBef>
-                <a:spcPts val="0"/>
-              </a:spcBef>
-              <a:spcAft>
-                <a:spcPts val="0"/>
-              </a:spcAft>
-              <a:buSzPts val="1600"/>
-              <a:buChar char="●"/>
-            </a:pPr>
-            <a:r>
-              <a:rPr lang="en"/>
-              <a:t>Try it: the game loop demo on the course site</a:t>
-            </a:r>
-            <a:endParaRPr/>
+          </a:p>
+          <a:p>
+            <a:pPr algn="ctr"/>
+            <a:r>
+              <a:rPr sz="1400" b="0">
+                <a:solidFill>
+                  <a:srgbClr val="9AA3AB"/>
+                </a:solidFill>
+              </a:rPr>
+              <a:t>0, 1 or more Updates per frame</a:t>
+            </a:r>
+          </a:p>
+          <a:p>
+            <a:pPr algn="ctr"/>
+            <a:r>
+              <a:rPr sz="1400" b="0">
+                <a:solidFill>
+                  <a:srgbClr val="9AA3AB"/>
+                </a:solidFill>
+              </a:rPr>
+              <a:t>deterministic and stable,</a:t>
+            </a:r>
+          </a:p>
+          <a:p>
+            <a:pPr algn="ctr"/>
+            <a:r>
+              <a:rPr sz="1400" b="0">
+                <a:solidFill>
+                  <a:srgbClr val="9AA3AB"/>
+                </a:solidFill>
+              </a:rPr>
+              <a:t>a little more complex</a:t>
+            </a:r>
+          </a:p>
+        </p:txBody>
+      </p:sp>
+      <p:sp>
+        <p:nvSpPr>
+          <p:cNvPr id="303" name="TextBox 302"/>
+          <p:cNvSpPr txBox="1"/>
+          <p:nvPr/>
+        </p:nvSpPr>
+        <p:spPr>
+          <a:xfrm>
+            <a:off x="548640" y="3108960"/>
+            <a:ext cx="8046720" cy="731520"/>
+          </a:xfrm>
+          <a:prstGeom prst="rect">
+            <a:avLst/>
+          </a:prstGeom>
+          <a:noFill/>
+        </p:spPr>
+        <p:txBody>
+          <a:bodyPr wrap="square">
+            <a:spAutoFit/>
+          </a:bodyPr>
+          <a:lstStyle/>
+          <a:p>
+            <a:pPr algn="ctr"/>
+            <a:r>
+              <a:rPr sz="1400" b="0" i="0">
+                <a:solidFill>
+                  <a:srgbClr val="9AA3AB"/>
+                </a:solidFill>
+              </a:rPr>
+              <a:t>MonoGame is fixed by default: IsFixedTimeStep = true.</a:t>
+            </a:r>
+          </a:p>
+          <a:p>
+            <a:pPr algn="ctr"/>
+            <a:r>
+              <a:rPr sz="1400" b="0" i="0">
+                <a:solidFill>
+                  <a:srgbClr val="9AA3AB"/>
+                </a:solidFill>
+              </a:rPr>
+              <a:t>Try both in the game-loop demo on the course site.</a:t>
+            </a:r>
           </a:p>
         </p:txBody>
       </p:sp>
@@ -19273,7 +20544,7 @@
         <p:spPr>
           <a:xfrm>
             <a:off x="311700" y="885950"/>
-            <a:ext cx="8520600" cy="4023300"/>
+            <a:ext cx="8520600" cy="521208"/>
           </a:xfrm>
           <a:prstGeom prst="rect">
             <a:avLst/>
@@ -19297,124 +20568,7 @@
             </a:pPr>
             <a:r>
               <a:rPr lang="en"/>
-              <a:t>Add a new Serve state to the game</a:t>
-            </a:r>
-            <a:endParaRPr/>
-          </a:p>
-          <a:p>
-            <a:pPr indent="-317500" lvl="1" marL="914400" rtl="0" algn="l">
-              <a:spcBef>
-                <a:spcPts val="0"/>
-              </a:spcBef>
-              <a:spcAft>
-                <a:spcPts val="0"/>
-              </a:spcAft>
-              <a:buSzPts val="1400"/>
-              <a:buChar char="○"/>
-            </a:pPr>
-            <a:r>
-              <a:rPr lang="en"/>
-              <a:t>When a player is serving, they send the ball towards the other player</a:t>
-            </a:r>
-            <a:endParaRPr/>
-          </a:p>
-          <a:p>
-            <a:pPr indent="-317500" lvl="1" marL="914400" rtl="0" algn="l">
-              <a:spcBef>
-                <a:spcPts val="0"/>
-              </a:spcBef>
-              <a:spcAft>
-                <a:spcPts val="0"/>
-              </a:spcAft>
-              <a:buSzPts val="1400"/>
-              <a:buChar char="○"/>
-            </a:pPr>
-            <a:r>
-              <a:rPr lang="en"/>
-              <a:t>The player who was last scored on gets to serve (random player at game start)</a:t>
-            </a:r>
-            <a:endParaRPr/>
-          </a:p>
-          <a:p>
-            <a:pPr indent="-317500" lvl="1" marL="914400" rtl="0" algn="l">
-              <a:spcBef>
-                <a:spcPts val="0"/>
-              </a:spcBef>
-              <a:spcAft>
-                <a:spcPts val="0"/>
-              </a:spcAft>
-              <a:buSzPts val="1400"/>
-              <a:buChar char="○"/>
-            </a:pPr>
-            <a:r>
-              <a:rPr lang="en"/>
-              <a:t>We transition from “play” to “serve” state when scoring</a:t>
-            </a:r>
-            <a:endParaRPr/>
-          </a:p>
-          <a:p>
-            <a:pPr indent="-317500" lvl="1" marL="914400" rtl="0" algn="l">
-              <a:spcBef>
-                <a:spcPts val="0"/>
-              </a:spcBef>
-              <a:spcAft>
-                <a:spcPts val="0"/>
-              </a:spcAft>
-              <a:buSzPts val="1400"/>
-              <a:buChar char="○"/>
-            </a:pPr>
-            <a:r>
-              <a:rPr lang="en"/>
-              <a:t>And from “serve” state to “play” state when pressing “Enter”</a:t>
-            </a:r>
-            <a:endParaRPr/>
-          </a:p>
-          <a:p>
-            <a:pPr indent="-317500" lvl="1" marL="914400" rtl="0" algn="l">
-              <a:spcBef>
-                <a:spcPts val="0"/>
-              </a:spcBef>
-              <a:spcAft>
-                <a:spcPts val="0"/>
-              </a:spcAft>
-              <a:buSzPts val="1400"/>
-              <a:buChar char="○"/>
-            </a:pPr>
-            <a:r>
-              <a:rPr lang="en"/>
-              <a:t>The game begins in the “start” state and transitions to the “serve” state by pressing “Enter”</a:t>
-            </a:r>
-            <a:endParaRPr/>
-          </a:p>
-          <a:p>
-            <a:pPr indent="0" lvl="0" marL="0" rtl="0" algn="l">
-              <a:spcBef>
-                <a:spcPts val="1200"/>
-              </a:spcBef>
-              <a:spcAft>
-                <a:spcPts val="0"/>
-              </a:spcAft>
-              <a:buNone/>
-            </a:pPr>
-            <a:r>
-              <a:rPr/>
-              <a:t/>
-            </a:r>
-            <a:endParaRPr/>
-          </a:p>
-          <a:p>
-            <a:pPr indent="0" lvl="0" marL="0" rtl="0" algn="l">
-              <a:spcBef>
-                <a:spcPts val="1200"/>
-              </a:spcBef>
-              <a:spcAft>
-                <a:spcPts val="1200"/>
-              </a:spcAft>
-              <a:buNone/>
-            </a:pPr>
-            <a:r>
-              <a:rPr/>
-              <a:t/>
+              <a:t>Add a serve state: the player who was scored on serves.</a:t>
             </a:r>
             <a:endParaRPr/>
           </a:p>
@@ -19436,14 +20590,512 @@
         </p:blipFill>
         <p:spPr>
           <a:xfrm>
-            <a:off x="2721375" y="2782723"/>
-            <a:ext cx="3701249" cy="2081952"/>
+            <a:off x="5120640" y="2651760"/>
+            <a:ext cx="3566160" cy="2005964"/>
           </a:xfrm>
           <a:prstGeom prst="rect">
             <a:avLst/>
           </a:prstGeom>
         </p:spPr>
       </p:pic>
+      <p:sp>
+        <p:nvSpPr>
+          <p:cNvPr id="288" name="Rounded Rectangle 287"/>
+          <p:cNvSpPr/>
+          <p:nvPr/>
+        </p:nvSpPr>
+        <p:spPr>
+          <a:xfrm>
+            <a:off x="457200" y="1508760"/>
+            <a:ext cx="1097280" cy="548640"/>
+          </a:xfrm>
+          <a:prstGeom prst="roundRect">
+            <a:avLst>
+              <a:gd name="adj" fmla="val 12000"/>
+            </a:avLst>
+          </a:prstGeom>
+          <a:solidFill>
+            <a:srgbClr val="2E3338"/>
+          </a:solidFill>
+          <a:ln>
+            <a:noFill/>
+          </a:ln>
+          <a:effectLst/>
+        </p:spPr>
+        <p:style>
+          <a:lnRef idx="1">
+            <a:schemeClr val="accent1"/>
+          </a:lnRef>
+          <a:fillRef idx="3">
+            <a:schemeClr val="accent1"/>
+          </a:fillRef>
+          <a:effectRef idx="2">
+            <a:schemeClr val="accent1"/>
+          </a:effectRef>
+          <a:fontRef idx="minor">
+            <a:schemeClr val="lt1"/>
+          </a:fontRef>
+        </p:style>
+        <p:txBody>
+          <a:bodyPr rtlCol="0" anchor="ctr" wrap="square" lIns="73152" rIns="73152"/>
+          <a:lstStyle/>
+          <a:p>
+            <a:pPr algn="ctr"/>
+            <a:r>
+              <a:rPr sz="1500" b="1">
+                <a:solidFill>
+                  <a:srgbClr val="DEE2E6"/>
+                </a:solidFill>
+              </a:rPr>
+              <a:t>start</a:t>
+            </a:r>
+          </a:p>
+        </p:txBody>
+      </p:sp>
+      <p:sp>
+        <p:nvSpPr>
+          <p:cNvPr id="289" name="Rounded Rectangle 288"/>
+          <p:cNvSpPr/>
+          <p:nvPr/>
+        </p:nvSpPr>
+        <p:spPr>
+          <a:xfrm>
+            <a:off x="2286000" y="1508760"/>
+            <a:ext cx="1097280" cy="548640"/>
+          </a:xfrm>
+          <a:prstGeom prst="roundRect">
+            <a:avLst>
+              <a:gd name="adj" fmla="val 12000"/>
+            </a:avLst>
+          </a:prstGeom>
+          <a:solidFill>
+            <a:srgbClr val="2E3338"/>
+          </a:solidFill>
+          <a:ln w="25400">
+            <a:solidFill>
+              <a:srgbClr val="D45D35"/>
+            </a:solidFill>
+          </a:ln>
+          <a:effectLst/>
+        </p:spPr>
+        <p:style>
+          <a:lnRef idx="1">
+            <a:schemeClr val="accent1"/>
+          </a:lnRef>
+          <a:fillRef idx="3">
+            <a:schemeClr val="accent1"/>
+          </a:fillRef>
+          <a:effectRef idx="2">
+            <a:schemeClr val="accent1"/>
+          </a:effectRef>
+          <a:fontRef idx="minor">
+            <a:schemeClr val="lt1"/>
+          </a:fontRef>
+        </p:style>
+        <p:txBody>
+          <a:bodyPr rtlCol="0" anchor="ctr" wrap="square" lIns="73152" rIns="73152"/>
+          <a:lstStyle/>
+          <a:p>
+            <a:pPr algn="ctr"/>
+            <a:r>
+              <a:rPr sz="1500" b="1">
+                <a:solidFill>
+                  <a:srgbClr val="DEE2E6"/>
+                </a:solidFill>
+              </a:rPr>
+              <a:t>serve</a:t>
+            </a:r>
+          </a:p>
+        </p:txBody>
+      </p:sp>
+      <p:sp>
+        <p:nvSpPr>
+          <p:cNvPr id="290" name="Rounded Rectangle 289"/>
+          <p:cNvSpPr/>
+          <p:nvPr/>
+        </p:nvSpPr>
+        <p:spPr>
+          <a:xfrm>
+            <a:off x="4114800" y="1508760"/>
+            <a:ext cx="1097280" cy="548640"/>
+          </a:xfrm>
+          <a:prstGeom prst="roundRect">
+            <a:avLst>
+              <a:gd name="adj" fmla="val 12000"/>
+            </a:avLst>
+          </a:prstGeom>
+          <a:solidFill>
+            <a:srgbClr val="2E3338"/>
+          </a:solidFill>
+          <a:ln>
+            <a:noFill/>
+          </a:ln>
+          <a:effectLst/>
+        </p:spPr>
+        <p:style>
+          <a:lnRef idx="1">
+            <a:schemeClr val="accent1"/>
+          </a:lnRef>
+          <a:fillRef idx="3">
+            <a:schemeClr val="accent1"/>
+          </a:fillRef>
+          <a:effectRef idx="2">
+            <a:schemeClr val="accent1"/>
+          </a:effectRef>
+          <a:fontRef idx="minor">
+            <a:schemeClr val="lt1"/>
+          </a:fontRef>
+        </p:style>
+        <p:txBody>
+          <a:bodyPr rtlCol="0" anchor="ctr" wrap="square" lIns="73152" rIns="73152"/>
+          <a:lstStyle/>
+          <a:p>
+            <a:pPr algn="ctr"/>
+            <a:r>
+              <a:rPr sz="1500" b="1">
+                <a:solidFill>
+                  <a:srgbClr val="DEE2E6"/>
+                </a:solidFill>
+              </a:rPr>
+              <a:t>play</a:t>
+            </a:r>
+          </a:p>
+        </p:txBody>
+      </p:sp>
+      <p:sp>
+        <p:nvSpPr>
+          <p:cNvPr id="291" name="Rounded Rectangle 290"/>
+          <p:cNvSpPr/>
+          <p:nvPr/>
+        </p:nvSpPr>
+        <p:spPr>
+          <a:xfrm>
+            <a:off x="5943600" y="1508760"/>
+            <a:ext cx="1097280" cy="548640"/>
+          </a:xfrm>
+          <a:prstGeom prst="roundRect">
+            <a:avLst>
+              <a:gd name="adj" fmla="val 12000"/>
+            </a:avLst>
+          </a:prstGeom>
+          <a:solidFill>
+            <a:srgbClr val="2E3338"/>
+          </a:solidFill>
+          <a:ln>
+            <a:noFill/>
+          </a:ln>
+          <a:effectLst/>
+        </p:spPr>
+        <p:style>
+          <a:lnRef idx="1">
+            <a:schemeClr val="accent1"/>
+          </a:lnRef>
+          <a:fillRef idx="3">
+            <a:schemeClr val="accent1"/>
+          </a:fillRef>
+          <a:effectRef idx="2">
+            <a:schemeClr val="accent1"/>
+          </a:effectRef>
+          <a:fontRef idx="minor">
+            <a:schemeClr val="lt1"/>
+          </a:fontRef>
+        </p:style>
+        <p:txBody>
+          <a:bodyPr rtlCol="0" anchor="ctr" wrap="square" lIns="73152" rIns="73152"/>
+          <a:lstStyle/>
+          <a:p>
+            <a:pPr algn="ctr"/>
+            <a:r>
+              <a:rPr sz="1500" b="1">
+                <a:solidFill>
+                  <a:srgbClr val="DEE2E6"/>
+                </a:solidFill>
+              </a:rPr>
+              <a:t>done</a:t>
+            </a:r>
+          </a:p>
+        </p:txBody>
+      </p:sp>
+      <p:cxnSp>
+        <p:nvCxnSpPr>
+          <p:cNvPr id="292" name="Connector 291"/>
+          <p:cNvCxnSpPr/>
+          <p:nvPr/>
+        </p:nvCxnSpPr>
+        <p:spPr>
+          <a:xfrm>
+            <a:off x="1572768" y="1783080"/>
+            <a:ext cx="694944" cy="0"/>
+          </a:xfrm>
+          <a:prstGeom prst="line">
+            <a:avLst/>
+          </a:prstGeom>
+          <a:ln w="25400">
+            <a:solidFill>
+              <a:srgbClr val="9AA3AB"/>
+            </a:solidFill>
+            <a:tailEnd type="triangle"/>
+          </a:ln>
+        </p:spPr>
+        <p:style>
+          <a:lnRef idx="2">
+            <a:schemeClr val="accent1"/>
+          </a:lnRef>
+          <a:fillRef idx="0">
+            <a:schemeClr val="accent1"/>
+          </a:fillRef>
+          <a:effectRef idx="1">
+            <a:schemeClr val="accent1"/>
+          </a:effectRef>
+          <a:fontRef idx="minor">
+            <a:schemeClr val="tx1"/>
+          </a:fontRef>
+        </p:style>
+      </p:cxnSp>
+      <p:sp>
+        <p:nvSpPr>
+          <p:cNvPr id="293" name="TextBox 292"/>
+          <p:cNvSpPr txBox="1"/>
+          <p:nvPr/>
+        </p:nvSpPr>
+        <p:spPr>
+          <a:xfrm>
+            <a:off x="1389888" y="1490472"/>
+            <a:ext cx="1060704" cy="274320"/>
+          </a:xfrm>
+          <a:prstGeom prst="rect">
+            <a:avLst/>
+          </a:prstGeom>
+          <a:noFill/>
+        </p:spPr>
+        <p:txBody>
+          <a:bodyPr wrap="square">
+            <a:spAutoFit/>
+          </a:bodyPr>
+          <a:lstStyle/>
+          <a:p>
+            <a:pPr algn="ctr"/>
+            <a:r>
+              <a:rPr sz="1100" b="0" i="0">
+                <a:solidFill>
+                  <a:srgbClr val="9AA3AB"/>
+                </a:solidFill>
+              </a:rPr>
+              <a:t>Enter</a:t>
+            </a:r>
+          </a:p>
+        </p:txBody>
+      </p:sp>
+      <p:cxnSp>
+        <p:nvCxnSpPr>
+          <p:cNvPr id="294" name="Connector 293"/>
+          <p:cNvCxnSpPr/>
+          <p:nvPr/>
+        </p:nvCxnSpPr>
+        <p:spPr>
+          <a:xfrm>
+            <a:off x="3401568" y="1691640"/>
+            <a:ext cx="694944" cy="0"/>
+          </a:xfrm>
+          <a:prstGeom prst="line">
+            <a:avLst/>
+          </a:prstGeom>
+          <a:ln w="25400">
+            <a:solidFill>
+              <a:srgbClr val="9AA3AB"/>
+            </a:solidFill>
+            <a:tailEnd type="triangle"/>
+          </a:ln>
+        </p:spPr>
+        <p:style>
+          <a:lnRef idx="2">
+            <a:schemeClr val="accent1"/>
+          </a:lnRef>
+          <a:fillRef idx="0">
+            <a:schemeClr val="accent1"/>
+          </a:fillRef>
+          <a:effectRef idx="1">
+            <a:schemeClr val="accent1"/>
+          </a:effectRef>
+          <a:fontRef idx="minor">
+            <a:schemeClr val="tx1"/>
+          </a:fontRef>
+        </p:style>
+      </p:cxnSp>
+      <p:sp>
+        <p:nvSpPr>
+          <p:cNvPr id="295" name="TextBox 294"/>
+          <p:cNvSpPr txBox="1"/>
+          <p:nvPr/>
+        </p:nvSpPr>
+        <p:spPr>
+          <a:xfrm>
+            <a:off x="3218688" y="1399032"/>
+            <a:ext cx="1060704" cy="274320"/>
+          </a:xfrm>
+          <a:prstGeom prst="rect">
+            <a:avLst/>
+          </a:prstGeom>
+          <a:noFill/>
+        </p:spPr>
+        <p:txBody>
+          <a:bodyPr wrap="square">
+            <a:spAutoFit/>
+          </a:bodyPr>
+          <a:lstStyle/>
+          <a:p>
+            <a:pPr algn="ctr"/>
+            <a:r>
+              <a:rPr sz="1100" b="0" i="0">
+                <a:solidFill>
+                  <a:srgbClr val="9AA3AB"/>
+                </a:solidFill>
+              </a:rPr>
+              <a:t>Enter</a:t>
+            </a:r>
+          </a:p>
+        </p:txBody>
+      </p:sp>
+      <p:cxnSp>
+        <p:nvCxnSpPr>
+          <p:cNvPr id="296" name="Connector 295"/>
+          <p:cNvCxnSpPr/>
+          <p:nvPr/>
+        </p:nvCxnSpPr>
+        <p:spPr>
+          <a:xfrm flipH="1">
+            <a:off x="3401568" y="1920240"/>
+            <a:ext cx="694944" cy="0"/>
+          </a:xfrm>
+          <a:prstGeom prst="line">
+            <a:avLst/>
+          </a:prstGeom>
+          <a:ln w="25400">
+            <a:solidFill>
+              <a:srgbClr val="9AA3AB"/>
+            </a:solidFill>
+            <a:tailEnd type="triangle"/>
+          </a:ln>
+        </p:spPr>
+        <p:style>
+          <a:lnRef idx="2">
+            <a:schemeClr val="accent1"/>
+          </a:lnRef>
+          <a:fillRef idx="0">
+            <a:schemeClr val="accent1"/>
+          </a:fillRef>
+          <a:effectRef idx="1">
+            <a:schemeClr val="accent1"/>
+          </a:effectRef>
+          <a:fontRef idx="minor">
+            <a:schemeClr val="tx1"/>
+          </a:fontRef>
+        </p:style>
+      </p:cxnSp>
+      <p:sp>
+        <p:nvSpPr>
+          <p:cNvPr id="297" name="TextBox 296"/>
+          <p:cNvSpPr txBox="1"/>
+          <p:nvPr/>
+        </p:nvSpPr>
+        <p:spPr>
+          <a:xfrm>
+            <a:off x="3200400" y="1965960"/>
+            <a:ext cx="1097280" cy="274320"/>
+          </a:xfrm>
+          <a:prstGeom prst="rect">
+            <a:avLst/>
+          </a:prstGeom>
+          <a:noFill/>
+        </p:spPr>
+        <p:txBody>
+          <a:bodyPr wrap="square">
+            <a:spAutoFit/>
+          </a:bodyPr>
+          <a:lstStyle/>
+          <a:p>
+            <a:pPr algn="ctr"/>
+            <a:r>
+              <a:rPr sz="1100" b="0" i="0">
+                <a:solidFill>
+                  <a:srgbClr val="9AA3AB"/>
+                </a:solidFill>
+              </a:rPr>
+              <a:t>a point</a:t>
+            </a:r>
+          </a:p>
+        </p:txBody>
+      </p:sp>
+      <p:cxnSp>
+        <p:nvCxnSpPr>
+          <p:cNvPr id="298" name="Connector 297"/>
+          <p:cNvCxnSpPr/>
+          <p:nvPr/>
+        </p:nvCxnSpPr>
+        <p:spPr>
+          <a:xfrm>
+            <a:off x="5230368" y="1783080"/>
+            <a:ext cx="694944" cy="0"/>
+          </a:xfrm>
+          <a:prstGeom prst="line">
+            <a:avLst/>
+          </a:prstGeom>
+          <a:ln w="25400">
+            <a:solidFill>
+              <a:srgbClr val="9AA3AB"/>
+            </a:solidFill>
+            <a:tailEnd type="triangle"/>
+          </a:ln>
+        </p:spPr>
+        <p:style>
+          <a:lnRef idx="2">
+            <a:schemeClr val="accent1"/>
+          </a:lnRef>
+          <a:fillRef idx="0">
+            <a:schemeClr val="accent1"/>
+          </a:fillRef>
+          <a:effectRef idx="1">
+            <a:schemeClr val="accent1"/>
+          </a:effectRef>
+          <a:fontRef idx="minor">
+            <a:schemeClr val="tx1"/>
+          </a:fontRef>
+        </p:style>
+      </p:cxnSp>
+      <p:sp>
+        <p:nvSpPr>
+          <p:cNvPr id="299" name="TextBox 298"/>
+          <p:cNvSpPr txBox="1"/>
+          <p:nvPr/>
+        </p:nvSpPr>
+        <p:spPr>
+          <a:xfrm>
+            <a:off x="5047488" y="1490472"/>
+            <a:ext cx="1060704" cy="274320"/>
+          </a:xfrm>
+          <a:prstGeom prst="rect">
+            <a:avLst/>
+          </a:prstGeom>
+          <a:noFill/>
+        </p:spPr>
+        <p:txBody>
+          <a:bodyPr wrap="square">
+            <a:spAutoFit/>
+          </a:bodyPr>
+          <a:lstStyle/>
+          <a:p>
+            <a:pPr algn="ctr"/>
+            <a:r>
+              <a:rPr sz="1100" b="0" i="0">
+                <a:solidFill>
+                  <a:srgbClr val="9AA3AB"/>
+                </a:solidFill>
+              </a:rPr>
+              <a:t>10 points</a:t>
+            </a:r>
+          </a:p>
+        </p:txBody>
+      </p:sp>
     </p:spTree>
   </p:cSld>
   <p:clrMapOvr>
@@ -19675,7 +21327,7 @@
         <p:spPr>
           <a:xfrm>
             <a:off x="311700" y="885950"/>
-            <a:ext cx="8520600" cy="4023300"/>
+            <a:ext cx="8520600" cy="521208"/>
           </a:xfrm>
           <a:prstGeom prst="rect">
             <a:avLst/>
@@ -19699,169 +21351,197 @@
             </a:pPr>
             <a:r>
               <a:rPr lang="en"/>
-              <a:t>The </a:t>
-            </a:r>
-            <a:r>
-              <a:rPr lang="en" u="sng">
-                <a:solidFill>
-                  <a:schemeClr val="hlink"/>
-                </a:solidFill>
-                <a:hlinkClick r:id="rId3"/>
+              <a:t>Two classes for audio: short sounds, and long music.</a:t>
+            </a:r>
+            <a:endParaRPr/>
+          </a:p>
+        </p:txBody>
+      </p:sp>
+      <p:sp>
+        <p:nvSpPr>
+          <p:cNvPr id="301" name="Rounded Rectangle 300"/>
+          <p:cNvSpPr/>
+          <p:nvPr/>
+        </p:nvSpPr>
+        <p:spPr>
+          <a:xfrm>
+            <a:off x="731520" y="1463040"/>
+            <a:ext cx="3566160" cy="1188720"/>
+          </a:xfrm>
+          <a:prstGeom prst="roundRect">
+            <a:avLst>
+              <a:gd name="adj" fmla="val 12000"/>
+            </a:avLst>
+          </a:prstGeom>
+          <a:solidFill>
+            <a:srgbClr val="2E3338"/>
+          </a:solidFill>
+          <a:ln w="25400">
+            <a:solidFill>
+              <a:srgbClr val="D45D35"/>
+            </a:solidFill>
+          </a:ln>
+          <a:effectLst/>
+        </p:spPr>
+        <p:style>
+          <a:lnRef idx="1">
+            <a:schemeClr val="accent1"/>
+          </a:lnRef>
+          <a:fillRef idx="3">
+            <a:schemeClr val="accent1"/>
+          </a:fillRef>
+          <a:effectRef idx="2">
+            <a:schemeClr val="accent1"/>
+          </a:effectRef>
+          <a:fontRef idx="minor">
+            <a:schemeClr val="lt1"/>
+          </a:fontRef>
+        </p:style>
+        <p:txBody>
+          <a:bodyPr rtlCol="0" anchor="ctr" wrap="square" lIns="73152" rIns="73152"/>
+          <a:lstStyle/>
+          <a:p>
+            <a:pPr algn="ctr"/>
+            <a:r>
+              <a:rPr sz="1700" b="1">
+                <a:solidFill>
+                  <a:srgbClr val="DEE2E6"/>
+                </a:solidFill>
               </a:rPr>
               <a:t>SoundEffect</a:t>
             </a:r>
-            <a:r>
-              <a:rPr lang="en"/>
-              <a:t> class handles short audio clips</a:t>
-            </a:r>
-            <a:endParaRPr/>
-          </a:p>
-          <a:p>
-            <a:pPr indent="-317500" lvl="1" marL="914400" rtl="0" algn="l">
-              <a:spcBef>
-                <a:spcPts val="0"/>
-              </a:spcBef>
-              <a:spcAft>
-                <a:spcPts val="0"/>
-              </a:spcAft>
-              <a:buSzPts val="1400"/>
-              <a:buChar char="○"/>
-            </a:pPr>
-            <a:r>
-              <a:rPr lang="en"/>
-              <a:t>collisions, jumping, shooting, button clicks, footsteps, ambient sounds, etc.</a:t>
-            </a:r>
-            <a:endParaRPr/>
-          </a:p>
-          <a:p>
-            <a:pPr indent="-330200" lvl="0" marL="457200" rtl="0" algn="l">
-              <a:spcBef>
-                <a:spcPts val="0"/>
-              </a:spcBef>
-              <a:spcAft>
-                <a:spcPts val="0"/>
-              </a:spcAft>
-              <a:buSzPts val="1600"/>
-              <a:buChar char="●"/>
-            </a:pPr>
-            <a:r>
-              <a:rPr lang="en"/>
-              <a:t>The key characteristics of sound effects are</a:t>
-            </a:r>
-            <a:endParaRPr/>
-          </a:p>
-          <a:p>
-            <a:pPr indent="-317500" lvl="0" marL="914400" rtl="0" algn="l">
-              <a:spcBef>
-                <a:spcPts val="0"/>
-              </a:spcBef>
-              <a:spcAft>
-                <a:spcPts val="0"/>
-              </a:spcAft>
-              <a:buClr>
-                <a:srgbClr val="6C757D"/>
-              </a:buClr>
-              <a:buSzPts val="1400"/>
-              <a:buChar char="●"/>
-            </a:pPr>
-            <a:r>
-              <a:rPr lang="en" sz="1400">
-                <a:solidFill>
-                  <a:srgbClr val="6C757D"/>
-                </a:solidFill>
-              </a:rPr>
-              <a:t>Loaded entirely into memory for quick access</a:t>
-            </a:r>
-            <a:endParaRPr sz="1400">
-              <a:solidFill>
-                <a:srgbClr val="6C757D"/>
-              </a:solidFill>
-            </a:endParaRPr>
-          </a:p>
-          <a:p>
-            <a:pPr indent="-317500" lvl="0" marL="914400" rtl="0" algn="l">
-              <a:spcBef>
-                <a:spcPts val="0"/>
-              </a:spcBef>
-              <a:spcAft>
-                <a:spcPts val="0"/>
-              </a:spcAft>
-              <a:buClr>
-                <a:srgbClr val="6C757D"/>
-              </a:buClr>
-              <a:buSzPts val="1400"/>
-              <a:buChar char="●"/>
-            </a:pPr>
-            <a:r>
-              <a:rPr lang="en" sz="1400">
-                <a:solidFill>
-                  <a:srgbClr val="6C757D"/>
-                </a:solidFill>
-              </a:rPr>
-              <a:t>Can play multiple instances simultaneously</a:t>
-            </a:r>
-            <a:endParaRPr sz="1400">
-              <a:solidFill>
-                <a:srgbClr val="6C757D"/>
-              </a:solidFill>
-            </a:endParaRPr>
-          </a:p>
-          <a:p>
-            <a:pPr indent="-317500" lvl="0" marL="914400" rtl="0" algn="l">
-              <a:spcBef>
-                <a:spcPts val="0"/>
-              </a:spcBef>
-              <a:spcAft>
-                <a:spcPts val="0"/>
-              </a:spcAft>
-              <a:buClr>
-                <a:srgbClr val="6C757D"/>
-              </a:buClr>
-              <a:buSzPts val="1400"/>
-              <a:buChar char="●"/>
-            </a:pPr>
-            <a:r>
-              <a:rPr lang="en" sz="1400">
-                <a:solidFill>
-                  <a:srgbClr val="6C757D"/>
-                </a:solidFill>
-              </a:rPr>
-              <a:t>Individual volume control per instance</a:t>
-            </a:r>
-            <a:endParaRPr sz="1400">
-              <a:solidFill>
-                <a:srgbClr val="6C757D"/>
-              </a:solidFill>
-            </a:endParaRPr>
-          </a:p>
-          <a:p>
-            <a:pPr indent="0" lvl="0" marL="0" rtl="0" algn="l">
-              <a:spcBef>
-                <a:spcPts val="1200"/>
-              </a:spcBef>
-              <a:spcAft>
-                <a:spcPts val="1200"/>
-              </a:spcAft>
-              <a:buNone/>
-            </a:pPr>
-            <a:r>
-              <a:rPr lang="en"/>
-              <a:t>For longer playing audio, the </a:t>
-            </a:r>
-            <a:r>
-              <a:rPr lang="en" u="sng">
-                <a:solidFill>
-                  <a:schemeClr val="hlink"/>
-                </a:solidFill>
-                <a:hlinkClick r:id="rId4"/>
+          </a:p>
+          <a:p>
+            <a:pPr algn="ctr"/>
+            <a:r>
+              <a:rPr sz="1500" b="0">
+                <a:solidFill>
+                  <a:srgbClr val="9AA3AB"/>
+                </a:solidFill>
+              </a:rPr>
+              <a:t>short clips, loaded into memory,</a:t>
+            </a:r>
+          </a:p>
+          <a:p>
+            <a:pPr algn="ctr"/>
+            <a:r>
+              <a:rPr sz="1500" b="0">
+                <a:solidFill>
+                  <a:srgbClr val="9AA3AB"/>
+                </a:solidFill>
+              </a:rPr>
+              <a:t>several at once, own volume</a:t>
+            </a:r>
+          </a:p>
+        </p:txBody>
+      </p:sp>
+      <p:sp>
+        <p:nvSpPr>
+          <p:cNvPr id="302" name="Rounded Rectangle 301"/>
+          <p:cNvSpPr/>
+          <p:nvPr/>
+        </p:nvSpPr>
+        <p:spPr>
+          <a:xfrm>
+            <a:off x="4846320" y="1463040"/>
+            <a:ext cx="3566160" cy="1188720"/>
+          </a:xfrm>
+          <a:prstGeom prst="roundRect">
+            <a:avLst>
+              <a:gd name="adj" fmla="val 12000"/>
+            </a:avLst>
+          </a:prstGeom>
+          <a:solidFill>
+            <a:srgbClr val="2E3338"/>
+          </a:solidFill>
+          <a:ln>
+            <a:noFill/>
+          </a:ln>
+          <a:effectLst/>
+        </p:spPr>
+        <p:style>
+          <a:lnRef idx="1">
+            <a:schemeClr val="accent1"/>
+          </a:lnRef>
+          <a:fillRef idx="3">
+            <a:schemeClr val="accent1"/>
+          </a:fillRef>
+          <a:effectRef idx="2">
+            <a:schemeClr val="accent1"/>
+          </a:effectRef>
+          <a:fontRef idx="minor">
+            <a:schemeClr val="lt1"/>
+          </a:fontRef>
+        </p:style>
+        <p:txBody>
+          <a:bodyPr rtlCol="0" anchor="ctr" wrap="square" lIns="73152" rIns="73152"/>
+          <a:lstStyle/>
+          <a:p>
+            <a:pPr algn="ctr"/>
+            <a:r>
+              <a:rPr sz="1700" b="1">
+                <a:solidFill>
+                  <a:srgbClr val="DEE2E6"/>
+                </a:solidFill>
               </a:rPr>
               <a:t>Song</a:t>
             </a:r>
-            <a:r>
-              <a:rPr lang="en"/>
-              <a:t> class is used (but not today…)</a:t>
-            </a:r>
-            <a:endParaRPr/>
+          </a:p>
+          <a:p>
+            <a:pPr algn="ctr"/>
+            <a:r>
+              <a:rPr sz="1500" b="0">
+                <a:solidFill>
+                  <a:srgbClr val="9AA3AB"/>
+                </a:solidFill>
+              </a:rPr>
+              <a:t>long music, streamed,</a:t>
+            </a:r>
+          </a:p>
+          <a:p>
+            <a:pPr algn="ctr"/>
+            <a:r>
+              <a:rPr sz="1500" b="0">
+                <a:solidFill>
+                  <a:srgbClr val="9AA3AB"/>
+                </a:solidFill>
+              </a:rPr>
+              <a:t>one at a time (not today)</a:t>
+            </a:r>
+          </a:p>
+        </p:txBody>
+      </p:sp>
+      <p:sp>
+        <p:nvSpPr>
+          <p:cNvPr id="303" name="TextBox 302"/>
+          <p:cNvSpPr txBox="1"/>
+          <p:nvPr/>
+        </p:nvSpPr>
+        <p:spPr>
+          <a:xfrm>
+            <a:off x="457200" y="3017520"/>
+            <a:ext cx="8229600" cy="731520"/>
+          </a:xfrm>
+          <a:prstGeom prst="rect">
+            <a:avLst/>
+          </a:prstGeom>
+          <a:noFill/>
+        </p:spPr>
+        <p:txBody>
+          <a:bodyPr wrap="square">
+            <a:spAutoFit/>
+          </a:bodyPr>
+          <a:lstStyle/>
+          <a:p>
+            <a:pPr algn="ctr"/>
+            <a:r>
+              <a:rPr sz="1800" b="1" i="0">
+                <a:solidFill>
+                  <a:srgbClr val="DEE2E6"/>
+                </a:solidFill>
+              </a:rPr>
+              <a:t>Which one for a hit? And for the background music?</a:t>
+            </a:r>
           </a:p>
         </p:txBody>
       </p:sp>
@@ -20791,6 +22471,162 @@
           </a:ln>
         </p:spPr>
       </p:pic>
+    </p:spTree>
+  </p:cSld>
+  <p:clrMapOvr>
+    <a:masterClrMapping/>
+  </p:clrMapOvr>
+</p:sld>
+</file>
+
+<file path=ppt/slides/slide51.xml><?xml version="1.0" encoding="utf-8"?>
+<p:sld xmlns:a="http://schemas.openxmlformats.org/drawingml/2006/main" xmlns:p="http://schemas.openxmlformats.org/presentationml/2006/main" xmlns:r="http://schemas.openxmlformats.org/officeDocument/2006/relationships">
+  <p:cSld>
+    <p:spTree>
+      <p:nvGrpSpPr>
+        <p:cNvPr id="1" name=""/>
+        <p:cNvGrpSpPr/>
+        <p:nvPr/>
+      </p:nvGrpSpPr>
+      <p:grpSpPr/>
+      <p:sp>
+        <p:nvSpPr>
+          <p:cNvPr id="2" name="Title 1"/>
+          <p:cNvSpPr>
+            <a:spLocks noGrp="1"/>
+          </p:cNvSpPr>
+          <p:nvPr>
+            <p:ph type="title"/>
+          </p:nvPr>
+        </p:nvSpPr>
+        <p:spPr/>
+        <p:txBody>
+          <a:bodyPr/>
+          <a:lstStyle/>
+          <a:p>
+            <a:pPr indent="0" lvl="0" marL="0" rtl="0" algn="l">
+              <a:spcBef>
+                <a:spcPts val="0"/>
+              </a:spcBef>
+              <a:spcAft>
+                <a:spcPts val="0"/>
+              </a:spcAft>
+              <a:buNone/>
+            </a:pPr>
+            <a:r>
+              <a:rPr lang="en"/>
+              <a:t>Check Yourself</a:t>
+            </a:r>
+            <a:endParaRPr/>
+          </a:p>
+        </p:txBody>
+      </p:sp>
+      <p:sp>
+        <p:nvSpPr>
+          <p:cNvPr id="3" name="Text Placeholder 2"/>
+          <p:cNvSpPr>
+            <a:spLocks noGrp="1"/>
+          </p:cNvSpPr>
+          <p:nvPr>
+            <p:ph type="body" idx="1"/>
+          </p:nvPr>
+        </p:nvSpPr>
+        <p:spPr>
+          <a:xfrm>
+            <a:off x="311700" y="885950"/>
+            <a:ext cx="8520600" cy="1335024"/>
+          </a:xfrm>
+        </p:spPr>
+        <p:txBody>
+          <a:bodyPr/>
+          <a:lstStyle/>
+          <a:p>
+            <a:pPr indent="-330200" lvl="0" marL="457200" rtl="0" algn="l">
+              <a:spcBef>
+                <a:spcPts val="0"/>
+              </a:spcBef>
+              <a:spcAft>
+                <a:spcPts val="0"/>
+              </a:spcAft>
+              <a:buSzPts val="1600"/>
+              <a:buChar char="●"/>
+            </a:pPr>
+            <a:r>
+              <a:rPr lang="en"/>
+              <a:t>What is the difference between a game engine and a game framework?</a:t>
+            </a:r>
+            <a:endParaRPr/>
+          </a:p>
+          <a:p>
+            <a:pPr indent="-330200" lvl="0" marL="457200" rtl="0" algn="l">
+              <a:spcBef>
+                <a:spcPts val="0"/>
+              </a:spcBef>
+              <a:spcAft>
+                <a:spcPts val="0"/>
+              </a:spcAft>
+              <a:buSzPts val="1600"/>
+              <a:buChar char="●"/>
+            </a:pPr>
+            <a:r>
+              <a:rPr lang="en"/>
+              <a:t>Why do we multiply movement by deltaTime?</a:t>
+            </a:r>
+            <a:endParaRPr/>
+          </a:p>
+          <a:p>
+            <a:pPr indent="-330200" lvl="0" marL="457200" rtl="0" algn="l">
+              <a:spcBef>
+                <a:spcPts val="0"/>
+              </a:spcBef>
+              <a:spcAft>
+                <a:spcPts val="0"/>
+              </a:spcAft>
+              <a:buSzPts val="1600"/>
+              <a:buChar char="●"/>
+            </a:pPr>
+            <a:r>
+              <a:rPr lang="en"/>
+              <a:t>Why is a string field a fragile way to store game state?</a:t>
+            </a:r>
+            <a:endParaRPr/>
+          </a:p>
+        </p:txBody>
+      </p:sp>
+      <p:sp>
+        <p:nvSpPr>
+          <p:cNvPr id="4" name="TextBox 3"/>
+          <p:cNvSpPr txBox="1"/>
+          <p:nvPr/>
+        </p:nvSpPr>
+        <p:spPr>
+          <a:xfrm>
+            <a:off x="457200" y="2798064"/>
+            <a:ext cx="8229600" cy="457200"/>
+          </a:xfrm>
+          <a:prstGeom prst="rect">
+            <a:avLst/>
+          </a:prstGeom>
+          <a:noFill/>
+        </p:spPr>
+        <p:txBody>
+          <a:bodyPr wrap="square">
+            <a:spAutoFit/>
+          </a:bodyPr>
+          <a:lstStyle/>
+          <a:p>
+            <a:pPr algn="ctr"/>
+            <a:r>
+              <a:rPr sz="1400" b="0" i="0">
+                <a:solidFill>
+                  <a:srgbClr val="9AA3AB"/>
+                </a:solidFill>
+              </a:rPr>
+              <a:t>The answers, and more questions, are on the course site.</a:t>
+            </a:r>
+          </a:p>
+        </p:txBody>
+      </p:sp>
     </p:spTree>
   </p:cSld>
   <p:clrMapOvr>

</xml_diff>

<commit_message>
Speaker notes written for presenting, in every deck
Every slide's notes now say what to say, what to ask the class (with
the expected answer), and how to run each demo (which steps to compare,
what to point at). Check yourself slides carry the site's answers.
The Pokemon deck uses the new monster names.

Co-Authored-By: Claude Opus 5.5 <noreply@anthropic.com>
Claude-Session: https://claude.ai/code/session_012sjsUQBbC7zon57rWHoo9d
</commit_message>
<xml_diff>
--- a/slides/01 Pong.pptx
+++ b/slides/01 Pong.pptx
@@ -831,19 +831,14 @@
           </a:bodyPr>
           <a:lstStyle/>
           <a:p>
-            <a:pPr indent="0" lvl="0" marL="0" rtl="0" algn="l">
-              <a:spcBef>
-                <a:spcPts val="0"/>
-              </a:spcBef>
-              <a:spcAft>
-                <a:spcPts val="0"/>
-              </a:spcAft>
-              <a:buNone/>
-            </a:pPr>
-            <a:r>
-              <a:t/>
-            </a:r>
-            <a:endParaRPr/>
+            <a:r>
+              <a:t>Welcome to Game Architecture. First the course: who we are, what you’ll build, how you’re assessed.</a:t>
+            </a:r>
+          </a:p>
+          <a:p>
+            <a:r>
+              <a:t>Then today’s game: Pong, the whole thing, from an empty window.</a:t>
+            </a:r>
           </a:p>
         </p:txBody>
       </p:sp>
@@ -931,17 +926,12 @@
           <a:lstStyle/>
           <a:p>
             <a:r>
-              <a:t>Talking points:</a:t>
-            </a:r>
-          </a:p>
-          <a:p>
-            <a:r>
-              <a:t>- The goal of the project is to create a simple 2D game that uses best practices for organizing and architecting a game project. That is, the project must include gameplay systems and design elements solved through patterns and principles taught in the course.</a:t>
-            </a:r>
-          </a:p>
-          <a:p>
-            <a:r>
-              <a:t>- Details on the course website</a:t>
+              <a:t>Groups of 1 to 3 make a small 2D game of their own, using the course’s patterns.</a:t>
+            </a:r>
+          </a:p>
+          <a:p>
+            <a:r>
+              <a:t>Show the project page on the site: milestones, what to hand in, and when.</a:t>
             </a:r>
           </a:p>
         </p:txBody>
@@ -1030,22 +1020,12 @@
           <a:lstStyle/>
           <a:p>
             <a:r>
-              <a:t>Talking points:</a:t>
-            </a:r>
-          </a:p>
-          <a:p>
-            <a:r>
-              <a:t>- Individual oral exam, 20 minutes, without preparation.</a:t>
-            </a:r>
-          </a:p>
-          <a:p>
-            <a:r>
-              <a:t>- The student will draw from a pool of known questions and is expected to reference their course project as part of the answer. This involves analyzing source code, as well as potentially writing or modifying source code during the exam. The final grade will be based on an overall assessment of the project presented and the oral examination.</a:t>
-            </a:r>
-          </a:p>
-          <a:p>
-            <a:r>
-              <a:t>- Internal assessment.</a:t>
+              <a:t>Walk through the flow on the slide. The question pool is on the site from today.</a:t>
+            </a:r>
+          </a:p>
+          <a:p>
+            <a:r>
+              <a:t>Say: your project is your exam material. Every session, ask where today’s topic fits in your game.</a:t>
             </a:r>
           </a:p>
         </p:txBody>
@@ -1133,19 +1113,14 @@
           </a:bodyPr>
           <a:lstStyle/>
           <a:p>
-            <a:pPr indent="0" lvl="0" marL="0" rtl="0" algn="l">
-              <a:spcBef>
-                <a:spcPts val="0"/>
-              </a:spcBef>
-              <a:spcAft>
-                <a:spcPts val="0"/>
-              </a:spcAft>
-              <a:buNone/>
-            </a:pPr>
-            <a:r>
-              <a:t/>
-            </a:r>
-            <a:endParaRPr/>
+            <a:r>
+              <a:t>Run Pong11 and play it for a minute.</a:t>
+            </a:r>
+          </a:p>
+          <a:p>
+            <a:r>
+              <a:t>Ask: what would you need to build this? Collect answers on the board, and come back to them at the end.</a:t>
+            </a:r>
           </a:p>
         </p:txBody>
       </p:sp>
@@ -1232,19 +1207,14 @@
           </a:bodyPr>
           <a:lstStyle/>
           <a:p>
-            <a:pPr indent="0" lvl="0" marL="0" rtl="0" algn="l">
-              <a:spcBef>
-                <a:spcPts val="0"/>
-              </a:spcBef>
-              <a:spcAft>
-                <a:spcPts val="0"/>
-              </a:spcAft>
-              <a:buNone/>
-            </a:pPr>
-            <a:r>
-              <a:t/>
-            </a:r>
-            <a:endParaRPr/>
+            <a:r>
+              <a:t>The main topic today is the game loop; everything else is what the loop needs: drawing, input, collisions, state, sound.</a:t>
+            </a:r>
+          </a:p>
+          <a:p>
+            <a:r>
+              <a:t>Each has a section on the course site.</a:t>
+            </a:r>
           </a:p>
         </p:txBody>
       </p:sp>
@@ -1331,19 +1301,9 @@
           </a:bodyPr>
           <a:lstStyle/>
           <a:p>
-            <a:pPr indent="0" lvl="0" marL="0" rtl="0" algn="l">
-              <a:spcBef>
-                <a:spcPts val="0"/>
-              </a:spcBef>
-              <a:spcAft>
-                <a:spcPts val="0"/>
-              </a:spcAft>
-              <a:buNone/>
-            </a:pPr>
-            <a:r>
-              <a:t/>
-            </a:r>
-            <a:endParaRPr/>
+            <a:r>
+              <a:t>MonoGame: our framework for the whole course. Free, open source, C#.</a:t>
+            </a:r>
           </a:p>
         </p:txBody>
       </p:sp>
@@ -1431,62 +1391,12 @@
           <a:lstStyle/>
           <a:p>
             <a:r>
-              <a:t>Talking points:</a:t>
-            </a:r>
-          </a:p>
-          <a:p>
-            <a:r>
-              <a:t>- At its core, MonoGame offers a set of libraries and APIs to handle common game development tasks</a:t>
-            </a:r>
-          </a:p>
-          <a:p>
-            <a:r>
-              <a:t>- Graphics Rendering</a:t>
-            </a:r>
-          </a:p>
-          <a:p>
-            <a:r>
-              <a:t>  - 2D and 3D rendering are supported through the graphics API offered by MonoGame</a:t>
-            </a:r>
-          </a:p>
-          <a:p>
-            <a:r>
-              <a:t>- Input Handling</a:t>
-            </a:r>
-          </a:p>
-          <a:p>
-            <a:r>
-              <a:t>  - Input from keyboard, mouse, gamepads, and touchscreens is supported</a:t>
-            </a:r>
-          </a:p>
-          <a:p>
-            <a:r>
-              <a:t>- Audio</a:t>
-            </a:r>
-          </a:p>
-          <a:p>
-            <a:r>
-              <a:t>  - A comprehensive audio system that can be used to create sound effects as well as play music</a:t>
-            </a:r>
-          </a:p>
-          <a:p>
-            <a:r>
-              <a:t>- Content Pipeline</a:t>
-            </a:r>
-          </a:p>
-          <a:p>
-            <a:r>
-              <a:t>  - An out-of-the-box workflow for importing and processing game assets</a:t>
-            </a:r>
-          </a:p>
-          <a:p>
-            <a:r>
-              <a:t>- Math Library</a:t>
-            </a:r>
-          </a:p>
-          <a:p>
-            <a:r>
-              <a:t>  - A math library specifically optimized for game development</a:t>
+              <a:t>Name the five boxes quickly. Then ask the question at the bottom.</a:t>
+            </a:r>
+          </a:p>
+          <a:p>
+            <a:r>
+              <a:t>Answer: we do. That is the course: we write the loop, the scenes and the entities ourselves, and learn how engines do it.</a:t>
             </a:r>
           </a:p>
         </p:txBody>
@@ -1574,19 +1484,14 @@
           </a:bodyPr>
           <a:lstStyle/>
           <a:p>
-            <a:pPr indent="0" lvl="0" marL="0" rtl="0" algn="l">
-              <a:spcBef>
-                <a:spcPts val="0"/>
-              </a:spcBef>
-              <a:spcAft>
-                <a:spcPts val="0"/>
-              </a:spcAft>
-              <a:buNone/>
-            </a:pPr>
-            <a:r>
-              <a:t/>
-            </a:r>
-            <a:endParaRPr/>
+            <a:r>
+              <a:t>Everyone installs these now, if they haven’t: the .NET 10 SDK, VS Code with the C# Dev Kit, Git.</a:t>
+            </a:r>
+          </a:p>
+          <a:p>
+            <a:r>
+              <a:t>Check that dotnet --version works before moving on.</a:t>
+            </a:r>
           </a:p>
         </p:txBody>
       </p:sp>
@@ -1673,19 +1578,14 @@
           </a:bodyPr>
           <a:lstStyle/>
           <a:p>
-            <a:pPr indent="0" lvl="0" marL="0" rtl="0" algn="l">
-              <a:spcBef>
-                <a:spcPts val="0"/>
-              </a:spcBef>
-              <a:spcAft>
-                <a:spcPts val="0"/>
-              </a:spcAft>
-              <a:buNone/>
-            </a:pPr>
-            <a:r>
-              <a:t/>
-            </a:r>
-            <a:endParaRPr/>
+            <a:r>
+              <a:t>Open gar-games/01-pong live. Show the README: the step table, the code map, how to run a step.</a:t>
+            </a:r>
+          </a:p>
+          <a:p>
+            <a:r>
+              <a:t>Say: the site explains the ideas, the README helps you find them in the code, the slides are for today.</a:t>
+            </a:r>
           </a:p>
         </p:txBody>
       </p:sp>
@@ -1772,19 +1672,14 @@
           </a:bodyPr>
           <a:lstStyle/>
           <a:p>
-            <a:pPr indent="0" lvl="0" marL="0" rtl="0" algn="l">
-              <a:spcBef>
-                <a:spcPts val="0"/>
-              </a:spcBef>
-              <a:spcAft>
-                <a:spcPts val="0"/>
-              </a:spcAft>
-              <a:buNone/>
-            </a:pPr>
-            <a:r>
-              <a:t/>
-            </a:r>
-            <a:endParaRPr/>
+            <a:r>
+              <a:t>First exercise: clone, open Pong0, run it. The screenshot is what they should see: an empty window.</a:t>
+            </a:r>
+          </a:p>
+          <a:p>
+            <a:r>
+              <a:t>Walk round and help anyone whose setup fails; don’t continue until most have a window.</a:t>
+            </a:r>
           </a:p>
         </p:txBody>
       </p:sp>
@@ -1871,19 +1766,14 @@
           </a:bodyPr>
           <a:lstStyle/>
           <a:p>
-            <a:pPr indent="0" lvl="0" marL="0" rtl="0" algn="l">
-              <a:spcBef>
-                <a:spcPts val="0"/>
-              </a:spcBef>
-              <a:spcAft>
-                <a:spcPts val="0"/>
-              </a:spcAft>
-              <a:buNone/>
-            </a:pPr>
-            <a:r>
-              <a:t/>
-            </a:r>
-            <a:endParaRPr/>
+            <a:r>
+              <a:t>Every game is this loop: process input, update the game, render. Many times a second, until the game ends.</a:t>
+            </a:r>
+          </a:p>
+          <a:p>
+            <a:r>
+              <a:t>Ask: why not wait for input like a normal app? Answer: the game has to keep moving even when nobody presses anything.</a:t>
+            </a:r>
           </a:p>
         </p:txBody>
       </p:sp>
@@ -1970,19 +1860,9 @@
           </a:bodyPr>
           <a:lstStyle/>
           <a:p>
-            <a:pPr indent="0" lvl="0" marL="0" rtl="0" algn="l">
-              <a:spcBef>
-                <a:spcPts val="0"/>
-              </a:spcBef>
-              <a:spcAft>
-                <a:spcPts val="0"/>
-              </a:spcAft>
-              <a:buNone/>
-            </a:pPr>
-            <a:r>
-              <a:t/>
-            </a:r>
-            <a:endParaRPr/>
+            <a:r>
+              <a:t>A short introduction: background, what I work on, how to reach me. Keep it to a minute.</a:t>
+            </a:r>
           </a:p>
         </p:txBody>
       </p:sp>
@@ -2069,19 +1949,14 @@
           </a:bodyPr>
           <a:lstStyle/>
           <a:p>
-            <a:pPr indent="0" lvl="0" marL="0" rtl="0" algn="l">
-              <a:spcBef>
-                <a:spcPts val="0"/>
-              </a:spcBef>
-              <a:spcAft>
-                <a:spcPts val="0"/>
-              </a:spcAft>
-              <a:buNone/>
-            </a:pPr>
-            <a:r>
-              <a:t/>
-            </a:r>
-            <a:endParaRPr/>
+            <a:r>
+              <a:t>The same loop in MonoGame: Initialize and LoadContent once, then Update and Draw every frame.</a:t>
+            </a:r>
+          </a:p>
+          <a:p>
+            <a:r>
+              <a:t>Open Game1.cs in Pong0 and find each method.</a:t>
+            </a:r>
           </a:p>
         </p:txBody>
       </p:sp>
@@ -2168,19 +2043,14 @@
           </a:bodyPr>
           <a:lstStyle/>
           <a:p>
-            <a:pPr indent="0" lvl="0" marL="0" rtl="0" algn="l">
-              <a:spcBef>
-                <a:spcPts val="0"/>
-              </a:spcBef>
-              <a:spcAft>
-                <a:spcPts val="0"/>
-              </a:spcAft>
-              <a:buNone/>
-            </a:pPr>
-            <a:r>
-              <a:t/>
-            </a:r>
-            <a:endParaRPr/>
+            <a:r>
+              <a:t>Follow an asset left to right: a file in Content/Assets, a rule in Builder.cs, the builder runs on build, an .xnb file, Content.Load at runtime.</a:t>
+            </a:r>
+          </a:p>
+          <a:p>
+            <a:r>
+              <a:t>Show Builder.cs briefly; they’ll add rules later.</a:t>
+            </a:r>
           </a:p>
         </p:txBody>
       </p:sp>
@@ -2267,19 +2137,9 @@
           </a:bodyPr>
           <a:lstStyle/>
           <a:p>
-            <a:pPr indent="0" lvl="0" marL="0" rtl="0" algn="l">
-              <a:spcBef>
-                <a:spcPts val="0"/>
-              </a:spcBef>
-              <a:spcAft>
-                <a:spcPts val="0"/>
-              </a:spcAft>
-              <a:buNone/>
-            </a:pPr>
-            <a:r>
-              <a:t/>
-            </a:r>
-            <a:endParaRPr/>
+            <a:r>
+              <a:t>Exercise: text centred on a 1280 × 720 window. They need a SpriteFont and MeasureString to centre it.</a:t>
+            </a:r>
           </a:p>
         </p:txBody>
       </p:sp>
@@ -2366,19 +2226,9 @@
           </a:bodyPr>
           <a:lstStyle/>
           <a:p>
-            <a:pPr indent="0" lvl="0" marL="0" rtl="0" algn="l">
-              <a:spcBef>
-                <a:spcPts val="0"/>
-              </a:spcBef>
-              <a:spcAft>
-                <a:spcPts val="0"/>
-              </a:spcAft>
-              <a:buNone/>
-            </a:pPr>
-            <a:r>
-              <a:t/>
-            </a:r>
-            <a:endParaRPr/>
+            <a:r>
+              <a:t>Point vs. linear filtering: pixel art wants point filtering, or it goes blurry when scaled up.</a:t>
+            </a:r>
           </a:p>
         </p:txBody>
       </p:sp>
@@ -2465,19 +2315,9 @@
           </a:bodyPr>
           <a:lstStyle/>
           <a:p>
-            <a:pPr indent="0" lvl="0" marL="0" rtl="0" algn="l">
-              <a:spcBef>
-                <a:spcPts val="0"/>
-              </a:spcBef>
-              <a:spcAft>
-                <a:spcPts val="0"/>
-              </a:spcAft>
-              <a:buNone/>
-            </a:pPr>
-            <a:r>
-              <a:t/>
-            </a:r>
-            <a:endParaRPr/>
+            <a:r>
+              <a:t>Exercise: draw at a fixed small resolution and scale it to the window. The window can resize; the game doesn’t notice.</a:t>
+            </a:r>
           </a:p>
         </p:txBody>
       </p:sp>
@@ -2564,19 +2404,9 @@
           </a:bodyPr>
           <a:lstStyle/>
           <a:p>
-            <a:pPr indent="0" lvl="0" marL="0" rtl="0" algn="l">
-              <a:spcBef>
-                <a:spcPts val="0"/>
-              </a:spcBef>
-              <a:spcAft>
-                <a:spcPts val="0"/>
-              </a:spcAft>
-              <a:buNone/>
-            </a:pPr>
-            <a:r>
-              <a:t/>
-            </a:r>
-            <a:endParaRPr/>
+            <a:r>
+              <a:t>The origin is the top left; y grows downwards. Most first bugs are a sign error here.</a:t>
+            </a:r>
           </a:p>
         </p:txBody>
       </p:sp>
@@ -2663,19 +2493,9 @@
           </a:bodyPr>
           <a:lstStyle/>
           <a:p>
-            <a:pPr indent="0" lvl="0" marL="0" rtl="0" algn="l">
-              <a:spcBef>
-                <a:spcPts val="0"/>
-              </a:spcBef>
-              <a:spcAft>
-                <a:spcPts val="0"/>
-              </a:spcAft>
-              <a:buNone/>
-            </a:pPr>
-            <a:r>
-              <a:t/>
-            </a:r>
-            <a:endParaRPr/>
+            <a:r>
+              <a:t>No image for a rectangle? Make a 1 × 1 white texture and stretch it. That’s all Pong needs.</a:t>
+            </a:r>
           </a:p>
         </p:txBody>
       </p:sp>
@@ -2762,19 +2582,9 @@
           </a:bodyPr>
           <a:lstStyle/>
           <a:p>
-            <a:pPr indent="0" lvl="0" marL="0" rtl="0" algn="l">
-              <a:spcBef>
-                <a:spcPts val="0"/>
-              </a:spcBef>
-              <a:spcAft>
-                <a:spcPts val="0"/>
-              </a:spcAft>
-              <a:buNone/>
-            </a:pPr>
-            <a:r>
-              <a:t/>
-            </a:r>
-            <a:endParaRPr/>
+            <a:r>
+              <a:t>Exercise: two paddles and a ball, a retro font, the background colour. The screenshot shows the result.</a:t>
+            </a:r>
           </a:p>
         </p:txBody>
       </p:sp>
@@ -2861,19 +2671,9 @@
           </a:bodyPr>
           <a:lstStyle/>
           <a:p>
-            <a:pPr indent="0" lvl="0" marL="0" rtl="0" algn="l">
-              <a:spcBef>
-                <a:spcPts val="0"/>
-              </a:spcBef>
-              <a:spcAft>
-                <a:spcPts val="0"/>
-              </a:spcAft>
-              <a:buNone/>
-            </a:pPr>
-            <a:r>
-              <a:t/>
-            </a:r>
-            <a:endParaRPr/>
+            <a:r>
+              <a:t>Keyboard.GetState() every frame, then IsKeyDown. Note the deltaTime in the movement: next slide.</a:t>
+            </a:r>
           </a:p>
         </p:txBody>
       </p:sp>
@@ -2960,19 +2760,14 @@
           </a:bodyPr>
           <a:lstStyle/>
           <a:p>
-            <a:pPr indent="0" lvl="0" marL="0" rtl="0" algn="l">
-              <a:spcBef>
-                <a:spcPts val="0"/>
-              </a:spcBef>
-              <a:spcAft>
-                <a:spcPts val="0"/>
-              </a:spcAft>
-              <a:buNone/>
-            </a:pPr>
-            <a:r>
-              <a:t/>
-            </a:r>
-            <a:endParaRPr/>
+            <a:r>
+              <a:t>Ask: why multiply by deltaTime? Answer: the same speed per second at any frame rate.</a:t>
+            </a:r>
+          </a:p>
+          <a:p>
+            <a:r>
+              <a:t>Velocity: speed with a direction; the ball needs one.</a:t>
+            </a:r>
           </a:p>
         </p:txBody>
       </p:sp>
@@ -3059,19 +2854,14 @@
           </a:bodyPr>
           <a:lstStyle/>
           <a:p>
-            <a:pPr indent="0" lvl="0" marL="0" rtl="0" algn="l">
-              <a:spcBef>
-                <a:spcPts val="0"/>
-              </a:spcBef>
-              <a:spcAft>
-                <a:spcPts val="0"/>
-              </a:spcAft>
-              <a:buNone/>
-            </a:pPr>
-            <a:r>
-              <a:t/>
-            </a:r>
-            <a:endParaRPr/>
+            <a:r>
+              <a:t>Go round the room: name, study line, a game you’ve played a lot, and whether you’ve made a game before.</a:t>
+            </a:r>
+          </a:p>
+          <a:p>
+            <a:r>
+              <a:t>Note who has made games before; they make good group anchors.</a:t>
+            </a:r>
           </a:p>
         </p:txBody>
       </p:sp>
@@ -3158,19 +2948,9 @@
           </a:bodyPr>
           <a:lstStyle/>
           <a:p>
-            <a:pPr indent="0" lvl="0" marL="0" rtl="0" algn="l">
-              <a:spcBef>
-                <a:spcPts val="0"/>
-              </a:spcBef>
-              <a:spcAft>
-                <a:spcPts val="0"/>
-              </a:spcAft>
-              <a:buNone/>
-            </a:pPr>
-            <a:r>
-              <a:t/>
-            </a:r>
-            <a:endParaRPr/>
+            <a:r>
+              <a:t>Exercise: W/S and the arrow keys move the paddles, the same speed at any frame rate.</a:t>
+            </a:r>
           </a:p>
         </p:txBody>
       </p:sp>
@@ -3257,19 +3037,14 @@
           </a:bodyPr>
           <a:lstStyle/>
           <a:p>
-            <a:pPr indent="0" lvl="0" marL="0" rtl="0" algn="l">
-              <a:spcBef>
-                <a:spcPts val="0"/>
-              </a:spcBef>
-              <a:spcAft>
-                <a:spcPts val="0"/>
-              </a:spcAft>
-              <a:buNone/>
-            </a:pPr>
-            <a:r>
-              <a:t/>
-            </a:r>
-            <a:endParaRPr/>
+            <a:r>
+              <a:t>IsKeyDown is true every frame the key is held. For a single press, compare with last frame’s state.</a:t>
+            </a:r>
+          </a:p>
+          <a:p>
+            <a:r>
+              <a:t>Flappy Bird moves this into GMDCore as WasKeyJustPressed.</a:t>
+            </a:r>
           </a:p>
         </p:txBody>
       </p:sp>
@@ -3356,19 +3131,9 @@
           </a:bodyPr>
           <a:lstStyle/>
           <a:p>
-            <a:pPr indent="0" lvl="0" marL="0" rtl="0" algn="l">
-              <a:spcBef>
-                <a:spcPts val="0"/>
-              </a:spcBef>
-              <a:spcAft>
-                <a:spcPts val="0"/>
-              </a:spcAft>
-              <a:buNone/>
-            </a:pPr>
-            <a:r>
-              <a:t/>
-            </a:r>
-            <a:endParaRPr/>
+            <a:r>
+              <a:t>Exercise: Enter launches the ball in a random direction; the paddles stay on screen.</a:t>
+            </a:r>
           </a:p>
         </p:txBody>
       </p:sp>
@@ -3455,19 +3220,9 @@
           </a:bodyPr>
           <a:lstStyle/>
           <a:p>
-            <a:pPr indent="0" lvl="0" marL="0" rtl="0" algn="l">
-              <a:spcBef>
-                <a:spcPts val="0"/>
-              </a:spcBef>
-              <a:spcAft>
-                <a:spcPts val="0"/>
-              </a:spcAft>
-              <a:buNone/>
-            </a:pPr>
-            <a:r>
-              <a:t/>
-            </a:r>
-            <a:endParaRPr/>
+            <a:r>
+              <a:t>Game1 is getting long. Data and the code that uses it belong together: a Paddle, a Ball.</a:t>
+            </a:r>
           </a:p>
         </p:txBody>
       </p:sp>
@@ -3554,19 +3309,9 @@
           </a:bodyPr>
           <a:lstStyle/>
           <a:p>
-            <a:pPr indent="0" lvl="0" marL="0" rtl="0" algn="l">
-              <a:spcBef>
-                <a:spcPts val="0"/>
-              </a:spcBef>
-              <a:spcAft>
-                <a:spcPts val="0"/>
-              </a:spcAft>
-              <a:buNone/>
-            </a:pPr>
-            <a:r>
-              <a:t/>
-            </a:r>
-            <a:endParaRPr/>
+            <a:r>
+              <a:t>Each object knows how to update itself; the game just calls them all. Read the chapter in Game Programming Patterns.</a:t>
+            </a:r>
           </a:p>
         </p:txBody>
       </p:sp>
@@ -3653,19 +3398,9 @@
           </a:bodyPr>
           <a:lstStyle/>
           <a:p>
-            <a:pPr indent="0" lvl="0" marL="0" rtl="0" algn="l">
-              <a:spcBef>
-                <a:spcPts val="0"/>
-              </a:spcBef>
-              <a:spcAft>
-                <a:spcPts val="0"/>
-              </a:spcAft>
-              <a:buNone/>
-            </a:pPr>
-            <a:r>
-              <a:t/>
-            </a:r>
-            <a:endParaRPr/>
+            <a:r>
+              <a:t>Exercise: refactor into Paddle and Ball. The game must behave exactly as before; that’s the point of a refactor.</a:t>
+            </a:r>
           </a:p>
         </p:txBody>
       </p:sp>
@@ -3752,19 +3487,14 @@
           </a:bodyPr>
           <a:lstStyle/>
           <a:p>
-            <a:pPr indent="0" lvl="0" marL="0" rtl="0" algn="l">
-              <a:spcBef>
-                <a:spcPts val="0"/>
-              </a:spcBef>
-              <a:spcAft>
-                <a:spcPts val="0"/>
-              </a:spcAft>
-              <a:buNone/>
-            </a:pPr>
-            <a:r>
-              <a:t/>
-            </a:r>
-            <a:endParaRPr/>
+            <a:r>
+              <a:t>Two boxes overlap unless one is entirely to the left, right, above or below the other.</a:t>
+            </a:r>
+          </a:p>
+          <a:p>
+            <a:r>
+              <a:t>Draw two boxes on the board and check the four conditions together.</a:t>
+            </a:r>
           </a:p>
         </p:txBody>
       </p:sp>
@@ -3851,19 +3581,9 @@
           </a:bodyPr>
           <a:lstStyle/>
           <a:p>
-            <a:pPr indent="0" lvl="0" marL="0" rtl="0" algn="l">
-              <a:spcBef>
-                <a:spcPts val="0"/>
-              </a:spcBef>
-              <a:spcAft>
-                <a:spcPts val="0"/>
-              </a:spcAft>
-              <a:buNone/>
-            </a:pPr>
-            <a:r>
-              <a:t/>
-            </a:r>
-            <a:endParaRPr/>
+            <a:r>
+              <a:t>Exercise: bounce off paddles and walls; each paddle hit speeds the ball up by 10%.</a:t>
+            </a:r>
           </a:p>
         </p:txBody>
       </p:sp>
@@ -3950,19 +3670,9 @@
           </a:bodyPr>
           <a:lstStyle/>
           <a:p>
-            <a:pPr indent="0" lvl="0" marL="0" rtl="0" algn="l">
-              <a:spcBef>
-                <a:spcPts val="0"/>
-              </a:spcBef>
-              <a:spcAft>
-                <a:spcPts val="0"/>
-              </a:spcAft>
-              <a:buNone/>
-            </a:pPr>
-            <a:r>
-              <a:t/>
-            </a:r>
-            <a:endParaRPr/>
+            <a:r>
+              <a:t>Exercise: keep score, shown in a bigger font.</a:t>
+            </a:r>
           </a:p>
         </p:txBody>
       </p:sp>
@@ -4049,19 +3759,9 @@
           </a:bodyPr>
           <a:lstStyle/>
           <a:p>
-            <a:pPr indent="0" lvl="0" marL="0" rtl="0" algn="l">
-              <a:spcBef>
-                <a:spcPts val="0"/>
-              </a:spcBef>
-              <a:spcAft>
-                <a:spcPts val="0"/>
-              </a:spcAft>
-              <a:buNone/>
-            </a:pPr>
-            <a:r>
-              <a:t/>
-            </a:r>
-            <a:endParaRPr/>
+            <a:r>
+              <a:t>The game is now in different modes: start, serve, play, done. So far a string field. Keep that in mind: Flappy Bird will show why it’s fragile.</a:t>
+            </a:r>
           </a:p>
         </p:txBody>
       </p:sp>
@@ -4148,19 +3848,9 @@
           </a:bodyPr>
           <a:lstStyle/>
           <a:p>
-            <a:pPr indent="0" lvl="0" marL="0" rtl="0" algn="l">
-              <a:spcBef>
-                <a:spcPts val="0"/>
-              </a:spcBef>
-              <a:spcAft>
-                <a:spcPts val="0"/>
-              </a:spcAft>
-              <a:buNone/>
-            </a:pPr>
-            <a:r>
-              <a:t/>
-            </a:r>
-            <a:endParaRPr/>
+            <a:r>
+              <a:t>Ask: what do you hope to get out of this course? Write answers on the board and keep them for the last session.</a:t>
+            </a:r>
           </a:p>
         </p:txBody>
       </p:sp>
@@ -4248,37 +3938,12 @@
           <a:lstStyle/>
           <a:p>
             <a:r>
-              <a:t>Talking points:</a:t>
-            </a:r>
-          </a:p>
-          <a:p>
-            <a:r>
-              <a:t>- Add a new Serve state to the game</a:t>
-            </a:r>
-          </a:p>
-          <a:p>
-            <a:r>
-              <a:t>  - When a player is serving, they send the ball towards the other player</a:t>
-            </a:r>
-          </a:p>
-          <a:p>
-            <a:r>
-              <a:t>  - The player who was last scored on gets to serve (random player at game start)</a:t>
-            </a:r>
-          </a:p>
-          <a:p>
-            <a:r>
-              <a:t>  - We transition from “play” to “serve” state when scoring</a:t>
-            </a:r>
-          </a:p>
-          <a:p>
-            <a:r>
-              <a:t>  - And from “serve” state to “play” state when pressing “Enter”</a:t>
-            </a:r>
-          </a:p>
-          <a:p>
-            <a:r>
-              <a:t>  - The game begins in the “start” state and transitions to the “serve” state by pressing “Enter”</a:t>
+              <a:t>Follow the diagram: start, Enter, serve, Enter, play; a point goes back to serve; 10 points ends it.</a:t>
+            </a:r>
+          </a:p>
+          <a:p>
+            <a:r>
+              <a:t>Exercise: add the serve state.</a:t>
             </a:r>
           </a:p>
         </p:txBody>
@@ -4366,19 +4031,9 @@
           </a:bodyPr>
           <a:lstStyle/>
           <a:p>
-            <a:pPr indent="0" lvl="0" marL="0" rtl="0" algn="l">
-              <a:spcBef>
-                <a:spcPts val="0"/>
-              </a:spcBef>
-              <a:spcAft>
-                <a:spcPts val="0"/>
-              </a:spcAft>
-              <a:buNone/>
-            </a:pPr>
-            <a:r>
-              <a:t/>
-            </a:r>
-            <a:endParaRPr/>
+            <a:r>
+              <a:t>Exercise: a done state at 10 points. The screenshot shows the end screen.</a:t>
+            </a:r>
           </a:p>
         </p:txBody>
       </p:sp>
@@ -4466,42 +4121,7 @@
           <a:lstStyle/>
           <a:p>
             <a:r>
-              <a:t>Talking points:</a:t>
-            </a:r>
-          </a:p>
-          <a:p>
-            <a:r>
-              <a:t>- The SoundEffect class handles short audio clips</a:t>
-            </a:r>
-          </a:p>
-          <a:p>
-            <a:r>
-              <a:t>  - collisions, jumping, shooting, button clicks, footsteps, ambient sounds, etc.</a:t>
-            </a:r>
-          </a:p>
-          <a:p>
-            <a:r>
-              <a:t>- The key characteristics of sound effects are</a:t>
-            </a:r>
-          </a:p>
-          <a:p>
-            <a:r>
-              <a:t>- Loaded entirely into memory for quick access</a:t>
-            </a:r>
-          </a:p>
-          <a:p>
-            <a:r>
-              <a:t>- Can play multiple instances simultaneously</a:t>
-            </a:r>
-          </a:p>
-          <a:p>
-            <a:r>
-              <a:t>- Individual volume control per instance</a:t>
-            </a:r>
-          </a:p>
-          <a:p>
-            <a:r>
-              <a:t>- For longer playing audio, the Song class is used (but not today…)</a:t>
+              <a:t>Ask the question. Answer: SoundEffect for the hit (short, several at once), Song for music (streamed, one at a time).</a:t>
             </a:r>
           </a:p>
         </p:txBody>
@@ -4589,19 +4209,9 @@
           </a:bodyPr>
           <a:lstStyle/>
           <a:p>
-            <a:pPr indent="0" lvl="0" marL="0" rtl="0" algn="l">
-              <a:spcBef>
-                <a:spcPts val="0"/>
-              </a:spcBef>
-              <a:spcAft>
-                <a:spcPts val="0"/>
-              </a:spcAft>
-              <a:buNone/>
-            </a:pPr>
-            <a:r>
-              <a:t/>
-            </a:r>
-            <a:endParaRPr/>
+            <a:r>
+              <a:t>bfxr.net makes retro sound effects in seconds. Or record your own.</a:t>
+            </a:r>
           </a:p>
         </p:txBody>
       </p:sp>
@@ -4688,19 +4298,9 @@
           </a:bodyPr>
           <a:lstStyle/>
           <a:p>
-            <a:pPr indent="0" lvl="0" marL="0" rtl="0" algn="l">
-              <a:spcBef>
-                <a:spcPts val="0"/>
-              </a:spcBef>
-              <a:spcAft>
-                <a:spcPts val="0"/>
-              </a:spcAft>
-              <a:buNone/>
-            </a:pPr>
-            <a:r>
-              <a:t/>
-            </a:r>
-            <a:endParaRPr/>
+            <a:r>
+              <a:t>Exercise: three sounds: paddle hit, wall hit, score.</a:t>
+            </a:r>
           </a:p>
         </p:txBody>
       </p:sp>
@@ -4787,19 +4387,14 @@
           </a:bodyPr>
           <a:lstStyle/>
           <a:p>
-            <a:pPr indent="0" lvl="0" marL="0" rtl="0" algn="l">
-              <a:spcBef>
-                <a:spcPts val="0"/>
-              </a:spcBef>
-              <a:spcAft>
-                <a:spcPts val="0"/>
-              </a:spcAft>
-              <a:buNone/>
-            </a:pPr>
-            <a:r>
-              <a:t/>
-            </a:r>
-            <a:endParaRPr/>
+            <a:r>
+              <a:t>Wrap up: the loop, drawing, input, collisions, state, sound. Everything later builds on this.</a:t>
+            </a:r>
+          </a:p>
+          <a:p>
+            <a:r>
+              <a:t>Before next time: read the Flappy Bird page’s Prepare section.</a:t>
+            </a:r>
           </a:p>
         </p:txBody>
       </p:sp>
@@ -4856,47 +4451,17 @@
           <a:lstStyle/>
           <a:p>
             <a:r>
-              <a:t>Talking points:</a:t>
-            </a:r>
-          </a:p>
-          <a:p>
-            <a:r>
-              <a:t>- Update changes the state of the world</a:t>
-            </a:r>
-          </a:p>
-          <a:p>
-            <a:r>
-              <a:t>  - Input, movement, collisions, game rules</a:t>
-            </a:r>
-          </a:p>
-          <a:p>
-            <a:r>
-              <a:t>- Draw only reads that state and renders it</a:t>
-            </a:r>
-          </a:p>
-          <a:p>
-            <a:r>
-              <a:t>  - Never change game state in Draw</a:t>
-            </a:r>
-          </a:p>
-          <a:p>
-            <a:r>
-              <a:t>- Keeping them apart lets the simulation and the rendering run at different rates</a:t>
-            </a:r>
-          </a:p>
-          <a:p>
-            <a:r>
-              <a:t>- Double buffer</a:t>
-            </a:r>
-          </a:p>
-          <a:p>
-            <a:r>
-              <a:t>  - We draw into a back buffer that isn't visible</a:t>
-            </a:r>
-          </a:p>
-          <a:p>
-            <a:r>
-              <a:t>  - At the end of Draw, MonoGame presents it: the player never sees a half-drawn frame</a:t>
+              <a:t>Update writes the game state; Draw only reads it.</a:t>
+            </a:r>
+          </a:p>
+          <a:p>
+            <a:r>
+              <a:t>Ask the question on the slide. Answer: the ball moves when frames are drawn, not when the game updates: faster on a fast screen, and wrong when Draw is skipped.</a:t>
+            </a:r>
+          </a:p>
+          <a:p>
+            <a:r>
+              <a:t>The back buffer: the player never sees a half-drawn frame.</a:t>
             </a:r>
           </a:p>
         </p:txBody>
@@ -4954,47 +4519,12 @@
           <a:lstStyle/>
           <a:p>
             <a:r>
-              <a:t>Talking points:</a:t>
-            </a:r>
-          </a:p>
-          <a:p>
-            <a:r>
-              <a:t>- Variable timestep</a:t>
-            </a:r>
-          </a:p>
-          <a:p>
-            <a:r>
-              <a:t>  - One Update per rendered frame, movement scaled by deltaTime</a:t>
-            </a:r>
-          </a:p>
-          <a:p>
-            <a:r>
-              <a:t>  - Simple, but the simulation behaves slightly differently at different frame rates</a:t>
-            </a:r>
-          </a:p>
-          <a:p>
-            <a:r>
-              <a:t>- Fixed timestep</a:t>
-            </a:r>
-          </a:p>
-          <a:p>
-            <a:r>
-              <a:t>  - Update in fixed-size steps (e.g. 60 per second): zero, one or several per frame</a:t>
-            </a:r>
-          </a:p>
-          <a:p>
-            <a:r>
-              <a:t>  - Deterministic and stable, at the cost of some complexity</a:t>
-            </a:r>
-          </a:p>
-          <a:p>
-            <a:r>
-              <a:t>- MonoGame uses a fixed timestep by default (IsFixedTimeStep = true)</a:t>
-            </a:r>
-          </a:p>
-          <a:p>
-            <a:r>
-              <a:t>- Try it: the game loop demo on the course site</a:t>
+              <a:t>Variable: one update per frame, scaled by delta time. Fixed: always the same step, zero or several times a frame.</a:t>
+            </a:r>
+          </a:p>
+          <a:p>
+            <a:r>
+              <a:t>Open the game-loop demo on the course site and try both at a low frame rate. Snake uses a fixed step on purpose.</a:t>
             </a:r>
           </a:p>
         </p:txBody>
@@ -5052,7 +4582,103 @@
           <a:lstStyle/>
           <a:p>
             <a:r>
-              <a:t>Ask, let them answer in pairs for a minute, then take a few answers. These are the site’s Check yourself questions.</a:t>
+              <a:t>Ask one question at a time. Pairs discuss for a minute, then take two or three answers.</a:t>
+            </a:r>
+          </a:p>
+          <a:p>
+            <a:r>
+              <a:t>Expected answers (from the course site):</a:t>
+            </a:r>
+          </a:p>
+          <a:p/>
+          <a:p>
+            <a:r>
+              <a:t>Q: What is the difference between a game engine and a game framework?</a:t>
+            </a:r>
+          </a:p>
+          <a:p>
+            <a:r>
+              <a:t>A: An engine is a complete environment: editor, scene and object model, and a loop that calls your scripts. A framework like MonoGame is a set of libraries. You write the game's structure yourself, including the loop's contents.</a:t>
+            </a:r>
+          </a:p>
+          <a:p/>
+          <a:p>
+            <a:r>
+              <a:t>Q: Why do we multiply movement by deltaTime?</a:t>
+            </a:r>
+          </a:p>
+          <a:p>
+            <a:r>
+              <a:t>A: So that movement per second is the same no matter how many frames are rendered per second.</a:t>
+            </a:r>
+          </a:p>
+          <a:p/>
+          <a:p>
+            <a:r>
+              <a:t>Q: Why is a string field a fragile way to store game state?</a:t>
+            </a:r>
+          </a:p>
+          <a:p>
+            <a:r>
+              <a:t>A: Typos aren't caught by the compiler, every Update/Draw needs an if-chain over all states, and adding a state means editing all of those chains.</a:t>
+            </a:r>
+          </a:p>
+        </p:txBody>
+      </p:sp>
+    </p:spTree>
+  </p:cSld>
+  <p:clrMapOvr>
+    <a:masterClrMapping/>
+  </p:clrMapOvr>
+</p:notes>
+</file>
+
+<file path=ppt/notesSlides/notesSlide49.xml><?xml version="1.0" encoding="utf-8"?>
+<p:notes xmlns:a="http://schemas.openxmlformats.org/drawingml/2006/main" xmlns:p="http://schemas.openxmlformats.org/presentationml/2006/main" xmlns:r="http://schemas.openxmlformats.org/officeDocument/2006/relationships">
+  <p:cSld>
+    <p:spTree>
+      <p:nvGrpSpPr>
+        <p:cNvPr id="1" name=""/>
+        <p:cNvGrpSpPr/>
+        <p:nvPr/>
+      </p:nvGrpSpPr>
+      <p:grpSpPr>
+        <a:xfrm>
+          <a:off x="0" y="0"/>
+          <a:ext cx="0" cy="0"/>
+          <a:chOff x="0" y="0"/>
+          <a:chExt cx="0" cy="0"/>
+        </a:xfrm>
+      </p:grpSpPr>
+      <p:sp>
+        <p:nvSpPr>
+          <p:cNvPr id="2" name="Slide Image Placeholder 1"/>
+          <p:cNvSpPr>
+            <a:spLocks noGrp="1"/>
+          </p:cNvSpPr>
+          <p:nvPr>
+            <p:ph type="sldImg" idx="2"/>
+          </p:nvPr>
+        </p:nvSpPr>
+        <p:spPr/>
+      </p:sp>
+      <p:sp>
+        <p:nvSpPr>
+          <p:cNvPr id="3" name="Notes Placeholder 2"/>
+          <p:cNvSpPr>
+            <a:spLocks noGrp="1"/>
+          </p:cNvSpPr>
+          <p:nvPr>
+            <p:ph type="body" idx="1"/>
+          </p:nvPr>
+        </p:nvSpPr>
+        <p:spPr/>
+        <p:txBody>
+          <a:bodyPr/>
+          <a:lstStyle/>
+          <a:p>
+            <a:r>
+              <a:t>Pong6: Game1.Update is three calls. Ask: what happens when we add a second ball? Answer: one more call, or a list.</a:t>
             </a:r>
           </a:p>
         </p:txBody>
@@ -5140,19 +4766,130 @@
           </a:bodyPr>
           <a:lstStyle/>
           <a:p>
-            <a:pPr indent="0" lvl="0" marL="0" rtl="0" algn="l">
-              <a:spcBef>
-                <a:spcPts val="0"/>
-              </a:spcBef>
-              <a:spcAft>
-                <a:spcPts val="0"/>
-              </a:spcAft>
-              <a:buNone/>
-            </a:pPr>
-            <a:r>
-              <a:t/>
-            </a:r>
-            <a:endParaRPr/>
+            <a:r>
+              <a:t>Say: build a lot, and learn from what you build. Come to class, do the exercises, and bring your project along.</a:t>
+            </a:r>
+          </a:p>
+        </p:txBody>
+      </p:sp>
+    </p:spTree>
+  </p:cSld>
+  <p:clrMapOvr>
+    <a:masterClrMapping/>
+  </p:clrMapOvr>
+</p:notes>
+</file>
+
+<file path=ppt/notesSlides/notesSlide50.xml><?xml version="1.0" encoding="utf-8"?>
+<p:notes xmlns:a="http://schemas.openxmlformats.org/drawingml/2006/main" xmlns:p="http://schemas.openxmlformats.org/presentationml/2006/main" xmlns:r="http://schemas.openxmlformats.org/officeDocument/2006/relationships">
+  <p:cSld>
+    <p:spTree>
+      <p:nvGrpSpPr>
+        <p:cNvPr id="1" name=""/>
+        <p:cNvGrpSpPr/>
+        <p:nvPr/>
+      </p:nvGrpSpPr>
+      <p:grpSpPr>
+        <a:xfrm>
+          <a:off x="0" y="0"/>
+          <a:ext cx="0" cy="0"/>
+          <a:chOff x="0" y="0"/>
+          <a:chExt cx="0" cy="0"/>
+        </a:xfrm>
+      </p:grpSpPr>
+      <p:sp>
+        <p:nvSpPr>
+          <p:cNvPr id="2" name="Slide Image Placeholder 1"/>
+          <p:cNvSpPr>
+            <a:spLocks noGrp="1"/>
+          </p:cNvSpPr>
+          <p:nvPr>
+            <p:ph type="sldImg" idx="2"/>
+          </p:nvPr>
+        </p:nvSpPr>
+        <p:spPr/>
+      </p:sp>
+      <p:sp>
+        <p:nvSpPr>
+          <p:cNvPr id="3" name="Notes Placeholder 2"/>
+          <p:cNvSpPr>
+            <a:spLocks noGrp="1"/>
+          </p:cNvSpPr>
+          <p:nvPr>
+            <p:ph type="body" idx="1"/>
+          </p:nvPr>
+        </p:nvSpPr>
+        <p:spPr/>
+        <p:txBody>
+          <a:bodyPr/>
+          <a:lstStyle/>
+          <a:p>
+            <a:r>
+              <a:t>Give the groups (or future groups) five minutes: two or three game ideas, and what updates and draws in each.</a:t>
+            </a:r>
+          </a:p>
+          <a:p>
+            <a:r>
+              <a:t>Ask a few to share. Encourage small, classic games.</a:t>
+            </a:r>
+          </a:p>
+        </p:txBody>
+      </p:sp>
+    </p:spTree>
+  </p:cSld>
+  <p:clrMapOvr>
+    <a:masterClrMapping/>
+  </p:clrMapOvr>
+</p:notes>
+</file>
+
+<file path=ppt/notesSlides/notesSlide51.xml><?xml version="1.0" encoding="utf-8"?>
+<p:notes xmlns:a="http://schemas.openxmlformats.org/drawingml/2006/main" xmlns:p="http://schemas.openxmlformats.org/presentationml/2006/main" xmlns:r="http://schemas.openxmlformats.org/officeDocument/2006/relationships">
+  <p:cSld>
+    <p:spTree>
+      <p:nvGrpSpPr>
+        <p:cNvPr id="1" name=""/>
+        <p:cNvGrpSpPr/>
+        <p:nvPr/>
+      </p:nvGrpSpPr>
+      <p:grpSpPr>
+        <a:xfrm>
+          <a:off x="0" y="0"/>
+          <a:ext cx="0" cy="0"/>
+          <a:chOff x="0" y="0"/>
+          <a:chExt cx="0" cy="0"/>
+        </a:xfrm>
+      </p:grpSpPr>
+      <p:sp>
+        <p:nvSpPr>
+          <p:cNvPr id="2" name="Slide Image Placeholder 1"/>
+          <p:cNvSpPr>
+            <a:spLocks noGrp="1"/>
+          </p:cNvSpPr>
+          <p:nvPr>
+            <p:ph type="sldImg" idx="2"/>
+          </p:nvPr>
+        </p:nvSpPr>
+        <p:spPr/>
+      </p:sp>
+      <p:sp>
+        <p:nvSpPr>
+          <p:cNvPr id="3" name="Notes Placeholder 2"/>
+          <p:cNvSpPr>
+            <a:spLocks noGrp="1"/>
+          </p:cNvSpPr>
+          <p:nvPr>
+            <p:ph type="body" idx="1"/>
+          </p:nvPr>
+        </p:nvSpPr>
+        <p:spPr/>
+        <p:txBody>
+          <a:bodyPr/>
+          <a:lstStyle/>
+          <a:p>
+            <a:r>
+              <a:t>Form groups before next time. First milestone by session 04: groups, a concept, a repository.</a:t>
+            </a:r>
           </a:p>
         </p:txBody>
       </p:sp>
@@ -5239,19 +4976,14 @@
           </a:bodyPr>
           <a:lstStyle/>
           <a:p>
-            <a:pPr indent="0" lvl="0" marL="0" rtl="0" algn="l">
-              <a:spcBef>
-                <a:spcPts val="0"/>
-              </a:spcBef>
-              <a:spcAft>
-                <a:spcPts val="0"/>
-              </a:spcAft>
-              <a:buNone/>
-            </a:pPr>
-            <a:r>
-              <a:t/>
-            </a:r>
-            <a:endParaRPr/>
+            <a:r>
+              <a:t>The official course description. Underline the last sentence: it’s a software engineering course, in a game context.</a:t>
+            </a:r>
+          </a:p>
+          <a:p>
+            <a:r>
+              <a:t>Games are the vehicle; architecture and patterns are the subject.</a:t>
+            </a:r>
           </a:p>
         </p:txBody>
       </p:sp>
@@ -5338,19 +5070,14 @@
           </a:bodyPr>
           <a:lstStyle/>
           <a:p>
-            <a:pPr indent="0" lvl="0" marL="0" rtl="0" algn="l">
-              <a:spcBef>
-                <a:spcPts val="0"/>
-              </a:spcBef>
-              <a:spcAft>
-                <a:spcPts val="0"/>
-              </a:spcAft>
-              <a:buNone/>
-            </a:pPr>
-            <a:r>
-              <a:t/>
-            </a:r>
-            <a:endParaRPr/>
+            <a:r>
+              <a:t>Point out the patterns: each session has one main topic, and most are a named pattern.</a:t>
+            </a:r>
+          </a:p>
+          <a:p>
+            <a:r>
+              <a:t>All of it is on the course site; the recap page connects them at the end.</a:t>
+            </a:r>
           </a:p>
         </p:txBody>
       </p:sp>
@@ -5437,19 +5164,14 @@
           </a:bodyPr>
           <a:lstStyle/>
           <a:p>
-            <a:pPr indent="0" lvl="0" marL="0" rtl="0" algn="l">
-              <a:spcBef>
-                <a:spcPts val="0"/>
-              </a:spcBef>
-              <a:spcAft>
-                <a:spcPts val="0"/>
-              </a:spcAft>
-              <a:buNone/>
-            </a:pPr>
-            <a:r>
-              <a:t/>
-            </a:r>
-            <a:endParaRPr/>
+            <a:r>
+              <a:t>One classic game per session, in this order. Each game is small, but introduces one main idea.</a:t>
+            </a:r>
+          </a:p>
+          <a:p>
+            <a:r>
+              <a:t>The schedule on the site says which topic comes when.</a:t>
+            </a:r>
           </a:p>
         </p:txBody>
       </p:sp>
@@ -5536,19 +5258,14 @@
           </a:bodyPr>
           <a:lstStyle/>
           <a:p>
-            <a:pPr indent="0" lvl="0" marL="0" rtl="0" algn="l">
-              <a:spcBef>
-                <a:spcPts val="0"/>
-              </a:spcBef>
-              <a:spcAft>
-                <a:spcPts val="0"/>
-              </a:spcAft>
-              <a:buNone/>
-            </a:pPr>
-            <a:r>
-              <a:t/>
-            </a:r>
-            <a:endParaRPr/>
+            <a:r>
+              <a:t>Game Programming Patterns by Robert Nystrom, free at gameprogrammingpatterns.com. The main reading for the course.</a:t>
+            </a:r>
+          </a:p>
+          <a:p>
+            <a:r>
+              <a:t>The site links the relevant chapter under Prepare for each session.</a:t>
+            </a:r>
           </a:p>
         </p:txBody>
       </p:sp>
@@ -21887,133 +21604,139 @@
       <p:grpSpPr/>
       <p:sp>
         <p:nvSpPr>
-          <p:cNvPr id="76" name="Google Shape;76;p15"/>
-          <p:cNvSpPr txBox="1"/>
+          <p:cNvPr id="2" name="Title 1"/>
+          <p:cNvSpPr>
+            <a:spLocks noGrp="1"/>
+          </p:cNvSpPr>
           <p:nvPr>
             <p:ph type="title"/>
           </p:nvPr>
         </p:nvSpPr>
-        <p:spPr>
-          <a:xfrm>
-            <a:off x="311700" y="195615"/>
-            <a:ext cx="8520600" cy="572700"/>
+        <p:spPr/>
+        <p:txBody>
+          <a:bodyPr/>
+          <a:lstStyle/>
+          <a:p>
+            <a:pPr indent="0" lvl="0" marL="0" rtl="0" algn="l">
+              <a:spcBef>
+                <a:spcPts val="0"/>
+              </a:spcBef>
+              <a:spcAft>
+                <a:spcPts val="0"/>
+              </a:spcAft>
+              <a:buNone/>
+            </a:pPr>
+            <a:r>
+              <a:rPr lang="en"/>
+              <a:t>Check Yourself</a:t>
+            </a:r>
+            <a:endParaRPr/>
+          </a:p>
+        </p:txBody>
+      </p:sp>
+      <p:sp>
+        <p:nvSpPr>
+          <p:cNvPr id="3" name="Text Placeholder 2"/>
+          <p:cNvSpPr>
+            <a:spLocks noGrp="1"/>
+          </p:cNvSpPr>
+          <p:nvPr>
+            <p:ph type="body" idx="1"/>
+          </p:nvPr>
+        </p:nvSpPr>
+        <p:spPr>
+          <a:xfrm>
+            <a:off x="311700" y="885950"/>
+            <a:ext cx="8520600" cy="1335024"/>
+          </a:xfrm>
+        </p:spPr>
+        <p:txBody>
+          <a:bodyPr/>
+          <a:lstStyle/>
+          <a:p>
+            <a:pPr indent="-330200" lvl="0" marL="457200" rtl="0" algn="l">
+              <a:spcBef>
+                <a:spcPts val="0"/>
+              </a:spcBef>
+              <a:spcAft>
+                <a:spcPts val="0"/>
+              </a:spcAft>
+              <a:buSzPts val="1600"/>
+              <a:buChar char="●"/>
+            </a:pPr>
+            <a:r>
+              <a:rPr lang="en"/>
+              <a:t>What is the difference between a game engine and a game framework?</a:t>
+            </a:r>
+            <a:endParaRPr/>
+          </a:p>
+          <a:p>
+            <a:pPr indent="-330200" lvl="0" marL="457200" rtl="0" algn="l">
+              <a:spcBef>
+                <a:spcPts val="0"/>
+              </a:spcBef>
+              <a:spcAft>
+                <a:spcPts val="0"/>
+              </a:spcAft>
+              <a:buSzPts val="1600"/>
+              <a:buChar char="●"/>
+            </a:pPr>
+            <a:r>
+              <a:rPr lang="en"/>
+              <a:t>Why do we multiply movement by deltaTime?</a:t>
+            </a:r>
+            <a:endParaRPr/>
+          </a:p>
+          <a:p>
+            <a:pPr indent="-330200" lvl="0" marL="457200" rtl="0" algn="l">
+              <a:spcBef>
+                <a:spcPts val="0"/>
+              </a:spcBef>
+              <a:spcAft>
+                <a:spcPts val="0"/>
+              </a:spcAft>
+              <a:buSzPts val="1600"/>
+              <a:buChar char="●"/>
+            </a:pPr>
+            <a:r>
+              <a:rPr lang="en"/>
+              <a:t>Why is a string field a fragile way to store game state?</a:t>
+            </a:r>
+            <a:endParaRPr/>
+          </a:p>
+        </p:txBody>
+      </p:sp>
+      <p:sp>
+        <p:nvSpPr>
+          <p:cNvPr id="4" name="TextBox 3"/>
+          <p:cNvSpPr txBox="1"/>
+          <p:nvPr/>
+        </p:nvSpPr>
+        <p:spPr>
+          <a:xfrm>
+            <a:off x="457200" y="2798064"/>
+            <a:ext cx="8229600" cy="457200"/>
           </a:xfrm>
           <a:prstGeom prst="rect">
             <a:avLst/>
           </a:prstGeom>
+          <a:noFill/>
         </p:spPr>
         <p:txBody>
-          <a:bodyPr anchorCtr="0" anchor="t" bIns="91425" lIns="91425" spcFirstLastPara="1" rIns="91425" wrap="square" tIns="91425">
-            <a:normAutofit fontScale="90000"/>
+          <a:bodyPr wrap="square">
+            <a:spAutoFit/>
           </a:bodyPr>
           <a:lstStyle/>
           <a:p>
-            <a:pPr indent="0" lvl="0" marL="0" rtl="0" algn="l">
-              <a:spcBef>
-                <a:spcPts val="0"/>
-              </a:spcBef>
-              <a:spcAft>
-                <a:spcPts val="0"/>
-              </a:spcAft>
-              <a:buNone/>
-            </a:pPr>
-            <a:r>
-              <a:rPr lang="en"/>
-              <a:t>Apply It to Your Project</a:t>
-            </a:r>
-            <a:endParaRPr/>
-          </a:p>
-        </p:txBody>
-      </p:sp>
-      <p:sp>
-        <p:nvSpPr>
-          <p:cNvPr id="77" name="Google Shape;77;p15"/>
-          <p:cNvSpPr txBox="1"/>
-          <p:nvPr>
-            <p:ph idx="1" type="body"/>
-          </p:nvPr>
-        </p:nvSpPr>
-        <p:spPr>
-          <a:xfrm>
-            <a:off x="311700" y="885950"/>
-            <a:ext cx="8520600" cy="4023300"/>
-          </a:xfrm>
-          <a:prstGeom prst="rect">
-            <a:avLst/>
-          </a:prstGeom>
-        </p:spPr>
-        <p:txBody>
-          <a:bodyPr anchorCtr="0" anchor="t" bIns="91425" lIns="91425" spcFirstLastPara="1" rIns="91425" wrap="square" tIns="91425">
-            <a:normAutofit/>
-          </a:bodyPr>
-          <a:lstStyle/>
-          <a:p>
-            <a:pPr indent="-330200" lvl="0" marL="457200" rtl="0" algn="l">
-              <a:spcBef>
-                <a:spcPts val="0"/>
-              </a:spcBef>
-              <a:spcAft>
-                <a:spcPts val="0"/>
-              </a:spcAft>
-              <a:buSzPts val="1600"/>
-              <a:buChar char="●"/>
-            </a:pPr>
-            <a:r>
-              <a:rPr lang="en"/>
-              <a:t>Which games would you like to make? Pick two or three candidates</a:t>
-            </a:r>
-            <a:endParaRPr/>
-          </a:p>
-          <a:p>
-            <a:pPr indent="-330200" lvl="0" marL="457200" rtl="0" algn="l">
-              <a:spcBef>
-                <a:spcPts val="0"/>
-              </a:spcBef>
-              <a:spcAft>
-                <a:spcPts val="0"/>
-              </a:spcAft>
-              <a:buSzPts val="1600"/>
-              <a:buChar char="●"/>
-            </a:pPr>
-            <a:r>
-              <a:rPr lang="en"/>
-              <a:t>For each: what updates every frame, and what is drawn?</a:t>
-            </a:r>
-            <a:endParaRPr/>
-          </a:p>
-          <a:p>
-            <a:pPr indent="-317500" lvl="1" marL="914400" rtl="0" algn="l">
-              <a:spcBef>
-                <a:spcPts val="0"/>
-              </a:spcBef>
-              <a:spcAft>
-                <a:spcPts val="0"/>
-              </a:spcAft>
-              <a:buSzPts val="1400"/>
-              <a:buChar char="○"/>
-            </a:pPr>
-            <a:r>
-              <a:rPr lang="en"/>
-              <a:t>That’s its game loop</a:t>
-            </a:r>
-            <a:endParaRPr/>
-          </a:p>
-          <a:p>
-            <a:pPr indent="-330200" lvl="0" marL="457200" rtl="0" algn="l">
-              <a:spcBef>
-                <a:spcPts val="0"/>
-              </a:spcBef>
-              <a:spcAft>
-                <a:spcPts val="0"/>
-              </a:spcAft>
-              <a:buSzPts val="1600"/>
-              <a:buChar char="●"/>
-            </a:pPr>
-            <a:r>
-              <a:rPr lang="en"/>
-              <a:t>Could you build a naive prototype of the core idea first, like this Pong?</a:t>
-            </a:r>
-            <a:endParaRPr/>
+            <a:pPr algn="ctr"/>
+            <a:r>
+              <a:rPr sz="1400" b="0" i="0">
+                <a:solidFill>
+                  <a:srgbClr val="9AA3AB"/>
+                </a:solidFill>
+              </a:rPr>
+              <a:t>The answers, and more questions, are on the course site.</a:t>
+            </a:r>
           </a:p>
         </p:txBody>
       </p:sp>
@@ -22069,7 +21792,7 @@
             </a:pPr>
             <a:r>
               <a:rPr lang="en"/>
-              <a:t>Your Course Project</a:t>
+              <a:t>Apply It to Your Project</a:t>
             </a:r>
             <a:endParaRPr/>
           </a:p>
@@ -22110,7 +21833,7 @@
             </a:pPr>
             <a:r>
               <a:rPr lang="en"/>
-              <a:t>Form groups of 1–3 students</a:t>
+              <a:t>Which games would you like to make? Pick two or three candidates</a:t>
             </a:r>
             <a:endParaRPr/>
           </a:p>
@@ -22127,7 +21850,7 @@
             </a:pPr>
             <a:r>
               <a:rPr lang="en"/>
-              <a:t>Think of a game you want to create</a:t>
+              <a:t>For each: what updates every frame, and what is drawn?</a:t>
             </a:r>
             <a:endParaRPr/>
           </a:p>
@@ -22144,24 +21867,7 @@
             </a:pPr>
             <a:r>
               <a:rPr lang="en"/>
-              <a:t>Take inspiration from classic games!</a:t>
-            </a:r>
-            <a:endParaRPr/>
-          </a:p>
-          <a:p>
-            <a:pPr indent="-317500" lvl="1" marL="914400" rtl="0" algn="l">
-              <a:spcBef>
-                <a:spcPts val="0"/>
-              </a:spcBef>
-              <a:spcAft>
-                <a:spcPts val="0"/>
-              </a:spcAft>
-              <a:buSzPts val="1400"/>
-              <a:buChar char="○"/>
-            </a:pPr>
-            <a:r>
-              <a:rPr lang="en"/>
-              <a:t>Be mindful of scope (creep)</a:t>
+              <a:t>That’s its game loop</a:t>
             </a:r>
             <a:endParaRPr/>
           </a:p>
@@ -22178,24 +21884,7 @@
             </a:pPr>
             <a:r>
               <a:rPr lang="en"/>
-              <a:t>First milestone, by session 04</a:t>
-            </a:r>
-            <a:endParaRPr/>
-          </a:p>
-          <a:p>
-            <a:pPr indent="-317500" lvl="1" marL="914400" rtl="0" algn="l">
-              <a:spcBef>
-                <a:spcPts val="0"/>
-              </a:spcBef>
-              <a:spcAft>
-                <a:spcPts val="0"/>
-              </a:spcAft>
-              <a:buSzPts val="1400"/>
-              <a:buChar char="○"/>
-            </a:pPr>
-            <a:r>
-              <a:rPr lang="en"/>
-              <a:t>Groups formed, game concept written, repository created</a:t>
+              <a:t>Could you build a naive prototype of the core idea first, like this Pong?</a:t>
             </a:r>
             <a:endParaRPr/>
           </a:p>
@@ -22347,6 +22036,190 @@
 </file>
 
 <file path=ppt/slides/slide50.xml><?xml version="1.0" encoding="utf-8"?>
+<p:sld xmlns:a="http://schemas.openxmlformats.org/drawingml/2006/main" xmlns:p="http://schemas.openxmlformats.org/presentationml/2006/main" xmlns:r="http://schemas.openxmlformats.org/officeDocument/2006/relationships">
+  <p:cSld>
+    <p:spTree>
+      <p:nvGrpSpPr>
+        <p:cNvPr id="1" name=""/>
+        <p:cNvGrpSpPr/>
+        <p:nvPr/>
+      </p:nvGrpSpPr>
+      <p:grpSpPr/>
+      <p:sp>
+        <p:nvSpPr>
+          <p:cNvPr id="76" name="Google Shape;76;p15"/>
+          <p:cNvSpPr txBox="1"/>
+          <p:nvPr>
+            <p:ph type="title"/>
+          </p:nvPr>
+        </p:nvSpPr>
+        <p:spPr>
+          <a:xfrm>
+            <a:off x="311700" y="195615"/>
+            <a:ext cx="8520600" cy="572700"/>
+          </a:xfrm>
+          <a:prstGeom prst="rect">
+            <a:avLst/>
+          </a:prstGeom>
+        </p:spPr>
+        <p:txBody>
+          <a:bodyPr anchorCtr="0" anchor="t" bIns="91425" lIns="91425" spcFirstLastPara="1" rIns="91425" wrap="square" tIns="91425">
+            <a:normAutofit fontScale="90000"/>
+          </a:bodyPr>
+          <a:lstStyle/>
+          <a:p>
+            <a:pPr indent="0" lvl="0" marL="0" rtl="0" algn="l">
+              <a:spcBef>
+                <a:spcPts val="0"/>
+              </a:spcBef>
+              <a:spcAft>
+                <a:spcPts val="0"/>
+              </a:spcAft>
+              <a:buNone/>
+            </a:pPr>
+            <a:r>
+              <a:rPr lang="en"/>
+              <a:t>Your Course Project</a:t>
+            </a:r>
+            <a:endParaRPr/>
+          </a:p>
+        </p:txBody>
+      </p:sp>
+      <p:sp>
+        <p:nvSpPr>
+          <p:cNvPr id="77" name="Google Shape;77;p15"/>
+          <p:cNvSpPr txBox="1"/>
+          <p:nvPr>
+            <p:ph idx="1" type="body"/>
+          </p:nvPr>
+        </p:nvSpPr>
+        <p:spPr>
+          <a:xfrm>
+            <a:off x="311700" y="885950"/>
+            <a:ext cx="8520600" cy="4023300"/>
+          </a:xfrm>
+          <a:prstGeom prst="rect">
+            <a:avLst/>
+          </a:prstGeom>
+        </p:spPr>
+        <p:txBody>
+          <a:bodyPr anchorCtr="0" anchor="t" bIns="91425" lIns="91425" spcFirstLastPara="1" rIns="91425" wrap="square" tIns="91425">
+            <a:normAutofit/>
+          </a:bodyPr>
+          <a:lstStyle/>
+          <a:p>
+            <a:pPr indent="-330200" lvl="0" marL="457200" rtl="0" algn="l">
+              <a:spcBef>
+                <a:spcPts val="0"/>
+              </a:spcBef>
+              <a:spcAft>
+                <a:spcPts val="0"/>
+              </a:spcAft>
+              <a:buSzPts val="1600"/>
+              <a:buChar char="●"/>
+            </a:pPr>
+            <a:r>
+              <a:rPr lang="en"/>
+              <a:t>Form groups of 1–3 students</a:t>
+            </a:r>
+            <a:endParaRPr/>
+          </a:p>
+          <a:p>
+            <a:pPr indent="-330200" lvl="0" marL="457200" rtl="0" algn="l">
+              <a:spcBef>
+                <a:spcPts val="0"/>
+              </a:spcBef>
+              <a:spcAft>
+                <a:spcPts val="0"/>
+              </a:spcAft>
+              <a:buSzPts val="1600"/>
+              <a:buChar char="●"/>
+            </a:pPr>
+            <a:r>
+              <a:rPr lang="en"/>
+              <a:t>Think of a game you want to create</a:t>
+            </a:r>
+            <a:endParaRPr/>
+          </a:p>
+          <a:p>
+            <a:pPr indent="-317500" lvl="1" marL="914400" rtl="0" algn="l">
+              <a:spcBef>
+                <a:spcPts val="0"/>
+              </a:spcBef>
+              <a:spcAft>
+                <a:spcPts val="0"/>
+              </a:spcAft>
+              <a:buSzPts val="1400"/>
+              <a:buChar char="○"/>
+            </a:pPr>
+            <a:r>
+              <a:rPr lang="en"/>
+              <a:t>Take inspiration from classic games!</a:t>
+            </a:r>
+            <a:endParaRPr/>
+          </a:p>
+          <a:p>
+            <a:pPr indent="-317500" lvl="1" marL="914400" rtl="0" algn="l">
+              <a:spcBef>
+                <a:spcPts val="0"/>
+              </a:spcBef>
+              <a:spcAft>
+                <a:spcPts val="0"/>
+              </a:spcAft>
+              <a:buSzPts val="1400"/>
+              <a:buChar char="○"/>
+            </a:pPr>
+            <a:r>
+              <a:rPr lang="en"/>
+              <a:t>Be mindful of scope (creep)</a:t>
+            </a:r>
+            <a:endParaRPr/>
+          </a:p>
+          <a:p>
+            <a:pPr indent="-330200" lvl="0" marL="457200" rtl="0" algn="l">
+              <a:spcBef>
+                <a:spcPts val="0"/>
+              </a:spcBef>
+              <a:spcAft>
+                <a:spcPts val="0"/>
+              </a:spcAft>
+              <a:buSzPts val="1600"/>
+              <a:buChar char="●"/>
+            </a:pPr>
+            <a:r>
+              <a:rPr lang="en"/>
+              <a:t>First milestone, by session 04</a:t>
+            </a:r>
+            <a:endParaRPr/>
+          </a:p>
+          <a:p>
+            <a:pPr indent="-317500" lvl="1" marL="914400" rtl="0" algn="l">
+              <a:spcBef>
+                <a:spcPts val="0"/>
+              </a:spcBef>
+              <a:spcAft>
+                <a:spcPts val="0"/>
+              </a:spcAft>
+              <a:buSzPts val="1400"/>
+              <a:buChar char="○"/>
+            </a:pPr>
+            <a:r>
+              <a:rPr lang="en"/>
+              <a:t>Groups formed, game concept written, repository created</a:t>
+            </a:r>
+            <a:endParaRPr/>
+          </a:p>
+        </p:txBody>
+      </p:sp>
+    </p:spTree>
+  </p:cSld>
+  <p:clrMapOvr>
+    <a:masterClrMapping/>
+  </p:clrMapOvr>
+</p:sld>
+</file>
+
+<file path=ppt/slides/slide51.xml><?xml version="1.0" encoding="utf-8"?>
 <p:sld xmlns:a="http://schemas.openxmlformats.org/drawingml/2006/main" xmlns:r="http://schemas.openxmlformats.org/officeDocument/2006/relationships" xmlns:mc="http://schemas.openxmlformats.org/markup-compatibility/2006" xmlns:mv="urn:schemas-microsoft-com:mac:vml" xmlns:p="http://schemas.openxmlformats.org/presentationml/2006/main" xmlns:c="http://schemas.openxmlformats.org/drawingml/2006/chart" xmlns:dgm="http://schemas.openxmlformats.org/drawingml/2006/diagram" xmlns:o="urn:schemas-microsoft-com:office:office" xmlns:v="urn:schemas-microsoft-com:vml" xmlns:pvml="urn:schemas-microsoft-com:office:powerpoint" xmlns:com="http://schemas.openxmlformats.org/drawingml/2006/compatibility" xmlns:p14="http://schemas.microsoft.com/office/powerpoint/2010/main" xmlns:p15="http://schemas.microsoft.com/office/powerpoint/2012/main" xmlns:ahyp="http://schemas.microsoft.com/office/drawing/2018/hyperlinkcolor">
   <p:cSld>
     <p:spTree>
@@ -22471,162 +22344,6 @@
           </a:ln>
         </p:spPr>
       </p:pic>
-    </p:spTree>
-  </p:cSld>
-  <p:clrMapOvr>
-    <a:masterClrMapping/>
-  </p:clrMapOvr>
-</p:sld>
-</file>
-
-<file path=ppt/slides/slide51.xml><?xml version="1.0" encoding="utf-8"?>
-<p:sld xmlns:a="http://schemas.openxmlformats.org/drawingml/2006/main" xmlns:p="http://schemas.openxmlformats.org/presentationml/2006/main" xmlns:r="http://schemas.openxmlformats.org/officeDocument/2006/relationships">
-  <p:cSld>
-    <p:spTree>
-      <p:nvGrpSpPr>
-        <p:cNvPr id="1" name=""/>
-        <p:cNvGrpSpPr/>
-        <p:nvPr/>
-      </p:nvGrpSpPr>
-      <p:grpSpPr/>
-      <p:sp>
-        <p:nvSpPr>
-          <p:cNvPr id="2" name="Title 1"/>
-          <p:cNvSpPr>
-            <a:spLocks noGrp="1"/>
-          </p:cNvSpPr>
-          <p:nvPr>
-            <p:ph type="title"/>
-          </p:nvPr>
-        </p:nvSpPr>
-        <p:spPr/>
-        <p:txBody>
-          <a:bodyPr/>
-          <a:lstStyle/>
-          <a:p>
-            <a:pPr indent="0" lvl="0" marL="0" rtl="0" algn="l">
-              <a:spcBef>
-                <a:spcPts val="0"/>
-              </a:spcBef>
-              <a:spcAft>
-                <a:spcPts val="0"/>
-              </a:spcAft>
-              <a:buNone/>
-            </a:pPr>
-            <a:r>
-              <a:rPr lang="en"/>
-              <a:t>Check Yourself</a:t>
-            </a:r>
-            <a:endParaRPr/>
-          </a:p>
-        </p:txBody>
-      </p:sp>
-      <p:sp>
-        <p:nvSpPr>
-          <p:cNvPr id="3" name="Text Placeholder 2"/>
-          <p:cNvSpPr>
-            <a:spLocks noGrp="1"/>
-          </p:cNvSpPr>
-          <p:nvPr>
-            <p:ph type="body" idx="1"/>
-          </p:nvPr>
-        </p:nvSpPr>
-        <p:spPr>
-          <a:xfrm>
-            <a:off x="311700" y="885950"/>
-            <a:ext cx="8520600" cy="1335024"/>
-          </a:xfrm>
-        </p:spPr>
-        <p:txBody>
-          <a:bodyPr/>
-          <a:lstStyle/>
-          <a:p>
-            <a:pPr indent="-330200" lvl="0" marL="457200" rtl="0" algn="l">
-              <a:spcBef>
-                <a:spcPts val="0"/>
-              </a:spcBef>
-              <a:spcAft>
-                <a:spcPts val="0"/>
-              </a:spcAft>
-              <a:buSzPts val="1600"/>
-              <a:buChar char="●"/>
-            </a:pPr>
-            <a:r>
-              <a:rPr lang="en"/>
-              <a:t>What is the difference between a game engine and a game framework?</a:t>
-            </a:r>
-            <a:endParaRPr/>
-          </a:p>
-          <a:p>
-            <a:pPr indent="-330200" lvl="0" marL="457200" rtl="0" algn="l">
-              <a:spcBef>
-                <a:spcPts val="0"/>
-              </a:spcBef>
-              <a:spcAft>
-                <a:spcPts val="0"/>
-              </a:spcAft>
-              <a:buSzPts val="1600"/>
-              <a:buChar char="●"/>
-            </a:pPr>
-            <a:r>
-              <a:rPr lang="en"/>
-              <a:t>Why do we multiply movement by deltaTime?</a:t>
-            </a:r>
-            <a:endParaRPr/>
-          </a:p>
-          <a:p>
-            <a:pPr indent="-330200" lvl="0" marL="457200" rtl="0" algn="l">
-              <a:spcBef>
-                <a:spcPts val="0"/>
-              </a:spcBef>
-              <a:spcAft>
-                <a:spcPts val="0"/>
-              </a:spcAft>
-              <a:buSzPts val="1600"/>
-              <a:buChar char="●"/>
-            </a:pPr>
-            <a:r>
-              <a:rPr lang="en"/>
-              <a:t>Why is a string field a fragile way to store game state?</a:t>
-            </a:r>
-            <a:endParaRPr/>
-          </a:p>
-        </p:txBody>
-      </p:sp>
-      <p:sp>
-        <p:nvSpPr>
-          <p:cNvPr id="4" name="TextBox 3"/>
-          <p:cNvSpPr txBox="1"/>
-          <p:nvPr/>
-        </p:nvSpPr>
-        <p:spPr>
-          <a:xfrm>
-            <a:off x="457200" y="2798064"/>
-            <a:ext cx="8229600" cy="457200"/>
-          </a:xfrm>
-          <a:prstGeom prst="rect">
-            <a:avLst/>
-          </a:prstGeom>
-          <a:noFill/>
-        </p:spPr>
-        <p:txBody>
-          <a:bodyPr wrap="square">
-            <a:spAutoFit/>
-          </a:bodyPr>
-          <a:lstStyle/>
-          <a:p>
-            <a:pPr algn="ctr"/>
-            <a:r>
-              <a:rPr sz="1400" b="0" i="0">
-                <a:solidFill>
-                  <a:srgbClr val="9AA3AB"/>
-                </a:solidFill>
-              </a:rPr>
-              <a:t>The answers, and more questions, are on the course site.</a:t>
-            </a:r>
-          </a:p>
-        </p:txBody>
-      </p:sp>
     </p:spTree>
   </p:cSld>
   <p:clrMapOvr>

</xml_diff>

<commit_message>
Pong: own step names, the bounce rule and new screenshots; Critters title in the Pokemon deck
Co-Authored-By: Claude Opus 5.5 <noreply@anthropic.com>
Claude-Session: https://claude.ai/code/session_012sjsUQBbC7zon57rWHoo9d
</commit_message>
<xml_diff>
--- a/slides/01 Pong.pptx
+++ b/slides/01 Pong.pptx
@@ -2138,7 +2138,12 @@
           <a:lstStyle/>
           <a:p>
             <a:r>
-              <a:t>Exercise: text centred on a 1280 × 720 window. They need a SpriteFont and MeasureString to centre it.</a:t>
+              <a:t>Exercise: “Hello, MonoGame!” centred on a 1280 × 720 window. They need a SpriteFont and MeasureString to centre it.</a:t>
+            </a:r>
+          </a:p>
+          <a:p>
+            <a:r>
+              <a:t>Full instructions are on the course site; students work from there. Walk round while they work.</a:t>
             </a:r>
           </a:p>
         </p:txBody>
@@ -2319,6 +2324,11 @@
               <a:t>Exercise: draw at a fixed small resolution and scale it to the window. The window can resize; the game doesn’t notice.</a:t>
             </a:r>
           </a:p>
+          <a:p>
+            <a:r>
+              <a:t>Full instructions are on the course site; students work from there. Walk round while they work.</a:t>
+            </a:r>
+          </a:p>
         </p:txBody>
       </p:sp>
     </p:spTree>
@@ -2586,6 +2596,11 @@
               <a:t>Exercise: two paddles and a ball, a retro font, the background colour. The screenshot shows the result.</a:t>
             </a:r>
           </a:p>
+          <a:p>
+            <a:r>
+              <a:t>Full instructions are on the course site; students work from there. Walk round while they work.</a:t>
+            </a:r>
+          </a:p>
         </p:txBody>
       </p:sp>
     </p:spTree>
@@ -2952,6 +2967,11 @@
               <a:t>Exercise: W/S and the arrow keys move the paddles, the same speed at any frame rate.</a:t>
             </a:r>
           </a:p>
+          <a:p>
+            <a:r>
+              <a:t>Full instructions are on the course site; students work from there. Walk round while they work.</a:t>
+            </a:r>
+          </a:p>
         </p:txBody>
       </p:sp>
     </p:spTree>
@@ -3135,6 +3155,16 @@
               <a:t>Exercise: Enter launches the ball in a random direction; the paddles stay on screen.</a:t>
             </a:r>
           </a:p>
+          <a:p>
+            <a:r>
+              <a:t>A string field remembers the mode: the first, simple version of game state.</a:t>
+            </a:r>
+          </a:p>
+          <a:p>
+            <a:r>
+              <a:t>Full instructions are on the course site; students work from there. Walk round while they work.</a:t>
+            </a:r>
+          </a:p>
         </p:txBody>
       </p:sp>
     </p:spTree>
@@ -3402,6 +3432,11 @@
               <a:t>Exercise: refactor into Paddle and Ball. The game must behave exactly as before; that’s the point of a refactor.</a:t>
             </a:r>
           </a:p>
+          <a:p>
+            <a:r>
+              <a:t>Full instructions are on the course site; students work from there. Walk round while they work.</a:t>
+            </a:r>
+          </a:p>
         </p:txBody>
       </p:sp>
     </p:spTree>
@@ -3585,6 +3620,21 @@
               <a:t>Exercise: bounce off paddles and walls; each paddle hit speeds the ball up by 10%.</a:t>
             </a:r>
           </a:p>
+          <a:p>
+            <a:r>
+              <a:t>Our rule: where the ball hits the paddle sets the angle. Show the three lines on the slide.</a:t>
+            </a:r>
+          </a:p>
+          <a:p>
+            <a:r>
+              <a:t>Ask the question. Answer: the player controls the angle, so hitting becomes a skill, not luck.</a:t>
+            </a:r>
+          </a:p>
+          <a:p>
+            <a:r>
+              <a:t>Full instructions are on the course site; students work from there. Walk round while they work.</a:t>
+            </a:r>
+          </a:p>
         </p:txBody>
       </p:sp>
     </p:spTree>
@@ -3674,6 +3724,11 @@
               <a:t>Exercise: keep score, shown in a bigger font.</a:t>
             </a:r>
           </a:p>
+          <a:p>
+            <a:r>
+              <a:t>Full instructions are on the course site; students work from there. Walk round while they work.</a:t>
+            </a:r>
+          </a:p>
         </p:txBody>
       </p:sp>
     </p:spTree>
@@ -3943,7 +3998,12 @@
           </a:p>
           <a:p>
             <a:r>
-              <a:t>Exercise: add the serve state.</a:t>
+              <a:t>Exercise: add the serve mode; the player who was scored on serves.</a:t>
+            </a:r>
+          </a:p>
+          <a:p>
+            <a:r>
+              <a:t>Full instructions are on the course site; students work from there. Walk round while they work.</a:t>
             </a:r>
           </a:p>
         </p:txBody>
@@ -4032,7 +4092,12 @@
           <a:lstStyle/>
           <a:p>
             <a:r>
-              <a:t>Exercise: a done state at 10 points. The screenshot shows the end screen.</a:t>
+              <a:t>Exercise: a done mode at 10 points. The screenshot shows the end screen.</a:t>
+            </a:r>
+          </a:p>
+          <a:p>
+            <a:r>
+              <a:t>Full instructions are on the course site; students work from there. Walk round while they work.</a:t>
             </a:r>
           </a:p>
         </p:txBody>
@@ -4300,6 +4365,11 @@
           <a:p>
             <a:r>
               <a:t>Exercise: three sounds: paddle hit, wall hit, score.</a:t>
+            </a:r>
+          </a:p>
+          <a:p>
+            <a:r>
+              <a:t>Full instructions are on the course site; students work from there. Walk round while they work.</a:t>
             </a:r>
           </a:p>
         </p:txBody>
@@ -9610,7 +9680,7 @@
           <p:nvPr/>
         </p:nvPicPr>
         <p:blipFill>
-          <a:blip r:embed="rId4"/>
+          <a:blip r:embed="rId3"/>
           <a:stretch>
             <a:fillRect/>
           </a:stretch>
@@ -9618,7 +9688,7 @@
         <p:spPr>
           <a:xfrm>
             <a:off x="1540933" y="1281973"/>
-            <a:ext cx="6062133" cy="3409950"/>
+            <a:ext cx="6062133" cy="3409949"/>
           </a:xfrm>
           <a:prstGeom prst="rect">
             <a:avLst/>
@@ -10784,15 +10854,7 @@
                   <a:schemeClr val="accent5"/>
                 </a:solidFill>
               </a:rPr>
-              <a:t>Pong</a:t>
-            </a:r>
-            <a:r>
-              <a:rPr lang="en">
-                <a:solidFill>
-                  <a:schemeClr val="accent5"/>
-                </a:solidFill>
-              </a:rPr>
-              <a:t> 0: New Game</a:t>
+              <a:t>Pong 0: An Empty Game</a:t>
             </a:r>
             <a:endParaRPr>
               <a:solidFill>
@@ -10813,7 +10875,7 @@
         <p:spPr>
           <a:xfrm>
             <a:off x="311700" y="885950"/>
-            <a:ext cx="8520600" cy="4023300"/>
+            <a:ext cx="8520600" cy="905256"/>
           </a:xfrm>
           <a:prstGeom prst="rect">
             <a:avLst/>
@@ -10837,7 +10899,7 @@
             </a:pPr>
             <a:r>
               <a:rPr lang="en"/>
-              <a:t>Install the tooling from the previous slide</a:t>
+              <a:t>Goal: clone gar-games, open 01-pong/Pong0, and run it.</a:t>
             </a:r>
             <a:endParaRPr/>
           </a:p>
@@ -10854,41 +10916,7 @@
             </a:pPr>
             <a:r>
               <a:rPr lang="en"/>
-              <a:t>Clone gar-games and open 01-pong/Pong0</a:t>
-            </a:r>
-            <a:endParaRPr/>
-          </a:p>
-          <a:p>
-            <a:pPr indent="-317500" lvl="1" marL="914400" rtl="0" algn="l">
-              <a:spcBef>
-                <a:spcPts val="0"/>
-              </a:spcBef>
-              <a:spcAft>
-                <a:spcPts val="0"/>
-              </a:spcAft>
-              <a:buSzPts val="1400"/>
-              <a:buChar char="○"/>
-            </a:pPr>
-            <a:r>
-              <a:rPr lang="en"/>
-              <a:t>An empty MonoGame game, already set up with the content builder</a:t>
-            </a:r>
-            <a:endParaRPr/>
-          </a:p>
-          <a:p>
-            <a:pPr indent="-330200" lvl="0" marL="457200" rtl="0" algn="l">
-              <a:spcBef>
-                <a:spcPts val="0"/>
-              </a:spcBef>
-              <a:spcAft>
-                <a:spcPts val="0"/>
-              </a:spcAft>
-              <a:buSzPts val="1600"/>
-              <a:buChar char="●"/>
-            </a:pPr>
-            <a:r>
-              <a:rPr lang="en"/>
-              <a:t>Run it from the 01-pong folder: dotnet run --project Pong0</a:t>
+              <a:t>From the 01-pong folder: dotnet run --project Pong0</a:t>
             </a:r>
             <a:endParaRPr/>
           </a:p>
@@ -12937,15 +12965,7 @@
                   <a:schemeClr val="accent5"/>
                 </a:solidFill>
               </a:rPr>
-              <a:t>Pong</a:t>
-            </a:r>
-            <a:r>
-              <a:rPr lang="en">
-                <a:solidFill>
-                  <a:schemeClr val="accent5"/>
-                </a:solidFill>
-              </a:rPr>
-              <a:t> 1: Hello Pong</a:t>
+              <a:t>Pong 1: Text on Screen</a:t>
             </a:r>
             <a:endParaRPr>
               <a:solidFill>
@@ -12966,7 +12986,7 @@
         <p:spPr>
           <a:xfrm>
             <a:off x="311700" y="885950"/>
-            <a:ext cx="8520600" cy="4023300"/>
+            <a:ext cx="8520600" cy="905256"/>
           </a:xfrm>
           <a:prstGeom prst="rect">
             <a:avLst/>
@@ -12990,63 +13010,7 @@
             </a:pPr>
             <a:r>
               <a:rPr lang="en"/>
-              <a:t>Update your Pong game to display “Hello Pong!” exactly in the center of the screen.</a:t>
-            </a:r>
-            <a:endParaRPr/>
-          </a:p>
-          <a:p>
-            <a:pPr indent="-317500" lvl="1" marL="914400" rtl="0" algn="l">
-              <a:spcBef>
-                <a:spcPts val="0"/>
-              </a:spcBef>
-              <a:spcAft>
-                <a:spcPts val="0"/>
-              </a:spcAft>
-              <a:buSzPts val="1400"/>
-              <a:buChar char="○"/>
-            </a:pPr>
-            <a:r>
-              <a:rPr lang="en"/>
-              <a:t>White text, black background</a:t>
-            </a:r>
-            <a:endParaRPr/>
-          </a:p>
-          <a:p>
-            <a:pPr indent="-317500" lvl="1" marL="914400" rtl="0" algn="l">
-              <a:spcBef>
-                <a:spcPts val="0"/>
-              </a:spcBef>
-              <a:spcAft>
-                <a:spcPts val="0"/>
-              </a:spcAft>
-              <a:buSzPts val="1400"/>
-              <a:buChar char="○"/>
-            </a:pPr>
-            <a:r>
-              <a:rPr lang="en"/>
-              <a:t>You will need a SpriteFont asset</a:t>
-            </a:r>
-            <a:endParaRPr/>
-          </a:p>
-          <a:p>
-            <a:pPr indent="-317500" lvl="1" marL="914400" rtl="0" algn="l">
-              <a:spcBef>
-                <a:spcPts val="0"/>
-              </a:spcBef>
-              <a:spcAft>
-                <a:spcPts val="0"/>
-              </a:spcAft>
-              <a:buSzPts val="1400"/>
-              <a:buChar char="○"/>
-            </a:pPr>
-            <a:r>
-              <a:rPr lang="en" u="sng">
-                <a:solidFill>
-                  <a:schemeClr val="hlink"/>
-                </a:solidFill>
-                <a:hlinkClick r:id="rId3"/>
-              </a:rPr>
-              <a:t>How to Draw Text</a:t>
+              <a:t>Goal: “Hello, MonoGame!” centred on a black 1280 × 720 window.</a:t>
             </a:r>
             <a:endParaRPr/>
           </a:p>
@@ -13063,24 +13027,7 @@
             </a:pPr>
             <a:r>
               <a:rPr lang="en"/>
-              <a:t>Set the window resolution to 1280x720</a:t>
-            </a:r>
-            <a:endParaRPr/>
-          </a:p>
-          <a:p>
-            <a:pPr indent="-317500" lvl="1" marL="914400" rtl="0" algn="l">
-              <a:spcBef>
-                <a:spcPts val="0"/>
-              </a:spcBef>
-              <a:spcAft>
-                <a:spcPts val="0"/>
-              </a:spcAft>
-              <a:buSzPts val="1400"/>
-              <a:buChar char="○"/>
-            </a:pPr>
-            <a:r>
-              <a:rPr lang="en"/>
-              <a:t>Use PreferredBackBuffer[Width/Height] property on GraphicsDeviceManager</a:t>
+              <a:t>You need a SpriteFont, and MeasureString to centre it.</a:t>
             </a:r>
             <a:endParaRPr/>
           </a:p>
@@ -13088,30 +13035,26 @@
       </p:sp>
       <p:pic>
         <p:nvPicPr>
-          <p:cNvPr id="168" name="Google Shape;168;p30"/>
-          <p:cNvPicPr preferRelativeResize="0"/>
+          <p:cNvPr id="168" name="Picture 168" descr="p1.png"/>
+          <p:cNvPicPr>
+            <a:picLocks noChangeAspect="1"/>
+          </p:cNvPicPr>
           <p:nvPr/>
         </p:nvPicPr>
         <p:blipFill>
-          <a:blip r:embed="rId4">
-            <a:alphaModFix/>
-          </a:blip>
+          <a:blip r:embed="rId5"/>
           <a:stretch>
             <a:fillRect/>
           </a:stretch>
         </p:blipFill>
         <p:spPr>
           <a:xfrm>
-            <a:off x="2703898" y="2755975"/>
-            <a:ext cx="3736200" cy="2191601"/>
+            <a:off x="2703898" y="2800969"/>
+            <a:ext cx="3736200" cy="2101612"/>
           </a:xfrm>
           <a:prstGeom prst="rect">
             <a:avLst/>
           </a:prstGeom>
-          <a:noFill/>
-          <a:ln>
-            <a:noFill/>
-          </a:ln>
         </p:spPr>
       </p:pic>
     </p:spTree>
@@ -13291,7 +13234,7 @@
         <p:spPr>
           <a:xfrm>
             <a:off x="311700" y="885950"/>
-            <a:ext cx="8520600" cy="4023300"/>
+            <a:ext cx="8520600" cy="905256"/>
           </a:xfrm>
           <a:prstGeom prst="rect">
             <a:avLst/>
@@ -13315,15 +13258,7 @@
             </a:pPr>
             <a:r>
               <a:rPr lang="en"/>
-              <a:t>Make the game resolution </a:t>
-            </a:r>
-            <a:r>
-              <a:rPr lang="en"/>
-              <a:t>independent</a:t>
-            </a:r>
-            <a:r>
-              <a:rPr lang="en"/>
-              <a:t> of window resolution</a:t>
+              <a:t>Goal: draw at a small fixed resolution, scaled to a resizable window.</a:t>
             </a:r>
             <a:endParaRPr/>
           </a:p>
@@ -13340,24 +13275,7 @@
             </a:pPr>
             <a:r>
               <a:rPr lang="en"/>
-              <a:t>Make the game window resizable</a:t>
-            </a:r>
-            <a:endParaRPr/>
-          </a:p>
-          <a:p>
-            <a:pPr indent="-330200" lvl="0" marL="457200" rtl="0" algn="l">
-              <a:spcBef>
-                <a:spcPts val="0"/>
-              </a:spcBef>
-              <a:spcAft>
-                <a:spcPts val="0"/>
-              </a:spcAft>
-              <a:buSzPts val="1600"/>
-              <a:buChar char="●"/>
-            </a:pPr>
-            <a:r>
-              <a:rPr lang="en"/>
-              <a:t>Update the game to use Point filtering</a:t>
+              <a:t>Use point filtering, so the pixels stay sharp.</a:t>
             </a:r>
             <a:endParaRPr/>
           </a:p>
@@ -13365,30 +13283,26 @@
       </p:sp>
       <p:pic>
         <p:nvPicPr>
-          <p:cNvPr id="181" name="Google Shape;181;p32"/>
-          <p:cNvPicPr preferRelativeResize="0"/>
+          <p:cNvPr id="181" name="Picture 181" descr="p2.png"/>
+          <p:cNvPicPr>
+            <a:picLocks noChangeAspect="1"/>
+          </p:cNvPicPr>
           <p:nvPr/>
         </p:nvPicPr>
         <p:blipFill>
-          <a:blip r:embed="rId3">
-            <a:alphaModFix/>
-          </a:blip>
+          <a:blip r:embed="rId4"/>
           <a:stretch>
             <a:fillRect/>
           </a:stretch>
         </p:blipFill>
         <p:spPr>
           <a:xfrm>
-            <a:off x="2541213" y="2380100"/>
-            <a:ext cx="4061575" cy="2382451"/>
+            <a:off x="2541213" y="2429008"/>
+            <a:ext cx="4061575" cy="2284635"/>
           </a:xfrm>
           <a:prstGeom prst="rect">
             <a:avLst/>
           </a:prstGeom>
-          <a:noFill/>
-          <a:ln>
-            <a:noFill/>
-          </a:ln>
         </p:spPr>
       </p:pic>
     </p:spTree>
@@ -14274,7 +14188,7 @@
                   <a:schemeClr val="accent5"/>
                 </a:solidFill>
               </a:rPr>
-              <a:t>Pong 3: Drawing Rectangles</a:t>
+              <a:t>Pong 3: Rectangles From a Pixel</a:t>
             </a:r>
             <a:endParaRPr>
               <a:solidFill>
@@ -14295,7 +14209,7 @@
         <p:spPr>
           <a:xfrm>
             <a:off x="311700" y="885950"/>
-            <a:ext cx="8520600" cy="4023300"/>
+            <a:ext cx="8520600" cy="905256"/>
           </a:xfrm>
           <a:prstGeom prst="rect">
             <a:avLst/>
@@ -14319,24 +14233,7 @@
             </a:pPr>
             <a:r>
               <a:rPr lang="en"/>
-              <a:t>Draw the three rectangles present in a Pong game (Paddle, Paddle, Ball)</a:t>
-            </a:r>
-            <a:endParaRPr/>
-          </a:p>
-          <a:p>
-            <a:pPr indent="-317500" lvl="1" marL="914400" rtl="0" algn="l">
-              <a:spcBef>
-                <a:spcPts val="0"/>
-              </a:spcBef>
-              <a:spcAft>
-                <a:spcPts val="0"/>
-              </a:spcAft>
-              <a:buSzPts val="1400"/>
-              <a:buChar char="○"/>
-            </a:pPr>
-            <a:r>
-              <a:rPr lang="en"/>
-              <a:t>Choose appropriate starting positions for each entity</a:t>
+              <a:t>Goal: two paddles and a ball, stretched from one white pixel.</a:t>
             </a:r>
             <a:endParaRPr/>
           </a:p>
@@ -14353,33 +14250,7 @@
             </a:pPr>
             <a:r>
               <a:rPr lang="en"/>
-              <a:t>Update the font to a custom </a:t>
-            </a:r>
-            <a:r>
-              <a:rPr lang="en" u="sng">
-                <a:solidFill>
-                  <a:schemeClr val="hlink"/>
-                </a:solidFill>
-                <a:hlinkClick r:id="rId3"/>
-              </a:rPr>
-              <a:t>retro font</a:t>
-            </a:r>
-            <a:endParaRPr/>
-          </a:p>
-          <a:p>
-            <a:pPr indent="-330200" lvl="0" marL="457200" rtl="0" algn="l">
-              <a:spcBef>
-                <a:spcPts val="0"/>
-              </a:spcBef>
-              <a:spcAft>
-                <a:spcPts val="0"/>
-              </a:spcAft>
-              <a:buSzPts val="1600"/>
-              <a:buChar char="●"/>
-            </a:pPr>
-            <a:r>
-              <a:rPr lang="en"/>
-              <a:t>Update the background color to RGBA value (40, 45, 52, 255)</a:t>
+              <a:t>A retro font, and the background colour (40, 45, 52).</a:t>
             </a:r>
             <a:endParaRPr/>
           </a:p>
@@ -14387,22 +14258,22 @@
       </p:sp>
       <p:pic>
         <p:nvPicPr>
-          <p:cNvPr id="201" name="Picture 201" descr="pong3.png"/>
+          <p:cNvPr id="201" name="Picture 201" descr="p3.png"/>
           <p:cNvPicPr>
             <a:picLocks noChangeAspect="1"/>
           </p:cNvPicPr>
           <p:nvPr/>
         </p:nvPicPr>
         <p:blipFill>
-          <a:blip r:embed="rId5"/>
+          <a:blip r:embed="rId4"/>
           <a:stretch>
             <a:fillRect/>
           </a:stretch>
         </p:blipFill>
         <p:spPr>
           <a:xfrm>
-            <a:off x="2393662" y="2406160"/>
-            <a:ext cx="4356675" cy="2450629"/>
+            <a:off x="2393663" y="2406160"/>
+            <a:ext cx="4356673" cy="2450629"/>
           </a:xfrm>
           <a:prstGeom prst="rect">
             <a:avLst/>
@@ -16045,7 +15916,7 @@
                   <a:schemeClr val="accent5"/>
                 </a:solidFill>
               </a:rPr>
-              <a:t>Pong 4: Paddle Movement</a:t>
+              <a:t>Pong 4: Input and Delta Time</a:t>
             </a:r>
             <a:endParaRPr>
               <a:solidFill>
@@ -16066,7 +15937,7 @@
         <p:spPr>
           <a:xfrm>
             <a:off x="311700" y="885950"/>
-            <a:ext cx="8520600" cy="4023300"/>
+            <a:ext cx="8520600" cy="905256"/>
           </a:xfrm>
           <a:prstGeom prst="rect">
             <a:avLst/>
@@ -16090,41 +15961,7 @@
             </a:pPr>
             <a:r>
               <a:rPr lang="en"/>
-              <a:t>Add interactivity by letting players move the paddles</a:t>
-            </a:r>
-            <a:endParaRPr/>
-          </a:p>
-          <a:p>
-            <a:pPr indent="-317500" lvl="1" marL="914400" rtl="0" algn="l">
-              <a:spcBef>
-                <a:spcPts val="0"/>
-              </a:spcBef>
-              <a:spcAft>
-                <a:spcPts val="0"/>
-              </a:spcAft>
-              <a:buSzPts val="1400"/>
-              <a:buChar char="○"/>
-            </a:pPr>
-            <a:r>
-              <a:rPr lang="en"/>
-              <a:t>W and S keys move Paddle 1 up and down</a:t>
-            </a:r>
-            <a:endParaRPr/>
-          </a:p>
-          <a:p>
-            <a:pPr indent="-317500" lvl="1" marL="914400" rtl="0" algn="l">
-              <a:spcBef>
-                <a:spcPts val="0"/>
-              </a:spcBef>
-              <a:spcAft>
-                <a:spcPts val="0"/>
-              </a:spcAft>
-              <a:buSzPts val="1400"/>
-              <a:buChar char="○"/>
-            </a:pPr>
-            <a:r>
-              <a:rPr lang="en"/>
-              <a:t>Up and Down arrow keys move Paddle 2 up and down</a:t>
+              <a:t>Goal: W/S and Up/Down move the paddles.</a:t>
             </a:r>
             <a:endParaRPr/>
           </a:p>
@@ -16141,7 +15978,7 @@
             </a:pPr>
             <a:r>
               <a:rPr lang="en"/>
-              <a:t>Ensure that movement is framerate independent</a:t>
+              <a:t>The same speed at any frame rate.</a:t>
             </a:r>
             <a:endParaRPr/>
           </a:p>
@@ -16149,14 +15986,14 @@
       </p:sp>
       <p:pic>
         <p:nvPicPr>
-          <p:cNvPr id="220" name="Picture 220" descr="pong4.png"/>
+          <p:cNvPr id="220" name="Picture 220" descr="p4.png"/>
           <p:cNvPicPr>
             <a:picLocks noChangeAspect="1"/>
           </p:cNvPicPr>
           <p:nvPr/>
         </p:nvPicPr>
         <p:blipFill>
-          <a:blip r:embed="rId4"/>
+          <a:blip r:embed="rId3"/>
           <a:stretch>
             <a:fillRect/>
           </a:stretch>
@@ -16164,7 +16001,7 @@
         <p:spPr>
           <a:xfrm>
             <a:off x="2542227" y="2576865"/>
-            <a:ext cx="4059549" cy="2283496"/>
+            <a:ext cx="4059548" cy="2283496"/>
           </a:xfrm>
           <a:prstGeom prst="rect">
             <a:avLst/>
@@ -16947,7 +16784,7 @@
                   <a:schemeClr val="accent5"/>
                 </a:solidFill>
               </a:rPr>
-              <a:t>Pong 5: Ball Movement</a:t>
+              <a:t>Pong 5: A Moving Ball</a:t>
             </a:r>
             <a:endParaRPr>
               <a:solidFill>
@@ -16968,7 +16805,7 @@
         <p:spPr>
           <a:xfrm>
             <a:off x="311700" y="885950"/>
-            <a:ext cx="8520600" cy="4023300"/>
+            <a:ext cx="8520600" cy="905256"/>
           </a:xfrm>
           <a:prstGeom prst="rect">
             <a:avLst/>
@@ -16992,41 +16829,7 @@
             </a:pPr>
             <a:r>
               <a:rPr lang="en"/>
-              <a:t>Add motion to the ball upon the user pressing “Enter”.</a:t>
-            </a:r>
-            <a:endParaRPr/>
-          </a:p>
-          <a:p>
-            <a:pPr indent="-317500" lvl="1" marL="914400" rtl="0" algn="l">
-              <a:spcBef>
-                <a:spcPts val="0"/>
-              </a:spcBef>
-              <a:spcAft>
-                <a:spcPts val="0"/>
-              </a:spcAft>
-              <a:buSzPts val="1400"/>
-              <a:buChar char="○"/>
-            </a:pPr>
-            <a:r>
-              <a:rPr lang="en"/>
-              <a:t>You will need to keep track of the state of the game, e.g. using a simple string field</a:t>
-            </a:r>
-            <a:endParaRPr/>
-          </a:p>
-          <a:p>
-            <a:pPr indent="-317500" lvl="1" marL="914400" rtl="0" algn="l">
-              <a:spcBef>
-                <a:spcPts val="0"/>
-              </a:spcBef>
-              <a:spcAft>
-                <a:spcPts val="0"/>
-              </a:spcAft>
-              <a:buSzPts val="1400"/>
-              <a:buChar char="○"/>
-            </a:pPr>
-            <a:r>
-              <a:rPr lang="en"/>
-              <a:t>Use the Random class to ensure the ball starts with different movement vectors</a:t>
+              <a:t>Goal: Enter launches the ball in a random direction.</a:t>
             </a:r>
             <a:endParaRPr/>
           </a:p>
@@ -17043,24 +16846,7 @@
             </a:pPr>
             <a:r>
               <a:rPr lang="en"/>
-              <a:t>Ensure the Paddles can’t move offscreen</a:t>
-            </a:r>
-            <a:endParaRPr/>
-          </a:p>
-          <a:p>
-            <a:pPr indent="-317500" lvl="1" marL="914400" rtl="0" algn="l">
-              <a:spcBef>
-                <a:spcPts val="0"/>
-              </a:spcBef>
-              <a:spcAft>
-                <a:spcPts val="0"/>
-              </a:spcAft>
-              <a:buSzPts val="1400"/>
-              <a:buChar char="○"/>
-            </a:pPr>
-            <a:r>
-              <a:rPr lang="en"/>
-              <a:t>Math.Min() and Math.Max() methods are helpful here</a:t>
+              <a:t>A string field remembers the mode; the paddles stay on screen.</a:t>
             </a:r>
             <a:endParaRPr/>
           </a:p>
@@ -17068,14 +16854,14 @@
       </p:sp>
       <p:pic>
         <p:nvPicPr>
-          <p:cNvPr id="233" name="Picture 233" descr="pong5.png"/>
+          <p:cNvPr id="233" name="Picture 233" descr="p5a.png"/>
           <p:cNvPicPr>
             <a:picLocks noChangeAspect="1"/>
           </p:cNvPicPr>
           <p:nvPr/>
         </p:nvPicPr>
         <p:blipFill>
-          <a:blip r:embed="rId4"/>
+          <a:blip r:embed="rId3"/>
           <a:stretch>
             <a:fillRect/>
           </a:stretch>
@@ -17083,7 +16869,7 @@
         <p:spPr>
           <a:xfrm>
             <a:off x="2579537" y="2619736"/>
-            <a:ext cx="3984937" cy="2241527"/>
+            <a:ext cx="3984936" cy="2241527"/>
           </a:xfrm>
           <a:prstGeom prst="rect">
             <a:avLst/>
@@ -18218,7 +18004,7 @@
                   <a:schemeClr val="accent5"/>
                 </a:solidFill>
               </a:rPr>
-              <a:t>Pong 6: Encapsulation </a:t>
+              <a:t>Pong 6: The Update Method</a:t>
             </a:r>
             <a:endParaRPr>
               <a:solidFill>
@@ -18239,7 +18025,7 @@
         <p:spPr>
           <a:xfrm>
             <a:off x="311700" y="885950"/>
-            <a:ext cx="8520600" cy="4023300"/>
+            <a:ext cx="8520600" cy="905256"/>
           </a:xfrm>
           <a:prstGeom prst="rect">
             <a:avLst/>
@@ -18263,54 +18049,24 @@
             </a:pPr>
             <a:r>
               <a:rPr lang="en"/>
-              <a:t>Refactor the Pong code by creating two classes, Paddle and Ball, that encapsulates the data and behaviour of the two entities</a:t>
+              <a:t>Goal: Paddle and Ball classes, each with its own Update and Draw.</a:t>
             </a:r>
             <a:endParaRPr/>
           </a:p>
           <a:p>
-            <a:pPr indent="-317500" lvl="1" marL="914400" rtl="0" algn="l">
-              <a:spcBef>
-                <a:spcPts val="0"/>
-              </a:spcBef>
-              <a:spcAft>
-                <a:spcPts val="0"/>
-              </a:spcAft>
-              <a:buSzPts val="1400"/>
-              <a:buChar char="○"/>
+            <a:pPr indent="-330200" lvl="0" marL="457200" rtl="0" algn="l">
+              <a:spcBef>
+                <a:spcPts val="0"/>
+              </a:spcBef>
+              <a:spcAft>
+                <a:spcPts val="0"/>
+              </a:spcAft>
+              <a:buSzPts val="1600"/>
+              <a:buChar char="●"/>
             </a:pPr>
             <a:r>
               <a:rPr lang="en"/>
-              <a:t>The behaviour of the Pong game will remain identical from the previous iteration</a:t>
-            </a:r>
-            <a:endParaRPr/>
-          </a:p>
-          <a:p>
-            <a:pPr indent="-317500" lvl="1" marL="914400" rtl="0" algn="l">
-              <a:spcBef>
-                <a:spcPts val="0"/>
-              </a:spcBef>
-              <a:spcAft>
-                <a:spcPts val="0"/>
-              </a:spcAft>
-              <a:buSzPts val="1400"/>
-              <a:buChar char="○"/>
-            </a:pPr>
-            <a:r>
-              <a:rPr lang="en"/>
-              <a:t>You will need to take advantage of </a:t>
-            </a:r>
-            <a:r>
-              <a:rPr lang="en" u="sng">
-                <a:solidFill>
-                  <a:schemeClr val="hlink"/>
-                </a:solidFill>
-                <a:hlinkClick r:id="rId3"/>
-              </a:rPr>
-              <a:t>Update Method</a:t>
-            </a:r>
-            <a:r>
-              <a:rPr lang="en"/>
-              <a:t> pattern</a:t>
+              <a:t>The game must behave exactly as before.</a:t>
             </a:r>
             <a:endParaRPr/>
           </a:p>
@@ -19737,7 +19493,7 @@
                   <a:schemeClr val="accent5"/>
                 </a:solidFill>
               </a:rPr>
-              <a:t>Pong 7: Collision Detection</a:t>
+              <a:t>Pong 7: Collisions and the Bounce</a:t>
             </a:r>
             <a:endParaRPr>
               <a:solidFill>
@@ -19758,7 +19514,7 @@
         <p:spPr>
           <a:xfrm>
             <a:off x="311700" y="885950"/>
-            <a:ext cx="8520600" cy="4023300"/>
+            <a:ext cx="8520600" cy="905256"/>
           </a:xfrm>
           <a:prstGeom prst="rect">
             <a:avLst/>
@@ -19782,60 +19538,145 @@
             </a:pPr>
             <a:r>
               <a:rPr lang="en"/>
-              <a:t>Allow for the ball to bounce off the Paddles and window boundaries using AABB collision detection</a:t>
+              <a:t>Goal: bounce off the paddles and the walls, with AABB.</a:t>
             </a:r>
             <a:endParaRPr/>
           </a:p>
           <a:p>
-            <a:pPr indent="-317500" lvl="1" marL="914400" rtl="0" algn="l">
-              <a:spcBef>
-                <a:spcPts val="0"/>
-              </a:spcBef>
-              <a:spcAft>
-                <a:spcPts val="0"/>
-              </a:spcAft>
-              <a:buSzPts val="1400"/>
-              <a:buChar char="○"/>
+            <a:pPr indent="-330200" lvl="0" marL="457200" rtl="0" algn="l">
+              <a:spcBef>
+                <a:spcPts val="0"/>
+              </a:spcBef>
+              <a:spcAft>
+                <a:spcPts val="0"/>
+              </a:spcAft>
+              <a:buSzPts val="1600"/>
+              <a:buChar char="●"/>
             </a:pPr>
             <a:r>
               <a:rPr lang="en"/>
-              <a:t>Implement the Collides(Paddle paddle) method on the Ball to check for collision</a:t>
+              <a:t>Where the ball hits the paddle sets the angle; each hit is 10% faster.</a:t>
             </a:r>
             <a:endParaRPr/>
           </a:p>
-          <a:p>
-            <a:pPr indent="-317500" lvl="1" marL="914400" rtl="0" algn="l">
-              <a:spcBef>
-                <a:spcPts val="0"/>
-              </a:spcBef>
-              <a:spcAft>
-                <a:spcPts val="0"/>
-              </a:spcAft>
-              <a:buSzPts val="1400"/>
-              <a:buChar char="○"/>
-            </a:pPr>
-            <a:r>
-              <a:rPr lang="en"/>
-              <a:t>Calculate a new random Y velocity of the Ball based on its current Y direction (up/down)</a:t>
-            </a:r>
-            <a:endParaRPr/>
-          </a:p>
-          <a:p>
-            <a:pPr indent="-317500" lvl="1" marL="914400" rtl="0" algn="l">
-              <a:spcBef>
-                <a:spcPts val="0"/>
-              </a:spcBef>
-              <a:spcAft>
-                <a:spcPts val="0"/>
-              </a:spcAft>
-              <a:buSzPts val="1400"/>
-              <a:buChar char="○"/>
-            </a:pPr>
-            <a:r>
-              <a:rPr lang="en"/>
-              <a:t>For every bounce on a Paddle, increase Ball X velocity by 10%</a:t>
-            </a:r>
-            <a:endParaRPr/>
+        </p:txBody>
+      </p:sp>
+      <p:sp>
+        <p:nvSpPr>
+          <p:cNvPr id="267" name="Rectangle 266"/>
+          <p:cNvSpPr/>
+          <p:nvPr/>
+        </p:nvSpPr>
+        <p:spPr>
+          <a:xfrm>
+            <a:off x="731520" y="1600200"/>
+            <a:ext cx="7680960" cy="1417320"/>
+          </a:xfrm>
+          <a:prstGeom prst="rect">
+            <a:avLst/>
+          </a:prstGeom>
+          <a:solidFill>
+            <a:srgbClr val="17191C"/>
+          </a:solidFill>
+          <a:ln>
+            <a:noFill/>
+          </a:ln>
+          <a:effectLst/>
+        </p:spPr>
+        <p:style>
+          <a:lnRef idx="1">
+            <a:schemeClr val="accent1"/>
+          </a:lnRef>
+          <a:fillRef idx="3">
+            <a:schemeClr val="accent1"/>
+          </a:fillRef>
+          <a:effectRef idx="2">
+            <a:schemeClr val="accent1"/>
+          </a:effectRef>
+          <a:fontRef idx="minor">
+            <a:schemeClr val="lt1"/>
+          </a:fontRef>
+        </p:style>
+        <p:txBody>
+          <a:bodyPr rtlCol="0" anchor="ctr" wrap="square" lIns="164592" rIns="73152"/>
+          <a:lstStyle/>
+          <a:p>
+            <a:pPr algn="l"/>
+            <a:r>
+              <a:rPr sz="1400" b="0">
+                <a:solidFill>
+                  <a:srgbClr val="DEE2E6"/>
+                </a:solidFill>
+              </a:rPr>
+              <a:t/>
+            </a:r>
+            <a:r>
+              <a:rPr sz="1400">
+                <a:solidFill>
+                  <a:srgbClr val="9AA3AB"/>
+                </a:solidFill>
+                <a:latin typeface="Consolas"/>
+              </a:rPr>
+              <a:t>// the middle sends it straight back, the ends steeply</a:t>
+            </a:r>
+          </a:p>
+          <a:p>
+            <a:pPr algn="l"/>
+            <a:r>
+              <a:rPr sz="1400">
+                <a:solidFill>
+                  <a:srgbClr val="DEE2E6"/>
+                </a:solidFill>
+                <a:latin typeface="Consolas"/>
+              </a:rPr>
+              <a:t>float offset = ballCentreY - paddleCentreY;</a:t>
+            </a:r>
+          </a:p>
+          <a:p>
+            <a:pPr algn="l"/>
+            <a:r>
+              <a:rPr sz="1400">
+                <a:solidFill>
+                  <a:srgbClr val="DEE2E6"/>
+                </a:solidFill>
+                <a:latin typeface="Consolas"/>
+              </a:rPr>
+              <a:t>float newY = offset / (paddle.Height / 2f) * 150;</a:t>
+            </a:r>
+          </a:p>
+        </p:txBody>
+      </p:sp>
+      <p:sp>
+        <p:nvSpPr>
+          <p:cNvPr id="268" name="TextBox 267"/>
+          <p:cNvSpPr txBox="1"/>
+          <p:nvPr/>
+        </p:nvSpPr>
+        <p:spPr>
+          <a:xfrm>
+            <a:off x="457200" y="3291840"/>
+            <a:ext cx="8229600" cy="731520"/>
+          </a:xfrm>
+          <a:prstGeom prst="rect">
+            <a:avLst/>
+          </a:prstGeom>
+          <a:noFill/>
+        </p:spPr>
+        <p:txBody>
+          <a:bodyPr wrap="square">
+            <a:spAutoFit/>
+          </a:bodyPr>
+          <a:lstStyle/>
+          <a:p>
+            <a:pPr algn="ctr"/>
+            <a:r>
+              <a:rPr sz="1600" b="1" i="0">
+                <a:solidFill>
+                  <a:srgbClr val="DEE2E6"/>
+                </a:solidFill>
+              </a:rPr>
+              <a:t>Why is this better than a random angle?</a:t>
+            </a:r>
           </a:p>
         </p:txBody>
       </p:sp>
@@ -19923,7 +19764,7 @@
         <p:spPr>
           <a:xfrm>
             <a:off x="311700" y="885950"/>
-            <a:ext cx="8520600" cy="4023300"/>
+            <a:ext cx="8520600" cy="521208"/>
           </a:xfrm>
           <a:prstGeom prst="rect">
             <a:avLst/>
@@ -19947,56 +19788,7 @@
             </a:pPr>
             <a:r>
               <a:rPr lang="en"/>
-              <a:t>Keep track of scoring</a:t>
-            </a:r>
-            <a:endParaRPr/>
-          </a:p>
-          <a:p>
-            <a:pPr indent="-317500" lvl="1" marL="914400" rtl="0" algn="l">
-              <a:spcBef>
-                <a:spcPts val="0"/>
-              </a:spcBef>
-              <a:spcAft>
-                <a:spcPts val="0"/>
-              </a:spcAft>
-              <a:buSzPts val="1400"/>
-              <a:buChar char="○"/>
-            </a:pPr>
-            <a:r>
-              <a:rPr lang="en"/>
-              <a:t>The scoring UI must use a bigger font than the text</a:t>
-            </a:r>
-            <a:endParaRPr/>
-          </a:p>
-          <a:p>
-            <a:pPr indent="0" lvl="0" marL="0" rtl="0" algn="l">
-              <a:spcBef>
-                <a:spcPts val="1200"/>
-              </a:spcBef>
-              <a:spcAft>
-                <a:spcPts val="0"/>
-              </a:spcAft>
-              <a:buNone/>
-            </a:pPr>
-            <a:r>
-              <a:rPr/>
-              <a:t/>
-            </a:r>
-            <a:endParaRPr/>
-          </a:p>
-          <a:p>
-            <a:pPr indent="0" lvl="0" marL="0" rtl="0" algn="l">
-              <a:spcBef>
-                <a:spcPts val="1200"/>
-              </a:spcBef>
-              <a:spcAft>
-                <a:spcPts val="1200"/>
-              </a:spcAft>
-              <a:buNone/>
-            </a:pPr>
-            <a:r>
-              <a:rPr/>
-              <a:t/>
+              <a:t>Goal: keep the score, and show it in a bigger font.</a:t>
             </a:r>
             <a:endParaRPr/>
           </a:p>
@@ -20004,14 +19796,14 @@
       </p:sp>
       <p:pic>
         <p:nvPicPr>
-          <p:cNvPr id="273" name="Picture 273" descr="pong8.png"/>
+          <p:cNvPr id="273" name="Picture 273" descr="p8.png"/>
           <p:cNvPicPr>
             <a:picLocks noChangeAspect="1"/>
           </p:cNvPicPr>
           <p:nvPr/>
         </p:nvPicPr>
         <p:blipFill>
-          <a:blip r:embed="rId4"/>
+          <a:blip r:embed="rId3"/>
           <a:stretch>
             <a:fillRect/>
           </a:stretch>
@@ -20019,7 +19811,7 @@
         <p:spPr>
           <a:xfrm>
             <a:off x="2120062" y="2034455"/>
-            <a:ext cx="4903894" cy="2758440"/>
+            <a:ext cx="4903893" cy="2758440"/>
           </a:xfrm>
           <a:prstGeom prst="rect">
             <a:avLst/>
@@ -20240,7 +20032,7 @@
                   <a:schemeClr val="accent5"/>
                 </a:solidFill>
               </a:rPr>
-              <a:t>Pong 9: Serve State</a:t>
+              <a:t>Pong 9: A Serve Mode</a:t>
             </a:r>
             <a:endParaRPr>
               <a:solidFill>
@@ -20293,22 +20085,22 @@
       </p:sp>
       <p:pic>
         <p:nvPicPr>
-          <p:cNvPr id="287" name="Picture 287" descr="pong9.png"/>
+          <p:cNvPr id="287" name="Picture 299" descr="p9.png"/>
           <p:cNvPicPr>
             <a:picLocks noChangeAspect="1"/>
           </p:cNvPicPr>
           <p:nvPr/>
         </p:nvPicPr>
         <p:blipFill>
-          <a:blip r:embed="rId4"/>
+          <a:blip r:embed="rId3"/>
           <a:stretch>
             <a:fillRect/>
           </a:stretch>
         </p:blipFill>
         <p:spPr>
           <a:xfrm>
-            <a:off x="5120640" y="2651760"/>
-            <a:ext cx="3566160" cy="2005964"/>
+            <a:off x="5120641" y="2651760"/>
+            <a:ext cx="3566158" cy="2005964"/>
           </a:xfrm>
           <a:prstGeom prst="rect">
             <a:avLst/>
@@ -20876,7 +20668,7 @@
                   <a:schemeClr val="accent5"/>
                 </a:solidFill>
               </a:rPr>
-              <a:t>Pong 10: Victory</a:t>
+              <a:t>Pong 10: A Winner</a:t>
             </a:r>
             <a:endParaRPr>
               <a:solidFill>
@@ -20897,7 +20689,7 @@
         <p:spPr>
           <a:xfrm>
             <a:off x="311700" y="885950"/>
-            <a:ext cx="8520600" cy="4023300"/>
+            <a:ext cx="8520600" cy="521208"/>
           </a:xfrm>
           <a:prstGeom prst="rect">
             <a:avLst/>
@@ -20921,24 +20713,7 @@
             </a:pPr>
             <a:r>
               <a:rPr lang="en"/>
-              <a:t>Allow a player to win the game</a:t>
-            </a:r>
-            <a:endParaRPr/>
-          </a:p>
-          <a:p>
-            <a:pPr indent="-317500" lvl="1" marL="914400" rtl="0" algn="l">
-              <a:spcBef>
-                <a:spcPts val="0"/>
-              </a:spcBef>
-              <a:spcAft>
-                <a:spcPts val="0"/>
-              </a:spcAft>
-              <a:buSzPts val="1400"/>
-              <a:buChar char="○"/>
-            </a:pPr>
-            <a:r>
-              <a:rPr lang="en"/>
-              <a:t>Introduce a new “done” state when maximum score is reached (e.g. 10)</a:t>
+              <a:t>Goal: a done mode when a player reaches 10 points.</a:t>
             </a:r>
             <a:endParaRPr/>
           </a:p>
@@ -20946,22 +20721,22 @@
       </p:sp>
       <p:pic>
         <p:nvPicPr>
-          <p:cNvPr id="294" name="Picture 294" descr="pong10.png"/>
+          <p:cNvPr id="294" name="Picture 294" descr="p10.png"/>
           <p:cNvPicPr>
             <a:picLocks noChangeAspect="1"/>
           </p:cNvPicPr>
           <p:nvPr/>
         </p:nvPicPr>
         <p:blipFill>
-          <a:blip r:embed="rId4"/>
+          <a:blip r:embed="rId3"/>
           <a:stretch>
             <a:fillRect/>
           </a:stretch>
         </p:blipFill>
         <p:spPr>
           <a:xfrm>
-            <a:off x="2027855" y="1938429"/>
-            <a:ext cx="5088300" cy="2862168"/>
+            <a:off x="2027856" y="1938429"/>
+            <a:ext cx="5088298" cy="2862168"/>
           </a:xfrm>
           <a:prstGeom prst="rect">
             <a:avLst/>
@@ -21477,7 +21252,7 @@
                   <a:schemeClr val="accent5"/>
                 </a:solidFill>
               </a:rPr>
-              <a:t>Pong 11: Audio</a:t>
+              <a:t>Pong 11: Sound Effects</a:t>
             </a:r>
             <a:endParaRPr>
               <a:solidFill>
@@ -21498,7 +21273,7 @@
         <p:spPr>
           <a:xfrm>
             <a:off x="311700" y="885950"/>
-            <a:ext cx="8520600" cy="4023300"/>
+            <a:ext cx="8520600" cy="521208"/>
           </a:xfrm>
           <a:prstGeom prst="rect">
             <a:avLst/>
@@ -21522,63 +21297,7 @@
             </a:pPr>
             <a:r>
               <a:rPr lang="en"/>
-              <a:t>Add sound effects to the game</a:t>
-            </a:r>
-            <a:endParaRPr/>
-          </a:p>
-          <a:p>
-            <a:pPr indent="-317500" lvl="1" marL="914400" rtl="0" algn="l">
-              <a:spcBef>
-                <a:spcPts val="0"/>
-              </a:spcBef>
-              <a:spcAft>
-                <a:spcPts val="0"/>
-              </a:spcAft>
-              <a:buSzPts val="1400"/>
-              <a:buChar char="○"/>
-            </a:pPr>
-            <a:r>
-              <a:rPr lang="en"/>
-              <a:t>You must have three distinct sounds: “</a:t>
-            </a:r>
-            <a:r>
-              <a:rPr lang="en" u="sng">
-                <a:solidFill>
-                  <a:schemeClr val="hlink"/>
-                </a:solidFill>
-                <a:hlinkClick r:id="rId3"/>
-              </a:rPr>
-              <a:t>paddle hit</a:t>
-            </a:r>
-            <a:r>
-              <a:rPr lang="en"/>
-              <a:t>”, “</a:t>
-            </a:r>
-            <a:r>
-              <a:rPr lang="en" u="sng">
-                <a:solidFill>
-                  <a:schemeClr val="hlink"/>
-                </a:solidFill>
-                <a:hlinkClick r:id="rId4"/>
-              </a:rPr>
-              <a:t>wall hit</a:t>
-            </a:r>
-            <a:r>
-              <a:rPr lang="en"/>
-              <a:t>” and “</a:t>
-            </a:r>
-            <a:r>
-              <a:rPr lang="en" u="sng">
-                <a:solidFill>
-                  <a:schemeClr val="hlink"/>
-                </a:solidFill>
-                <a:hlinkClick r:id="rId5"/>
-              </a:rPr>
-              <a:t>score</a:t>
-            </a:r>
-            <a:r>
-              <a:rPr lang="en"/>
-              <a:t>”</a:t>
+              <a:t>Goal: three sounds: a paddle hit, a wall hit, and a score.</a:t>
             </a:r>
             <a:endParaRPr/>
           </a:p>

</xml_diff>

<commit_message>
Consistency pass: one Source Code slide layout, one try-it format, sentence-case subheadings, spelling
- Every deck's Source Code slide: the folder, the README with the step range, the site
- Try-its without a step say where they happen: (on paper), (Sokoban.Tests)
- Subheadings in sentence case; Delta Time & Velocity; sprite sheet; colour
- Snake's example textures are its own; Geometry Wars describes its steps like the others
- Pattern names capitalised on the slides (Strategy, Observer)

Co-Authored-By: Claude Opus 5.5 <noreply@anthropic.com>
Claude-Session: https://claude.ai/code/session_012sjsUQBbC7zon57rWHoo9d
</commit_message>
<xml_diff>
--- a/slides/01 Pong.pptx
+++ b/slides/01 Pong.pptx
@@ -12509,7 +12509,7 @@
             </a:pPr>
             <a:r>
               <a:rPr lang="en"/>
-              <a:t>DeltaTime &amp; Velocity</a:t>
+              <a:t>Delta Time &amp; Velocity</a:t>
             </a:r>
             <a:endParaRPr/>
           </a:p>
@@ -18549,7 +18549,7 @@
             </a:pPr>
             <a:r>
               <a:rPr lang="en"/>
-              <a:t>DeltaTime &amp; Velocity</a:t>
+              <a:t>Delta Time &amp; Velocity</a:t>
             </a:r>
             <a:endParaRPr/>
           </a:p>
@@ -19674,7 +19674,7 @@
         <p:spPr>
           <a:xfrm>
             <a:off x="311700" y="885950"/>
-            <a:ext cx="8520600" cy="4023300"/>
+            <a:ext cx="8520600" cy="1289304"/>
           </a:xfrm>
           <a:prstGeom prst="rect">
             <a:avLst/>
@@ -19698,29 +19698,7 @@
             </a:pPr>
             <a:r>
               <a:rPr lang="en"/>
-              <a:t>All Source code for today’s game can be found here:</a:t>
-            </a:r>
-            <a:endParaRPr/>
-          </a:p>
-          <a:p>
-            <a:pPr indent="-317500" lvl="1" marL="914400" rtl="0" algn="l">
-              <a:spcBef>
-                <a:spcPts val="0"/>
-              </a:spcBef>
-              <a:spcAft>
-                <a:spcPts val="0"/>
-              </a:spcAft>
-              <a:buSzPts val="1400"/>
-              <a:buChar char="○"/>
-            </a:pPr>
-            <a:r>
-              <a:rPr lang="en" u="sng">
-                <a:solidFill>
-                  <a:schemeClr val="hlink"/>
-                </a:solidFill>
-                <a:hlinkClick r:id="rId3"/>
-              </a:rPr>
-              <a:t>github.com/Metamate/gar-games (folder 01-pong)</a:t>
+              <a:t>github.com/Metamate/gar-games, folder 01-pong</a:t>
             </a:r>
             <a:endParaRPr/>
           </a:p>
@@ -19737,24 +19715,24 @@
             </a:pPr>
             <a:r>
               <a:rPr lang="en"/>
-              <a:t>Each exercise is its own project: Pong0 → Pong11</a:t>
+              <a:t>Its README: the steps (Pong0 to Pong11), where things are in the code, how to run it</a:t>
             </a:r>
             <a:endParaRPr/>
           </a:p>
           <a:p>
-            <a:pPr indent="-317500" lvl="1" marL="914400" rtl="0" algn="l">
-              <a:spcBef>
-                <a:spcPts val="0"/>
-              </a:spcBef>
-              <a:spcAft>
-                <a:spcPts val="0"/>
-              </a:spcAft>
-              <a:buSzPts val="1400"/>
-              <a:buChar char="○"/>
+            <a:pPr indent="-330200" lvl="0" marL="457200" rtl="0" algn="l">
+              <a:spcBef>
+                <a:spcPts val="0"/>
+              </a:spcBef>
+              <a:spcAft>
+                <a:spcPts val="0"/>
+              </a:spcAft>
+              <a:buSzPts val="1600"/>
+              <a:buChar char="●"/>
             </a:pPr>
             <a:r>
               <a:rPr lang="en"/>
-              <a:t>Compare neighbouring steps to see exactly what changed</a:t>
+              <a:t>The course site: today’s concepts in full, the exercises, and questions to check yourself</a:t>
             </a:r>
             <a:endParaRPr/>
           </a:p>

</xml_diff>

<commit_message>
Acting on the course evaluation
- Pong and Flappy Bird: steps that repeat an idea are demos with a try-it; build exercises
  start from the step a demo ended on
- Zelda's main topic is events and the Observer pattern; a try-it on easing the scroll
- Mario's player states say only what is new after Pac-Man (shared physics, transitions
  from the level); the repeated State slides and question are gone
- Pokemon: try-its on the state stack, the tweens and the Service Locator; RPG detail trimmed
- Plants vs. Zombies: testing a component, with a try-it
- Going further: pathfinding (Pac-Man), rebinding (Snake), auto-tiling and a scene graph (Mario)
- Exercise answers on a draft page; Mario's art redrawn and recorded again

Co-Authored-By: Claude Opus 5.5 <noreply@anthropic.com>
Claude-Session: https://claude.ai/code/session_012sjsUQBbC7zon57rWHoo9d
</commit_message>
<xml_diff>
--- a/slides/01 Pong.pptx
+++ b/slides/01 Pong.pptx
@@ -39,13 +39,13 @@
     <p:sldId id="290" r:id="rId40"/>
     <p:sldId id="291" r:id="rId41"/>
     <p:sldId id="292" r:id="rId42"/>
-    <p:sldId id="293" r:id="rId43"/>
     <p:sldId id="294" r:id="rId44"/>
     <p:sldId id="295" r:id="rId45"/>
-    <p:sldId id="296" r:id="rId46"/>
+    <p:sldId id="308" r:id="rId16"/>
     <p:sldId id="297" r:id="rId47"/>
     <p:sldId id="298" r:id="rId48"/>
     <p:sldId id="299" r:id="rId49"/>
+    <p:sldId id="309" r:id="rId15"/>
     <p:sldId id="306" r:id="rId65"/>
     <p:sldId id="304" r:id="rId63"/>
     <p:sldId id="300" r:id="rId50"/>
@@ -3260,11 +3260,11 @@
 </file>
 
 <file path=ppt/notesSlides/notesSlide38.xml><?xml version="1.0" encoding="utf-8"?>
-<p:notes xmlns:a="http://schemas.openxmlformats.org/drawingml/2006/main" xmlns:r="http://schemas.openxmlformats.org/officeDocument/2006/relationships" xmlns:mc="http://schemas.openxmlformats.org/markup-compatibility/2006" xmlns:mv="urn:schemas-microsoft-com:mac:vml" xmlns:p="http://schemas.openxmlformats.org/presentationml/2006/main" xmlns:c="http://schemas.openxmlformats.org/drawingml/2006/chart" xmlns:dgm="http://schemas.openxmlformats.org/drawingml/2006/diagram" xmlns:o="urn:schemas-microsoft-com:office:office" xmlns:v="urn:schemas-microsoft-com:vml" xmlns:pvml="urn:schemas-microsoft-com:office:powerpoint" xmlns:com="http://schemas.openxmlformats.org/drawingml/2006/compatibility" xmlns:p14="http://schemas.microsoft.com/office/powerpoint/2010/main" xmlns:p15="http://schemas.microsoft.com/office/powerpoint/2012/main" xmlns:ahyp="http://schemas.microsoft.com/office/drawing/2018/hyperlinkcolor" showMasterPhAnim="0" showMasterSp="0">
+<p:notes xmlns:a="http://schemas.openxmlformats.org/drawingml/2006/main" xmlns:p="http://schemas.openxmlformats.org/presentationml/2006/main" xmlns:r="http://schemas.openxmlformats.org/officeDocument/2006/relationships">
   <p:cSld>
     <p:spTree>
       <p:nvGrpSpPr>
-        <p:cNvPr id="267" name="Shape 267"/>
+        <p:cNvPr id="1" name=""/>
         <p:cNvGrpSpPr/>
         <p:nvPr/>
       </p:nvGrpSpPr>
@@ -3278,69 +3278,33 @@
       </p:grpSpPr>
       <p:sp>
         <p:nvSpPr>
-          <p:cNvPr id="268" name="Google Shape;268;g3c2ab6540c5_0_93:notes"/>
-          <p:cNvSpPr/>
+          <p:cNvPr id="2" name="Slide Image Placeholder 1"/>
+          <p:cNvSpPr>
+            <a:spLocks noGrp="1"/>
+          </p:cNvSpPr>
           <p:nvPr>
-            <p:ph idx="2" type="sldImg"/>
+            <p:ph type="sldImg" idx="2"/>
           </p:nvPr>
         </p:nvSpPr>
-        <p:spPr>
-          <a:xfrm>
-            <a:off x="381300" y="685800"/>
-            <a:ext cx="6096000" cy="3429000"/>
-          </a:xfrm>
-          <a:custGeom>
-            <a:rect b="b" l="l" r="r" t="t"/>
-            <a:pathLst>
-              <a:path extrusionOk="0" h="120000" w="120000">
-                <a:moveTo>
-                  <a:pt x="0" y="0"/>
-                </a:moveTo>
-                <a:lnTo>
-                  <a:pt x="120000" y="0"/>
-                </a:lnTo>
-                <a:lnTo>
-                  <a:pt x="120000" y="120000"/>
-                </a:lnTo>
-                <a:lnTo>
-                  <a:pt x="0" y="120000"/>
-                </a:lnTo>
-                <a:close/>
-              </a:path>
-            </a:pathLst>
-          </a:custGeom>
-        </p:spPr>
-      </p:sp>
-      <p:sp>
-        <p:nvSpPr>
-          <p:cNvPr id="269" name="Google Shape;269;g3c2ab6540c5_0_93:notes"/>
-          <p:cNvSpPr txBox="1"/>
+        <p:spPr/>
+      </p:sp>
+      <p:sp>
+        <p:nvSpPr>
+          <p:cNvPr id="3" name="Notes Placeholder 2"/>
+          <p:cNvSpPr>
+            <a:spLocks noGrp="1"/>
+          </p:cNvSpPr>
           <p:nvPr>
-            <p:ph idx="1" type="body"/>
+            <p:ph type="body" idx="1"/>
           </p:nvPr>
         </p:nvSpPr>
-        <p:spPr>
-          <a:xfrm>
-            <a:off x="685800" y="4343400"/>
-            <a:ext cx="5486400" cy="4114800"/>
-          </a:xfrm>
-          <a:prstGeom prst="rect">
-            <a:avLst/>
-          </a:prstGeom>
-        </p:spPr>
+        <p:spPr/>
         <p:txBody>
-          <a:bodyPr anchorCtr="0" anchor="t" bIns="91425" lIns="91425" spcFirstLastPara="1" rIns="91425" wrap="square" tIns="91425">
-            <a:noAutofit/>
-          </a:bodyPr>
+          <a:bodyPr/>
           <a:lstStyle/>
           <a:p>
             <a:r>
-              <a:t>Exercise: keep score, shown in a bigger font.</a:t>
-            </a:r>
-          </a:p>
-          <a:p>
-            <a:r>
-              <a:t>Full instructions are on the course site; students work from there. Walk round while they work.</a:t>
+              <a:t>Pairs, about 6 minutes. _winningScore in Game1. The pause needs a new if in Update (skip the play logic) and in Draw (show Paused), and a key check: every mode touches every method. That is the problem Flappy Bird solves with a state machine.</a:t>
             </a:r>
           </a:p>
         </p:txBody>
@@ -3518,17 +3482,27 @@
           <a:lstStyle/>
           <a:p>
             <a:r>
-              <a:t>Follow the diagram: start, Enter, serve, Enter, play; a point goes back to serve; 10 points ends it.</a:t>
-            </a:r>
-          </a:p>
-          <a:p>
-            <a:r>
-              <a:t>Exercise: add the serve mode; the player who was scored on serves.</a:t>
-            </a:r>
-          </a:p>
-          <a:p>
-            <a:r>
-              <a:t>Full instructions are on the course site; students work from there. Walk round while they work.</a:t>
+              <a:t>Demo: open Pong7 and Pong10 side by side, then run Pong10.</a:t>
+            </a:r>
+          </a:p>
+          <a:p>
+            <a:r>
+              <a:t>- Pong8: the score, in font-big</a:t>
+            </a:r>
+          </a:p>
+          <a:p>
+            <a:r>
+              <a:t>- Pong9: serve, and the player who was scored on serves</a:t>
+            </a:r>
+          </a:p>
+          <a:p>
+            <a:r>
+              <a:t>- Pong10: done at 10 points</a:t>
+            </a:r>
+          </a:p>
+          <a:p>
+            <a:r>
+              <a:t>Point at the ifs on the mode string in Update and in Draw.</a:t>
             </a:r>
           </a:p>
         </p:txBody>
@@ -3542,11 +3516,11 @@
 </file>
 
 <file path=ppt/notesSlides/notesSlide41.xml><?xml version="1.0" encoding="utf-8"?>
-<p:notes xmlns:a="http://schemas.openxmlformats.org/drawingml/2006/main" xmlns:r="http://schemas.openxmlformats.org/officeDocument/2006/relationships" xmlns:mc="http://schemas.openxmlformats.org/markup-compatibility/2006" xmlns:mv="urn:schemas-microsoft-com:mac:vml" xmlns:p="http://schemas.openxmlformats.org/presentationml/2006/main" xmlns:c="http://schemas.openxmlformats.org/drawingml/2006/chart" xmlns:dgm="http://schemas.openxmlformats.org/drawingml/2006/diagram" xmlns:o="urn:schemas-microsoft-com:office:office" xmlns:v="urn:schemas-microsoft-com:vml" xmlns:pvml="urn:schemas-microsoft-com:office:powerpoint" xmlns:com="http://schemas.openxmlformats.org/drawingml/2006/compatibility" xmlns:p14="http://schemas.microsoft.com/office/powerpoint/2010/main" xmlns:p15="http://schemas.microsoft.com/office/powerpoint/2012/main" xmlns:ahyp="http://schemas.microsoft.com/office/drawing/2018/hyperlinkcolor" showMasterPhAnim="0" showMasterSp="0">
+<p:notes xmlns:a="http://schemas.openxmlformats.org/drawingml/2006/main" xmlns:p="http://schemas.openxmlformats.org/presentationml/2006/main" xmlns:r="http://schemas.openxmlformats.org/officeDocument/2006/relationships">
   <p:cSld>
     <p:spTree>
       <p:nvGrpSpPr>
-        <p:cNvPr id="288" name="Shape 288"/>
+        <p:cNvPr id="1" name=""/>
         <p:cNvGrpSpPr/>
         <p:nvPr/>
       </p:nvGrpSpPr>
@@ -3560,69 +3534,33 @@
       </p:grpSpPr>
       <p:sp>
         <p:nvSpPr>
-          <p:cNvPr id="289" name="Google Shape;289;g3c2ab6540c5_0_102:notes"/>
-          <p:cNvSpPr/>
+          <p:cNvPr id="2" name="Slide Image Placeholder 1"/>
+          <p:cNvSpPr>
+            <a:spLocks noGrp="1"/>
+          </p:cNvSpPr>
           <p:nvPr>
-            <p:ph idx="2" type="sldImg"/>
+            <p:ph type="sldImg" idx="2"/>
           </p:nvPr>
         </p:nvSpPr>
-        <p:spPr>
-          <a:xfrm>
-            <a:off x="381300" y="685800"/>
-            <a:ext cx="6096000" cy="3429000"/>
-          </a:xfrm>
-          <a:custGeom>
-            <a:rect b="b" l="l" r="r" t="t"/>
-            <a:pathLst>
-              <a:path extrusionOk="0" h="120000" w="120000">
-                <a:moveTo>
-                  <a:pt x="0" y="0"/>
-                </a:moveTo>
-                <a:lnTo>
-                  <a:pt x="120000" y="0"/>
-                </a:lnTo>
-                <a:lnTo>
-                  <a:pt x="120000" y="120000"/>
-                </a:lnTo>
-                <a:lnTo>
-                  <a:pt x="0" y="120000"/>
-                </a:lnTo>
-                <a:close/>
-              </a:path>
-            </a:pathLst>
-          </a:custGeom>
-        </p:spPr>
-      </p:sp>
-      <p:sp>
-        <p:nvSpPr>
-          <p:cNvPr id="290" name="Google Shape;290;g3c2ab6540c5_0_102:notes"/>
-          <p:cNvSpPr txBox="1"/>
+        <p:spPr/>
+      </p:sp>
+      <p:sp>
+        <p:nvSpPr>
+          <p:cNvPr id="3" name="Notes Placeholder 2"/>
+          <p:cNvSpPr>
+            <a:spLocks noGrp="1"/>
+          </p:cNvSpPr>
           <p:nvPr>
-            <p:ph idx="1" type="body"/>
+            <p:ph type="body" idx="1"/>
           </p:nvPr>
         </p:nvSpPr>
-        <p:spPr>
-          <a:xfrm>
-            <a:off x="685800" y="4343400"/>
-            <a:ext cx="5486400" cy="4114800"/>
-          </a:xfrm>
-          <a:prstGeom prst="rect">
-            <a:avLst/>
-          </a:prstGeom>
-        </p:spPr>
+        <p:spPr/>
         <p:txBody>
-          <a:bodyPr anchorCtr="0" anchor="t" bIns="91425" lIns="91425" spcFirstLastPara="1" rIns="91425" wrap="square" tIns="91425">
-            <a:noAutofit/>
-          </a:bodyPr>
+          <a:bodyPr/>
           <a:lstStyle/>
           <a:p>
             <a:r>
-              <a:t>Exercise: a done mode at 10 points. The screenshot shows the end screen.</a:t>
-            </a:r>
-          </a:p>
-          <a:p>
-            <a:r>
-              <a:t>Full instructions are on the course site; students work from there. Walk round while they work.</a:t>
+              <a:t>Pairs, about 5 minutes. Play(volume, pitch, pan): pitch runs from -1 to 1. For example Math.Clamp(speed / maxSpeed - 0.5f, -1, 1) at the paddle hit.</a:t>
             </a:r>
           </a:p>
         </p:txBody>
@@ -3889,12 +3827,7 @@
           <a:lstStyle/>
           <a:p>
             <a:r>
-              <a:t>Exercise: three sounds: paddle hit, wall hit, score.</a:t>
-            </a:r>
-          </a:p>
-          <a:p>
-            <a:r>
-              <a:t>Full instructions are on the course site; students work from there. Walk round while they work.</a:t>
+              <a:t>Demo: run Pong11, and show the three Play calls: paddle hit, wall hit, point.</a:t>
             </a:r>
           </a:p>
         </p:txBody>
@@ -16615,144 +16548,6 @@
   <p:cSld>
     <p:spTree>
       <p:nvGrpSpPr>
-        <p:cNvPr id="270" name="Shape 270"/>
-        <p:cNvGrpSpPr/>
-        <p:nvPr/>
-      </p:nvGrpSpPr>
-      <p:grpSpPr>
-        <a:xfrm>
-          <a:off x="0" y="0"/>
-          <a:ext cx="0" cy="0"/>
-          <a:chOff x="0" y="0"/>
-          <a:chExt cx="0" cy="0"/>
-        </a:xfrm>
-      </p:grpSpPr>
-      <p:sp>
-        <p:nvSpPr>
-          <p:cNvPr id="271" name="Google Shape;271;p46"/>
-          <p:cNvSpPr txBox="1"/>
-          <p:nvPr>
-            <p:ph type="title"/>
-          </p:nvPr>
-        </p:nvSpPr>
-        <p:spPr>
-          <a:xfrm>
-            <a:off x="311700" y="195615"/>
-            <a:ext cx="8520600" cy="572700"/>
-          </a:xfrm>
-          <a:prstGeom prst="rect">
-            <a:avLst/>
-          </a:prstGeom>
-        </p:spPr>
-        <p:txBody>
-          <a:bodyPr anchorCtr="0" anchor="t" bIns="91425" lIns="91425" spcFirstLastPara="1" rIns="91425" wrap="square" tIns="91425">
-            <a:normAutofit fontScale="90000"/>
-          </a:bodyPr>
-          <a:lstStyle/>
-          <a:p>
-            <a:pPr indent="0" lvl="0" marL="0" rtl="0" algn="l">
-              <a:spcBef>
-                <a:spcPts val="0"/>
-              </a:spcBef>
-              <a:spcAft>
-                <a:spcPts val="0"/>
-              </a:spcAft>
-              <a:buNone/>
-            </a:pPr>
-            <a:r>
-              <a:rPr lang="en">
-                <a:solidFill>
-                  <a:schemeClr val="accent5"/>
-                </a:solidFill>
-              </a:rPr>
-              <a:t>Pong 8: Scoring</a:t>
-            </a:r>
-            <a:endParaRPr>
-              <a:solidFill>
-                <a:schemeClr val="accent5"/>
-              </a:solidFill>
-            </a:endParaRPr>
-          </a:p>
-        </p:txBody>
-      </p:sp>
-      <p:sp>
-        <p:nvSpPr>
-          <p:cNvPr id="272" name="Google Shape;272;p46"/>
-          <p:cNvSpPr txBox="1"/>
-          <p:nvPr>
-            <p:ph idx="1" type="body"/>
-          </p:nvPr>
-        </p:nvSpPr>
-        <p:spPr>
-          <a:xfrm>
-            <a:off x="311700" y="885950"/>
-            <a:ext cx="8520600" cy="521208"/>
-          </a:xfrm>
-          <a:prstGeom prst="rect">
-            <a:avLst/>
-          </a:prstGeom>
-        </p:spPr>
-        <p:txBody>
-          <a:bodyPr anchorCtr="0" anchor="t" bIns="91425" lIns="91425" spcFirstLastPara="1" rIns="91425" wrap="square" tIns="91425">
-            <a:normAutofit/>
-          </a:bodyPr>
-          <a:lstStyle/>
-          <a:p>
-            <a:pPr indent="-330200" lvl="0" marL="457200" rtl="0" algn="l">
-              <a:spcBef>
-                <a:spcPts val="0"/>
-              </a:spcBef>
-              <a:spcAft>
-                <a:spcPts val="0"/>
-              </a:spcAft>
-              <a:buSzPts val="1600"/>
-              <a:buChar char="●"/>
-            </a:pPr>
-            <a:r>
-              <a:rPr lang="en"/>
-              <a:t>Goal: keep the score, and show it in a bigger font.</a:t>
-            </a:r>
-            <a:endParaRPr/>
-          </a:p>
-        </p:txBody>
-      </p:sp>
-      <p:pic>
-        <p:nvPicPr>
-          <p:cNvPr id="273" name="Picture 273" descr="p8.png"/>
-          <p:cNvPicPr>
-            <a:picLocks noChangeAspect="1"/>
-          </p:cNvPicPr>
-          <p:nvPr/>
-        </p:nvPicPr>
-        <p:blipFill>
-          <a:blip r:embed="rId3"/>
-          <a:stretch>
-            <a:fillRect/>
-          </a:stretch>
-        </p:blipFill>
-        <p:spPr>
-          <a:xfrm>
-            <a:off x="2120062" y="2034455"/>
-            <a:ext cx="4903893" cy="2758440"/>
-          </a:xfrm>
-          <a:prstGeom prst="rect">
-            <a:avLst/>
-          </a:prstGeom>
-        </p:spPr>
-      </p:pic>
-    </p:spTree>
-  </p:cSld>
-  <p:clrMapOvr>
-    <a:masterClrMapping/>
-  </p:clrMapOvr>
-</p:sld>
-</file>
-
-<file path=ppt/slides/slide33.xml><?xml version="1.0" encoding="utf-8"?>
-<p:sld xmlns:a="http://schemas.openxmlformats.org/drawingml/2006/main" xmlns:r="http://schemas.openxmlformats.org/officeDocument/2006/relationships" xmlns:mc="http://schemas.openxmlformats.org/markup-compatibility/2006" xmlns:mv="urn:schemas-microsoft-com:mac:vml" xmlns:p="http://schemas.openxmlformats.org/presentationml/2006/main" xmlns:c="http://schemas.openxmlformats.org/drawingml/2006/chart" xmlns:dgm="http://schemas.openxmlformats.org/drawingml/2006/diagram" xmlns:o="urn:schemas-microsoft-com:office:office" xmlns:v="urn:schemas-microsoft-com:vml" xmlns:pvml="urn:schemas-microsoft-com:office:powerpoint" xmlns:com="http://schemas.openxmlformats.org/drawingml/2006/compatibility" xmlns:p14="http://schemas.microsoft.com/office/powerpoint/2010/main" xmlns:p15="http://schemas.microsoft.com/office/powerpoint/2012/main" xmlns:ahyp="http://schemas.microsoft.com/office/drawing/2018/hyperlinkcolor">
-  <p:cSld>
-    <p:spTree>
-      <p:nvGrpSpPr>
         <p:cNvPr id="277" name="Shape 277"/>
         <p:cNvGrpSpPr/>
         <p:nvPr/>
@@ -16899,7 +16694,7 @@
 </p:sld>
 </file>
 
-<file path=ppt/slides/slide34.xml><?xml version="1.0" encoding="utf-8"?>
+<file path=ppt/slides/slide33.xml><?xml version="1.0" encoding="utf-8"?>
 <p:sld xmlns:a="http://schemas.openxmlformats.org/drawingml/2006/main" xmlns:r="http://schemas.openxmlformats.org/officeDocument/2006/relationships" xmlns:mc="http://schemas.openxmlformats.org/markup-compatibility/2006" xmlns:mv="urn:schemas-microsoft-com:mac:vml" xmlns:p="http://schemas.openxmlformats.org/presentationml/2006/main" xmlns:c="http://schemas.openxmlformats.org/drawingml/2006/chart" xmlns:dgm="http://schemas.openxmlformats.org/drawingml/2006/diagram" xmlns:o="urn:schemas-microsoft-com:office:office" xmlns:v="urn:schemas-microsoft-com:vml" xmlns:pvml="urn:schemas-microsoft-com:office:powerpoint" xmlns:com="http://schemas.openxmlformats.org/drawingml/2006/compatibility" xmlns:p14="http://schemas.microsoft.com/office/powerpoint/2010/main" xmlns:p15="http://schemas.microsoft.com/office/powerpoint/2012/main" xmlns:ahyp="http://schemas.microsoft.com/office/drawing/2018/hyperlinkcolor">
   <p:cSld>
     <p:spTree>
@@ -16954,7 +16749,7 @@
                   <a:schemeClr val="accent5"/>
                 </a:solidFill>
               </a:rPr>
-              <a:t>Pong 9: A Serve Mode</a:t>
+              <a:t>Game State Implementation</a:t>
             </a:r>
             <a:endParaRPr>
               <a:solidFill>
@@ -16999,7 +16794,7 @@
             </a:pPr>
             <a:r>
               <a:rPr lang="en"/>
-              <a:t>Add a serve state: the player who was scored on serves.</a:t>
+              <a:t>Demo: Pong7 → Pong10: score, serve and done modes</a:t>
             </a:r>
             <a:endParaRPr/>
           </a:p>
@@ -17535,44 +17330,29 @@
 </p:sld>
 </file>
 
-<file path=ppt/slides/slide35.xml><?xml version="1.0" encoding="utf-8"?>
-<p:sld xmlns:a="http://schemas.openxmlformats.org/drawingml/2006/main" xmlns:r="http://schemas.openxmlformats.org/officeDocument/2006/relationships" xmlns:mc="http://schemas.openxmlformats.org/markup-compatibility/2006" xmlns:mv="urn:schemas-microsoft-com:mac:vml" xmlns:p="http://schemas.openxmlformats.org/presentationml/2006/main" xmlns:c="http://schemas.openxmlformats.org/drawingml/2006/chart" xmlns:dgm="http://schemas.openxmlformats.org/drawingml/2006/diagram" xmlns:o="urn:schemas-microsoft-com:office:office" xmlns:v="urn:schemas-microsoft-com:vml" xmlns:pvml="urn:schemas-microsoft-com:office:powerpoint" xmlns:com="http://schemas.openxmlformats.org/drawingml/2006/compatibility" xmlns:p14="http://schemas.microsoft.com/office/powerpoint/2010/main" xmlns:p15="http://schemas.microsoft.com/office/powerpoint/2012/main" xmlns:ahyp="http://schemas.microsoft.com/office/drawing/2018/hyperlinkcolor">
+<file path=ppt/slides/slide34.xml><?xml version="1.0" encoding="utf-8"?>
+<p:sld xmlns:a="http://schemas.openxmlformats.org/drawingml/2006/main" xmlns:p="http://schemas.openxmlformats.org/presentationml/2006/main" xmlns:r="http://schemas.openxmlformats.org/officeDocument/2006/relationships">
   <p:cSld>
     <p:spTree>
       <p:nvGrpSpPr>
-        <p:cNvPr id="291" name="Shape 291"/>
+        <p:cNvPr id="1" name=""/>
         <p:cNvGrpSpPr/>
         <p:nvPr/>
       </p:nvGrpSpPr>
-      <p:grpSpPr>
-        <a:xfrm>
-          <a:off x="0" y="0"/>
-          <a:ext cx="0" cy="0"/>
-          <a:chOff x="0" y="0"/>
-          <a:chExt cx="0" cy="0"/>
-        </a:xfrm>
-      </p:grpSpPr>
-      <p:sp>
-        <p:nvSpPr>
-          <p:cNvPr id="292" name="Google Shape;292;p49"/>
-          <p:cNvSpPr txBox="1"/>
+      <p:grpSpPr/>
+      <p:sp>
+        <p:nvSpPr>
+          <p:cNvPr id="2" name="Title 1"/>
+          <p:cNvSpPr>
+            <a:spLocks noGrp="1"/>
+          </p:cNvSpPr>
           <p:nvPr>
             <p:ph type="title"/>
           </p:nvPr>
         </p:nvSpPr>
-        <p:spPr>
-          <a:xfrm>
-            <a:off x="311700" y="195615"/>
-            <a:ext cx="8520600" cy="572700"/>
-          </a:xfrm>
-          <a:prstGeom prst="rect">
-            <a:avLst/>
-          </a:prstGeom>
-        </p:spPr>
+        <p:spPr/>
         <p:txBody>
-          <a:bodyPr anchorCtr="0" anchor="t" bIns="91425" lIns="91425" spcFirstLastPara="1" rIns="91425" wrap="square" tIns="91425">
-            <a:normAutofit fontScale="90000"/>
-          </a:bodyPr>
+          <a:bodyPr/>
           <a:lstStyle/>
           <a:p>
             <a:pPr indent="0" lvl="0" marL="0" rtl="0" algn="l">
@@ -17585,42 +17365,31 @@
               <a:buNone/>
             </a:pPr>
             <a:r>
-              <a:rPr lang="en">
-                <a:solidFill>
-                  <a:schemeClr val="accent5"/>
-                </a:solidFill>
-              </a:rPr>
-              <a:t>Pong 10: A Winner</a:t>
-            </a:r>
-            <a:endParaRPr>
-              <a:solidFill>
-                <a:schemeClr val="accent5"/>
-              </a:solidFill>
-            </a:endParaRPr>
+              <a:rPr lang="en"/>
+              <a:t>Try It: Three Points and a Pause</a:t>
+            </a:r>
+            <a:endParaRPr/>
           </a:p>
         </p:txBody>
       </p:sp>
       <p:sp>
         <p:nvSpPr>
-          <p:cNvPr id="293" name="Google Shape;293;p49"/>
-          <p:cNvSpPr txBox="1"/>
+          <p:cNvPr id="3" name="Text Placeholder 2"/>
+          <p:cNvSpPr>
+            <a:spLocks noGrp="1"/>
+          </p:cNvSpPr>
           <p:nvPr>
-            <p:ph idx="1" type="body"/>
+            <p:ph type="body" idx="1"/>
           </p:nvPr>
         </p:nvSpPr>
         <p:spPr>
           <a:xfrm>
             <a:off x="311700" y="885950"/>
-            <a:ext cx="8520600" cy="521208"/>
-          </a:xfrm>
-          <a:prstGeom prst="rect">
-            <a:avLst/>
-          </a:prstGeom>
+            <a:ext cx="8520600" cy="1673352"/>
+          </a:xfrm>
         </p:spPr>
         <p:txBody>
-          <a:bodyPr anchorCtr="0" anchor="t" bIns="91425" lIns="91425" spcFirstLastPara="1" rIns="91425" wrap="square" tIns="91425">
-            <a:normAutofit/>
-          </a:bodyPr>
+          <a:bodyPr/>
           <a:lstStyle/>
           <a:p>
             <a:pPr indent="-330200" lvl="0" marL="457200" rtl="0" algn="l">
@@ -17635,36 +17404,63 @@
             </a:pPr>
             <a:r>
               <a:rPr lang="en"/>
-              <a:t>Goal: a done mode when a player reaches 10 points.</a:t>
+              <a:t>In Pong10:</a:t>
             </a:r>
             <a:endParaRPr/>
           </a:p>
+          <a:p>
+            <a:pPr indent="-330200" lvl="0" marL="457200" rtl="0" algn="l">
+              <a:spcBef>
+                <a:spcPts val="0"/>
+              </a:spcBef>
+              <a:spcAft>
+                <a:spcPts val="0"/>
+              </a:spcAft>
+              <a:buSzPts val="1600"/>
+              <a:buChar char="●"/>
+            </a:pPr>
+            <a:r>
+              <a:rPr lang="en"/>
+              <a:t>End a game at 3 points</a:t>
+            </a:r>
+            <a:endParaRPr/>
+          </a:p>
+          <a:p>
+            <a:pPr indent="-330200" lvl="0" marL="457200" rtl="0" algn="l">
+              <a:spcBef>
+                <a:spcPts val="0"/>
+              </a:spcBef>
+              <a:spcAft>
+                <a:spcPts val="0"/>
+              </a:spcAft>
+              <a:buSzPts val="1600"/>
+              <a:buChar char="●"/>
+            </a:pPr>
+            <a:r>
+              <a:rPr lang="en"/>
+              <a:t>Add a paused mode that P toggles during play</a:t>
+            </a:r>
+            <a:endParaRPr/>
+          </a:p>
+          <a:p>
+            <a:pPr indent="-330200" lvl="0" marL="457200" rtl="0" algn="l">
+              <a:spcBef>
+                <a:spcPts val="0"/>
+              </a:spcBef>
+              <a:spcAft>
+                <a:spcPts val="0"/>
+              </a:spcAft>
+              <a:buSzPts val="1600"/>
+              <a:buChar char="●"/>
+            </a:pPr>
+            <a:r>
+              <a:rPr lang="en"/>
+              <a:t>Which methods did you have to change?</a:t>
+            </a:r>
+            <a:endParaRPr/>
+          </a:p>
         </p:txBody>
       </p:sp>
-      <p:pic>
-        <p:nvPicPr>
-          <p:cNvPr id="294" name="Picture 294" descr="p10.png"/>
-          <p:cNvPicPr>
-            <a:picLocks noChangeAspect="1"/>
-          </p:cNvPicPr>
-          <p:nvPr/>
-        </p:nvPicPr>
-        <p:blipFill>
-          <a:blip r:embed="rId3"/>
-          <a:stretch>
-            <a:fillRect/>
-          </a:stretch>
-        </p:blipFill>
-        <p:spPr>
-          <a:xfrm>
-            <a:off x="2027856" y="1938429"/>
-            <a:ext cx="5088298" cy="2862168"/>
-          </a:xfrm>
-          <a:prstGeom prst="rect">
-            <a:avLst/>
-          </a:prstGeom>
-        </p:spPr>
-      </p:pic>
     </p:spTree>
   </p:cSld>
   <p:clrMapOvr>
@@ -17673,7 +17469,7 @@
 </p:sld>
 </file>
 
-<file path=ppt/slides/slide36.xml><?xml version="1.0" encoding="utf-8"?>
+<file path=ppt/slides/slide35.xml><?xml version="1.0" encoding="utf-8"?>
 <p:sld xmlns:a="http://schemas.openxmlformats.org/drawingml/2006/main" xmlns:r="http://schemas.openxmlformats.org/officeDocument/2006/relationships" xmlns:mc="http://schemas.openxmlformats.org/markup-compatibility/2006" xmlns:mv="urn:schemas-microsoft-com:mac:vml" xmlns:p="http://schemas.openxmlformats.org/presentationml/2006/main" xmlns:c="http://schemas.openxmlformats.org/drawingml/2006/chart" xmlns:dgm="http://schemas.openxmlformats.org/drawingml/2006/diagram" xmlns:o="urn:schemas-microsoft-com:office:office" xmlns:v="urn:schemas-microsoft-com:vml" xmlns:pvml="urn:schemas-microsoft-com:office:powerpoint" xmlns:com="http://schemas.openxmlformats.org/drawingml/2006/compatibility" xmlns:p14="http://schemas.microsoft.com/office/powerpoint/2010/main" xmlns:p15="http://schemas.microsoft.com/office/powerpoint/2012/main" xmlns:ahyp="http://schemas.microsoft.com/office/drawing/2018/hyperlinkcolor">
   <p:cSld>
     <p:spTree>
@@ -17920,7 +17716,7 @@
                   <a:srgbClr val="9AA3AB"/>
                 </a:solidFill>
               </a:rPr>
-              <a:t>one at a time (not today)</a:t>
+              <a:t>one at a time (Flappy Bird)</a:t>
             </a:r>
           </a:p>
         </p:txBody>
@@ -17967,7 +17763,7 @@
 </p:sld>
 </file>
 
-<file path=ppt/slides/slide37.xml><?xml version="1.0" encoding="utf-8"?>
+<file path=ppt/slides/slide36.xml><?xml version="1.0" encoding="utf-8"?>
 <p:sld xmlns:a="http://schemas.openxmlformats.org/drawingml/2006/main" xmlns:r="http://schemas.openxmlformats.org/officeDocument/2006/relationships" xmlns:mc="http://schemas.openxmlformats.org/markup-compatibility/2006" xmlns:mv="urn:schemas-microsoft-com:mac:vml" xmlns:p="http://schemas.openxmlformats.org/presentationml/2006/main" xmlns:c="http://schemas.openxmlformats.org/drawingml/2006/chart" xmlns:dgm="http://schemas.openxmlformats.org/drawingml/2006/diagram" xmlns:o="urn:schemas-microsoft-com:office:office" xmlns:v="urn:schemas-microsoft-com:vml" xmlns:pvml="urn:schemas-microsoft-com:office:powerpoint" xmlns:com="http://schemas.openxmlformats.org/drawingml/2006/compatibility" xmlns:p14="http://schemas.microsoft.com/office/powerpoint/2010/main" xmlns:p15="http://schemas.microsoft.com/office/powerpoint/2012/main" xmlns:ahyp="http://schemas.microsoft.com/office/drawing/2018/hyperlinkcolor">
   <p:cSld>
     <p:spTree>
@@ -18119,7 +17915,7 @@
 </p:sld>
 </file>
 
-<file path=ppt/slides/slide38.xml><?xml version="1.0" encoding="utf-8"?>
+<file path=ppt/slides/slide37.xml><?xml version="1.0" encoding="utf-8"?>
 <p:sld xmlns:a="http://schemas.openxmlformats.org/drawingml/2006/main" xmlns:r="http://schemas.openxmlformats.org/officeDocument/2006/relationships" xmlns:mc="http://schemas.openxmlformats.org/markup-compatibility/2006" xmlns:mv="urn:schemas-microsoft-com:mac:vml" xmlns:p="http://schemas.openxmlformats.org/presentationml/2006/main" xmlns:c="http://schemas.openxmlformats.org/drawingml/2006/chart" xmlns:dgm="http://schemas.openxmlformats.org/drawingml/2006/diagram" xmlns:o="urn:schemas-microsoft-com:office:office" xmlns:v="urn:schemas-microsoft-com:vml" xmlns:pvml="urn:schemas-microsoft-com:office:powerpoint" xmlns:com="http://schemas.openxmlformats.org/drawingml/2006/compatibility" xmlns:p14="http://schemas.microsoft.com/office/powerpoint/2010/main" xmlns:p15="http://schemas.microsoft.com/office/powerpoint/2012/main" xmlns:ahyp="http://schemas.microsoft.com/office/drawing/2018/hyperlinkcolor">
   <p:cSld>
     <p:spTree>
@@ -18174,7 +17970,7 @@
                   <a:schemeClr val="accent5"/>
                 </a:solidFill>
               </a:rPr>
-              <a:t>Pong 11: Sound Effects</a:t>
+              <a:t>Sound Effects Implementation</a:t>
             </a:r>
             <a:endParaRPr>
               <a:solidFill>
@@ -18219,7 +18015,129 @@
             </a:pPr>
             <a:r>
               <a:rPr lang="en"/>
-              <a:t>Goal: three sounds: a paddle hit, a wall hit, and a score.</a:t>
+              <a:t>Demo: Pong11: a sound for a paddle hit, a wall hit and a point</a:t>
+            </a:r>
+            <a:endParaRPr/>
+          </a:p>
+        </p:txBody>
+      </p:sp>
+    </p:spTree>
+  </p:cSld>
+  <p:clrMapOvr>
+    <a:masterClrMapping/>
+  </p:clrMapOvr>
+</p:sld>
+</file>
+
+<file path=ppt/slides/slide38.xml><?xml version="1.0" encoding="utf-8"?>
+<p:sld xmlns:a="http://schemas.openxmlformats.org/drawingml/2006/main" xmlns:p="http://schemas.openxmlformats.org/presentationml/2006/main" xmlns:r="http://schemas.openxmlformats.org/officeDocument/2006/relationships">
+  <p:cSld>
+    <p:spTree>
+      <p:nvGrpSpPr>
+        <p:cNvPr id="1" name=""/>
+        <p:cNvGrpSpPr/>
+        <p:nvPr/>
+      </p:nvGrpSpPr>
+      <p:grpSpPr/>
+      <p:sp>
+        <p:nvSpPr>
+          <p:cNvPr id="2" name="Title 1"/>
+          <p:cNvSpPr>
+            <a:spLocks noGrp="1"/>
+          </p:cNvSpPr>
+          <p:nvPr>
+            <p:ph type="title"/>
+          </p:nvPr>
+        </p:nvSpPr>
+        <p:spPr/>
+        <p:txBody>
+          <a:bodyPr/>
+          <a:lstStyle/>
+          <a:p>
+            <a:pPr indent="0" lvl="0" marL="0" rtl="0" algn="l">
+              <a:spcBef>
+                <a:spcPts val="0"/>
+              </a:spcBef>
+              <a:spcAft>
+                <a:spcPts val="0"/>
+              </a:spcAft>
+              <a:buNone/>
+            </a:pPr>
+            <a:r>
+              <a:rPr lang="en"/>
+              <a:t>Try It: Pitch With Speed</a:t>
+            </a:r>
+            <a:endParaRPr/>
+          </a:p>
+        </p:txBody>
+      </p:sp>
+      <p:sp>
+        <p:nvSpPr>
+          <p:cNvPr id="3" name="Text Placeholder 2"/>
+          <p:cNvSpPr>
+            <a:spLocks noGrp="1"/>
+          </p:cNvSpPr>
+          <p:nvPr>
+            <p:ph type="body" idx="1"/>
+          </p:nvPr>
+        </p:nvSpPr>
+        <p:spPr>
+          <a:xfrm>
+            <a:off x="311700" y="885950"/>
+            <a:ext cx="8520600" cy="1289304"/>
+          </a:xfrm>
+        </p:spPr>
+        <p:txBody>
+          <a:bodyPr/>
+          <a:lstStyle/>
+          <a:p>
+            <a:pPr indent="-330200" lvl="0" marL="457200" rtl="0" algn="l">
+              <a:spcBef>
+                <a:spcPts val="0"/>
+              </a:spcBef>
+              <a:spcAft>
+                <a:spcPts val="0"/>
+              </a:spcAft>
+              <a:buSzPts val="1600"/>
+              <a:buChar char="●"/>
+            </a:pPr>
+            <a:r>
+              <a:rPr lang="en"/>
+              <a:t>In Pong11:</a:t>
+            </a:r>
+            <a:endParaRPr/>
+          </a:p>
+          <a:p>
+            <a:pPr indent="-330200" lvl="0" marL="457200" rtl="0" algn="l">
+              <a:spcBef>
+                <a:spcPts val="0"/>
+              </a:spcBef>
+              <a:spcAft>
+                <a:spcPts val="0"/>
+              </a:spcAft>
+              <a:buSzPts val="1600"/>
+              <a:buChar char="●"/>
+            </a:pPr>
+            <a:r>
+              <a:rPr lang="en"/>
+              <a:t>Play takes a volume, a pitch and a pan</a:t>
+            </a:r>
+            <a:endParaRPr/>
+          </a:p>
+          <a:p>
+            <a:pPr indent="-330200" lvl="0" marL="457200" rtl="0" algn="l">
+              <a:spcBef>
+                <a:spcPts val="0"/>
+              </a:spcBef>
+              <a:spcAft>
+                <a:spcPts val="0"/>
+              </a:spcAft>
+              <a:buSzPts val="1600"/>
+              <a:buChar char="●"/>
+            </a:pPr>
+            <a:r>
+              <a:rPr lang="en"/>
+              <a:t>Raise the paddle sound’s pitch as the ball speeds up</a:t>
             </a:r>
             <a:endParaRPr/>
           </a:p>

</xml_diff>

<commit_message>
Main topics are the problem each session solves; patterns get their own column
- Schedule and course plan: Main topic, Patterns, Also
- Mario's main topic is the game world (tiles, entities, a camera), not physics
- Every page intro states its main topic the same way; every deck's Today's Topics opens with it

Co-Authored-By: Claude Opus 5.5 <noreply@anthropic.com>
Claude-Session: https://claude.ai/code/session_012sjsUQBbC7zon57rWHoo9d
</commit_message>
<xml_diff>
--- a/slides/01 Pong.pptx
+++ b/slides/01 Pong.pptx
@@ -18375,7 +18375,7 @@
         <p:spPr>
           <a:xfrm>
             <a:off x="311700" y="885950"/>
-            <a:ext cx="8520600" cy="4023300"/>
+            <a:ext cx="8520600" cy="3977640"/>
           </a:xfrm>
           <a:prstGeom prst="rect">
             <a:avLst/>
@@ -18386,6 +18386,23 @@
             <a:normAutofit/>
           </a:bodyPr>
           <a:lstStyle/>
+          <a:p>
+            <a:pPr indent="-330200" lvl="0" marL="457200" rtl="0" algn="l">
+              <a:spcBef>
+                <a:spcPts val="0"/>
+              </a:spcBef>
+              <a:spcAft>
+                <a:spcPts val="0"/>
+              </a:spcAft>
+              <a:buSzPts val="1600"/>
+              <a:buChar char="●"/>
+            </a:pPr>
+            <a:r>
+              <a:rPr lang="en" b="1"/>
+              <a:t>Main topic: The game loop</a:t>
+            </a:r>
+            <a:endParaRPr/>
+          </a:p>
           <a:p>
             <a:pPr indent="-330200" lvl="0" marL="457200" rtl="0" algn="l">
               <a:spcBef>

</xml_diff>

<commit_message>
Drop the "X, not Y" contrasts from the pages, slides and notes
Co-Authored-By: Claude Opus 5.5 <noreply@anthropic.com>
Claude-Session: https://claude.ai/code/session_012sjsUQBbC7zon57rWHoo9d
</commit_message>
<xml_diff>
--- a/slides/01 Pong.pptx
+++ b/slides/01 Pong.pptx
@@ -3241,7 +3241,7 @@
           </a:p>
           <a:p>
             <a:r>
-              <a:t>Ask the question. Answer: the player controls the angle, so hitting becomes a skill, not luck.</a:t>
+              <a:t>Ask the question. Answer: the player controls the angle, so hitting becomes a skill.</a:t>
             </a:r>
           </a:p>
           <a:p>
@@ -3984,7 +3984,7 @@
           </a:p>
           <a:p>
             <a:r>
-              <a:t>Ask the question on the slide. Answer: the ball moves when frames are drawn, not when the game updates: faster on a fast screen, and wrong when Draw is skipped.</a:t>
+              <a:t>Ask the question on the slide. Answer: the ball would move once per drawn frame, so it goes faster on a fast screen, and stops when Draw is skipped.</a:t>
             </a:r>
           </a:p>
           <a:p>
@@ -4332,7 +4332,7 @@
           </a:p>
           <a:p>
             <a:r>
-              <a:t>Today we build the parts that matter for the architecture, not the whole game.</a:t>
+              <a:t>Today we build the parts that matter for the architecture.</a:t>
             </a:r>
           </a:p>
         </p:txBody>

</xml_diff>

<commit_message>
Slides: light wording pass (no "exactly", fewer colon-joined sentences)
Co-Authored-By: Claude Opus 5.5 <noreply@anthropic.com>
Claude-Session: https://claude.ai/code/session_012sjsUQBbC7zon57rWHoo9d
</commit_message>
<xml_diff>
--- a/slides/01 Pong.pptx
+++ b/slides/01 Pong.pptx
@@ -1193,7 +1193,7 @@
           </a:p>
           <a:p>
             <a:r>
-              <a:t>Answer: we do. That is the course: we write the loop, the scenes and the entities ourselves, and learn how engines do it.</a:t>
+              <a:t>Answer: we do. In this course we write the loop, the scenes and the entities ourselves, and learn how engines do it.</a:t>
             </a:r>
           </a:p>
         </p:txBody>
@@ -3043,7 +3043,7 @@
           <a:lstStyle/>
           <a:p>
             <a:r>
-              <a:t>Exercise: refactor into Paddle and Ball. The game must behave exactly as before; that’s the point of a refactor.</a:t>
+              <a:t>Exercise: refactor into Paddle and Ball. The game must behave as it did before, since a refactor changes only the structure.</a:t>
             </a:r>
           </a:p>
           <a:p>
@@ -3304,7 +3304,7 @@
           <a:lstStyle/>
           <a:p>
             <a:r>
-              <a:t>Pairs, about 6 minutes. _winningScore in Game1. The pause needs a new if in Update (skip the play logic) and in Draw (show Paused), and a key check: every mode touches every method. That is the problem Flappy Bird solves with a state machine.</a:t>
+              <a:t>Pairs, about 6 minutes. _winningScore in Game1. The pause needs a new if in Update (skip the play logic) and in Draw (show Paused), and a key check. Every mode touches every method, and Flappy Bird fixes this with a state machine.</a:t>
             </a:r>
           </a:p>
         </p:txBody>
@@ -14897,7 +14897,7 @@
             </a:pPr>
             <a:r>
               <a:rPr lang="en"/>
-              <a:t>The game must behave exactly as before.</a:t>
+              <a:t>The game must behave as it did before.</a:t>
             </a:r>
             <a:endParaRPr/>
           </a:p>
@@ -18994,7 +18994,7 @@
             </a:pPr>
             <a:r>
               <a:rPr lang="en"/>
-              <a:t>A framework: libraries for the basics, without an editor, scenes or entities.</a:t>
+              <a:t>A framework gives you libraries for the basics, without an editor, scenes or entities.</a:t>
             </a:r>
             <a:endParaRPr/>
           </a:p>
@@ -19354,7 +19354,7 @@
                   <a:srgbClr val="DEE2E6"/>
                 </a:solidFill>
               </a:rPr>
-              <a:t>So who writes the game loop, the scenes and the entities?</a:t>
+              <a:t>Who writes the game loop, the scenes and the entities?</a:t>
             </a:r>
           </a:p>
         </p:txBody>

</xml_diff>

<commit_message>
New recordings of all twelve games, played by bots
Every game now has a bot that plays it sensibly for the recording: rallies and a
point in Pong, a flight through six pipes, three solved Sokoban levels, a Pac-Man
that eats dots and avoids ghosts, a Mario run with boxes and stomps, a Zelda room
fought, switched and left, three aimed shots in Angry Birds, a defended lawn, a
walk into the grass and a battle in Pokemon, and the two swarms survived.

The session pages' animations, the home page's stills and the decks' Today's
Goal slides use the new recordings. Flappy Bird's page names the wider gap.

Co-Authored-By: Claude Opus 5.5 <noreply@anthropic.com>
Claude-Session: https://claude.ai/code/session_012sjsUQBbC7zon57rWHoo9d
</commit_message>
<xml_diff>
--- a/slides/01 Pong.pptx
+++ b/slides/01 Pong.pptx
@@ -14970,22 +14970,22 @@
       </p:sp>
       <p:pic>
         <p:nvPicPr>
-          <p:cNvPr id="107" name="Picture 107" descr="gif-pong.gif"/>
+          <p:cNvPr id="107" name="Picture 107" descr="pong.gif"/>
           <p:cNvPicPr>
             <a:picLocks noChangeAspect="1"/>
           </p:cNvPicPr>
           <p:nvPr/>
         </p:nvPicPr>
         <p:blipFill>
-          <a:blip r:embed="rId3"/>
+          <a:blip r:embed="rId4"/>
           <a:stretch>
             <a:fillRect/>
           </a:stretch>
         </p:blipFill>
         <p:spPr>
           <a:xfrm>
-            <a:off x="1540933" y="1281973"/>
-            <a:ext cx="6062133" cy="3409949"/>
+            <a:off x="1540934" y="1281973"/>
+            <a:ext cx="6062131" cy="3409949"/>
           </a:xfrm>
           <a:prstGeom prst="rect">
             <a:avLst/>

</xml_diff>

<commit_message>
A consistency pass: decks follow their pages, exercise art matches the sheets, plainer wording
Co-Authored-By: Claude Opus 5.5 <noreply@anthropic.com>
Claude-Session: https://claude.ai/code/session_012sjsUQBbC7zon57rWHoo9d
</commit_message>
<xml_diff>
--- a/slides/01 Pong.pptx
+++ b/slides/01 Pong.pptx
@@ -18501,7 +18501,7 @@
             </a:pPr>
             <a:r>
               <a:rPr lang="en"/>
-              <a:t>Game State</a:t>
+              <a:t>Encapsulation &amp; the Update Method Pattern</a:t>
             </a:r>
             <a:endParaRPr/>
           </a:p>
@@ -18518,7 +18518,7 @@
             </a:pPr>
             <a:r>
               <a:rPr lang="en"/>
-              <a:t>Encapsulation &amp; the Update Method Pattern</a:t>
+              <a:t>Collision Detection</a:t>
             </a:r>
             <a:endParaRPr/>
           </a:p>
@@ -18535,7 +18535,7 @@
             </a:pPr>
             <a:r>
               <a:rPr lang="en"/>
-              <a:t>Collision Detection</a:t>
+              <a:t>Game State</a:t>
             </a:r>
             <a:endParaRPr/>
           </a:p>

</xml_diff>

<commit_message>
Decks: a read-through fixes a stale demo reference, leftover wording in Mario, and Pokemon's closing list
Co-Authored-By: Claude Opus 5.5 <noreply@anthropic.com>
Claude-Session: https://claude.ai/code/session_012sjsUQBbC7zon57rWHoo9d
</commit_message>
<xml_diff>
--- a/slides/01 Pong.pptx
+++ b/slides/01 Pong.pptx
@@ -4052,7 +4052,7 @@
           </a:p>
           <a:p>
             <a:r>
-              <a:t>Open the game-loop demo on the course site and try both at a low frame rate. Snake uses a fixed step on purpose.</a:t>
+              <a:t>Snake uses a fixed step on purpose.</a:t>
             </a:r>
           </a:p>
         </p:txBody>
@@ -9006,17 +9006,6 @@
               <a:t>MonoGame is fixed by default: IsFixedTimeStep = true.</a:t>
             </a:r>
           </a:p>
-          <a:p>
-            <a:pPr algn="ctr"/>
-            <a:r>
-              <a:rPr sz="1400" b="0" i="0">
-                <a:solidFill>
-                  <a:srgbClr val="9AA3AB"/>
-                </a:solidFill>
-              </a:rPr>
-              <a:t>Try both in the game-loop demo on the course site.</a:t>
-            </a:r>
-          </a:p>
         </p:txBody>
       </p:sp>
     </p:spTree>
@@ -12483,7 +12472,7 @@
             </a:pPr>
             <a:r>
               <a:rPr lang="en"/>
-              <a:t>Why do we care about deltatime?</a:t>
+              <a:t>Why multiply movement by delta time?</a:t>
             </a:r>
             <a:endParaRPr/>
           </a:p>
@@ -12938,7 +12927,7 @@
             </a:pPr>
             <a:r>
               <a:rPr lang="en"/>
-              <a:t>How to emulate “GetKeyDown”?</a:t>
+              <a:t>How do we tell that a key was just pressed?</a:t>
             </a:r>
             <a:endParaRPr/>
           </a:p>

</xml_diff>

<commit_message>
Pong and Flappy Bird: screen scaling, gravity and input become demos; Mario's power-up slide shows our own art
Pong's virtual resolution step and Flappy's gravity and input manager steps are
shown as demos with a try-it, and the build exercises copy them in. The Mario
power-up slide drops the Nintendo artwork for extras.png and absorbs the Extra
Assets slide.

Co-Authored-By: Claude Opus 5.5 <noreply@anthropic.com>
Claude-Session: https://claude.ai/code/session_012sjsUQBbC7zon57rWHoo9d
</commit_message>
<xml_diff>
--- a/slides/01 Pong.pptx
+++ b/slides/01 Pong.pptx
@@ -25,6 +25,7 @@
     <p:sldId id="277" r:id="rId27"/>
     <p:sldId id="278" r:id="rId28"/>
     <p:sldId id="279" r:id="rId29"/>
+    <p:sldId id="310" r:id="rId46"/>
     <p:sldId id="280" r:id="rId30"/>
     <p:sldId id="281" r:id="rId31"/>
     <p:sldId id="282" r:id="rId32"/>
@@ -835,6 +836,69 @@
 </p:notes>
 </file>
 
+<file path=ppt/notesSlides/notesSlide11.xml><?xml version="1.0" encoding="utf-8"?>
+<p:notes xmlns:a="http://schemas.openxmlformats.org/drawingml/2006/main" xmlns:p="http://schemas.openxmlformats.org/presentationml/2006/main" xmlns:r="http://schemas.openxmlformats.org/officeDocument/2006/relationships">
+  <p:cSld>
+    <p:spTree>
+      <p:nvGrpSpPr>
+        <p:cNvPr id="1" name=""/>
+        <p:cNvGrpSpPr/>
+        <p:nvPr/>
+      </p:nvGrpSpPr>
+      <p:grpSpPr>
+        <a:xfrm>
+          <a:off x="0" y="0"/>
+          <a:ext cx="0" cy="0"/>
+          <a:chOff x="0" y="0"/>
+          <a:chExt cx="0" cy="0"/>
+        </a:xfrm>
+      </p:grpSpPr>
+      <p:sp>
+        <p:nvSpPr>
+          <p:cNvPr id="2" name="Slide Image Placeholder 1"/>
+          <p:cNvSpPr>
+            <a:spLocks noGrp="1"/>
+          </p:cNvSpPr>
+          <p:nvPr>
+            <p:ph type="sldImg" idx="2"/>
+          </p:nvPr>
+        </p:nvSpPr>
+        <p:spPr/>
+      </p:sp>
+      <p:sp>
+        <p:nvSpPr>
+          <p:cNvPr id="3" name="Notes Placeholder 2"/>
+          <p:cNvSpPr>
+            <a:spLocks noGrp="1"/>
+          </p:cNvSpPr>
+          <p:nvPr>
+            <p:ph type="body" idx="1"/>
+          </p:nvPr>
+        </p:nvSpPr>
+        <p:spPr/>
+        <p:txBody>
+          <a:bodyPr/>
+          <a:lstStyle/>
+          <a:p>
+            <a:r>
+              <a:t>Pairs, about 5 minutes. Bars at the sides when the window is wide, above and below when it is tall.</a:t>
+            </a:r>
+          </a:p>
+          <a:p>
+            <a:r>
+              <a:t>LinearClamp blurs the text. At 640 × 360 the text is half as big on screen: the scale is now 2.</a:t>
+            </a:r>
+          </a:p>
+        </p:txBody>
+      </p:sp>
+    </p:spTree>
+  </p:cSld>
+  <p:clrMapOvr>
+    <a:masterClrMapping/>
+  </p:clrMapOvr>
+</p:notes>
+</file>
+
 <file path=ppt/notesSlides/notesSlide12.xml><?xml version="1.0" encoding="utf-8"?>
 <p:notes xmlns:a="http://schemas.openxmlformats.org/drawingml/2006/main" xmlns:r="http://schemas.openxmlformats.org/officeDocument/2006/relationships" xmlns:mc="http://schemas.openxmlformats.org/markup-compatibility/2006" xmlns:mv="urn:schemas-microsoft-com:mac:vml" xmlns:p="http://schemas.openxmlformats.org/presentationml/2006/main" xmlns:c="http://schemas.openxmlformats.org/drawingml/2006/chart" xmlns:dgm="http://schemas.openxmlformats.org/drawingml/2006/diagram" xmlns:o="urn:schemas-microsoft-com:office:office" xmlns:v="urn:schemas-microsoft-com:vml" xmlns:pvml="urn:schemas-microsoft-com:office:powerpoint" xmlns:com="http://schemas.openxmlformats.org/drawingml/2006/compatibility" xmlns:p14="http://schemas.microsoft.com/office/powerpoint/2010/main" xmlns:p15="http://schemas.microsoft.com/office/powerpoint/2012/main" xmlns:ahyp="http://schemas.microsoft.com/office/drawing/2018/hyperlinkcolor" showMasterPhAnim="0" showMasterSp="0">
   <p:cSld>
@@ -2029,12 +2093,27 @@
           <a:lstStyle/>
           <a:p>
             <a:r>
-              <a:t>Exercise: draw at a fixed small resolution and scale it to the window. The window can resize; the game doesn’t notice.</a:t>
-            </a:r>
-          </a:p>
-          <a:p>
-            <a:r>
-              <a:t>Full instructions are on the course site; students work from there. Walk round while they work.</a:t>
+              <a:t>Demo: open Pong1 and Pong2 side by side, then run Pong2 and resize the window.</a:t>
+            </a:r>
+          </a:p>
+          <a:p>
+            <a:r>
+              <a:t>- the transform matrix passed to Begin</a:t>
+            </a:r>
+          </a:p>
+          <a:p>
+            <a:r>
+              <a:t>- the scale is the smaller of the two ratios, so nothing stretches</a:t>
+            </a:r>
+          </a:p>
+          <a:p>
+            <a:r>
+              <a:t>- the viewport centres the picture; black bars fill the rest</a:t>
+            </a:r>
+          </a:p>
+          <a:p>
+            <a:r>
+              <a:t>The game code only ever sees 320 × 180. The next exercise starts from Pong2.</a:t>
             </a:r>
           </a:p>
         </p:txBody>
@@ -10013,7 +10092,7 @@
                   <a:schemeClr val="accent5"/>
                 </a:solidFill>
               </a:rPr>
-              <a:t>Pong 2: Virtual Resolution</a:t>
+              <a:t>Virtual Resolution Implementation</a:t>
             </a:r>
             <a:endParaRPr>
               <a:solidFill>
@@ -10058,7 +10137,7 @@
             </a:pPr>
             <a:r>
               <a:rPr lang="en"/>
-              <a:t>Goal: draw at a small fixed resolution, scaled to a resizable window.</a:t>
+              <a:t>Demo: Pong1 → Pong2: drawn at 320 × 180, scaled to a resizable window</a:t>
             </a:r>
             <a:endParaRPr/>
           </a:p>
@@ -10075,7 +10154,7 @@
             </a:pPr>
             <a:r>
               <a:rPr lang="en"/>
-              <a:t>Use point filtering, so the pixels stay sharp.</a:t>
+              <a:t>Point filtering keeps the pixels sharp; black bars keep the shape.</a:t>
             </a:r>
             <a:endParaRPr/>
           </a:p>
@@ -18830,6 +18909,145 @@
           </a:ln>
         </p:spPr>
       </p:pic>
+    </p:spTree>
+  </p:cSld>
+  <p:clrMapOvr>
+    <a:masterClrMapping/>
+  </p:clrMapOvr>
+</p:sld>
+</file>
+
+<file path=ppt/slides/slide42.xml><?xml version="1.0" encoding="utf-8"?>
+<p:sld xmlns:a="http://schemas.openxmlformats.org/drawingml/2006/main" xmlns:p="http://schemas.openxmlformats.org/presentationml/2006/main" xmlns:r="http://schemas.openxmlformats.org/officeDocument/2006/relationships">
+  <p:cSld>
+    <p:spTree>
+      <p:nvGrpSpPr>
+        <p:cNvPr id="1" name=""/>
+        <p:cNvGrpSpPr/>
+        <p:nvPr/>
+      </p:nvGrpSpPr>
+      <p:grpSpPr/>
+      <p:sp>
+        <p:nvSpPr>
+          <p:cNvPr id="2" name="Title 1"/>
+          <p:cNvSpPr>
+            <a:spLocks noGrp="1"/>
+          </p:cNvSpPr>
+          <p:nvPr>
+            <p:ph type="title"/>
+          </p:nvPr>
+        </p:nvSpPr>
+        <p:spPr/>
+        <p:txBody>
+          <a:bodyPr/>
+          <a:lstStyle/>
+          <a:p>
+            <a:pPr indent="0" lvl="0" marL="0" rtl="0" algn="l">
+              <a:spcBef>
+                <a:spcPts val="0"/>
+              </a:spcBef>
+              <a:spcAft>
+                <a:spcPts val="0"/>
+              </a:spcAft>
+              <a:buNone/>
+            </a:pPr>
+            <a:r>
+              <a:rPr lang="en"/>
+              <a:t>Try It: Resize the Window</a:t>
+            </a:r>
+            <a:endParaRPr/>
+          </a:p>
+        </p:txBody>
+      </p:sp>
+      <p:sp>
+        <p:nvSpPr>
+          <p:cNvPr id="3" name="Text Placeholder 2"/>
+          <p:cNvSpPr>
+            <a:spLocks noGrp="1"/>
+          </p:cNvSpPr>
+          <p:nvPr>
+            <p:ph type="body" idx="1"/>
+          </p:nvPr>
+        </p:nvSpPr>
+        <p:spPr>
+          <a:xfrm>
+            <a:off x="311700" y="885950"/>
+            <a:ext cx="8520600" cy="1673352"/>
+          </a:xfrm>
+        </p:spPr>
+        <p:txBody>
+          <a:bodyPr/>
+          <a:lstStyle/>
+          <a:p>
+            <a:pPr indent="-330200" lvl="0" marL="457200" rtl="0" algn="l">
+              <a:spcBef>
+                <a:spcPts val="0"/>
+              </a:spcBef>
+              <a:spcAft>
+                <a:spcPts val="0"/>
+              </a:spcAft>
+              <a:buSzPts val="1600"/>
+              <a:buChar char="●"/>
+            </a:pPr>
+            <a:r>
+              <a:rPr lang="en" b="1"/>
+              <a:t>In Pong2:</a:t>
+            </a:r>
+            <a:endParaRPr/>
+          </a:p>
+          <a:p>
+            <a:pPr indent="-330200" lvl="0" marL="457200" rtl="0" algn="l">
+              <a:spcBef>
+                <a:spcPts val="0"/>
+              </a:spcBef>
+              <a:spcAft>
+                <a:spcPts val="0"/>
+              </a:spcAft>
+              <a:buSzPts val="1600"/>
+              <a:buChar char="●"/>
+            </a:pPr>
+            <a:r>
+              <a:rPr lang="en" b="1"/>
+              <a:t>Drag the window wide, then tall. Where do the bars go?</a:t>
+            </a:r>
+            <a:endParaRPr/>
+          </a:p>
+          <a:p>
+            <a:pPr indent="-330200" lvl="0" marL="457200" rtl="0" algn="l">
+              <a:spcBef>
+                <a:spcPts val="0"/>
+              </a:spcBef>
+              <a:spcAft>
+                <a:spcPts val="0"/>
+              </a:spcAft>
+              <a:buSzPts val="1600"/>
+              <a:buChar char="●"/>
+            </a:pPr>
+            <a:r>
+              <a:rPr lang="en" b="1"/>
+              <a:t>Swap PointClamp for LinearClamp</a:t>
+            </a:r>
+            <a:endParaRPr/>
+          </a:p>
+          <a:p>
+            <a:pPr indent="-330200" lvl="0" marL="457200" rtl="0" algn="l">
+              <a:spcBef>
+                <a:spcPts val="0"/>
+              </a:spcBef>
+              <a:spcAft>
+                <a:spcPts val="0"/>
+              </a:spcAft>
+              <a:buSzPts val="1600"/>
+              <a:buChar char="●"/>
+            </a:pPr>
+            <a:r>
+              <a:rPr lang="en" b="1"/>
+              <a:t>Set the virtual size to 640 × 360. What happens to the text?</a:t>
+            </a:r>
+            <a:endParaRPr/>
+          </a:p>
+        </p:txBody>
+      </p:sp>
     </p:spTree>
   </p:cSld>
   <p:clrMapOvr>

</xml_diff>

<commit_message>
Pong: what a student working alone was missing
Drawing text with Begin and End, setting the window's size, how the ball bounces
off a paddle, and the sizes for the first rectangles. The bounce slide's number
now matches Pong7.

Co-Authored-By: Claude Opus 5.5 <noreply@anthropic.com>
Claude-Session: https://claude.ai/code/session_012sjsUQBbC7zon57rWHoo9d
</commit_message>
<xml_diff>
--- a/slides/01 Pong.pptx
+++ b/slides/01 Pong.pptx
@@ -10193,6 +10193,145 @@
 </file>
 
 <file path=ppt/slides/slide18.xml><?xml version="1.0" encoding="utf-8"?>
+<p:sld xmlns:a="http://schemas.openxmlformats.org/drawingml/2006/main" xmlns:p="http://schemas.openxmlformats.org/presentationml/2006/main" xmlns:r="http://schemas.openxmlformats.org/officeDocument/2006/relationships">
+  <p:cSld>
+    <p:spTree>
+      <p:nvGrpSpPr>
+        <p:cNvPr id="1" name=""/>
+        <p:cNvGrpSpPr/>
+        <p:nvPr/>
+      </p:nvGrpSpPr>
+      <p:grpSpPr/>
+      <p:sp>
+        <p:nvSpPr>
+          <p:cNvPr id="2" name="Title 1"/>
+          <p:cNvSpPr>
+            <a:spLocks noGrp="1"/>
+          </p:cNvSpPr>
+          <p:nvPr>
+            <p:ph type="title"/>
+          </p:nvPr>
+        </p:nvSpPr>
+        <p:spPr/>
+        <p:txBody>
+          <a:bodyPr/>
+          <a:lstStyle/>
+          <a:p>
+            <a:pPr indent="0" lvl="0" marL="0" rtl="0" algn="l">
+              <a:spcBef>
+                <a:spcPts val="0"/>
+              </a:spcBef>
+              <a:spcAft>
+                <a:spcPts val="0"/>
+              </a:spcAft>
+              <a:buNone/>
+            </a:pPr>
+            <a:r>
+              <a:rPr lang="en"/>
+              <a:t>Try It: Resize the Window</a:t>
+            </a:r>
+            <a:endParaRPr/>
+          </a:p>
+        </p:txBody>
+      </p:sp>
+      <p:sp>
+        <p:nvSpPr>
+          <p:cNvPr id="3" name="Text Placeholder 2"/>
+          <p:cNvSpPr>
+            <a:spLocks noGrp="1"/>
+          </p:cNvSpPr>
+          <p:nvPr>
+            <p:ph type="body" idx="1"/>
+          </p:nvPr>
+        </p:nvSpPr>
+        <p:spPr>
+          <a:xfrm>
+            <a:off x="311700" y="885950"/>
+            <a:ext cx="8520600" cy="1673352"/>
+          </a:xfrm>
+        </p:spPr>
+        <p:txBody>
+          <a:bodyPr/>
+          <a:lstStyle/>
+          <a:p>
+            <a:pPr indent="-330200" lvl="0" marL="457200" rtl="0" algn="l">
+              <a:spcBef>
+                <a:spcPts val="0"/>
+              </a:spcBef>
+              <a:spcAft>
+                <a:spcPts val="0"/>
+              </a:spcAft>
+              <a:buSzPts val="1600"/>
+              <a:buChar char="●"/>
+            </a:pPr>
+            <a:r>
+              <a:rPr lang="en" b="1"/>
+              <a:t>In Pong2:</a:t>
+            </a:r>
+            <a:endParaRPr/>
+          </a:p>
+          <a:p>
+            <a:pPr indent="-330200" lvl="0" marL="457200" rtl="0" algn="l">
+              <a:spcBef>
+                <a:spcPts val="0"/>
+              </a:spcBef>
+              <a:spcAft>
+                <a:spcPts val="0"/>
+              </a:spcAft>
+              <a:buSzPts val="1600"/>
+              <a:buChar char="●"/>
+            </a:pPr>
+            <a:r>
+              <a:rPr lang="en" b="1"/>
+              <a:t>Drag the window wide, then tall. Where do the bars go?</a:t>
+            </a:r>
+            <a:endParaRPr/>
+          </a:p>
+          <a:p>
+            <a:pPr indent="-330200" lvl="0" marL="457200" rtl="0" algn="l">
+              <a:spcBef>
+                <a:spcPts val="0"/>
+              </a:spcBef>
+              <a:spcAft>
+                <a:spcPts val="0"/>
+              </a:spcAft>
+              <a:buSzPts val="1600"/>
+              <a:buChar char="●"/>
+            </a:pPr>
+            <a:r>
+              <a:rPr lang="en" b="1"/>
+              <a:t>Swap PointClamp for LinearClamp</a:t>
+            </a:r>
+            <a:endParaRPr/>
+          </a:p>
+          <a:p>
+            <a:pPr indent="-330200" lvl="0" marL="457200" rtl="0" algn="l">
+              <a:spcBef>
+                <a:spcPts val="0"/>
+              </a:spcBef>
+              <a:spcAft>
+                <a:spcPts val="0"/>
+              </a:spcAft>
+              <a:buSzPts val="1600"/>
+              <a:buChar char="●"/>
+            </a:pPr>
+            <a:r>
+              <a:rPr lang="en" b="1"/>
+              <a:t>Set the virtual size to 640 × 360. What happens to the text?</a:t>
+            </a:r>
+            <a:endParaRPr/>
+          </a:p>
+        </p:txBody>
+      </p:sp>
+    </p:spTree>
+  </p:cSld>
+  <p:clrMapOvr>
+    <a:masterClrMapping/>
+  </p:clrMapOvr>
+</p:sld>
+</file>
+
+<file path=ppt/slides/slide19.xml><?xml version="1.0" encoding="utf-8"?>
 <p:sld xmlns:a="http://schemas.openxmlformats.org/drawingml/2006/main" xmlns:r="http://schemas.openxmlformats.org/officeDocument/2006/relationships" xmlns:mc="http://schemas.openxmlformats.org/markup-compatibility/2006" xmlns:mv="urn:schemas-microsoft-com:mac:vml" xmlns:p="http://schemas.openxmlformats.org/presentationml/2006/main" xmlns:c="http://schemas.openxmlformats.org/drawingml/2006/chart" xmlns:dgm="http://schemas.openxmlformats.org/drawingml/2006/diagram" xmlns:o="urn:schemas-microsoft-com:office:office" xmlns:v="urn:schemas-microsoft-com:vml" xmlns:pvml="urn:schemas-microsoft-com:office:powerpoint" xmlns:com="http://schemas.openxmlformats.org/drawingml/2006/compatibility" xmlns:p14="http://schemas.microsoft.com/office/powerpoint/2010/main" xmlns:p15="http://schemas.microsoft.com/office/powerpoint/2012/main" xmlns:ahyp="http://schemas.microsoft.com/office/drawing/2018/hyperlinkcolor">
   <p:cSld>
     <p:spTree>
@@ -10317,693 +10456,6 @@
           </a:ln>
         </p:spPr>
       </p:pic>
-    </p:spTree>
-  </p:cSld>
-  <p:clrMapOvr>
-    <a:masterClrMapping/>
-  </p:clrMapOvr>
-</p:sld>
-</file>
-
-<file path=ppt/slides/slide19.xml><?xml version="1.0" encoding="utf-8"?>
-<p:sld xmlns:a="http://schemas.openxmlformats.org/drawingml/2006/main" xmlns:r="http://schemas.openxmlformats.org/officeDocument/2006/relationships" xmlns:mc="http://schemas.openxmlformats.org/markup-compatibility/2006" xmlns:mv="urn:schemas-microsoft-com:mac:vml" xmlns:p="http://schemas.openxmlformats.org/presentationml/2006/main" xmlns:c="http://schemas.openxmlformats.org/drawingml/2006/chart" xmlns:dgm="http://schemas.openxmlformats.org/drawingml/2006/diagram" xmlns:o="urn:schemas-microsoft-com:office:office" xmlns:v="urn:schemas-microsoft-com:vml" xmlns:pvml="urn:schemas-microsoft-com:office:powerpoint" xmlns:com="http://schemas.openxmlformats.org/drawingml/2006/compatibility" xmlns:p14="http://schemas.microsoft.com/office/powerpoint/2010/main" xmlns:p15="http://schemas.microsoft.com/office/powerpoint/2012/main" xmlns:ahyp="http://schemas.microsoft.com/office/drawing/2018/hyperlinkcolor">
-  <p:cSld>
-    <p:spTree>
-      <p:nvGrpSpPr>
-        <p:cNvPr id="192" name="Shape 192"/>
-        <p:cNvGrpSpPr/>
-        <p:nvPr/>
-      </p:nvGrpSpPr>
-      <p:grpSpPr>
-        <a:xfrm>
-          <a:off x="0" y="0"/>
-          <a:ext cx="0" cy="0"/>
-          <a:chOff x="0" y="0"/>
-          <a:chExt cx="0" cy="0"/>
-        </a:xfrm>
-      </p:grpSpPr>
-      <p:sp>
-        <p:nvSpPr>
-          <p:cNvPr id="193" name="Google Shape;193;p34"/>
-          <p:cNvSpPr txBox="1"/>
-          <p:nvPr>
-            <p:ph type="title"/>
-          </p:nvPr>
-        </p:nvSpPr>
-        <p:spPr>
-          <a:xfrm>
-            <a:off x="311700" y="195615"/>
-            <a:ext cx="8520600" cy="572700"/>
-          </a:xfrm>
-          <a:prstGeom prst="rect">
-            <a:avLst/>
-          </a:prstGeom>
-        </p:spPr>
-        <p:txBody>
-          <a:bodyPr anchorCtr="0" anchor="t" bIns="91425" lIns="91425" spcFirstLastPara="1" rIns="91425" wrap="square" tIns="91425">
-            <a:normAutofit fontScale="90000"/>
-          </a:bodyPr>
-          <a:lstStyle/>
-          <a:p>
-            <a:pPr indent="0" lvl="0" marL="0" rtl="0" algn="l">
-              <a:spcBef>
-                <a:spcPts val="0"/>
-              </a:spcBef>
-              <a:spcAft>
-                <a:spcPts val="0"/>
-              </a:spcAft>
-              <a:buNone/>
-            </a:pPr>
-            <a:r>
-              <a:rPr lang="en"/>
-              <a:t>Drawing to The Screen</a:t>
-            </a:r>
-            <a:endParaRPr/>
-          </a:p>
-        </p:txBody>
-      </p:sp>
-      <p:sp>
-        <p:nvSpPr>
-          <p:cNvPr id="194" name="Google Shape;194;p34"/>
-          <p:cNvSpPr txBox="1"/>
-          <p:nvPr>
-            <p:ph idx="1" type="body"/>
-          </p:nvPr>
-        </p:nvSpPr>
-        <p:spPr>
-          <a:xfrm>
-            <a:off x="311700" y="885950"/>
-            <a:ext cx="8520600" cy="4023300"/>
-          </a:xfrm>
-          <a:prstGeom prst="rect">
-            <a:avLst/>
-          </a:prstGeom>
-        </p:spPr>
-        <p:txBody>
-          <a:bodyPr anchorCtr="0" anchor="t" bIns="91425" lIns="91425" spcFirstLastPara="1" rIns="91425" wrap="square" tIns="91425">
-            <a:normAutofit/>
-          </a:bodyPr>
-          <a:lstStyle/>
-          <a:p>
-            <a:pPr indent="-330200" lvl="0" marL="457200" rtl="0" algn="l">
-              <a:spcBef>
-                <a:spcPts val="0"/>
-              </a:spcBef>
-              <a:spcAft>
-                <a:spcPts val="0"/>
-              </a:spcAft>
-              <a:buSzPts val="1600"/>
-              <a:buChar char="●"/>
-            </a:pPr>
-            <a:r>
-              <a:rPr lang="en"/>
-              <a:t>Normally a texture is needed to draw to the screen</a:t>
-            </a:r>
-            <a:endParaRPr/>
-          </a:p>
-          <a:p>
-            <a:pPr indent="-330200" lvl="0" marL="457200" rtl="0" algn="l">
-              <a:spcBef>
-                <a:spcPts val="0"/>
-              </a:spcBef>
-              <a:spcAft>
-                <a:spcPts val="0"/>
-              </a:spcAft>
-              <a:buSzPts val="1600"/>
-              <a:buChar char="●"/>
-            </a:pPr>
-            <a:r>
-              <a:rPr lang="en"/>
-              <a:t>A Pong game doesn’t need explicit texture assets, but we do need to draw rectangles</a:t>
-            </a:r>
-            <a:endParaRPr/>
-          </a:p>
-          <a:p>
-            <a:pPr indent="0" lvl="0" marL="0" rtl="0" algn="l">
-              <a:spcBef>
-                <a:spcPts val="1200"/>
-              </a:spcBef>
-              <a:spcAft>
-                <a:spcPts val="0"/>
-              </a:spcAft>
-              <a:buNone/>
-            </a:pPr>
-            <a:r>
-              <a:rPr/>
-              <a:t/>
-            </a:r>
-            <a:endParaRPr/>
-          </a:p>
-          <a:p>
-            <a:pPr indent="0" lvl="0" marL="457200" rtl="0" algn="l">
-              <a:lnSpc>
-                <a:spcPct val="157500"/>
-              </a:lnSpc>
-              <a:spcBef>
-                <a:spcPts val="1200"/>
-              </a:spcBef>
-              <a:spcAft>
-                <a:spcPts val="0"/>
-              </a:spcAft>
-              <a:buNone/>
-            </a:pPr>
-            <a:r>
-              <a:rPr lang="en" sz="1000">
-                <a:solidFill>
-                  <a:srgbClr val="569CD6"/>
-                </a:solidFill>
-                <a:highlight>
-                  <a:srgbClr val="1F1F1F"/>
-                </a:highlight>
-                <a:latin typeface="Consolas"/>
-                <a:ea typeface="Consolas"/>
-                <a:cs typeface="Consolas"/>
-                <a:sym typeface="Consolas"/>
-              </a:rPr>
-              <a:t>private</a:t>
-            </a:r>
-            <a:r>
-              <a:rPr lang="en" sz="1000">
-                <a:solidFill>
-                  <a:srgbClr val="CCCCCC"/>
-                </a:solidFill>
-                <a:highlight>
-                  <a:srgbClr val="1F1F1F"/>
-                </a:highlight>
-                <a:latin typeface="Consolas"/>
-                <a:ea typeface="Consolas"/>
-                <a:cs typeface="Consolas"/>
-                <a:sym typeface="Consolas"/>
-              </a:rPr>
-              <a:t> </a:t>
-            </a:r>
-            <a:r>
-              <a:rPr lang="en" sz="1000">
-                <a:solidFill>
-                  <a:srgbClr val="4EC9B0"/>
-                </a:solidFill>
-                <a:highlight>
-                  <a:srgbClr val="1F1F1F"/>
-                </a:highlight>
-                <a:latin typeface="Consolas"/>
-                <a:ea typeface="Consolas"/>
-                <a:cs typeface="Consolas"/>
-                <a:sym typeface="Consolas"/>
-              </a:rPr>
-              <a:t>Texture2D</a:t>
-            </a:r>
-            <a:r>
-              <a:rPr lang="en" sz="1000">
-                <a:solidFill>
-                  <a:srgbClr val="CCCCCC"/>
-                </a:solidFill>
-                <a:highlight>
-                  <a:srgbClr val="1F1F1F"/>
-                </a:highlight>
-                <a:latin typeface="Consolas"/>
-                <a:ea typeface="Consolas"/>
-                <a:cs typeface="Consolas"/>
-                <a:sym typeface="Consolas"/>
-              </a:rPr>
-              <a:t> </a:t>
-            </a:r>
-            <a:r>
-              <a:rPr lang="en" sz="1000">
-                <a:solidFill>
-                  <a:srgbClr val="9CDCFE"/>
-                </a:solidFill>
-                <a:highlight>
-                  <a:srgbClr val="1F1F1F"/>
-                </a:highlight>
-                <a:latin typeface="Consolas"/>
-                <a:ea typeface="Consolas"/>
-                <a:cs typeface="Consolas"/>
-                <a:sym typeface="Consolas"/>
-              </a:rPr>
-              <a:t>_texture</a:t>
-            </a:r>
-            <a:r>
-              <a:rPr lang="en" sz="1000">
-                <a:solidFill>
-                  <a:srgbClr val="CCCCCC"/>
-                </a:solidFill>
-                <a:highlight>
-                  <a:srgbClr val="1F1F1F"/>
-                </a:highlight>
-                <a:latin typeface="Consolas"/>
-                <a:ea typeface="Consolas"/>
-                <a:cs typeface="Consolas"/>
-                <a:sym typeface="Consolas"/>
-              </a:rPr>
-              <a:t>;</a:t>
-            </a:r>
-            <a:endParaRPr sz="1000">
-              <a:solidFill>
-                <a:srgbClr val="CCCCCC"/>
-              </a:solidFill>
-              <a:highlight>
-                <a:srgbClr val="1F1F1F"/>
-              </a:highlight>
-              <a:latin typeface="Consolas"/>
-              <a:ea typeface="Consolas"/>
-              <a:cs typeface="Consolas"/>
-              <a:sym typeface="Consolas"/>
-            </a:endParaRPr>
-          </a:p>
-          <a:p>
-            <a:pPr indent="0" lvl="0" marL="457200" rtl="0" algn="l">
-              <a:lnSpc>
-                <a:spcPct val="157500"/>
-              </a:lnSpc>
-              <a:spcBef>
-                <a:spcPts val="0"/>
-              </a:spcBef>
-              <a:spcAft>
-                <a:spcPts val="0"/>
-              </a:spcAft>
-              <a:buNone/>
-            </a:pPr>
-            <a:r>
-              <a:rPr lang="en" sz="1000">
-                <a:solidFill>
-                  <a:srgbClr val="CCCCCC"/>
-                </a:solidFill>
-                <a:highlight>
-                  <a:schemeClr val="dk2"/>
-                </a:highlight>
-                <a:latin typeface="Consolas"/>
-                <a:ea typeface="Consolas"/>
-                <a:cs typeface="Consolas"/>
-                <a:sym typeface="Consolas"/>
-              </a:rPr>
-              <a:t>…</a:t>
-            </a:r>
-            <a:endParaRPr sz="1000">
-              <a:solidFill>
-                <a:srgbClr val="CCCCCC"/>
-              </a:solidFill>
-              <a:highlight>
-                <a:schemeClr val="dk2"/>
-              </a:highlight>
-              <a:latin typeface="Consolas"/>
-              <a:ea typeface="Consolas"/>
-              <a:cs typeface="Consolas"/>
-              <a:sym typeface="Consolas"/>
-            </a:endParaRPr>
-          </a:p>
-          <a:p>
-            <a:pPr indent="0" lvl="0" marL="457200" rtl="0" algn="l">
-              <a:lnSpc>
-                <a:spcPct val="157500"/>
-              </a:lnSpc>
-              <a:spcBef>
-                <a:spcPts val="0"/>
-              </a:spcBef>
-              <a:spcAft>
-                <a:spcPts val="0"/>
-              </a:spcAft>
-              <a:buNone/>
-            </a:pPr>
-            <a:r>
-              <a:rPr lang="en" sz="1000">
-                <a:solidFill>
-                  <a:srgbClr val="9CDCFE"/>
-                </a:solidFill>
-                <a:highlight>
-                  <a:srgbClr val="1F1F1F"/>
-                </a:highlight>
-                <a:latin typeface="Consolas"/>
-                <a:ea typeface="Consolas"/>
-                <a:cs typeface="Consolas"/>
-                <a:sym typeface="Consolas"/>
-              </a:rPr>
-              <a:t>_texture</a:t>
-            </a:r>
-            <a:r>
-              <a:rPr lang="en" sz="1000">
-                <a:solidFill>
-                  <a:srgbClr val="CCCCCC"/>
-                </a:solidFill>
-                <a:highlight>
-                  <a:srgbClr val="1F1F1F"/>
-                </a:highlight>
-                <a:latin typeface="Consolas"/>
-                <a:ea typeface="Consolas"/>
-                <a:cs typeface="Consolas"/>
-                <a:sym typeface="Consolas"/>
-              </a:rPr>
-              <a:t> </a:t>
-            </a:r>
-            <a:r>
-              <a:rPr lang="en" sz="1000">
-                <a:solidFill>
-                  <a:srgbClr val="D4D4D4"/>
-                </a:solidFill>
-                <a:highlight>
-                  <a:srgbClr val="1F1F1F"/>
-                </a:highlight>
-                <a:latin typeface="Consolas"/>
-                <a:ea typeface="Consolas"/>
-                <a:cs typeface="Consolas"/>
-                <a:sym typeface="Consolas"/>
-              </a:rPr>
-              <a:t>=</a:t>
-            </a:r>
-            <a:r>
-              <a:rPr lang="en" sz="1000">
-                <a:solidFill>
-                  <a:srgbClr val="CCCCCC"/>
-                </a:solidFill>
-                <a:highlight>
-                  <a:srgbClr val="1F1F1F"/>
-                </a:highlight>
-                <a:latin typeface="Consolas"/>
-                <a:ea typeface="Consolas"/>
-                <a:cs typeface="Consolas"/>
-                <a:sym typeface="Consolas"/>
-              </a:rPr>
-              <a:t> </a:t>
-            </a:r>
-            <a:r>
-              <a:rPr lang="en" sz="1000">
-                <a:solidFill>
-                  <a:srgbClr val="569CD6"/>
-                </a:solidFill>
-                <a:highlight>
-                  <a:srgbClr val="1F1F1F"/>
-                </a:highlight>
-                <a:latin typeface="Consolas"/>
-                <a:ea typeface="Consolas"/>
-                <a:cs typeface="Consolas"/>
-                <a:sym typeface="Consolas"/>
-              </a:rPr>
-              <a:t>new</a:t>
-            </a:r>
-            <a:r>
-              <a:rPr lang="en" sz="1000">
-                <a:solidFill>
-                  <a:srgbClr val="CCCCCC"/>
-                </a:solidFill>
-                <a:highlight>
-                  <a:srgbClr val="1F1F1F"/>
-                </a:highlight>
-                <a:latin typeface="Consolas"/>
-                <a:ea typeface="Consolas"/>
-                <a:cs typeface="Consolas"/>
-                <a:sym typeface="Consolas"/>
-              </a:rPr>
-              <a:t>(</a:t>
-            </a:r>
-            <a:r>
-              <a:rPr lang="en" sz="1000">
-                <a:solidFill>
-                  <a:srgbClr val="9CDCFE"/>
-                </a:solidFill>
-                <a:highlight>
-                  <a:srgbClr val="1F1F1F"/>
-                </a:highlight>
-                <a:latin typeface="Consolas"/>
-                <a:ea typeface="Consolas"/>
-                <a:cs typeface="Consolas"/>
-                <a:sym typeface="Consolas"/>
-              </a:rPr>
-              <a:t>GraphicsDevice</a:t>
-            </a:r>
-            <a:r>
-              <a:rPr lang="en" sz="1000">
-                <a:solidFill>
-                  <a:srgbClr val="CCCCCC"/>
-                </a:solidFill>
-                <a:highlight>
-                  <a:srgbClr val="1F1F1F"/>
-                </a:highlight>
-                <a:latin typeface="Consolas"/>
-                <a:ea typeface="Consolas"/>
-                <a:cs typeface="Consolas"/>
-                <a:sym typeface="Consolas"/>
-              </a:rPr>
-              <a:t>, </a:t>
-            </a:r>
-            <a:r>
-              <a:rPr lang="en" sz="1000">
-                <a:solidFill>
-                  <a:srgbClr val="B5CEA8"/>
-                </a:solidFill>
-                <a:highlight>
-                  <a:srgbClr val="1F1F1F"/>
-                </a:highlight>
-                <a:latin typeface="Consolas"/>
-                <a:ea typeface="Consolas"/>
-                <a:cs typeface="Consolas"/>
-                <a:sym typeface="Consolas"/>
-              </a:rPr>
-              <a:t>1</a:t>
-            </a:r>
-            <a:r>
-              <a:rPr lang="en" sz="1000">
-                <a:solidFill>
-                  <a:srgbClr val="CCCCCC"/>
-                </a:solidFill>
-                <a:highlight>
-                  <a:srgbClr val="1F1F1F"/>
-                </a:highlight>
-                <a:latin typeface="Consolas"/>
-                <a:ea typeface="Consolas"/>
-                <a:cs typeface="Consolas"/>
-                <a:sym typeface="Consolas"/>
-              </a:rPr>
-              <a:t>, </a:t>
-            </a:r>
-            <a:r>
-              <a:rPr lang="en" sz="1000">
-                <a:solidFill>
-                  <a:srgbClr val="B5CEA8"/>
-                </a:solidFill>
-                <a:highlight>
-                  <a:srgbClr val="1F1F1F"/>
-                </a:highlight>
-                <a:latin typeface="Consolas"/>
-                <a:ea typeface="Consolas"/>
-                <a:cs typeface="Consolas"/>
-                <a:sym typeface="Consolas"/>
-              </a:rPr>
-              <a:t>1</a:t>
-            </a:r>
-            <a:r>
-              <a:rPr lang="en" sz="1000">
-                <a:solidFill>
-                  <a:srgbClr val="CCCCCC"/>
-                </a:solidFill>
-                <a:highlight>
-                  <a:srgbClr val="1F1F1F"/>
-                </a:highlight>
-                <a:latin typeface="Consolas"/>
-                <a:ea typeface="Consolas"/>
-                <a:cs typeface="Consolas"/>
-                <a:sym typeface="Consolas"/>
-              </a:rPr>
-              <a:t>);</a:t>
-            </a:r>
-            <a:endParaRPr sz="1000">
-              <a:solidFill>
-                <a:srgbClr val="CCCCCC"/>
-              </a:solidFill>
-              <a:highlight>
-                <a:srgbClr val="1F1F1F"/>
-              </a:highlight>
-              <a:latin typeface="Consolas"/>
-              <a:ea typeface="Consolas"/>
-              <a:cs typeface="Consolas"/>
-              <a:sym typeface="Consolas"/>
-            </a:endParaRPr>
-          </a:p>
-          <a:p>
-            <a:pPr indent="0" lvl="0" marL="457200" rtl="0" algn="l">
-              <a:lnSpc>
-                <a:spcPct val="157500"/>
-              </a:lnSpc>
-              <a:spcBef>
-                <a:spcPts val="0"/>
-              </a:spcBef>
-              <a:spcAft>
-                <a:spcPts val="0"/>
-              </a:spcAft>
-              <a:buNone/>
-            </a:pPr>
-            <a:r>
-              <a:rPr lang="en" sz="1000">
-                <a:solidFill>
-                  <a:srgbClr val="9CDCFE"/>
-                </a:solidFill>
-                <a:highlight>
-                  <a:srgbClr val="1F1F1F"/>
-                </a:highlight>
-                <a:latin typeface="Consolas"/>
-                <a:ea typeface="Consolas"/>
-                <a:cs typeface="Consolas"/>
-                <a:sym typeface="Consolas"/>
-              </a:rPr>
-              <a:t>_texture</a:t>
-            </a:r>
-            <a:r>
-              <a:rPr lang="en" sz="1000">
-                <a:solidFill>
-                  <a:srgbClr val="D4D4D4"/>
-                </a:solidFill>
-                <a:highlight>
-                  <a:srgbClr val="1F1F1F"/>
-                </a:highlight>
-                <a:latin typeface="Consolas"/>
-                <a:ea typeface="Consolas"/>
-                <a:cs typeface="Consolas"/>
-                <a:sym typeface="Consolas"/>
-              </a:rPr>
-              <a:t>.</a:t>
-            </a:r>
-            <a:r>
-              <a:rPr lang="en" sz="1000">
-                <a:solidFill>
-                  <a:srgbClr val="DCDCAA"/>
-                </a:solidFill>
-                <a:highlight>
-                  <a:srgbClr val="1F1F1F"/>
-                </a:highlight>
-                <a:latin typeface="Consolas"/>
-                <a:ea typeface="Consolas"/>
-                <a:cs typeface="Consolas"/>
-                <a:sym typeface="Consolas"/>
-              </a:rPr>
-              <a:t>SetData</a:t>
-            </a:r>
-            <a:r>
-              <a:rPr lang="en" sz="1000">
-                <a:solidFill>
-                  <a:srgbClr val="CCCCCC"/>
-                </a:solidFill>
-                <a:highlight>
-                  <a:srgbClr val="1F1F1F"/>
-                </a:highlight>
-                <a:latin typeface="Consolas"/>
-                <a:ea typeface="Consolas"/>
-                <a:cs typeface="Consolas"/>
-                <a:sym typeface="Consolas"/>
-              </a:rPr>
-              <a:t>([</a:t>
-            </a:r>
-            <a:r>
-              <a:rPr lang="en" sz="1000">
-                <a:solidFill>
-                  <a:srgbClr val="4EC9B0"/>
-                </a:solidFill>
-                <a:highlight>
-                  <a:srgbClr val="1F1F1F"/>
-                </a:highlight>
-                <a:latin typeface="Consolas"/>
-                <a:ea typeface="Consolas"/>
-                <a:cs typeface="Consolas"/>
-                <a:sym typeface="Consolas"/>
-              </a:rPr>
-              <a:t>Color</a:t>
-            </a:r>
-            <a:r>
-              <a:rPr lang="en" sz="1000">
-                <a:solidFill>
-                  <a:srgbClr val="D4D4D4"/>
-                </a:solidFill>
-                <a:highlight>
-                  <a:srgbClr val="1F1F1F"/>
-                </a:highlight>
-                <a:latin typeface="Consolas"/>
-                <a:ea typeface="Consolas"/>
-                <a:cs typeface="Consolas"/>
-                <a:sym typeface="Consolas"/>
-              </a:rPr>
-              <a:t>.</a:t>
-            </a:r>
-            <a:r>
-              <a:rPr lang="en" sz="1000">
-                <a:solidFill>
-                  <a:srgbClr val="9CDCFE"/>
-                </a:solidFill>
-                <a:highlight>
-                  <a:srgbClr val="1F1F1F"/>
-                </a:highlight>
-                <a:latin typeface="Consolas"/>
-                <a:ea typeface="Consolas"/>
-                <a:cs typeface="Consolas"/>
-                <a:sym typeface="Consolas"/>
-              </a:rPr>
-              <a:t>White</a:t>
-            </a:r>
-            <a:r>
-              <a:rPr lang="en" sz="1000">
-                <a:solidFill>
-                  <a:srgbClr val="CCCCCC"/>
-                </a:solidFill>
-                <a:highlight>
-                  <a:srgbClr val="1F1F1F"/>
-                </a:highlight>
-                <a:latin typeface="Consolas"/>
-                <a:ea typeface="Consolas"/>
-                <a:cs typeface="Consolas"/>
-                <a:sym typeface="Consolas"/>
-              </a:rPr>
-              <a:t>]);</a:t>
-            </a:r>
-            <a:endParaRPr/>
-          </a:p>
-          <a:p>
-            <a:pPr indent="0" lvl="0" marL="0" rtl="0" algn="l">
-              <a:spcBef>
-                <a:spcPts val="0"/>
-              </a:spcBef>
-              <a:spcAft>
-                <a:spcPts val="0"/>
-              </a:spcAft>
-              <a:buNone/>
-            </a:pPr>
-            <a:r>
-              <a:rPr/>
-              <a:t/>
-            </a:r>
-            <a:endParaRPr/>
-          </a:p>
-          <a:p>
-            <a:pPr indent="-330200" lvl="0" marL="457200" rtl="0" algn="l">
-              <a:spcBef>
-                <a:spcPts val="1200"/>
-              </a:spcBef>
-              <a:spcAft>
-                <a:spcPts val="0"/>
-              </a:spcAft>
-              <a:buSzPts val="1600"/>
-              <a:buChar char="●"/>
-            </a:pPr>
-            <a:r>
-              <a:rPr lang="en"/>
-              <a:t>Use the texture as an argument to SpriteBatch.Draw()</a:t>
-            </a:r>
-            <a:endParaRPr/>
-          </a:p>
-          <a:p>
-            <a:pPr indent="-317500" lvl="1" marL="914400" rtl="0" algn="l">
-              <a:spcBef>
-                <a:spcPts val="0"/>
-              </a:spcBef>
-              <a:spcAft>
-                <a:spcPts val="0"/>
-              </a:spcAft>
-              <a:buSzPts val="1400"/>
-              <a:buChar char="○"/>
-            </a:pPr>
-            <a:r>
-              <a:rPr lang="en"/>
-              <a:t>SpriteBatch.Draw() has a method overload that receives a Rectangle</a:t>
-            </a:r>
-            <a:endParaRPr/>
-          </a:p>
-        </p:txBody>
-      </p:sp>
     </p:spTree>
   </p:cSld>
   <p:clrMapOvr>
@@ -11130,6 +10582,693 @@
   <p:cSld>
     <p:spTree>
       <p:nvGrpSpPr>
+        <p:cNvPr id="192" name="Shape 192"/>
+        <p:cNvGrpSpPr/>
+        <p:nvPr/>
+      </p:nvGrpSpPr>
+      <p:grpSpPr>
+        <a:xfrm>
+          <a:off x="0" y="0"/>
+          <a:ext cx="0" cy="0"/>
+          <a:chOff x="0" y="0"/>
+          <a:chExt cx="0" cy="0"/>
+        </a:xfrm>
+      </p:grpSpPr>
+      <p:sp>
+        <p:nvSpPr>
+          <p:cNvPr id="193" name="Google Shape;193;p34"/>
+          <p:cNvSpPr txBox="1"/>
+          <p:nvPr>
+            <p:ph type="title"/>
+          </p:nvPr>
+        </p:nvSpPr>
+        <p:spPr>
+          <a:xfrm>
+            <a:off x="311700" y="195615"/>
+            <a:ext cx="8520600" cy="572700"/>
+          </a:xfrm>
+          <a:prstGeom prst="rect">
+            <a:avLst/>
+          </a:prstGeom>
+        </p:spPr>
+        <p:txBody>
+          <a:bodyPr anchorCtr="0" anchor="t" bIns="91425" lIns="91425" spcFirstLastPara="1" rIns="91425" wrap="square" tIns="91425">
+            <a:normAutofit fontScale="90000"/>
+          </a:bodyPr>
+          <a:lstStyle/>
+          <a:p>
+            <a:pPr indent="0" lvl="0" marL="0" rtl="0" algn="l">
+              <a:spcBef>
+                <a:spcPts val="0"/>
+              </a:spcBef>
+              <a:spcAft>
+                <a:spcPts val="0"/>
+              </a:spcAft>
+              <a:buNone/>
+            </a:pPr>
+            <a:r>
+              <a:rPr lang="en"/>
+              <a:t>Drawing to The Screen</a:t>
+            </a:r>
+            <a:endParaRPr/>
+          </a:p>
+        </p:txBody>
+      </p:sp>
+      <p:sp>
+        <p:nvSpPr>
+          <p:cNvPr id="194" name="Google Shape;194;p34"/>
+          <p:cNvSpPr txBox="1"/>
+          <p:nvPr>
+            <p:ph idx="1" type="body"/>
+          </p:nvPr>
+        </p:nvSpPr>
+        <p:spPr>
+          <a:xfrm>
+            <a:off x="311700" y="885950"/>
+            <a:ext cx="8520600" cy="4023300"/>
+          </a:xfrm>
+          <a:prstGeom prst="rect">
+            <a:avLst/>
+          </a:prstGeom>
+        </p:spPr>
+        <p:txBody>
+          <a:bodyPr anchorCtr="0" anchor="t" bIns="91425" lIns="91425" spcFirstLastPara="1" rIns="91425" wrap="square" tIns="91425">
+            <a:normAutofit/>
+          </a:bodyPr>
+          <a:lstStyle/>
+          <a:p>
+            <a:pPr indent="-330200" lvl="0" marL="457200" rtl="0" algn="l">
+              <a:spcBef>
+                <a:spcPts val="0"/>
+              </a:spcBef>
+              <a:spcAft>
+                <a:spcPts val="0"/>
+              </a:spcAft>
+              <a:buSzPts val="1600"/>
+              <a:buChar char="●"/>
+            </a:pPr>
+            <a:r>
+              <a:rPr lang="en"/>
+              <a:t>Normally a texture is needed to draw to the screen</a:t>
+            </a:r>
+            <a:endParaRPr/>
+          </a:p>
+          <a:p>
+            <a:pPr indent="-330200" lvl="0" marL="457200" rtl="0" algn="l">
+              <a:spcBef>
+                <a:spcPts val="0"/>
+              </a:spcBef>
+              <a:spcAft>
+                <a:spcPts val="0"/>
+              </a:spcAft>
+              <a:buSzPts val="1600"/>
+              <a:buChar char="●"/>
+            </a:pPr>
+            <a:r>
+              <a:rPr lang="en"/>
+              <a:t>A Pong game doesn’t need explicit texture assets, but we do need to draw rectangles</a:t>
+            </a:r>
+            <a:endParaRPr/>
+          </a:p>
+          <a:p>
+            <a:pPr indent="0" lvl="0" marL="0" rtl="0" algn="l">
+              <a:spcBef>
+                <a:spcPts val="1200"/>
+              </a:spcBef>
+              <a:spcAft>
+                <a:spcPts val="0"/>
+              </a:spcAft>
+              <a:buNone/>
+            </a:pPr>
+            <a:r>
+              <a:rPr/>
+              <a:t/>
+            </a:r>
+            <a:endParaRPr/>
+          </a:p>
+          <a:p>
+            <a:pPr indent="0" lvl="0" marL="457200" rtl="0" algn="l">
+              <a:lnSpc>
+                <a:spcPct val="157500"/>
+              </a:lnSpc>
+              <a:spcBef>
+                <a:spcPts val="1200"/>
+              </a:spcBef>
+              <a:spcAft>
+                <a:spcPts val="0"/>
+              </a:spcAft>
+              <a:buNone/>
+            </a:pPr>
+            <a:r>
+              <a:rPr lang="en" sz="1000">
+                <a:solidFill>
+                  <a:srgbClr val="569CD6"/>
+                </a:solidFill>
+                <a:highlight>
+                  <a:srgbClr val="1F1F1F"/>
+                </a:highlight>
+                <a:latin typeface="Consolas"/>
+                <a:ea typeface="Consolas"/>
+                <a:cs typeface="Consolas"/>
+                <a:sym typeface="Consolas"/>
+              </a:rPr>
+              <a:t>private</a:t>
+            </a:r>
+            <a:r>
+              <a:rPr lang="en" sz="1000">
+                <a:solidFill>
+                  <a:srgbClr val="CCCCCC"/>
+                </a:solidFill>
+                <a:highlight>
+                  <a:srgbClr val="1F1F1F"/>
+                </a:highlight>
+                <a:latin typeface="Consolas"/>
+                <a:ea typeface="Consolas"/>
+                <a:cs typeface="Consolas"/>
+                <a:sym typeface="Consolas"/>
+              </a:rPr>
+              <a:t> </a:t>
+            </a:r>
+            <a:r>
+              <a:rPr lang="en" sz="1000">
+                <a:solidFill>
+                  <a:srgbClr val="4EC9B0"/>
+                </a:solidFill>
+                <a:highlight>
+                  <a:srgbClr val="1F1F1F"/>
+                </a:highlight>
+                <a:latin typeface="Consolas"/>
+                <a:ea typeface="Consolas"/>
+                <a:cs typeface="Consolas"/>
+                <a:sym typeface="Consolas"/>
+              </a:rPr>
+              <a:t>Texture2D</a:t>
+            </a:r>
+            <a:r>
+              <a:rPr lang="en" sz="1000">
+                <a:solidFill>
+                  <a:srgbClr val="CCCCCC"/>
+                </a:solidFill>
+                <a:highlight>
+                  <a:srgbClr val="1F1F1F"/>
+                </a:highlight>
+                <a:latin typeface="Consolas"/>
+                <a:ea typeface="Consolas"/>
+                <a:cs typeface="Consolas"/>
+                <a:sym typeface="Consolas"/>
+              </a:rPr>
+              <a:t> </a:t>
+            </a:r>
+            <a:r>
+              <a:rPr lang="en" sz="1000">
+                <a:solidFill>
+                  <a:srgbClr val="9CDCFE"/>
+                </a:solidFill>
+                <a:highlight>
+                  <a:srgbClr val="1F1F1F"/>
+                </a:highlight>
+                <a:latin typeface="Consolas"/>
+                <a:ea typeface="Consolas"/>
+                <a:cs typeface="Consolas"/>
+                <a:sym typeface="Consolas"/>
+              </a:rPr>
+              <a:t>_texture</a:t>
+            </a:r>
+            <a:r>
+              <a:rPr lang="en" sz="1000">
+                <a:solidFill>
+                  <a:srgbClr val="CCCCCC"/>
+                </a:solidFill>
+                <a:highlight>
+                  <a:srgbClr val="1F1F1F"/>
+                </a:highlight>
+                <a:latin typeface="Consolas"/>
+                <a:ea typeface="Consolas"/>
+                <a:cs typeface="Consolas"/>
+                <a:sym typeface="Consolas"/>
+              </a:rPr>
+              <a:t>;</a:t>
+            </a:r>
+            <a:endParaRPr sz="1000">
+              <a:solidFill>
+                <a:srgbClr val="CCCCCC"/>
+              </a:solidFill>
+              <a:highlight>
+                <a:srgbClr val="1F1F1F"/>
+              </a:highlight>
+              <a:latin typeface="Consolas"/>
+              <a:ea typeface="Consolas"/>
+              <a:cs typeface="Consolas"/>
+              <a:sym typeface="Consolas"/>
+            </a:endParaRPr>
+          </a:p>
+          <a:p>
+            <a:pPr indent="0" lvl="0" marL="457200" rtl="0" algn="l">
+              <a:lnSpc>
+                <a:spcPct val="157500"/>
+              </a:lnSpc>
+              <a:spcBef>
+                <a:spcPts val="0"/>
+              </a:spcBef>
+              <a:spcAft>
+                <a:spcPts val="0"/>
+              </a:spcAft>
+              <a:buNone/>
+            </a:pPr>
+            <a:r>
+              <a:rPr lang="en" sz="1000">
+                <a:solidFill>
+                  <a:srgbClr val="CCCCCC"/>
+                </a:solidFill>
+                <a:highlight>
+                  <a:schemeClr val="dk2"/>
+                </a:highlight>
+                <a:latin typeface="Consolas"/>
+                <a:ea typeface="Consolas"/>
+                <a:cs typeface="Consolas"/>
+                <a:sym typeface="Consolas"/>
+              </a:rPr>
+              <a:t>…</a:t>
+            </a:r>
+            <a:endParaRPr sz="1000">
+              <a:solidFill>
+                <a:srgbClr val="CCCCCC"/>
+              </a:solidFill>
+              <a:highlight>
+                <a:schemeClr val="dk2"/>
+              </a:highlight>
+              <a:latin typeface="Consolas"/>
+              <a:ea typeface="Consolas"/>
+              <a:cs typeface="Consolas"/>
+              <a:sym typeface="Consolas"/>
+            </a:endParaRPr>
+          </a:p>
+          <a:p>
+            <a:pPr indent="0" lvl="0" marL="457200" rtl="0" algn="l">
+              <a:lnSpc>
+                <a:spcPct val="157500"/>
+              </a:lnSpc>
+              <a:spcBef>
+                <a:spcPts val="0"/>
+              </a:spcBef>
+              <a:spcAft>
+                <a:spcPts val="0"/>
+              </a:spcAft>
+              <a:buNone/>
+            </a:pPr>
+            <a:r>
+              <a:rPr lang="en" sz="1000">
+                <a:solidFill>
+                  <a:srgbClr val="9CDCFE"/>
+                </a:solidFill>
+                <a:highlight>
+                  <a:srgbClr val="1F1F1F"/>
+                </a:highlight>
+                <a:latin typeface="Consolas"/>
+                <a:ea typeface="Consolas"/>
+                <a:cs typeface="Consolas"/>
+                <a:sym typeface="Consolas"/>
+              </a:rPr>
+              <a:t>_texture</a:t>
+            </a:r>
+            <a:r>
+              <a:rPr lang="en" sz="1000">
+                <a:solidFill>
+                  <a:srgbClr val="CCCCCC"/>
+                </a:solidFill>
+                <a:highlight>
+                  <a:srgbClr val="1F1F1F"/>
+                </a:highlight>
+                <a:latin typeface="Consolas"/>
+                <a:ea typeface="Consolas"/>
+                <a:cs typeface="Consolas"/>
+                <a:sym typeface="Consolas"/>
+              </a:rPr>
+              <a:t> </a:t>
+            </a:r>
+            <a:r>
+              <a:rPr lang="en" sz="1000">
+                <a:solidFill>
+                  <a:srgbClr val="D4D4D4"/>
+                </a:solidFill>
+                <a:highlight>
+                  <a:srgbClr val="1F1F1F"/>
+                </a:highlight>
+                <a:latin typeface="Consolas"/>
+                <a:ea typeface="Consolas"/>
+                <a:cs typeface="Consolas"/>
+                <a:sym typeface="Consolas"/>
+              </a:rPr>
+              <a:t>=</a:t>
+            </a:r>
+            <a:r>
+              <a:rPr lang="en" sz="1000">
+                <a:solidFill>
+                  <a:srgbClr val="CCCCCC"/>
+                </a:solidFill>
+                <a:highlight>
+                  <a:srgbClr val="1F1F1F"/>
+                </a:highlight>
+                <a:latin typeface="Consolas"/>
+                <a:ea typeface="Consolas"/>
+                <a:cs typeface="Consolas"/>
+                <a:sym typeface="Consolas"/>
+              </a:rPr>
+              <a:t> </a:t>
+            </a:r>
+            <a:r>
+              <a:rPr lang="en" sz="1000">
+                <a:solidFill>
+                  <a:srgbClr val="569CD6"/>
+                </a:solidFill>
+                <a:highlight>
+                  <a:srgbClr val="1F1F1F"/>
+                </a:highlight>
+                <a:latin typeface="Consolas"/>
+                <a:ea typeface="Consolas"/>
+                <a:cs typeface="Consolas"/>
+                <a:sym typeface="Consolas"/>
+              </a:rPr>
+              <a:t>new</a:t>
+            </a:r>
+            <a:r>
+              <a:rPr lang="en" sz="1000">
+                <a:solidFill>
+                  <a:srgbClr val="CCCCCC"/>
+                </a:solidFill>
+                <a:highlight>
+                  <a:srgbClr val="1F1F1F"/>
+                </a:highlight>
+                <a:latin typeface="Consolas"/>
+                <a:ea typeface="Consolas"/>
+                <a:cs typeface="Consolas"/>
+                <a:sym typeface="Consolas"/>
+              </a:rPr>
+              <a:t>(</a:t>
+            </a:r>
+            <a:r>
+              <a:rPr lang="en" sz="1000">
+                <a:solidFill>
+                  <a:srgbClr val="9CDCFE"/>
+                </a:solidFill>
+                <a:highlight>
+                  <a:srgbClr val="1F1F1F"/>
+                </a:highlight>
+                <a:latin typeface="Consolas"/>
+                <a:ea typeface="Consolas"/>
+                <a:cs typeface="Consolas"/>
+                <a:sym typeface="Consolas"/>
+              </a:rPr>
+              <a:t>GraphicsDevice</a:t>
+            </a:r>
+            <a:r>
+              <a:rPr lang="en" sz="1000">
+                <a:solidFill>
+                  <a:srgbClr val="CCCCCC"/>
+                </a:solidFill>
+                <a:highlight>
+                  <a:srgbClr val="1F1F1F"/>
+                </a:highlight>
+                <a:latin typeface="Consolas"/>
+                <a:ea typeface="Consolas"/>
+                <a:cs typeface="Consolas"/>
+                <a:sym typeface="Consolas"/>
+              </a:rPr>
+              <a:t>, </a:t>
+            </a:r>
+            <a:r>
+              <a:rPr lang="en" sz="1000">
+                <a:solidFill>
+                  <a:srgbClr val="B5CEA8"/>
+                </a:solidFill>
+                <a:highlight>
+                  <a:srgbClr val="1F1F1F"/>
+                </a:highlight>
+                <a:latin typeface="Consolas"/>
+                <a:ea typeface="Consolas"/>
+                <a:cs typeface="Consolas"/>
+                <a:sym typeface="Consolas"/>
+              </a:rPr>
+              <a:t>1</a:t>
+            </a:r>
+            <a:r>
+              <a:rPr lang="en" sz="1000">
+                <a:solidFill>
+                  <a:srgbClr val="CCCCCC"/>
+                </a:solidFill>
+                <a:highlight>
+                  <a:srgbClr val="1F1F1F"/>
+                </a:highlight>
+                <a:latin typeface="Consolas"/>
+                <a:ea typeface="Consolas"/>
+                <a:cs typeface="Consolas"/>
+                <a:sym typeface="Consolas"/>
+              </a:rPr>
+              <a:t>, </a:t>
+            </a:r>
+            <a:r>
+              <a:rPr lang="en" sz="1000">
+                <a:solidFill>
+                  <a:srgbClr val="B5CEA8"/>
+                </a:solidFill>
+                <a:highlight>
+                  <a:srgbClr val="1F1F1F"/>
+                </a:highlight>
+                <a:latin typeface="Consolas"/>
+                <a:ea typeface="Consolas"/>
+                <a:cs typeface="Consolas"/>
+                <a:sym typeface="Consolas"/>
+              </a:rPr>
+              <a:t>1</a:t>
+            </a:r>
+            <a:r>
+              <a:rPr lang="en" sz="1000">
+                <a:solidFill>
+                  <a:srgbClr val="CCCCCC"/>
+                </a:solidFill>
+                <a:highlight>
+                  <a:srgbClr val="1F1F1F"/>
+                </a:highlight>
+                <a:latin typeface="Consolas"/>
+                <a:ea typeface="Consolas"/>
+                <a:cs typeface="Consolas"/>
+                <a:sym typeface="Consolas"/>
+              </a:rPr>
+              <a:t>);</a:t>
+            </a:r>
+            <a:endParaRPr sz="1000">
+              <a:solidFill>
+                <a:srgbClr val="CCCCCC"/>
+              </a:solidFill>
+              <a:highlight>
+                <a:srgbClr val="1F1F1F"/>
+              </a:highlight>
+              <a:latin typeface="Consolas"/>
+              <a:ea typeface="Consolas"/>
+              <a:cs typeface="Consolas"/>
+              <a:sym typeface="Consolas"/>
+            </a:endParaRPr>
+          </a:p>
+          <a:p>
+            <a:pPr indent="0" lvl="0" marL="457200" rtl="0" algn="l">
+              <a:lnSpc>
+                <a:spcPct val="157500"/>
+              </a:lnSpc>
+              <a:spcBef>
+                <a:spcPts val="0"/>
+              </a:spcBef>
+              <a:spcAft>
+                <a:spcPts val="0"/>
+              </a:spcAft>
+              <a:buNone/>
+            </a:pPr>
+            <a:r>
+              <a:rPr lang="en" sz="1000">
+                <a:solidFill>
+                  <a:srgbClr val="9CDCFE"/>
+                </a:solidFill>
+                <a:highlight>
+                  <a:srgbClr val="1F1F1F"/>
+                </a:highlight>
+                <a:latin typeface="Consolas"/>
+                <a:ea typeface="Consolas"/>
+                <a:cs typeface="Consolas"/>
+                <a:sym typeface="Consolas"/>
+              </a:rPr>
+              <a:t>_texture</a:t>
+            </a:r>
+            <a:r>
+              <a:rPr lang="en" sz="1000">
+                <a:solidFill>
+                  <a:srgbClr val="D4D4D4"/>
+                </a:solidFill>
+                <a:highlight>
+                  <a:srgbClr val="1F1F1F"/>
+                </a:highlight>
+                <a:latin typeface="Consolas"/>
+                <a:ea typeface="Consolas"/>
+                <a:cs typeface="Consolas"/>
+                <a:sym typeface="Consolas"/>
+              </a:rPr>
+              <a:t>.</a:t>
+            </a:r>
+            <a:r>
+              <a:rPr lang="en" sz="1000">
+                <a:solidFill>
+                  <a:srgbClr val="DCDCAA"/>
+                </a:solidFill>
+                <a:highlight>
+                  <a:srgbClr val="1F1F1F"/>
+                </a:highlight>
+                <a:latin typeface="Consolas"/>
+                <a:ea typeface="Consolas"/>
+                <a:cs typeface="Consolas"/>
+                <a:sym typeface="Consolas"/>
+              </a:rPr>
+              <a:t>SetData</a:t>
+            </a:r>
+            <a:r>
+              <a:rPr lang="en" sz="1000">
+                <a:solidFill>
+                  <a:srgbClr val="CCCCCC"/>
+                </a:solidFill>
+                <a:highlight>
+                  <a:srgbClr val="1F1F1F"/>
+                </a:highlight>
+                <a:latin typeface="Consolas"/>
+                <a:ea typeface="Consolas"/>
+                <a:cs typeface="Consolas"/>
+                <a:sym typeface="Consolas"/>
+              </a:rPr>
+              <a:t>([</a:t>
+            </a:r>
+            <a:r>
+              <a:rPr lang="en" sz="1000">
+                <a:solidFill>
+                  <a:srgbClr val="4EC9B0"/>
+                </a:solidFill>
+                <a:highlight>
+                  <a:srgbClr val="1F1F1F"/>
+                </a:highlight>
+                <a:latin typeface="Consolas"/>
+                <a:ea typeface="Consolas"/>
+                <a:cs typeface="Consolas"/>
+                <a:sym typeface="Consolas"/>
+              </a:rPr>
+              <a:t>Color</a:t>
+            </a:r>
+            <a:r>
+              <a:rPr lang="en" sz="1000">
+                <a:solidFill>
+                  <a:srgbClr val="D4D4D4"/>
+                </a:solidFill>
+                <a:highlight>
+                  <a:srgbClr val="1F1F1F"/>
+                </a:highlight>
+                <a:latin typeface="Consolas"/>
+                <a:ea typeface="Consolas"/>
+                <a:cs typeface="Consolas"/>
+                <a:sym typeface="Consolas"/>
+              </a:rPr>
+              <a:t>.</a:t>
+            </a:r>
+            <a:r>
+              <a:rPr lang="en" sz="1000">
+                <a:solidFill>
+                  <a:srgbClr val="9CDCFE"/>
+                </a:solidFill>
+                <a:highlight>
+                  <a:srgbClr val="1F1F1F"/>
+                </a:highlight>
+                <a:latin typeface="Consolas"/>
+                <a:ea typeface="Consolas"/>
+                <a:cs typeface="Consolas"/>
+                <a:sym typeface="Consolas"/>
+              </a:rPr>
+              <a:t>White</a:t>
+            </a:r>
+            <a:r>
+              <a:rPr lang="en" sz="1000">
+                <a:solidFill>
+                  <a:srgbClr val="CCCCCC"/>
+                </a:solidFill>
+                <a:highlight>
+                  <a:srgbClr val="1F1F1F"/>
+                </a:highlight>
+                <a:latin typeface="Consolas"/>
+                <a:ea typeface="Consolas"/>
+                <a:cs typeface="Consolas"/>
+                <a:sym typeface="Consolas"/>
+              </a:rPr>
+              <a:t>]);</a:t>
+            </a:r>
+            <a:endParaRPr/>
+          </a:p>
+          <a:p>
+            <a:pPr indent="0" lvl="0" marL="0" rtl="0" algn="l">
+              <a:spcBef>
+                <a:spcPts val="0"/>
+              </a:spcBef>
+              <a:spcAft>
+                <a:spcPts val="0"/>
+              </a:spcAft>
+              <a:buNone/>
+            </a:pPr>
+            <a:r>
+              <a:rPr/>
+              <a:t/>
+            </a:r>
+            <a:endParaRPr/>
+          </a:p>
+          <a:p>
+            <a:pPr indent="-330200" lvl="0" marL="457200" rtl="0" algn="l">
+              <a:spcBef>
+                <a:spcPts val="1200"/>
+              </a:spcBef>
+              <a:spcAft>
+                <a:spcPts val="0"/>
+              </a:spcAft>
+              <a:buSzPts val="1600"/>
+              <a:buChar char="●"/>
+            </a:pPr>
+            <a:r>
+              <a:rPr lang="en"/>
+              <a:t>Use the texture as an argument to SpriteBatch.Draw()</a:t>
+            </a:r>
+            <a:endParaRPr/>
+          </a:p>
+          <a:p>
+            <a:pPr indent="-317500" lvl="1" marL="914400" rtl="0" algn="l">
+              <a:spcBef>
+                <a:spcPts val="0"/>
+              </a:spcBef>
+              <a:spcAft>
+                <a:spcPts val="0"/>
+              </a:spcAft>
+              <a:buSzPts val="1400"/>
+              <a:buChar char="○"/>
+            </a:pPr>
+            <a:r>
+              <a:rPr lang="en"/>
+              <a:t>SpriteBatch.Draw() has a method overload that receives a Rectangle</a:t>
+            </a:r>
+            <a:endParaRPr/>
+          </a:p>
+        </p:txBody>
+      </p:sp>
+    </p:spTree>
+  </p:cSld>
+  <p:clrMapOvr>
+    <a:masterClrMapping/>
+  </p:clrMapOvr>
+</p:sld>
+</file>
+
+<file path=ppt/slides/slide21.xml><?xml version="1.0" encoding="utf-8"?>
+<p:sld xmlns:a="http://schemas.openxmlformats.org/drawingml/2006/main" xmlns:r="http://schemas.openxmlformats.org/officeDocument/2006/relationships" xmlns:mc="http://schemas.openxmlformats.org/markup-compatibility/2006" xmlns:mv="urn:schemas-microsoft-com:mac:vml" xmlns:p="http://schemas.openxmlformats.org/presentationml/2006/main" xmlns:c="http://schemas.openxmlformats.org/drawingml/2006/chart" xmlns:dgm="http://schemas.openxmlformats.org/drawingml/2006/diagram" xmlns:o="urn:schemas-microsoft-com:office:office" xmlns:v="urn:schemas-microsoft-com:vml" xmlns:pvml="urn:schemas-microsoft-com:office:powerpoint" xmlns:com="http://schemas.openxmlformats.org/drawingml/2006/compatibility" xmlns:p14="http://schemas.microsoft.com/office/powerpoint/2010/main" xmlns:p15="http://schemas.microsoft.com/office/powerpoint/2012/main" xmlns:ahyp="http://schemas.microsoft.com/office/drawing/2018/hyperlinkcolor">
+  <p:cSld>
+    <p:spTree>
+      <p:nvGrpSpPr>
         <p:cNvPr id="198" name="Shape 198"/>
         <p:cNvGrpSpPr/>
         <p:nvPr/>
@@ -11280,7 +11419,7 @@
 </p:sld>
 </file>
 
-<file path=ppt/slides/slide21.xml><?xml version="1.0" encoding="utf-8"?>
+<file path=ppt/slides/slide22.xml><?xml version="1.0" encoding="utf-8"?>
 <p:sld xmlns:a="http://schemas.openxmlformats.org/drawingml/2006/main" xmlns:r="http://schemas.openxmlformats.org/officeDocument/2006/relationships" xmlns:mc="http://schemas.openxmlformats.org/markup-compatibility/2006" xmlns:mv="urn:schemas-microsoft-com:mac:vml" xmlns:p="http://schemas.openxmlformats.org/presentationml/2006/main" xmlns:c="http://schemas.openxmlformats.org/drawingml/2006/chart" xmlns:dgm="http://schemas.openxmlformats.org/drawingml/2006/diagram" xmlns:o="urn:schemas-microsoft-com:office:office" xmlns:v="urn:schemas-microsoft-com:vml" xmlns:pvml="urn:schemas-microsoft-com:office:powerpoint" xmlns:com="http://schemas.openxmlformats.org/drawingml/2006/compatibility" xmlns:p14="http://schemas.microsoft.com/office/powerpoint/2010/main" xmlns:p15="http://schemas.microsoft.com/office/powerpoint/2012/main" xmlns:ahyp="http://schemas.microsoft.com/office/drawing/2018/hyperlinkcolor">
   <p:cSld>
     <p:spTree>
@@ -12459,7 +12598,7 @@
 </p:sld>
 </file>
 
-<file path=ppt/slides/slide22.xml><?xml version="1.0" encoding="utf-8"?>
+<file path=ppt/slides/slide23.xml><?xml version="1.0" encoding="utf-8"?>
 <p:sld xmlns:a="http://schemas.openxmlformats.org/drawingml/2006/main" xmlns:r="http://schemas.openxmlformats.org/officeDocument/2006/relationships" xmlns:mc="http://schemas.openxmlformats.org/markup-compatibility/2006" xmlns:mv="urn:schemas-microsoft-com:mac:vml" xmlns:p="http://schemas.openxmlformats.org/presentationml/2006/main" xmlns:c="http://schemas.openxmlformats.org/drawingml/2006/chart" xmlns:dgm="http://schemas.openxmlformats.org/drawingml/2006/diagram" xmlns:o="urn:schemas-microsoft-com:office:office" xmlns:v="urn:schemas-microsoft-com:vml" xmlns:pvml="urn:schemas-microsoft-com:office:powerpoint" xmlns:com="http://schemas.openxmlformats.org/drawingml/2006/compatibility" xmlns:p14="http://schemas.microsoft.com/office/powerpoint/2010/main" xmlns:p15="http://schemas.microsoft.com/office/powerpoint/2012/main" xmlns:ahyp="http://schemas.microsoft.com/office/drawing/2018/hyperlinkcolor">
   <p:cSld>
     <p:spTree>
@@ -12760,7 +12899,7 @@
 </p:sld>
 </file>
 
-<file path=ppt/slides/slide23.xml><?xml version="1.0" encoding="utf-8"?>
+<file path=ppt/slides/slide24.xml><?xml version="1.0" encoding="utf-8"?>
 <p:sld xmlns:a="http://schemas.openxmlformats.org/drawingml/2006/main" xmlns:r="http://schemas.openxmlformats.org/officeDocument/2006/relationships" xmlns:mc="http://schemas.openxmlformats.org/markup-compatibility/2006" xmlns:mv="urn:schemas-microsoft-com:mac:vml" xmlns:p="http://schemas.openxmlformats.org/presentationml/2006/main" xmlns:c="http://schemas.openxmlformats.org/drawingml/2006/chart" xmlns:dgm="http://schemas.openxmlformats.org/drawingml/2006/diagram" xmlns:o="urn:schemas-microsoft-com:office:office" xmlns:v="urn:schemas-microsoft-com:vml" xmlns:pvml="urn:schemas-microsoft-com:office:powerpoint" xmlns:com="http://schemas.openxmlformats.org/drawingml/2006/compatibility" xmlns:p14="http://schemas.microsoft.com/office/powerpoint/2010/main" xmlns:p15="http://schemas.microsoft.com/office/powerpoint/2012/main" xmlns:ahyp="http://schemas.microsoft.com/office/drawing/2018/hyperlinkcolor">
   <p:cSld>
     <p:spTree>
@@ -12915,7 +13054,7 @@
 </p:sld>
 </file>
 
-<file path=ppt/slides/slide24.xml><?xml version="1.0" encoding="utf-8"?>
+<file path=ppt/slides/slide25.xml><?xml version="1.0" encoding="utf-8"?>
 <p:sld xmlns:a="http://schemas.openxmlformats.org/drawingml/2006/main" xmlns:r="http://schemas.openxmlformats.org/officeDocument/2006/relationships" xmlns:mc="http://schemas.openxmlformats.org/markup-compatibility/2006" xmlns:mv="urn:schemas-microsoft-com:mac:vml" xmlns:p="http://schemas.openxmlformats.org/presentationml/2006/main" xmlns:c="http://schemas.openxmlformats.org/drawingml/2006/chart" xmlns:dgm="http://schemas.openxmlformats.org/drawingml/2006/diagram" xmlns:o="urn:schemas-microsoft-com:office:office" xmlns:v="urn:schemas-microsoft-com:vml" xmlns:pvml="urn:schemas-microsoft-com:office:powerpoint" xmlns:com="http://schemas.openxmlformats.org/drawingml/2006/compatibility" xmlns:p14="http://schemas.microsoft.com/office/powerpoint/2010/main" xmlns:p15="http://schemas.microsoft.com/office/powerpoint/2012/main" xmlns:ahyp="http://schemas.microsoft.com/office/drawing/2018/hyperlinkcolor">
   <p:cSld>
     <p:spTree>
@@ -13628,7 +13767,7 @@
 </p:sld>
 </file>
 
-<file path=ppt/slides/slide25.xml><?xml version="1.0" encoding="utf-8"?>
+<file path=ppt/slides/slide26.xml><?xml version="1.0" encoding="utf-8"?>
 <p:sld xmlns:a="http://schemas.openxmlformats.org/drawingml/2006/main" xmlns:r="http://schemas.openxmlformats.org/officeDocument/2006/relationships" xmlns:mc="http://schemas.openxmlformats.org/markup-compatibility/2006" xmlns:mv="urn:schemas-microsoft-com:mac:vml" xmlns:p="http://schemas.openxmlformats.org/presentationml/2006/main" xmlns:c="http://schemas.openxmlformats.org/drawingml/2006/chart" xmlns:dgm="http://schemas.openxmlformats.org/drawingml/2006/diagram" xmlns:o="urn:schemas-microsoft-com:office:office" xmlns:v="urn:schemas-microsoft-com:vml" xmlns:pvml="urn:schemas-microsoft-com:office:powerpoint" xmlns:com="http://schemas.openxmlformats.org/drawingml/2006/compatibility" xmlns:p14="http://schemas.microsoft.com/office/powerpoint/2010/main" xmlns:p15="http://schemas.microsoft.com/office/powerpoint/2012/main" xmlns:ahyp="http://schemas.microsoft.com/office/drawing/2018/hyperlinkcolor">
   <p:cSld>
     <p:spTree>
@@ -13783,7 +13922,7 @@
 </p:sld>
 </file>
 
-<file path=ppt/slides/slide26.xml><?xml version="1.0" encoding="utf-8"?>
+<file path=ppt/slides/slide27.xml><?xml version="1.0" encoding="utf-8"?>
 <p:sld xmlns:a="http://schemas.openxmlformats.org/drawingml/2006/main" xmlns:r="http://schemas.openxmlformats.org/officeDocument/2006/relationships" xmlns:mc="http://schemas.openxmlformats.org/markup-compatibility/2006" xmlns:mv="urn:schemas-microsoft-com:mac:vml" xmlns:p="http://schemas.openxmlformats.org/presentationml/2006/main" xmlns:c="http://schemas.openxmlformats.org/drawingml/2006/chart" xmlns:dgm="http://schemas.openxmlformats.org/drawingml/2006/diagram" xmlns:o="urn:schemas-microsoft-com:office:office" xmlns:v="urn:schemas-microsoft-com:vml" xmlns:pvml="urn:schemas-microsoft-com:office:powerpoint" xmlns:com="http://schemas.openxmlformats.org/drawingml/2006/compatibility" xmlns:p14="http://schemas.microsoft.com/office/powerpoint/2010/main" xmlns:p15="http://schemas.microsoft.com/office/powerpoint/2012/main" xmlns:ahyp="http://schemas.microsoft.com/office/drawing/2018/hyperlinkcolor">
   <p:cSld>
     <p:spTree>
@@ -13916,7 +14055,7 @@
 </p:sld>
 </file>
 
-<file path=ppt/slides/slide27.xml><?xml version="1.0" encoding="utf-8"?>
+<file path=ppt/slides/slide28.xml><?xml version="1.0" encoding="utf-8"?>
 <p:sld xmlns:a="http://schemas.openxmlformats.org/drawingml/2006/main" xmlns:r="http://schemas.openxmlformats.org/officeDocument/2006/relationships" xmlns:mc="http://schemas.openxmlformats.org/markup-compatibility/2006" xmlns:mv="urn:schemas-microsoft-com:mac:vml" xmlns:p="http://schemas.openxmlformats.org/presentationml/2006/main" xmlns:c="http://schemas.openxmlformats.org/drawingml/2006/chart" xmlns:dgm="http://schemas.openxmlformats.org/drawingml/2006/diagram" xmlns:o="urn:schemas-microsoft-com:office:office" xmlns:v="urn:schemas-microsoft-com:vml" xmlns:pvml="urn:schemas-microsoft-com:office:powerpoint" xmlns:com="http://schemas.openxmlformats.org/drawingml/2006/compatibility" xmlns:p14="http://schemas.microsoft.com/office/powerpoint/2010/main" xmlns:p15="http://schemas.microsoft.com/office/powerpoint/2012/main" xmlns:ahyp="http://schemas.microsoft.com/office/drawing/2018/hyperlinkcolor">
   <p:cSld>
     <p:spTree>
@@ -14049,7 +14188,7 @@
 </p:sld>
 </file>
 
-<file path=ppt/slides/slide28.xml><?xml version="1.0" encoding="utf-8"?>
+<file path=ppt/slides/slide29.xml><?xml version="1.0" encoding="utf-8"?>
 <p:sld xmlns:a="http://schemas.openxmlformats.org/drawingml/2006/main" xmlns:p="http://schemas.openxmlformats.org/presentationml/2006/main" xmlns:r="http://schemas.openxmlformats.org/officeDocument/2006/relationships">
   <p:cSld>
     <p:spTree>
@@ -14837,137 +14976,6 @@
               <a:cs typeface="Consolas"/>
               <a:sym typeface="Consolas"/>
             </a:endParaRPr>
-          </a:p>
-        </p:txBody>
-      </p:sp>
-    </p:spTree>
-  </p:cSld>
-  <p:clrMapOvr>
-    <a:masterClrMapping/>
-  </p:clrMapOvr>
-</p:sld>
-</file>
-
-<file path=ppt/slides/slide29.xml><?xml version="1.0" encoding="utf-8"?>
-<p:sld xmlns:a="http://schemas.openxmlformats.org/drawingml/2006/main" xmlns:r="http://schemas.openxmlformats.org/officeDocument/2006/relationships" xmlns:mc="http://schemas.openxmlformats.org/markup-compatibility/2006" xmlns:mv="urn:schemas-microsoft-com:mac:vml" xmlns:p="http://schemas.openxmlformats.org/presentationml/2006/main" xmlns:c="http://schemas.openxmlformats.org/drawingml/2006/chart" xmlns:dgm="http://schemas.openxmlformats.org/drawingml/2006/diagram" xmlns:o="urn:schemas-microsoft-com:office:office" xmlns:v="urn:schemas-microsoft-com:vml" xmlns:pvml="urn:schemas-microsoft-com:office:powerpoint" xmlns:com="http://schemas.openxmlformats.org/drawingml/2006/compatibility" xmlns:p14="http://schemas.microsoft.com/office/powerpoint/2010/main" xmlns:p15="http://schemas.microsoft.com/office/powerpoint/2012/main" xmlns:ahyp="http://schemas.microsoft.com/office/drawing/2018/hyperlinkcolor">
-  <p:cSld>
-    <p:spTree>
-      <p:nvGrpSpPr>
-        <p:cNvPr id="251" name="Shape 251"/>
-        <p:cNvGrpSpPr/>
-        <p:nvPr/>
-      </p:nvGrpSpPr>
-      <p:grpSpPr>
-        <a:xfrm>
-          <a:off x="0" y="0"/>
-          <a:ext cx="0" cy="0"/>
-          <a:chOff x="0" y="0"/>
-          <a:chExt cx="0" cy="0"/>
-        </a:xfrm>
-      </p:grpSpPr>
-      <p:sp>
-        <p:nvSpPr>
-          <p:cNvPr id="252" name="Google Shape;252;p43"/>
-          <p:cNvSpPr txBox="1"/>
-          <p:nvPr>
-            <p:ph type="title"/>
-          </p:nvPr>
-        </p:nvSpPr>
-        <p:spPr>
-          <a:xfrm>
-            <a:off x="311700" y="195615"/>
-            <a:ext cx="8520600" cy="572700"/>
-          </a:xfrm>
-          <a:prstGeom prst="rect">
-            <a:avLst/>
-          </a:prstGeom>
-        </p:spPr>
-        <p:txBody>
-          <a:bodyPr anchorCtr="0" anchor="t" bIns="91425" lIns="91425" spcFirstLastPara="1" rIns="91425" wrap="square" tIns="91425">
-            <a:normAutofit fontScale="90000"/>
-          </a:bodyPr>
-          <a:lstStyle/>
-          <a:p>
-            <a:pPr indent="0" lvl="0" marL="0" rtl="0" algn="l">
-              <a:spcBef>
-                <a:spcPts val="0"/>
-              </a:spcBef>
-              <a:spcAft>
-                <a:spcPts val="0"/>
-              </a:spcAft>
-              <a:buNone/>
-            </a:pPr>
-            <a:r>
-              <a:rPr lang="en">
-                <a:solidFill>
-                  <a:schemeClr val="accent5"/>
-                </a:solidFill>
-              </a:rPr>
-              <a:t>Pong 6: The Update Method</a:t>
-            </a:r>
-            <a:endParaRPr>
-              <a:solidFill>
-                <a:schemeClr val="accent5"/>
-              </a:solidFill>
-            </a:endParaRPr>
-          </a:p>
-        </p:txBody>
-      </p:sp>
-      <p:sp>
-        <p:nvSpPr>
-          <p:cNvPr id="253" name="Google Shape;253;p43"/>
-          <p:cNvSpPr txBox="1"/>
-          <p:nvPr>
-            <p:ph idx="1" type="body"/>
-          </p:nvPr>
-        </p:nvSpPr>
-        <p:spPr>
-          <a:xfrm>
-            <a:off x="311700" y="885950"/>
-            <a:ext cx="8520600" cy="905256"/>
-          </a:xfrm>
-          <a:prstGeom prst="rect">
-            <a:avLst/>
-          </a:prstGeom>
-        </p:spPr>
-        <p:txBody>
-          <a:bodyPr anchorCtr="0" anchor="t" bIns="91425" lIns="91425" spcFirstLastPara="1" rIns="91425" wrap="square" tIns="91425">
-            <a:normAutofit/>
-          </a:bodyPr>
-          <a:lstStyle/>
-          <a:p>
-            <a:pPr indent="-330200" lvl="0" marL="457200" rtl="0" algn="l">
-              <a:spcBef>
-                <a:spcPts val="0"/>
-              </a:spcBef>
-              <a:spcAft>
-                <a:spcPts val="0"/>
-              </a:spcAft>
-              <a:buSzPts val="1600"/>
-              <a:buChar char="●"/>
-            </a:pPr>
-            <a:r>
-              <a:rPr lang="en"/>
-              <a:t>Goal: Paddle and Ball classes, each with its own Update and Draw.</a:t>
-            </a:r>
-            <a:endParaRPr/>
-          </a:p>
-          <a:p>
-            <a:pPr indent="-330200" lvl="0" marL="457200" rtl="0" algn="l">
-              <a:spcBef>
-                <a:spcPts val="0"/>
-              </a:spcBef>
-              <a:spcAft>
-                <a:spcPts val="0"/>
-              </a:spcAft>
-              <a:buSzPts val="1600"/>
-              <a:buChar char="●"/>
-            </a:pPr>
-            <a:r>
-              <a:rPr lang="en"/>
-              <a:t>The game must behave as it did before.</a:t>
-            </a:r>
-            <a:endParaRPr/>
           </a:p>
         </p:txBody>
       </p:sp>
@@ -15073,6 +15081,137 @@
   <p:cSld>
     <p:spTree>
       <p:nvGrpSpPr>
+        <p:cNvPr id="251" name="Shape 251"/>
+        <p:cNvGrpSpPr/>
+        <p:nvPr/>
+      </p:nvGrpSpPr>
+      <p:grpSpPr>
+        <a:xfrm>
+          <a:off x="0" y="0"/>
+          <a:ext cx="0" cy="0"/>
+          <a:chOff x="0" y="0"/>
+          <a:chExt cx="0" cy="0"/>
+        </a:xfrm>
+      </p:grpSpPr>
+      <p:sp>
+        <p:nvSpPr>
+          <p:cNvPr id="252" name="Google Shape;252;p43"/>
+          <p:cNvSpPr txBox="1"/>
+          <p:nvPr>
+            <p:ph type="title"/>
+          </p:nvPr>
+        </p:nvSpPr>
+        <p:spPr>
+          <a:xfrm>
+            <a:off x="311700" y="195615"/>
+            <a:ext cx="8520600" cy="572700"/>
+          </a:xfrm>
+          <a:prstGeom prst="rect">
+            <a:avLst/>
+          </a:prstGeom>
+        </p:spPr>
+        <p:txBody>
+          <a:bodyPr anchorCtr="0" anchor="t" bIns="91425" lIns="91425" spcFirstLastPara="1" rIns="91425" wrap="square" tIns="91425">
+            <a:normAutofit fontScale="90000"/>
+          </a:bodyPr>
+          <a:lstStyle/>
+          <a:p>
+            <a:pPr indent="0" lvl="0" marL="0" rtl="0" algn="l">
+              <a:spcBef>
+                <a:spcPts val="0"/>
+              </a:spcBef>
+              <a:spcAft>
+                <a:spcPts val="0"/>
+              </a:spcAft>
+              <a:buNone/>
+            </a:pPr>
+            <a:r>
+              <a:rPr lang="en">
+                <a:solidFill>
+                  <a:schemeClr val="accent5"/>
+                </a:solidFill>
+              </a:rPr>
+              <a:t>Pong 6: The Update Method</a:t>
+            </a:r>
+            <a:endParaRPr>
+              <a:solidFill>
+                <a:schemeClr val="accent5"/>
+              </a:solidFill>
+            </a:endParaRPr>
+          </a:p>
+        </p:txBody>
+      </p:sp>
+      <p:sp>
+        <p:nvSpPr>
+          <p:cNvPr id="253" name="Google Shape;253;p43"/>
+          <p:cNvSpPr txBox="1"/>
+          <p:nvPr>
+            <p:ph idx="1" type="body"/>
+          </p:nvPr>
+        </p:nvSpPr>
+        <p:spPr>
+          <a:xfrm>
+            <a:off x="311700" y="885950"/>
+            <a:ext cx="8520600" cy="905256"/>
+          </a:xfrm>
+          <a:prstGeom prst="rect">
+            <a:avLst/>
+          </a:prstGeom>
+        </p:spPr>
+        <p:txBody>
+          <a:bodyPr anchorCtr="0" anchor="t" bIns="91425" lIns="91425" spcFirstLastPara="1" rIns="91425" wrap="square" tIns="91425">
+            <a:normAutofit/>
+          </a:bodyPr>
+          <a:lstStyle/>
+          <a:p>
+            <a:pPr indent="-330200" lvl="0" marL="457200" rtl="0" algn="l">
+              <a:spcBef>
+                <a:spcPts val="0"/>
+              </a:spcBef>
+              <a:spcAft>
+                <a:spcPts val="0"/>
+              </a:spcAft>
+              <a:buSzPts val="1600"/>
+              <a:buChar char="●"/>
+            </a:pPr>
+            <a:r>
+              <a:rPr lang="en"/>
+              <a:t>Goal: Paddle and Ball classes, each with its own Update and Draw.</a:t>
+            </a:r>
+            <a:endParaRPr/>
+          </a:p>
+          <a:p>
+            <a:pPr indent="-330200" lvl="0" marL="457200" rtl="0" algn="l">
+              <a:spcBef>
+                <a:spcPts val="0"/>
+              </a:spcBef>
+              <a:spcAft>
+                <a:spcPts val="0"/>
+              </a:spcAft>
+              <a:buSzPts val="1600"/>
+              <a:buChar char="●"/>
+            </a:pPr>
+            <a:r>
+              <a:rPr lang="en"/>
+              <a:t>The game must behave as it did before.</a:t>
+            </a:r>
+            <a:endParaRPr/>
+          </a:p>
+        </p:txBody>
+      </p:sp>
+    </p:spTree>
+  </p:cSld>
+  <p:clrMapOvr>
+    <a:masterClrMapping/>
+  </p:clrMapOvr>
+</p:sld>
+</file>
+
+<file path=ppt/slides/slide31.xml><?xml version="1.0" encoding="utf-8"?>
+<p:sld xmlns:a="http://schemas.openxmlformats.org/drawingml/2006/main" xmlns:r="http://schemas.openxmlformats.org/officeDocument/2006/relationships" xmlns:mc="http://schemas.openxmlformats.org/markup-compatibility/2006" xmlns:mv="urn:schemas-microsoft-com:mac:vml" xmlns:p="http://schemas.openxmlformats.org/presentationml/2006/main" xmlns:c="http://schemas.openxmlformats.org/drawingml/2006/chart" xmlns:dgm="http://schemas.openxmlformats.org/drawingml/2006/diagram" xmlns:o="urn:schemas-microsoft-com:office:office" xmlns:v="urn:schemas-microsoft-com:vml" xmlns:pvml="urn:schemas-microsoft-com:office:powerpoint" xmlns:com="http://schemas.openxmlformats.org/drawingml/2006/compatibility" xmlns:p14="http://schemas.microsoft.com/office/powerpoint/2010/main" xmlns:p15="http://schemas.microsoft.com/office/powerpoint/2012/main" xmlns:ahyp="http://schemas.microsoft.com/office/drawing/2018/hyperlinkcolor">
+  <p:cSld>
+    <p:spTree>
+      <p:nvGrpSpPr>
         <p:cNvPr id="257" name="Shape 257"/>
         <p:cNvGrpSpPr/>
         <p:nvPr/>
@@ -16361,7 +16500,7 @@
 </p:sld>
 </file>
 
-<file path=ppt/slides/slide31.xml><?xml version="1.0" encoding="utf-8"?>
+<file path=ppt/slides/slide32.xml><?xml version="1.0" encoding="utf-8"?>
 <p:sld xmlns:a="http://schemas.openxmlformats.org/drawingml/2006/main" xmlns:r="http://schemas.openxmlformats.org/officeDocument/2006/relationships" xmlns:mc="http://schemas.openxmlformats.org/markup-compatibility/2006" xmlns:mv="urn:schemas-microsoft-com:mac:vml" xmlns:p="http://schemas.openxmlformats.org/presentationml/2006/main" xmlns:c="http://schemas.openxmlformats.org/drawingml/2006/chart" xmlns:dgm="http://schemas.openxmlformats.org/drawingml/2006/diagram" xmlns:o="urn:schemas-microsoft-com:office:office" xmlns:v="urn:schemas-microsoft-com:vml" xmlns:pvml="urn:schemas-microsoft-com:office:powerpoint" xmlns:com="http://schemas.openxmlformats.org/drawingml/2006/compatibility" xmlns:p14="http://schemas.microsoft.com/office/powerpoint/2010/main" xmlns:p15="http://schemas.microsoft.com/office/powerpoint/2012/main" xmlns:ahyp="http://schemas.microsoft.com/office/drawing/2018/hyperlinkcolor">
   <p:cSld>
     <p:spTree>
@@ -16564,7 +16703,7 @@
                 </a:solidFill>
                 <a:latin typeface="Consolas"/>
               </a:rPr>
-              <a:t>float newY = offset / (paddle.Height / 2f) * 150;</a:t>
+              <a:t>float newY = offset / (paddle.Height / 2f) * 110;</a:t>
             </a:r>
           </a:p>
         </p:txBody>
@@ -16611,7 +16750,7 @@
 </p:sld>
 </file>
 
-<file path=ppt/slides/slide32.xml><?xml version="1.0" encoding="utf-8"?>
+<file path=ppt/slides/slide33.xml><?xml version="1.0" encoding="utf-8"?>
 <p:sld xmlns:a="http://schemas.openxmlformats.org/drawingml/2006/main" xmlns:r="http://schemas.openxmlformats.org/officeDocument/2006/relationships" xmlns:mc="http://schemas.openxmlformats.org/markup-compatibility/2006" xmlns:mv="urn:schemas-microsoft-com:mac:vml" xmlns:p="http://schemas.openxmlformats.org/presentationml/2006/main" xmlns:c="http://schemas.openxmlformats.org/drawingml/2006/chart" xmlns:dgm="http://schemas.openxmlformats.org/drawingml/2006/diagram" xmlns:o="urn:schemas-microsoft-com:office:office" xmlns:v="urn:schemas-microsoft-com:vml" xmlns:pvml="urn:schemas-microsoft-com:office:powerpoint" xmlns:com="http://schemas.openxmlformats.org/drawingml/2006/compatibility" xmlns:p14="http://schemas.microsoft.com/office/powerpoint/2010/main" xmlns:p15="http://schemas.microsoft.com/office/powerpoint/2012/main" xmlns:ahyp="http://schemas.microsoft.com/office/drawing/2018/hyperlinkcolor">
   <p:cSld>
     <p:spTree>
@@ -16762,7 +16901,7 @@
 </p:sld>
 </file>
 
-<file path=ppt/slides/slide33.xml><?xml version="1.0" encoding="utf-8"?>
+<file path=ppt/slides/slide34.xml><?xml version="1.0" encoding="utf-8"?>
 <p:sld xmlns:a="http://schemas.openxmlformats.org/drawingml/2006/main" xmlns:r="http://schemas.openxmlformats.org/officeDocument/2006/relationships" xmlns:mc="http://schemas.openxmlformats.org/markup-compatibility/2006" xmlns:mv="urn:schemas-microsoft-com:mac:vml" xmlns:p="http://schemas.openxmlformats.org/presentationml/2006/main" xmlns:c="http://schemas.openxmlformats.org/drawingml/2006/chart" xmlns:dgm="http://schemas.openxmlformats.org/drawingml/2006/diagram" xmlns:o="urn:schemas-microsoft-com:office:office" xmlns:v="urn:schemas-microsoft-com:vml" xmlns:pvml="urn:schemas-microsoft-com:office:powerpoint" xmlns:com="http://schemas.openxmlformats.org/drawingml/2006/compatibility" xmlns:p14="http://schemas.microsoft.com/office/powerpoint/2010/main" xmlns:p15="http://schemas.microsoft.com/office/powerpoint/2012/main" xmlns:ahyp="http://schemas.microsoft.com/office/drawing/2018/hyperlinkcolor">
   <p:cSld>
     <p:spTree>
@@ -17398,7 +17537,7 @@
 </p:sld>
 </file>
 
-<file path=ppt/slides/slide34.xml><?xml version="1.0" encoding="utf-8"?>
+<file path=ppt/slides/slide35.xml><?xml version="1.0" encoding="utf-8"?>
 <p:sld xmlns:a="http://schemas.openxmlformats.org/drawingml/2006/main" xmlns:p="http://schemas.openxmlformats.org/presentationml/2006/main" xmlns:r="http://schemas.openxmlformats.org/officeDocument/2006/relationships">
   <p:cSld>
     <p:spTree>
@@ -17537,7 +17676,7 @@
 </p:sld>
 </file>
 
-<file path=ppt/slides/slide35.xml><?xml version="1.0" encoding="utf-8"?>
+<file path=ppt/slides/slide36.xml><?xml version="1.0" encoding="utf-8"?>
 <p:sld xmlns:a="http://schemas.openxmlformats.org/drawingml/2006/main" xmlns:r="http://schemas.openxmlformats.org/officeDocument/2006/relationships" xmlns:mc="http://schemas.openxmlformats.org/markup-compatibility/2006" xmlns:mv="urn:schemas-microsoft-com:mac:vml" xmlns:p="http://schemas.openxmlformats.org/presentationml/2006/main" xmlns:c="http://schemas.openxmlformats.org/drawingml/2006/chart" xmlns:dgm="http://schemas.openxmlformats.org/drawingml/2006/diagram" xmlns:o="urn:schemas-microsoft-com:office:office" xmlns:v="urn:schemas-microsoft-com:vml" xmlns:pvml="urn:schemas-microsoft-com:office:powerpoint" xmlns:com="http://schemas.openxmlformats.org/drawingml/2006/compatibility" xmlns:p14="http://schemas.microsoft.com/office/powerpoint/2010/main" xmlns:p15="http://schemas.microsoft.com/office/powerpoint/2012/main" xmlns:ahyp="http://schemas.microsoft.com/office/drawing/2018/hyperlinkcolor">
   <p:cSld>
     <p:spTree>
@@ -17831,7 +17970,7 @@
 </p:sld>
 </file>
 
-<file path=ppt/slides/slide36.xml><?xml version="1.0" encoding="utf-8"?>
+<file path=ppt/slides/slide37.xml><?xml version="1.0" encoding="utf-8"?>
 <p:sld xmlns:a="http://schemas.openxmlformats.org/drawingml/2006/main" xmlns:r="http://schemas.openxmlformats.org/officeDocument/2006/relationships" xmlns:mc="http://schemas.openxmlformats.org/markup-compatibility/2006" xmlns:mv="urn:schemas-microsoft-com:mac:vml" xmlns:p="http://schemas.openxmlformats.org/presentationml/2006/main" xmlns:c="http://schemas.openxmlformats.org/drawingml/2006/chart" xmlns:dgm="http://schemas.openxmlformats.org/drawingml/2006/diagram" xmlns:o="urn:schemas-microsoft-com:office:office" xmlns:v="urn:schemas-microsoft-com:vml" xmlns:pvml="urn:schemas-microsoft-com:office:powerpoint" xmlns:com="http://schemas.openxmlformats.org/drawingml/2006/compatibility" xmlns:p14="http://schemas.microsoft.com/office/powerpoint/2010/main" xmlns:p15="http://schemas.microsoft.com/office/powerpoint/2012/main" xmlns:ahyp="http://schemas.microsoft.com/office/drawing/2018/hyperlinkcolor">
   <p:cSld>
     <p:spTree>
@@ -17983,7 +18122,7 @@
 </p:sld>
 </file>
 
-<file path=ppt/slides/slide37.xml><?xml version="1.0" encoding="utf-8"?>
+<file path=ppt/slides/slide38.xml><?xml version="1.0" encoding="utf-8"?>
 <p:sld xmlns:a="http://schemas.openxmlformats.org/drawingml/2006/main" xmlns:r="http://schemas.openxmlformats.org/officeDocument/2006/relationships" xmlns:mc="http://schemas.openxmlformats.org/markup-compatibility/2006" xmlns:mv="urn:schemas-microsoft-com:mac:vml" xmlns:p="http://schemas.openxmlformats.org/presentationml/2006/main" xmlns:c="http://schemas.openxmlformats.org/drawingml/2006/chart" xmlns:dgm="http://schemas.openxmlformats.org/drawingml/2006/diagram" xmlns:o="urn:schemas-microsoft-com:office:office" xmlns:v="urn:schemas-microsoft-com:vml" xmlns:pvml="urn:schemas-microsoft-com:office:powerpoint" xmlns:com="http://schemas.openxmlformats.org/drawingml/2006/compatibility" xmlns:p14="http://schemas.microsoft.com/office/powerpoint/2010/main" xmlns:p15="http://schemas.microsoft.com/office/powerpoint/2012/main" xmlns:ahyp="http://schemas.microsoft.com/office/drawing/2018/hyperlinkcolor">
   <p:cSld>
     <p:spTree>
@@ -18084,128 +18223,6 @@
             <a:r>
               <a:rPr lang="en"/>
               <a:t>Demo: Pong11: a sound for a paddle hit, a wall hit and a point</a:t>
-            </a:r>
-            <a:endParaRPr/>
-          </a:p>
-        </p:txBody>
-      </p:sp>
-    </p:spTree>
-  </p:cSld>
-  <p:clrMapOvr>
-    <a:masterClrMapping/>
-  </p:clrMapOvr>
-</p:sld>
-</file>
-
-<file path=ppt/slides/slide38.xml><?xml version="1.0" encoding="utf-8"?>
-<p:sld xmlns:a="http://schemas.openxmlformats.org/drawingml/2006/main" xmlns:p="http://schemas.openxmlformats.org/presentationml/2006/main" xmlns:r="http://schemas.openxmlformats.org/officeDocument/2006/relationships">
-  <p:cSld>
-    <p:spTree>
-      <p:nvGrpSpPr>
-        <p:cNvPr id="1" name=""/>
-        <p:cNvGrpSpPr/>
-        <p:nvPr/>
-      </p:nvGrpSpPr>
-      <p:grpSpPr/>
-      <p:sp>
-        <p:nvSpPr>
-          <p:cNvPr id="2" name="Title 1"/>
-          <p:cNvSpPr>
-            <a:spLocks noGrp="1"/>
-          </p:cNvSpPr>
-          <p:nvPr>
-            <p:ph type="title"/>
-          </p:nvPr>
-        </p:nvSpPr>
-        <p:spPr/>
-        <p:txBody>
-          <a:bodyPr/>
-          <a:lstStyle/>
-          <a:p>
-            <a:pPr indent="0" lvl="0" marL="0" rtl="0" algn="l">
-              <a:spcBef>
-                <a:spcPts val="0"/>
-              </a:spcBef>
-              <a:spcAft>
-                <a:spcPts val="0"/>
-              </a:spcAft>
-              <a:buNone/>
-            </a:pPr>
-            <a:r>
-              <a:rPr lang="en"/>
-              <a:t>Try It: Pitch With Speed</a:t>
-            </a:r>
-            <a:endParaRPr/>
-          </a:p>
-        </p:txBody>
-      </p:sp>
-      <p:sp>
-        <p:nvSpPr>
-          <p:cNvPr id="3" name="Text Placeholder 2"/>
-          <p:cNvSpPr>
-            <a:spLocks noGrp="1"/>
-          </p:cNvSpPr>
-          <p:nvPr>
-            <p:ph type="body" idx="1"/>
-          </p:nvPr>
-        </p:nvSpPr>
-        <p:spPr>
-          <a:xfrm>
-            <a:off x="311700" y="885950"/>
-            <a:ext cx="8520600" cy="1289304"/>
-          </a:xfrm>
-        </p:spPr>
-        <p:txBody>
-          <a:bodyPr/>
-          <a:lstStyle/>
-          <a:p>
-            <a:pPr indent="-330200" lvl="0" marL="457200" rtl="0" algn="l">
-              <a:spcBef>
-                <a:spcPts val="0"/>
-              </a:spcBef>
-              <a:spcAft>
-                <a:spcPts val="0"/>
-              </a:spcAft>
-              <a:buSzPts val="1600"/>
-              <a:buChar char="●"/>
-            </a:pPr>
-            <a:r>
-              <a:rPr lang="en"/>
-              <a:t>In Pong11:</a:t>
-            </a:r>
-            <a:endParaRPr/>
-          </a:p>
-          <a:p>
-            <a:pPr indent="-330200" lvl="0" marL="457200" rtl="0" algn="l">
-              <a:spcBef>
-                <a:spcPts val="0"/>
-              </a:spcBef>
-              <a:spcAft>
-                <a:spcPts val="0"/>
-              </a:spcAft>
-              <a:buSzPts val="1600"/>
-              <a:buChar char="●"/>
-            </a:pPr>
-            <a:r>
-              <a:rPr lang="en"/>
-              <a:t>Play takes a volume, a pitch and a pan</a:t>
-            </a:r>
-            <a:endParaRPr/>
-          </a:p>
-          <a:p>
-            <a:pPr indent="-330200" lvl="0" marL="457200" rtl="0" algn="l">
-              <a:spcBef>
-                <a:spcPts val="0"/>
-              </a:spcBef>
-              <a:spcAft>
-                <a:spcPts val="0"/>
-              </a:spcAft>
-              <a:buSzPts val="1600"/>
-              <a:buChar char="●"/>
-            </a:pPr>
-            <a:r>
-              <a:rPr lang="en"/>
-              <a:t>Raise the paddle sound’s pitch as the ball speeds up</a:t>
             </a:r>
             <a:endParaRPr/>
           </a:p>
@@ -18255,7 +18272,7 @@
             </a:pPr>
             <a:r>
               <a:rPr lang="en"/>
-              <a:t>Check Yourself</a:t>
+              <a:t>Try It: Pitch With Speed</a:t>
             </a:r>
             <a:endParaRPr/>
           </a:p>
@@ -18274,7 +18291,7 @@
         <p:spPr>
           <a:xfrm>
             <a:off x="311700" y="885950"/>
-            <a:ext cx="8520600" cy="1335024"/>
+            <a:ext cx="8520600" cy="1289304"/>
           </a:xfrm>
         </p:spPr>
         <p:txBody>
@@ -18293,7 +18310,7 @@
             </a:pPr>
             <a:r>
               <a:rPr lang="en"/>
-              <a:t>What is the difference between a game engine and a game framework?</a:t>
+              <a:t>In Pong11:</a:t>
             </a:r>
             <a:endParaRPr/>
           </a:p>
@@ -18310,7 +18327,7 @@
             </a:pPr>
             <a:r>
               <a:rPr lang="en"/>
-              <a:t>Why do we multiply movement by deltaTime?</a:t>
+              <a:t>Play takes a volume, a pitch and a pan</a:t>
             </a:r>
             <a:endParaRPr/>
           </a:p>
@@ -18327,43 +18344,9 @@
             </a:pPr>
             <a:r>
               <a:rPr lang="en"/>
-              <a:t>Why is a string field a fragile way to store game state?</a:t>
+              <a:t>Raise the paddle sound’s pitch as the ball speeds up</a:t>
             </a:r>
             <a:endParaRPr/>
-          </a:p>
-        </p:txBody>
-      </p:sp>
-      <p:sp>
-        <p:nvSpPr>
-          <p:cNvPr id="4" name="TextBox 3"/>
-          <p:cNvSpPr txBox="1"/>
-          <p:nvPr/>
-        </p:nvSpPr>
-        <p:spPr>
-          <a:xfrm>
-            <a:off x="457200" y="2798064"/>
-            <a:ext cx="8229600" cy="457200"/>
-          </a:xfrm>
-          <a:prstGeom prst="rect">
-            <a:avLst/>
-          </a:prstGeom>
-          <a:noFill/>
-        </p:spPr>
-        <p:txBody>
-          <a:bodyPr wrap="square">
-            <a:spAutoFit/>
-          </a:bodyPr>
-          <a:lstStyle/>
-          <a:p>
-            <a:pPr algn="ctr"/>
-            <a:r>
-              <a:rPr sz="1400" b="0" i="0">
-                <a:solidFill>
-                  <a:srgbClr val="9AA3AB"/>
-                </a:solidFill>
-              </a:rPr>
-              <a:t>The answers, and more questions, are on the course site.</a:t>
-            </a:r>
           </a:p>
         </p:txBody>
       </p:sp>
@@ -18646,133 +18629,139 @@
       <p:grpSpPr/>
       <p:sp>
         <p:nvSpPr>
-          <p:cNvPr id="76" name="Google Shape;76;p15"/>
-          <p:cNvSpPr txBox="1"/>
+          <p:cNvPr id="2" name="Title 1"/>
+          <p:cNvSpPr>
+            <a:spLocks noGrp="1"/>
+          </p:cNvSpPr>
           <p:nvPr>
             <p:ph type="title"/>
           </p:nvPr>
         </p:nvSpPr>
-        <p:spPr>
-          <a:xfrm>
-            <a:off x="311700" y="195615"/>
-            <a:ext cx="8520600" cy="572700"/>
+        <p:spPr/>
+        <p:txBody>
+          <a:bodyPr/>
+          <a:lstStyle/>
+          <a:p>
+            <a:pPr indent="0" lvl="0" marL="0" rtl="0" algn="l">
+              <a:spcBef>
+                <a:spcPts val="0"/>
+              </a:spcBef>
+              <a:spcAft>
+                <a:spcPts val="0"/>
+              </a:spcAft>
+              <a:buNone/>
+            </a:pPr>
+            <a:r>
+              <a:rPr lang="en"/>
+              <a:t>Check Yourself</a:t>
+            </a:r>
+            <a:endParaRPr/>
+          </a:p>
+        </p:txBody>
+      </p:sp>
+      <p:sp>
+        <p:nvSpPr>
+          <p:cNvPr id="3" name="Text Placeholder 2"/>
+          <p:cNvSpPr>
+            <a:spLocks noGrp="1"/>
+          </p:cNvSpPr>
+          <p:nvPr>
+            <p:ph type="body" idx="1"/>
+          </p:nvPr>
+        </p:nvSpPr>
+        <p:spPr>
+          <a:xfrm>
+            <a:off x="311700" y="885950"/>
+            <a:ext cx="8520600" cy="1335024"/>
+          </a:xfrm>
+        </p:spPr>
+        <p:txBody>
+          <a:bodyPr/>
+          <a:lstStyle/>
+          <a:p>
+            <a:pPr indent="-330200" lvl="0" marL="457200" rtl="0" algn="l">
+              <a:spcBef>
+                <a:spcPts val="0"/>
+              </a:spcBef>
+              <a:spcAft>
+                <a:spcPts val="0"/>
+              </a:spcAft>
+              <a:buSzPts val="1600"/>
+              <a:buChar char="●"/>
+            </a:pPr>
+            <a:r>
+              <a:rPr lang="en"/>
+              <a:t>What is the difference between a game engine and a game framework?</a:t>
+            </a:r>
+            <a:endParaRPr/>
+          </a:p>
+          <a:p>
+            <a:pPr indent="-330200" lvl="0" marL="457200" rtl="0" algn="l">
+              <a:spcBef>
+                <a:spcPts val="0"/>
+              </a:spcBef>
+              <a:spcAft>
+                <a:spcPts val="0"/>
+              </a:spcAft>
+              <a:buSzPts val="1600"/>
+              <a:buChar char="●"/>
+            </a:pPr>
+            <a:r>
+              <a:rPr lang="en"/>
+              <a:t>Why do we multiply movement by deltaTime?</a:t>
+            </a:r>
+            <a:endParaRPr/>
+          </a:p>
+          <a:p>
+            <a:pPr indent="-330200" lvl="0" marL="457200" rtl="0" algn="l">
+              <a:spcBef>
+                <a:spcPts val="0"/>
+              </a:spcBef>
+              <a:spcAft>
+                <a:spcPts val="0"/>
+              </a:spcAft>
+              <a:buSzPts val="1600"/>
+              <a:buChar char="●"/>
+            </a:pPr>
+            <a:r>
+              <a:rPr lang="en"/>
+              <a:t>Why is a string field a fragile way to store game state?</a:t>
+            </a:r>
+            <a:endParaRPr/>
+          </a:p>
+        </p:txBody>
+      </p:sp>
+      <p:sp>
+        <p:nvSpPr>
+          <p:cNvPr id="4" name="TextBox 3"/>
+          <p:cNvSpPr txBox="1"/>
+          <p:nvPr/>
+        </p:nvSpPr>
+        <p:spPr>
+          <a:xfrm>
+            <a:off x="457200" y="2798064"/>
+            <a:ext cx="8229600" cy="457200"/>
           </a:xfrm>
           <a:prstGeom prst="rect">
             <a:avLst/>
           </a:prstGeom>
+          <a:noFill/>
         </p:spPr>
         <p:txBody>
-          <a:bodyPr anchorCtr="0" anchor="t" bIns="91425" lIns="91425" spcFirstLastPara="1" rIns="91425" wrap="square" tIns="91425">
-            <a:normAutofit fontScale="90000"/>
+          <a:bodyPr wrap="square">
+            <a:spAutoFit/>
           </a:bodyPr>
           <a:lstStyle/>
           <a:p>
-            <a:pPr indent="0" lvl="0" marL="0" rtl="0" algn="l">
-              <a:spcBef>
-                <a:spcPts val="0"/>
-              </a:spcBef>
-              <a:spcAft>
-                <a:spcPts val="0"/>
-              </a:spcAft>
-              <a:buNone/>
-            </a:pPr>
-            <a:r>
-              <a:rPr lang="en"/>
-              <a:t>Apply It to Your Project</a:t>
-            </a:r>
-            <a:endParaRPr/>
-          </a:p>
-        </p:txBody>
-      </p:sp>
-      <p:sp>
-        <p:nvSpPr>
-          <p:cNvPr id="77" name="Google Shape;77;p15"/>
-          <p:cNvSpPr txBox="1"/>
-          <p:nvPr>
-            <p:ph idx="1" type="body"/>
-          </p:nvPr>
-        </p:nvSpPr>
-        <p:spPr>
-          <a:xfrm>
-            <a:off x="311700" y="885950"/>
-            <a:ext cx="8520600" cy="4023300"/>
-          </a:xfrm>
-          <a:prstGeom prst="rect">
-            <a:avLst/>
-          </a:prstGeom>
-        </p:spPr>
-        <p:txBody>
-          <a:bodyPr anchorCtr="0" anchor="t" bIns="91425" lIns="91425" spcFirstLastPara="1" rIns="91425" wrap="square" tIns="91425">
-            <a:normAutofit/>
-          </a:bodyPr>
-          <a:lstStyle/>
-          <a:p>
-            <a:pPr indent="-330200" lvl="0" marL="457200" rtl="0" algn="l">
-              <a:spcBef>
-                <a:spcPts val="0"/>
-              </a:spcBef>
-              <a:spcAft>
-                <a:spcPts val="0"/>
-              </a:spcAft>
-              <a:buSzPts val="1600"/>
-              <a:buChar char="●"/>
-            </a:pPr>
-            <a:r>
-              <a:rPr lang="en"/>
-              <a:t>Which games would you like to make? Pick two or three candidates</a:t>
-            </a:r>
-            <a:endParaRPr/>
-          </a:p>
-          <a:p>
-            <a:pPr indent="-330200" lvl="0" marL="457200" rtl="0" algn="l">
-              <a:spcBef>
-                <a:spcPts val="0"/>
-              </a:spcBef>
-              <a:spcAft>
-                <a:spcPts val="0"/>
-              </a:spcAft>
-              <a:buSzPts val="1600"/>
-              <a:buChar char="●"/>
-            </a:pPr>
-            <a:r>
-              <a:rPr lang="en"/>
-              <a:t>For each: what updates every frame, and what is drawn?</a:t>
-            </a:r>
-            <a:endParaRPr/>
-          </a:p>
-          <a:p>
-            <a:pPr indent="-317500" lvl="1" marL="914400" rtl="0" algn="l">
-              <a:spcBef>
-                <a:spcPts val="0"/>
-              </a:spcBef>
-              <a:spcAft>
-                <a:spcPts val="0"/>
-              </a:spcAft>
-              <a:buSzPts val="1400"/>
-              <a:buChar char="○"/>
-            </a:pPr>
-            <a:r>
-              <a:rPr lang="en"/>
-              <a:t>That’s its game loop</a:t>
-            </a:r>
-            <a:endParaRPr/>
-          </a:p>
-          <a:p>
-            <a:pPr indent="-330200" lvl="0" marL="457200" rtl="0" algn="l">
-              <a:spcBef>
-                <a:spcPts val="0"/>
-              </a:spcBef>
-              <a:spcAft>
-                <a:spcPts val="0"/>
-              </a:spcAft>
-              <a:buSzPts val="1600"/>
-              <a:buChar char="●"/>
-            </a:pPr>
-            <a:r>
-              <a:rPr lang="en"/>
-              <a:t>Could you build a naive prototype of the core idea first, like this Pong?</a:t>
-            </a:r>
-            <a:endParaRPr/>
+            <a:pPr algn="ctr"/>
+            <a:r>
+              <a:rPr sz="1400" b="0" i="0">
+                <a:solidFill>
+                  <a:srgbClr val="9AA3AB"/>
+                </a:solidFill>
+              </a:rPr>
+              <a:t>The answers, and more questions, are on the course site.</a:t>
+            </a:r>
           </a:p>
         </p:txBody>
       </p:sp>
@@ -18785,6 +18774,156 @@
 </file>
 
 <file path=ppt/slides/slide41.xml><?xml version="1.0" encoding="utf-8"?>
+<p:sld xmlns:a="http://schemas.openxmlformats.org/drawingml/2006/main" xmlns:p="http://schemas.openxmlformats.org/presentationml/2006/main" xmlns:r="http://schemas.openxmlformats.org/officeDocument/2006/relationships">
+  <p:cSld>
+    <p:spTree>
+      <p:nvGrpSpPr>
+        <p:cNvPr id="1" name=""/>
+        <p:cNvGrpSpPr/>
+        <p:nvPr/>
+      </p:nvGrpSpPr>
+      <p:grpSpPr/>
+      <p:sp>
+        <p:nvSpPr>
+          <p:cNvPr id="76" name="Google Shape;76;p15"/>
+          <p:cNvSpPr txBox="1"/>
+          <p:nvPr>
+            <p:ph type="title"/>
+          </p:nvPr>
+        </p:nvSpPr>
+        <p:spPr>
+          <a:xfrm>
+            <a:off x="311700" y="195615"/>
+            <a:ext cx="8520600" cy="572700"/>
+          </a:xfrm>
+          <a:prstGeom prst="rect">
+            <a:avLst/>
+          </a:prstGeom>
+        </p:spPr>
+        <p:txBody>
+          <a:bodyPr anchorCtr="0" anchor="t" bIns="91425" lIns="91425" spcFirstLastPara="1" rIns="91425" wrap="square" tIns="91425">
+            <a:normAutofit fontScale="90000"/>
+          </a:bodyPr>
+          <a:lstStyle/>
+          <a:p>
+            <a:pPr indent="0" lvl="0" marL="0" rtl="0" algn="l">
+              <a:spcBef>
+                <a:spcPts val="0"/>
+              </a:spcBef>
+              <a:spcAft>
+                <a:spcPts val="0"/>
+              </a:spcAft>
+              <a:buNone/>
+            </a:pPr>
+            <a:r>
+              <a:rPr lang="en"/>
+              <a:t>Apply It to Your Project</a:t>
+            </a:r>
+            <a:endParaRPr/>
+          </a:p>
+        </p:txBody>
+      </p:sp>
+      <p:sp>
+        <p:nvSpPr>
+          <p:cNvPr id="77" name="Google Shape;77;p15"/>
+          <p:cNvSpPr txBox="1"/>
+          <p:nvPr>
+            <p:ph idx="1" type="body"/>
+          </p:nvPr>
+        </p:nvSpPr>
+        <p:spPr>
+          <a:xfrm>
+            <a:off x="311700" y="885950"/>
+            <a:ext cx="8520600" cy="4023300"/>
+          </a:xfrm>
+          <a:prstGeom prst="rect">
+            <a:avLst/>
+          </a:prstGeom>
+        </p:spPr>
+        <p:txBody>
+          <a:bodyPr anchorCtr="0" anchor="t" bIns="91425" lIns="91425" spcFirstLastPara="1" rIns="91425" wrap="square" tIns="91425">
+            <a:normAutofit/>
+          </a:bodyPr>
+          <a:lstStyle/>
+          <a:p>
+            <a:pPr indent="-330200" lvl="0" marL="457200" rtl="0" algn="l">
+              <a:spcBef>
+                <a:spcPts val="0"/>
+              </a:spcBef>
+              <a:spcAft>
+                <a:spcPts val="0"/>
+              </a:spcAft>
+              <a:buSzPts val="1600"/>
+              <a:buChar char="●"/>
+            </a:pPr>
+            <a:r>
+              <a:rPr lang="en"/>
+              <a:t>Which games would you like to make? Pick two or three candidates</a:t>
+            </a:r>
+            <a:endParaRPr/>
+          </a:p>
+          <a:p>
+            <a:pPr indent="-330200" lvl="0" marL="457200" rtl="0" algn="l">
+              <a:spcBef>
+                <a:spcPts val="0"/>
+              </a:spcBef>
+              <a:spcAft>
+                <a:spcPts val="0"/>
+              </a:spcAft>
+              <a:buSzPts val="1600"/>
+              <a:buChar char="●"/>
+            </a:pPr>
+            <a:r>
+              <a:rPr lang="en"/>
+              <a:t>For each: what updates every frame, and what is drawn?</a:t>
+            </a:r>
+            <a:endParaRPr/>
+          </a:p>
+          <a:p>
+            <a:pPr indent="-317500" lvl="1" marL="914400" rtl="0" algn="l">
+              <a:spcBef>
+                <a:spcPts val="0"/>
+              </a:spcBef>
+              <a:spcAft>
+                <a:spcPts val="0"/>
+              </a:spcAft>
+              <a:buSzPts val="1400"/>
+              <a:buChar char="○"/>
+            </a:pPr>
+            <a:r>
+              <a:rPr lang="en"/>
+              <a:t>That’s its game loop</a:t>
+            </a:r>
+            <a:endParaRPr/>
+          </a:p>
+          <a:p>
+            <a:pPr indent="-330200" lvl="0" marL="457200" rtl="0" algn="l">
+              <a:spcBef>
+                <a:spcPts val="0"/>
+              </a:spcBef>
+              <a:spcAft>
+                <a:spcPts val="0"/>
+              </a:spcAft>
+              <a:buSzPts val="1600"/>
+              <a:buChar char="●"/>
+            </a:pPr>
+            <a:r>
+              <a:rPr lang="en"/>
+              <a:t>Could you build a naive prototype of the core idea first, like this Pong?</a:t>
+            </a:r>
+            <a:endParaRPr/>
+          </a:p>
+        </p:txBody>
+      </p:sp>
+    </p:spTree>
+  </p:cSld>
+  <p:clrMapOvr>
+    <a:masterClrMapping/>
+  </p:clrMapOvr>
+</p:sld>
+</file>
+
+<file path=ppt/slides/slide42.xml><?xml version="1.0" encoding="utf-8"?>
 <p:sld xmlns:a="http://schemas.openxmlformats.org/drawingml/2006/main" xmlns:r="http://schemas.openxmlformats.org/officeDocument/2006/relationships" xmlns:mc="http://schemas.openxmlformats.org/markup-compatibility/2006" xmlns:mv="urn:schemas-microsoft-com:mac:vml" xmlns:p="http://schemas.openxmlformats.org/presentationml/2006/main" xmlns:c="http://schemas.openxmlformats.org/drawingml/2006/chart" xmlns:dgm="http://schemas.openxmlformats.org/drawingml/2006/diagram" xmlns:o="urn:schemas-microsoft-com:office:office" xmlns:v="urn:schemas-microsoft-com:vml" xmlns:pvml="urn:schemas-microsoft-com:office:powerpoint" xmlns:com="http://schemas.openxmlformats.org/drawingml/2006/compatibility" xmlns:p14="http://schemas.microsoft.com/office/powerpoint/2010/main" xmlns:p15="http://schemas.microsoft.com/office/powerpoint/2012/main" xmlns:ahyp="http://schemas.microsoft.com/office/drawing/2018/hyperlinkcolor">
   <p:cSld>
     <p:spTree>
@@ -18909,145 +19048,6 @@
           </a:ln>
         </p:spPr>
       </p:pic>
-    </p:spTree>
-  </p:cSld>
-  <p:clrMapOvr>
-    <a:masterClrMapping/>
-  </p:clrMapOvr>
-</p:sld>
-</file>
-
-<file path=ppt/slides/slide42.xml><?xml version="1.0" encoding="utf-8"?>
-<p:sld xmlns:a="http://schemas.openxmlformats.org/drawingml/2006/main" xmlns:p="http://schemas.openxmlformats.org/presentationml/2006/main" xmlns:r="http://schemas.openxmlformats.org/officeDocument/2006/relationships">
-  <p:cSld>
-    <p:spTree>
-      <p:nvGrpSpPr>
-        <p:cNvPr id="1" name=""/>
-        <p:cNvGrpSpPr/>
-        <p:nvPr/>
-      </p:nvGrpSpPr>
-      <p:grpSpPr/>
-      <p:sp>
-        <p:nvSpPr>
-          <p:cNvPr id="2" name="Title 1"/>
-          <p:cNvSpPr>
-            <a:spLocks noGrp="1"/>
-          </p:cNvSpPr>
-          <p:nvPr>
-            <p:ph type="title"/>
-          </p:nvPr>
-        </p:nvSpPr>
-        <p:spPr/>
-        <p:txBody>
-          <a:bodyPr/>
-          <a:lstStyle/>
-          <a:p>
-            <a:pPr indent="0" lvl="0" marL="0" rtl="0" algn="l">
-              <a:spcBef>
-                <a:spcPts val="0"/>
-              </a:spcBef>
-              <a:spcAft>
-                <a:spcPts val="0"/>
-              </a:spcAft>
-              <a:buNone/>
-            </a:pPr>
-            <a:r>
-              <a:rPr lang="en"/>
-              <a:t>Try It: Resize the Window</a:t>
-            </a:r>
-            <a:endParaRPr/>
-          </a:p>
-        </p:txBody>
-      </p:sp>
-      <p:sp>
-        <p:nvSpPr>
-          <p:cNvPr id="3" name="Text Placeholder 2"/>
-          <p:cNvSpPr>
-            <a:spLocks noGrp="1"/>
-          </p:cNvSpPr>
-          <p:nvPr>
-            <p:ph type="body" idx="1"/>
-          </p:nvPr>
-        </p:nvSpPr>
-        <p:spPr>
-          <a:xfrm>
-            <a:off x="311700" y="885950"/>
-            <a:ext cx="8520600" cy="1673352"/>
-          </a:xfrm>
-        </p:spPr>
-        <p:txBody>
-          <a:bodyPr/>
-          <a:lstStyle/>
-          <a:p>
-            <a:pPr indent="-330200" lvl="0" marL="457200" rtl="0" algn="l">
-              <a:spcBef>
-                <a:spcPts val="0"/>
-              </a:spcBef>
-              <a:spcAft>
-                <a:spcPts val="0"/>
-              </a:spcAft>
-              <a:buSzPts val="1600"/>
-              <a:buChar char="●"/>
-            </a:pPr>
-            <a:r>
-              <a:rPr lang="en" b="1"/>
-              <a:t>In Pong2:</a:t>
-            </a:r>
-            <a:endParaRPr/>
-          </a:p>
-          <a:p>
-            <a:pPr indent="-330200" lvl="0" marL="457200" rtl="0" algn="l">
-              <a:spcBef>
-                <a:spcPts val="0"/>
-              </a:spcBef>
-              <a:spcAft>
-                <a:spcPts val="0"/>
-              </a:spcAft>
-              <a:buSzPts val="1600"/>
-              <a:buChar char="●"/>
-            </a:pPr>
-            <a:r>
-              <a:rPr lang="en" b="1"/>
-              <a:t>Drag the window wide, then tall. Where do the bars go?</a:t>
-            </a:r>
-            <a:endParaRPr/>
-          </a:p>
-          <a:p>
-            <a:pPr indent="-330200" lvl="0" marL="457200" rtl="0" algn="l">
-              <a:spcBef>
-                <a:spcPts val="0"/>
-              </a:spcBef>
-              <a:spcAft>
-                <a:spcPts val="0"/>
-              </a:spcAft>
-              <a:buSzPts val="1600"/>
-              <a:buChar char="●"/>
-            </a:pPr>
-            <a:r>
-              <a:rPr lang="en" b="1"/>
-              <a:t>Swap PointClamp for LinearClamp</a:t>
-            </a:r>
-            <a:endParaRPr/>
-          </a:p>
-          <a:p>
-            <a:pPr indent="-330200" lvl="0" marL="457200" rtl="0" algn="l">
-              <a:spcBef>
-                <a:spcPts val="0"/>
-              </a:spcBef>
-              <a:spcAft>
-                <a:spcPts val="0"/>
-              </a:spcAft>
-              <a:buSzPts val="1600"/>
-              <a:buChar char="●"/>
-            </a:pPr>
-            <a:r>
-              <a:rPr lang="en" b="1"/>
-              <a:t>Set the virtual size to 640 × 360. What happens to the text?</a:t>
-            </a:r>
-            <a:endParaRPr/>
-          </a:p>
-        </p:txBody>
-      </p:sp>
     </p:spTree>
   </p:cSld>
   <p:clrMapOvr>

</xml_diff>

<commit_message>
Pong: six concept figures, on the page and on the slides
Our own drawings for the coordinate system, virtual resolution, delta time,
fixed and variable timesteps, AABB overlap and the paddle bounce, plus a state
diagram for the game's modes. tools/figures draws them: one SVG per figure for
the site, and a PNG for the decks.

Co-Authored-By: Claude Opus 5.5 <noreply@anthropic.com>
Claude-Session: https://claude.ai/code/session_012sjsUQBbC7zon57rWHoo9d
</commit_message>
<xml_diff>
--- a/slides/01 Pong.pptx
+++ b/slides/01 Pong.pptx
@@ -8871,222 +8871,36 @@
             </a:pPr>
             <a:r>
               <a:rPr lang="en"/>
-              <a:t>Variable: one update per frame, scaled by delta time. Fixed: always the same step.</a:t>
+              <a:t>Variable: one update per frame. Fixed: equal steps (MonoGame’s default).</a:t>
             </a:r>
             <a:endParaRPr/>
           </a:p>
         </p:txBody>
       </p:sp>
-      <p:sp>
-        <p:nvSpPr>
-          <p:cNvPr id="301" name="Rounded Rectangle 300"/>
-          <p:cNvSpPr/>
+      <p:pic>
+        <p:nvPicPr>
+          <p:cNvPr id="304" name="Picture 303" descr="timestep.png"/>
+          <p:cNvPicPr>
+            <a:picLocks noChangeAspect="1"/>
+          </p:cNvPicPr>
           <p:nvPr/>
-        </p:nvSpPr>
-        <p:spPr>
-          <a:xfrm>
-            <a:off x="548640" y="1463040"/>
-            <a:ext cx="3749039" cy="1463040"/>
-          </a:xfrm>
-          <a:prstGeom prst="roundRect">
-            <a:avLst>
-              <a:gd name="adj" fmla="val 12000"/>
-            </a:avLst>
-          </a:prstGeom>
-          <a:solidFill>
-            <a:srgbClr val="2E3338"/>
-          </a:solidFill>
-          <a:ln>
-            <a:noFill/>
-          </a:ln>
-          <a:effectLst/>
-        </p:spPr>
-        <p:style>
-          <a:lnRef idx="1">
-            <a:schemeClr val="accent1"/>
-          </a:lnRef>
-          <a:fillRef idx="3">
-            <a:schemeClr val="accent1"/>
-          </a:fillRef>
-          <a:effectRef idx="2">
-            <a:schemeClr val="accent1"/>
-          </a:effectRef>
-          <a:fontRef idx="minor">
-            <a:schemeClr val="lt1"/>
-          </a:fontRef>
-        </p:style>
-        <p:txBody>
-          <a:bodyPr rtlCol="0" anchor="ctr" wrap="square" lIns="73152" rIns="73152"/>
-          <a:lstStyle/>
-          <a:p>
-            <a:pPr algn="ctr"/>
-            <a:r>
-              <a:rPr sz="1600" b="1">
-                <a:solidFill>
-                  <a:srgbClr val="DEE2E6"/>
-                </a:solidFill>
-              </a:rPr>
-              <a:t>Variable timestep</a:t>
-            </a:r>
-          </a:p>
-          <a:p>
-            <a:pPr algn="ctr"/>
-            <a:r>
-              <a:rPr sz="1400" b="0">
-                <a:solidFill>
-                  <a:srgbClr val="9AA3AB"/>
-                </a:solidFill>
-              </a:rPr>
-              <a:t>one Update per frame, × deltaTime</a:t>
-            </a:r>
-          </a:p>
-          <a:p>
-            <a:pPr algn="ctr"/>
-            <a:r>
-              <a:rPr sz="1400" b="0">
-                <a:solidFill>
-                  <a:srgbClr val="9AA3AB"/>
-                </a:solidFill>
-              </a:rPr>
-              <a:t>simple, but slightly different</a:t>
-            </a:r>
-          </a:p>
-          <a:p>
-            <a:pPr algn="ctr"/>
-            <a:r>
-              <a:rPr sz="1400" b="0">
-                <a:solidFill>
-                  <a:srgbClr val="9AA3AB"/>
-                </a:solidFill>
-              </a:rPr>
-              <a:t>at every frame rate</a:t>
-            </a:r>
-          </a:p>
-        </p:txBody>
-      </p:sp>
-      <p:sp>
-        <p:nvSpPr>
-          <p:cNvPr id="302" name="Rounded Rectangle 301"/>
-          <p:cNvSpPr/>
-          <p:nvPr/>
-        </p:nvSpPr>
-        <p:spPr>
-          <a:xfrm>
-            <a:off x="4846320" y="1463040"/>
-            <a:ext cx="3749039" cy="1463040"/>
-          </a:xfrm>
-          <a:prstGeom prst="roundRect">
-            <a:avLst>
-              <a:gd name="adj" fmla="val 12000"/>
-            </a:avLst>
-          </a:prstGeom>
-          <a:solidFill>
-            <a:srgbClr val="2E3338"/>
-          </a:solidFill>
-          <a:ln w="25400">
-            <a:solidFill>
-              <a:srgbClr val="D45D35"/>
-            </a:solidFill>
-          </a:ln>
-          <a:effectLst/>
-        </p:spPr>
-        <p:style>
-          <a:lnRef idx="1">
-            <a:schemeClr val="accent1"/>
-          </a:lnRef>
-          <a:fillRef idx="3">
-            <a:schemeClr val="accent1"/>
-          </a:fillRef>
-          <a:effectRef idx="2">
-            <a:schemeClr val="accent1"/>
-          </a:effectRef>
-          <a:fontRef idx="minor">
-            <a:schemeClr val="lt1"/>
-          </a:fontRef>
-        </p:style>
-        <p:txBody>
-          <a:bodyPr rtlCol="0" anchor="ctr" wrap="square" lIns="73152" rIns="73152"/>
-          <a:lstStyle/>
-          <a:p>
-            <a:pPr algn="ctr"/>
-            <a:r>
-              <a:rPr sz="1600" b="1">
-                <a:solidFill>
-                  <a:srgbClr val="DEE2E6"/>
-                </a:solidFill>
-              </a:rPr>
-              <a:t>Fixed timestep</a:t>
-            </a:r>
-          </a:p>
-          <a:p>
-            <a:pPr algn="ctr"/>
-            <a:r>
-              <a:rPr sz="1400" b="0">
-                <a:solidFill>
-                  <a:srgbClr val="9AA3AB"/>
-                </a:solidFill>
-              </a:rPr>
-              <a:t>0, 1 or more Updates per frame</a:t>
-            </a:r>
-          </a:p>
-          <a:p>
-            <a:pPr algn="ctr"/>
-            <a:r>
-              <a:rPr sz="1400" b="0">
-                <a:solidFill>
-                  <a:srgbClr val="9AA3AB"/>
-                </a:solidFill>
-              </a:rPr>
-              <a:t>deterministic and stable,</a:t>
-            </a:r>
-          </a:p>
-          <a:p>
-            <a:pPr algn="ctr"/>
-            <a:r>
-              <a:rPr sz="1400" b="0">
-                <a:solidFill>
-                  <a:srgbClr val="9AA3AB"/>
-                </a:solidFill>
-              </a:rPr>
-              <a:t>a little more complex</a:t>
-            </a:r>
-          </a:p>
-        </p:txBody>
-      </p:sp>
-      <p:sp>
-        <p:nvSpPr>
-          <p:cNvPr id="303" name="TextBox 302"/>
-          <p:cNvSpPr txBox="1"/>
-          <p:nvPr/>
-        </p:nvSpPr>
-        <p:spPr>
-          <a:xfrm>
-            <a:off x="548640" y="3108960"/>
-            <a:ext cx="8046720" cy="731520"/>
+        </p:nvPicPr>
+        <p:blipFill>
+          <a:blip r:embed="rId3"/>
+          <a:stretch>
+            <a:fillRect/>
+          </a:stretch>
+        </p:blipFill>
+        <p:spPr>
+          <a:xfrm>
+            <a:off x="640080" y="1325880"/>
+            <a:ext cx="7863840" cy="3713480"/>
           </a:xfrm>
           <a:prstGeom prst="rect">
             <a:avLst/>
           </a:prstGeom>
-          <a:noFill/>
-        </p:spPr>
-        <p:txBody>
-          <a:bodyPr wrap="square">
-            <a:spAutoFit/>
-          </a:bodyPr>
-          <a:lstStyle/>
-          <a:p>
-            <a:pPr algn="ctr"/>
-            <a:r>
-              <a:rPr sz="1400" b="0" i="0">
-                <a:solidFill>
-                  <a:srgbClr val="9AA3AB"/>
-                </a:solidFill>
-              </a:rPr>
-              <a:t>MonoGame is fixed by default: IsFixedTimeStep = true.</a:t>
-            </a:r>
-          </a:p>
-        </p:txBody>
-      </p:sp>
+        </p:spPr>
+      </p:pic>
     </p:spTree>
   </p:cSld>
   <p:clrMapOvr>
@@ -10162,22 +9976,22 @@
       </p:sp>
       <p:pic>
         <p:nvPicPr>
-          <p:cNvPr id="181" name="Picture 181" descr="p2.png"/>
+          <p:cNvPr id="181" name="Picture 180" descr="virtual-resolution.png"/>
           <p:cNvPicPr>
             <a:picLocks noChangeAspect="1"/>
           </p:cNvPicPr>
           <p:nvPr/>
         </p:nvPicPr>
         <p:blipFill>
-          <a:blip r:embed="rId4"/>
+          <a:blip r:embed="rId3"/>
           <a:stretch>
             <a:fillRect/>
           </a:stretch>
         </p:blipFill>
         <p:spPr>
           <a:xfrm>
-            <a:off x="2541213" y="2429008"/>
-            <a:ext cx="4061575" cy="2284635"/>
+            <a:off x="1188720" y="1691640"/>
+            <a:ext cx="6766560" cy="3383280"/>
           </a:xfrm>
           <a:prstGeom prst="rect">
             <a:avLst/>
@@ -10430,30 +10244,26 @@
       </p:sp>
       <p:pic>
         <p:nvPicPr>
-          <p:cNvPr id="188" name="Google Shape;188;p33"/>
-          <p:cNvPicPr preferRelativeResize="0"/>
+          <p:cNvPr id="188" name="Picture 187" descr="coordinates.png"/>
+          <p:cNvPicPr>
+            <a:picLocks noChangeAspect="1"/>
+          </p:cNvPicPr>
           <p:nvPr/>
         </p:nvPicPr>
         <p:blipFill>
-          <a:blip r:embed="rId3">
-            <a:alphaModFix/>
-          </a:blip>
+          <a:blip r:embed="rId4"/>
           <a:stretch>
             <a:fillRect/>
           </a:stretch>
         </p:blipFill>
         <p:spPr>
           <a:xfrm>
-            <a:off x="2505075" y="1731955"/>
-            <a:ext cx="4133850" cy="2171700"/>
+            <a:off x="1188720" y="1097280"/>
+            <a:ext cx="6766560" cy="3853180"/>
           </a:xfrm>
           <a:prstGeom prst="rect">
             <a:avLst/>
           </a:prstGeom>
-          <a:noFill/>
-          <a:ln>
-            <a:noFill/>
-          </a:ln>
         </p:spPr>
       </p:pic>
     </p:spTree>
@@ -12666,7 +12476,7 @@
         <p:spPr>
           <a:xfrm>
             <a:off x="311700" y="885950"/>
-            <a:ext cx="8520600" cy="4023300"/>
+            <a:ext cx="8520600" cy="548640"/>
           </a:xfrm>
           <a:prstGeom prst="rect">
             <a:avLst/>
@@ -12694,203 +12504,32 @@
             </a:r>
             <a:endParaRPr/>
           </a:p>
-          <a:p>
-            <a:pPr indent="0" lvl="0" marL="0" rtl="0" algn="l">
-              <a:lnSpc>
-                <a:spcPct val="157500"/>
-              </a:lnSpc>
-              <a:spcBef>
-                <a:spcPts val="1200"/>
-              </a:spcBef>
-              <a:spcAft>
-                <a:spcPts val="0"/>
-              </a:spcAft>
-              <a:buNone/>
-            </a:pPr>
-            <a:r>
-              <a:rPr lang="en" sz="1000">
-                <a:solidFill>
-                  <a:srgbClr val="CCCCCC"/>
-                </a:solidFill>
-                <a:highlight>
-                  <a:srgbClr val="1F1F1F"/>
-                </a:highlight>
-                <a:latin typeface="Consolas"/>
-                <a:ea typeface="Consolas"/>
-                <a:cs typeface="Consolas"/>
-                <a:sym typeface="Consolas"/>
-              </a:rPr>
-              <a:t>(</a:t>
-            </a:r>
-            <a:r>
-              <a:rPr lang="en" sz="1000">
-                <a:solidFill>
-                  <a:srgbClr val="569CD6"/>
-                </a:solidFill>
-                <a:highlight>
-                  <a:srgbClr val="1F1F1F"/>
-                </a:highlight>
-                <a:latin typeface="Consolas"/>
-                <a:ea typeface="Consolas"/>
-                <a:cs typeface="Consolas"/>
-                <a:sym typeface="Consolas"/>
-              </a:rPr>
-              <a:t>float</a:t>
-            </a:r>
-            <a:r>
-              <a:rPr lang="en" sz="1000">
-                <a:solidFill>
-                  <a:srgbClr val="CCCCCC"/>
-                </a:solidFill>
-                <a:highlight>
-                  <a:srgbClr val="1F1F1F"/>
-                </a:highlight>
-                <a:latin typeface="Consolas"/>
-                <a:ea typeface="Consolas"/>
-                <a:cs typeface="Consolas"/>
-                <a:sym typeface="Consolas"/>
-              </a:rPr>
-              <a:t>)</a:t>
-            </a:r>
-            <a:r>
-              <a:rPr lang="en" sz="1000">
-                <a:solidFill>
-                  <a:srgbClr val="9CDCFE"/>
-                </a:solidFill>
-                <a:highlight>
-                  <a:srgbClr val="1F1F1F"/>
-                </a:highlight>
-                <a:latin typeface="Consolas"/>
-                <a:ea typeface="Consolas"/>
-                <a:cs typeface="Consolas"/>
-                <a:sym typeface="Consolas"/>
-              </a:rPr>
-              <a:t>gameTime</a:t>
-            </a:r>
-            <a:r>
-              <a:rPr lang="en" sz="1000">
-                <a:solidFill>
-                  <a:srgbClr val="D4D4D4"/>
-                </a:solidFill>
-                <a:highlight>
-                  <a:srgbClr val="1F1F1F"/>
-                </a:highlight>
-                <a:latin typeface="Consolas"/>
-                <a:ea typeface="Consolas"/>
-                <a:cs typeface="Consolas"/>
-                <a:sym typeface="Consolas"/>
-              </a:rPr>
-              <a:t>.</a:t>
-            </a:r>
-            <a:r>
-              <a:rPr lang="en" sz="1000">
-                <a:solidFill>
-                  <a:srgbClr val="9CDCFE"/>
-                </a:solidFill>
-                <a:highlight>
-                  <a:srgbClr val="1F1F1F"/>
-                </a:highlight>
-                <a:latin typeface="Consolas"/>
-                <a:ea typeface="Consolas"/>
-                <a:cs typeface="Consolas"/>
-                <a:sym typeface="Consolas"/>
-              </a:rPr>
-              <a:t>ElapsedGameTime</a:t>
-            </a:r>
-            <a:r>
-              <a:rPr lang="en" sz="1000">
-                <a:solidFill>
-                  <a:srgbClr val="D4D4D4"/>
-                </a:solidFill>
-                <a:highlight>
-                  <a:srgbClr val="1F1F1F"/>
-                </a:highlight>
-                <a:latin typeface="Consolas"/>
-                <a:ea typeface="Consolas"/>
-                <a:cs typeface="Consolas"/>
-                <a:sym typeface="Consolas"/>
-              </a:rPr>
-              <a:t>.</a:t>
-            </a:r>
-            <a:r>
-              <a:rPr lang="en" sz="1000">
-                <a:solidFill>
-                  <a:srgbClr val="9CDCFE"/>
-                </a:solidFill>
-                <a:highlight>
-                  <a:srgbClr val="1F1F1F"/>
-                </a:highlight>
-                <a:latin typeface="Consolas"/>
-                <a:ea typeface="Consolas"/>
-                <a:cs typeface="Consolas"/>
-                <a:sym typeface="Consolas"/>
-              </a:rPr>
-              <a:t>TotalSeconds</a:t>
-            </a:r>
-            <a:endParaRPr sz="1000">
-              <a:solidFill>
-                <a:srgbClr val="9CDCFE"/>
-              </a:solidFill>
-              <a:highlight>
-                <a:srgbClr val="1F1F1F"/>
-              </a:highlight>
-              <a:latin typeface="Consolas"/>
-              <a:ea typeface="Consolas"/>
-              <a:cs typeface="Consolas"/>
-              <a:sym typeface="Consolas"/>
-            </a:endParaRPr>
-          </a:p>
-          <a:p>
-            <a:pPr indent="0" lvl="0" marL="0" rtl="0" algn="l">
-              <a:spcBef>
-                <a:spcPts val="0"/>
-              </a:spcBef>
-              <a:spcAft>
-                <a:spcPts val="0"/>
-              </a:spcAft>
-              <a:buNone/>
-            </a:pPr>
-            <a:r>
-              <a:rPr/>
-              <a:t/>
-            </a:r>
-            <a:endParaRPr/>
-          </a:p>
-          <a:p>
-            <a:pPr indent="-330200" lvl="0" marL="457200" rtl="0" algn="l">
-              <a:spcBef>
-                <a:spcPts val="1200"/>
-              </a:spcBef>
-              <a:spcAft>
-                <a:spcPts val="0"/>
-              </a:spcAft>
-              <a:buSzPts val="1600"/>
-              <a:buChar char="●"/>
-            </a:pPr>
-            <a:r>
-              <a:rPr lang="en"/>
-              <a:t>What do we need velocity for?</a:t>
-            </a:r>
-            <a:endParaRPr/>
-          </a:p>
-          <a:p>
-            <a:pPr indent="0" lvl="0" marL="0" rtl="0" algn="l">
-              <a:spcBef>
-                <a:spcPts val="1200"/>
-              </a:spcBef>
-              <a:spcAft>
-                <a:spcPts val="1200"/>
-              </a:spcAft>
-              <a:buNone/>
-            </a:pPr>
-            <a:r>
-              <a:rPr/>
-              <a:t/>
-            </a:r>
-            <a:endParaRPr/>
-          </a:p>
         </p:txBody>
       </p:sp>
+      <p:pic>
+        <p:nvPicPr>
+          <p:cNvPr id="214" name="Picture 213" descr="delta-time.png"/>
+          <p:cNvPicPr>
+            <a:picLocks noChangeAspect="1"/>
+          </p:cNvPicPr>
+          <p:nvPr/>
+        </p:nvPicPr>
+        <p:blipFill>
+          <a:blip r:embed="rId3"/>
+          <a:stretch>
+            <a:fillRect/>
+          </a:stretch>
+        </p:blipFill>
+        <p:spPr>
+          <a:xfrm>
+            <a:off x="822960" y="1417320"/>
+            <a:ext cx="7498079" cy="3582415"/>
+          </a:xfrm>
+          <a:prstGeom prst="rect">
+            <a:avLst/>
+          </a:prstGeom>
+        </p:spPr>
+      </p:pic>
     </p:spTree>
   </p:cSld>
   <p:clrMapOvr>
@@ -15274,8 +14913,8 @@
         </p:nvSpPr>
         <p:spPr>
           <a:xfrm>
-            <a:off x="4787600" y="1675200"/>
-            <a:ext cx="4044600" cy="1793100"/>
+            <a:off x="4754880" y="1675200"/>
+            <a:ext cx="4297680" cy="1793100"/>
           </a:xfrm>
           <a:prstGeom prst="rect">
             <a:avLst/>
@@ -16466,30 +16105,26 @@
       </p:sp>
       <p:pic>
         <p:nvPicPr>
-          <p:cNvPr id="260" name="Google Shape;260;p44"/>
-          <p:cNvPicPr preferRelativeResize="0"/>
+          <p:cNvPr id="260" name="Picture 259" descr="aabb.png"/>
+          <p:cNvPicPr>
+            <a:picLocks noChangeAspect="1"/>
+          </p:cNvPicPr>
           <p:nvPr/>
         </p:nvPicPr>
         <p:blipFill>
-          <a:blip r:embed="rId3">
-            <a:alphaModFix/>
-          </a:blip>
+          <a:blip r:embed="rId4"/>
           <a:stretch>
             <a:fillRect/>
           </a:stretch>
         </p:blipFill>
         <p:spPr>
           <a:xfrm>
-            <a:off x="595656" y="1625188"/>
-            <a:ext cx="3365555" cy="1893125"/>
+            <a:off x="182880" y="1463040"/>
+            <a:ext cx="4480560" cy="2240280"/>
           </a:xfrm>
           <a:prstGeom prst="rect">
             <a:avLst/>
           </a:prstGeom>
-          <a:noFill/>
-          <a:ln>
-            <a:noFill/>
-          </a:ln>
         </p:spPr>
       </p:pic>
     </p:spTree>

</xml_diff>

<commit_message>
Figures: labels clear of lines, and three cramped figures get their own slide
Parallax, circles, the ghost's junction, the mode schedule, hitboxes, type
object, flyweight and memory layout had labels under lines or lines through
text. On the decks, the AABB, singleton and broad/narrow phase figures were
too small next to other content and now fill a slide each.

Co-Authored-By: Claude Opus 5.5 <noreply@anthropic.com>
Claude-Session: https://claude.ai/code/session_012sjsUQBbC7zon57rWHoo9d
</commit_message>
<xml_diff>
--- a/slides/01 Pong.pptx
+++ b/slides/01 Pong.pptx
@@ -38,6 +38,7 @@
     <p:sldId id="289" r:id="rId39"/>
     <p:sldId id="303" r:id="rId62"/>
     <p:sldId id="290" r:id="rId40"/>
+    <p:sldId id="311" r:id="rId43"/>
     <p:sldId id="291" r:id="rId41"/>
     <p:sldId id="292" r:id="rId42"/>
     <p:sldId id="294" r:id="rId44"/>
@@ -824,6 +825,69 @@
           <a:p>
             <a:r>
               <a:t>Today’s game: Pong, the whole thing, from an empty window. The main topic: the game loop.</a:t>
+            </a:r>
+          </a:p>
+        </p:txBody>
+      </p:sp>
+    </p:spTree>
+  </p:cSld>
+  <p:clrMapOvr>
+    <a:masterClrMapping/>
+  </p:clrMapOvr>
+</p:notes>
+</file>
+
+<file path=ppt/notesSlides/notesSlide10.xml><?xml version="1.0" encoding="utf-8"?>
+<p:notes xmlns:a="http://schemas.openxmlformats.org/drawingml/2006/main" xmlns:p="http://schemas.openxmlformats.org/presentationml/2006/main" xmlns:r="http://schemas.openxmlformats.org/officeDocument/2006/relationships">
+  <p:cSld>
+    <p:spTree>
+      <p:nvGrpSpPr>
+        <p:cNvPr id="1" name=""/>
+        <p:cNvGrpSpPr/>
+        <p:nvPr/>
+      </p:nvGrpSpPr>
+      <p:grpSpPr>
+        <a:xfrm>
+          <a:off x="0" y="0"/>
+          <a:ext cx="0" cy="0"/>
+          <a:chOff x="0" y="0"/>
+          <a:chExt cx="0" cy="0"/>
+        </a:xfrm>
+      </p:grpSpPr>
+      <p:sp>
+        <p:nvSpPr>
+          <p:cNvPr id="2" name="Slide Image Placeholder 1"/>
+          <p:cNvSpPr>
+            <a:spLocks noGrp="1"/>
+          </p:cNvSpPr>
+          <p:nvPr>
+            <p:ph type="sldImg" idx="2"/>
+          </p:nvPr>
+        </p:nvSpPr>
+        <p:spPr/>
+      </p:sp>
+      <p:sp>
+        <p:nvSpPr>
+          <p:cNvPr id="3" name="Notes Placeholder 2"/>
+          <p:cNvSpPr>
+            <a:spLocks noGrp="1"/>
+          </p:cNvSpPr>
+          <p:nvPr>
+            <p:ph type="body" idx="1"/>
+          </p:nvPr>
+        </p:nvSpPr>
+        <p:spPr/>
+        <p:txBody>
+          <a:bodyPr/>
+          <a:lstStyle/>
+          <a:p>
+            <a:r>
+              <a:t>Two rectangles overlap only if they overlap on both axes. On the right they overlap on x only, so there is no collision.</a:t>
+            </a:r>
+          </a:p>
+          <a:p>
+            <a:r>
+              <a:t>Ask: what are the four comparisons? Answer: a.Left &lt; b.Right, a.Right &gt; b.Left, and the same two for top and bottom.</a:t>
             </a:r>
           </a:p>
         </p:txBody>
@@ -14813,7 +14877,7 @@
         </p:nvSpPr>
         <p:spPr>
           <a:xfrm>
-            <a:off x="4754880" y="1675200"/>
+            <a:off x="2423160" y="1675200"/>
             <a:ext cx="4297680" cy="1793100"/>
           </a:xfrm>
           <a:prstGeom prst="rect">
@@ -16003,30 +16067,6 @@
           </a:p>
         </p:txBody>
       </p:sp>
-      <p:pic>
-        <p:nvPicPr>
-          <p:cNvPr id="260" name="Picture 259" descr="aabb.png"/>
-          <p:cNvPicPr>
-            <a:picLocks noChangeAspect="1"/>
-          </p:cNvPicPr>
-          <p:nvPr/>
-        </p:nvPicPr>
-        <p:blipFill>
-          <a:blip r:embed="rId4"/>
-          <a:stretch>
-            <a:fillRect/>
-          </a:stretch>
-        </p:blipFill>
-        <p:spPr>
-          <a:xfrm>
-            <a:off x="182880" y="1463040"/>
-            <a:ext cx="4480560" cy="2240280"/>
-          </a:xfrm>
-          <a:prstGeom prst="rect">
-            <a:avLst/>
-          </a:prstGeom>
-        </p:spPr>
-      </p:pic>
     </p:spTree>
   </p:cSld>
   <p:clrMapOvr>
@@ -18499,6 +18539,80 @@
           </a:p>
         </p:txBody>
       </p:sp>
+    </p:spTree>
+  </p:cSld>
+  <p:clrMapOvr>
+    <a:masterClrMapping/>
+  </p:clrMapOvr>
+</p:sld>
+</file>
+
+<file path=ppt/slides/slide43.xml><?xml version="1.0" encoding="utf-8"?>
+<p:sld xmlns:a="http://schemas.openxmlformats.org/drawingml/2006/main" xmlns:p="http://schemas.openxmlformats.org/presentationml/2006/main" xmlns:r="http://schemas.openxmlformats.org/officeDocument/2006/relationships">
+  <p:cSld>
+    <p:spTree>
+      <p:nvGrpSpPr>
+        <p:cNvPr id="1" name=""/>
+        <p:cNvGrpSpPr/>
+        <p:nvPr/>
+      </p:nvGrpSpPr>
+      <p:grpSpPr/>
+      <p:sp>
+        <p:nvSpPr>
+          <p:cNvPr id="2" name="Title 1"/>
+          <p:cNvSpPr>
+            <a:spLocks noGrp="1"/>
+          </p:cNvSpPr>
+          <p:nvPr>
+            <p:ph type="title"/>
+          </p:nvPr>
+        </p:nvSpPr>
+        <p:spPr/>
+        <p:txBody>
+          <a:bodyPr/>
+          <a:lstStyle/>
+          <a:p>
+            <a:pPr indent="0" lvl="0" marL="0" rtl="0" algn="l">
+              <a:spcBef>
+                <a:spcPts val="0"/>
+              </a:spcBef>
+              <a:spcAft>
+                <a:spcPts val="0"/>
+              </a:spcAft>
+              <a:buNone/>
+            </a:pPr>
+            <a:r>
+              <a:rPr lang="en"/>
+              <a:t>Do Two Rectangles Overlap?</a:t>
+            </a:r>
+            <a:endParaRPr/>
+          </a:p>
+        </p:txBody>
+      </p:sp>
+      <p:pic>
+        <p:nvPicPr>
+          <p:cNvPr id="3" name="Picture 2" descr="image.png"/>
+          <p:cNvPicPr>
+            <a:picLocks noChangeAspect="1"/>
+          </p:cNvPicPr>
+          <p:nvPr/>
+        </p:nvPicPr>
+        <p:blipFill>
+          <a:blip r:embed="rId2"/>
+          <a:stretch>
+            <a:fillRect/>
+          </a:stretch>
+        </p:blipFill>
+        <p:spPr>
+          <a:xfrm>
+            <a:off x="594360" y="1051560"/>
+            <a:ext cx="7955279" cy="3977639"/>
+          </a:xfrm>
+          <a:prstGeom prst="rect">
+            <a:avLst/>
+          </a:prstGeom>
+        </p:spPr>
+      </p:pic>
     </p:spTree>
   </p:cSld>
   <p:clrMapOvr>

</xml_diff>

<commit_message>
Figures on both the pages and the decks where the topic is on both
Twelve figures that were only on slides are now on their session pages.
Pong's AABB slide has the figure and the comparisons together again, and
the bounce figure has a slide before the exercise that builds it.

Co-Authored-By: Claude Opus 5.5 <noreply@anthropic.com>
Claude-Session: https://claude.ai/code/session_012sjsUQBbC7zon57rWHoo9d
</commit_message>
<xml_diff>
--- a/slides/01 Pong.pptx
+++ b/slides/01 Pong.pptx
@@ -39,7 +39,7 @@
     <p:sldId id="303" r:id="rId62"/>
     <p:sldId id="290" r:id="rId40"/>
     <p:sldId id="311" r:id="rId43"/>
-    <p:sldId id="291" r:id="rId41"/>
+    <p:sldId id="312" r:id="rId41"/>
     <p:sldId id="292" r:id="rId42"/>
     <p:sldId id="294" r:id="rId44"/>
     <p:sldId id="295" r:id="rId45"/>
@@ -887,7 +887,12 @@
           </a:p>
           <a:p>
             <a:r>
-              <a:t>Ask: what are the four comparisons? Answer: a.Left &lt; b.Right, a.Right &gt; b.Left, and the same two for top and bottom.</a:t>
+              <a:t>The code is the picture: the first line is the bars under the boxes, the second the bars beside them.</a:t>
+            </a:r>
+          </a:p>
+          <a:p>
+            <a:r>
+              <a:t>Draw two boxes on the board and check the four comparisons together.</a:t>
             </a:r>
           </a:p>
         </p:txBody>
@@ -3205,11 +3210,11 @@
 </file>
 
 <file path=ppt/notesSlides/notesSlide36.xml><?xml version="1.0" encoding="utf-8"?>
-<p:notes xmlns:a="http://schemas.openxmlformats.org/drawingml/2006/main" xmlns:r="http://schemas.openxmlformats.org/officeDocument/2006/relationships" xmlns:mc="http://schemas.openxmlformats.org/markup-compatibility/2006" xmlns:mv="urn:schemas-microsoft-com:mac:vml" xmlns:p="http://schemas.openxmlformats.org/presentationml/2006/main" xmlns:c="http://schemas.openxmlformats.org/drawingml/2006/chart" xmlns:dgm="http://schemas.openxmlformats.org/drawingml/2006/diagram" xmlns:o="urn:schemas-microsoft-com:office:office" xmlns:v="urn:schemas-microsoft-com:vml" xmlns:pvml="urn:schemas-microsoft-com:office:powerpoint" xmlns:com="http://schemas.openxmlformats.org/drawingml/2006/compatibility" xmlns:p14="http://schemas.microsoft.com/office/powerpoint/2010/main" xmlns:p15="http://schemas.microsoft.com/office/powerpoint/2012/main" xmlns:ahyp="http://schemas.microsoft.com/office/drawing/2018/hyperlinkcolor" showMasterPhAnim="0" showMasterSp="0">
+<p:notes xmlns:a="http://schemas.openxmlformats.org/drawingml/2006/main" xmlns:p="http://schemas.openxmlformats.org/presentationml/2006/main" xmlns:r="http://schemas.openxmlformats.org/officeDocument/2006/relationships">
   <p:cSld>
     <p:spTree>
       <p:nvGrpSpPr>
-        <p:cNvPr id="254" name="Shape 254"/>
+        <p:cNvPr id="1" name=""/>
         <p:cNvGrpSpPr/>
         <p:nvPr/>
       </p:nvGrpSpPr>
@@ -3223,69 +3228,38 @@
       </p:grpSpPr>
       <p:sp>
         <p:nvSpPr>
-          <p:cNvPr id="255" name="Google Shape;255;g3932a601320_0_19:notes"/>
-          <p:cNvSpPr/>
+          <p:cNvPr id="2" name="Slide Image Placeholder 1"/>
+          <p:cNvSpPr>
+            <a:spLocks noGrp="1"/>
+          </p:cNvSpPr>
           <p:nvPr>
-            <p:ph idx="2" type="sldImg"/>
+            <p:ph type="sldImg" idx="2"/>
           </p:nvPr>
         </p:nvSpPr>
-        <p:spPr>
-          <a:xfrm>
-            <a:off x="381300" y="685800"/>
-            <a:ext cx="6096000" cy="3429000"/>
-          </a:xfrm>
-          <a:custGeom>
-            <a:rect b="b" l="l" r="r" t="t"/>
-            <a:pathLst>
-              <a:path extrusionOk="0" h="120000" w="120000">
-                <a:moveTo>
-                  <a:pt x="0" y="0"/>
-                </a:moveTo>
-                <a:lnTo>
-                  <a:pt x="120000" y="0"/>
-                </a:lnTo>
-                <a:lnTo>
-                  <a:pt x="120000" y="120000"/>
-                </a:lnTo>
-                <a:lnTo>
-                  <a:pt x="0" y="120000"/>
-                </a:lnTo>
-                <a:close/>
-              </a:path>
-            </a:pathLst>
-          </a:custGeom>
-        </p:spPr>
-      </p:sp>
-      <p:sp>
-        <p:nvSpPr>
-          <p:cNvPr id="256" name="Google Shape;256;g3932a601320_0_19:notes"/>
-          <p:cNvSpPr txBox="1"/>
+        <p:spPr/>
+      </p:sp>
+      <p:sp>
+        <p:nvSpPr>
+          <p:cNvPr id="3" name="Notes Placeholder 2"/>
+          <p:cNvSpPr>
+            <a:spLocks noGrp="1"/>
+          </p:cNvSpPr>
           <p:nvPr>
-            <p:ph idx="1" type="body"/>
+            <p:ph type="body" idx="1"/>
           </p:nvPr>
         </p:nvSpPr>
-        <p:spPr>
-          <a:xfrm>
-            <a:off x="685800" y="4343400"/>
-            <a:ext cx="5486400" cy="4114800"/>
-          </a:xfrm>
-          <a:prstGeom prst="rect">
-            <a:avLst/>
-          </a:prstGeom>
-        </p:spPr>
+        <p:spPr/>
         <p:txBody>
-          <a:bodyPr anchorCtr="0" anchor="t" bIns="91425" lIns="91425" spcFirstLastPara="1" rIns="91425" wrap="square" tIns="91425">
-            <a:noAutofit/>
-          </a:bodyPr>
+          <a:bodyPr/>
           <a:lstStyle/>
           <a:p>
             <a:r>
-              <a:t>Two boxes overlap unless one is entirely to the left, right, above or below the other.</a:t>
-            </a:r>
-          </a:p>
-          <a:p>
-            <a:r>
-              <a:t>Draw two boxes on the board and check the four conditions together.</a:t>
+              <a:t>The middle of the paddle sends the ball straight back; the further from the middle, the steeper.</a:t>
+            </a:r>
+          </a:p>
+          <a:p>
+            <a:r>
+              <a:t>Ask: why is this better than a random angle? Answer: the player controls the angle, so hitting becomes a skill.</a:t>
             </a:r>
           </a:p>
         </p:txBody>
@@ -14811,1259 +14785,141 @@
 </file>
 
 <file path=ppt/slides/slide31.xml><?xml version="1.0" encoding="utf-8"?>
-<p:sld xmlns:a="http://schemas.openxmlformats.org/drawingml/2006/main" xmlns:r="http://schemas.openxmlformats.org/officeDocument/2006/relationships" xmlns:mc="http://schemas.openxmlformats.org/markup-compatibility/2006" xmlns:mv="urn:schemas-microsoft-com:mac:vml" xmlns:p="http://schemas.openxmlformats.org/presentationml/2006/main" xmlns:c="http://schemas.openxmlformats.org/drawingml/2006/chart" xmlns:dgm="http://schemas.openxmlformats.org/drawingml/2006/diagram" xmlns:o="urn:schemas-microsoft-com:office:office" xmlns:v="urn:schemas-microsoft-com:vml" xmlns:pvml="urn:schemas-microsoft-com:office:powerpoint" xmlns:com="http://schemas.openxmlformats.org/drawingml/2006/compatibility" xmlns:p14="http://schemas.microsoft.com/office/powerpoint/2010/main" xmlns:p15="http://schemas.microsoft.com/office/powerpoint/2012/main" xmlns:ahyp="http://schemas.microsoft.com/office/drawing/2018/hyperlinkcolor">
+<p:sld xmlns:a="http://schemas.openxmlformats.org/drawingml/2006/main" xmlns:p="http://schemas.openxmlformats.org/presentationml/2006/main" xmlns:r="http://schemas.openxmlformats.org/officeDocument/2006/relationships">
   <p:cSld>
     <p:spTree>
       <p:nvGrpSpPr>
-        <p:cNvPr id="257" name="Shape 257"/>
+        <p:cNvPr id="1" name=""/>
         <p:cNvGrpSpPr/>
         <p:nvPr/>
       </p:nvGrpSpPr>
-      <p:grpSpPr>
-        <a:xfrm>
-          <a:off x="0" y="0"/>
-          <a:ext cx="0" cy="0"/>
-          <a:chOff x="0" y="0"/>
-          <a:chExt cx="0" cy="0"/>
-        </a:xfrm>
-      </p:grpSpPr>
-      <p:sp>
-        <p:nvSpPr>
-          <p:cNvPr id="258" name="Google Shape;258;p44"/>
-          <p:cNvSpPr txBox="1"/>
+      <p:grpSpPr/>
+      <p:sp>
+        <p:nvSpPr>
+          <p:cNvPr id="2" name="Title 1"/>
+          <p:cNvSpPr>
+            <a:spLocks noGrp="1"/>
+          </p:cNvSpPr>
           <p:nvPr>
             <p:ph type="title"/>
           </p:nvPr>
         </p:nvSpPr>
-        <p:spPr>
-          <a:xfrm>
-            <a:off x="311700" y="195615"/>
-            <a:ext cx="8520600" cy="572700"/>
+        <p:spPr/>
+        <p:txBody>
+          <a:bodyPr/>
+          <a:lstStyle/>
+          <a:p>
+            <a:pPr indent="0" lvl="0" marL="0" rtl="0" algn="l">
+              <a:spcBef>
+                <a:spcPts val="0"/>
+              </a:spcBef>
+              <a:spcAft>
+                <a:spcPts val="0"/>
+              </a:spcAft>
+              <a:buNone/>
+            </a:pPr>
+            <a:r>
+              <a:rPr lang="en"/>
+              <a:t>Collision Detection (AABB)</a:t>
+            </a:r>
+            <a:endParaRPr/>
+          </a:p>
+        </p:txBody>
+      </p:sp>
+      <p:pic>
+        <p:nvPicPr>
+          <p:cNvPr id="3" name="Picture 2" descr="image.png"/>
+          <p:cNvPicPr>
+            <a:picLocks noChangeAspect="1"/>
+          </p:cNvPicPr>
+          <p:nvPr/>
+        </p:nvPicPr>
+        <p:blipFill>
+          <a:blip r:embed="rId2"/>
+          <a:stretch>
+            <a:fillRect/>
+          </a:stretch>
+        </p:blipFill>
+        <p:spPr>
+          <a:xfrm>
+            <a:off x="1554479" y="914400"/>
+            <a:ext cx="6035040" cy="3017520"/>
           </a:xfrm>
           <a:prstGeom prst="rect">
             <a:avLst/>
           </a:prstGeom>
         </p:spPr>
-        <p:txBody>
-          <a:bodyPr anchorCtr="0" anchor="t" bIns="91425" lIns="91425" spcFirstLastPara="1" rIns="91425" wrap="square" tIns="91425">
-            <a:normAutofit fontScale="90000"/>
-          </a:bodyPr>
-          <a:lstStyle/>
-          <a:p>
-            <a:pPr indent="0" lvl="0" marL="0" rtl="0" algn="l">
-              <a:spcBef>
-                <a:spcPts val="0"/>
-              </a:spcBef>
-              <a:spcAft>
-                <a:spcPts val="0"/>
-              </a:spcAft>
-              <a:buNone/>
-            </a:pPr>
-            <a:r>
-              <a:rPr lang="en"/>
-              <a:t>Collision Detection (AABB)</a:t>
-            </a:r>
-            <a:endParaRPr/>
-          </a:p>
-        </p:txBody>
-      </p:sp>
-      <p:sp>
-        <p:nvSpPr>
-          <p:cNvPr id="259" name="Google Shape;259;p44"/>
-          <p:cNvSpPr txBox="1"/>
-          <p:nvPr>
-            <p:ph idx="2" type="body"/>
-          </p:nvPr>
-        </p:nvSpPr>
-        <p:spPr>
-          <a:xfrm>
-            <a:off x="2423160" y="1675200"/>
-            <a:ext cx="4297680" cy="1793100"/>
+      </p:pic>
+      <p:sp>
+        <p:nvSpPr>
+          <p:cNvPr id="4" name="Rectangle 3"/>
+          <p:cNvSpPr/>
+          <p:nvPr/>
+        </p:nvSpPr>
+        <p:spPr>
+          <a:xfrm>
+            <a:off x="914400" y="4069080"/>
+            <a:ext cx="7315200" cy="822960"/>
           </a:xfrm>
           <a:prstGeom prst="rect">
             <a:avLst/>
           </a:prstGeom>
-        </p:spPr>
+          <a:solidFill>
+            <a:srgbClr val="17191C"/>
+          </a:solidFill>
+          <a:ln>
+            <a:noFill/>
+          </a:ln>
+          <a:effectLst/>
+        </p:spPr>
+        <p:style>
+          <a:lnRef idx="1">
+            <a:schemeClr val="accent1"/>
+          </a:lnRef>
+          <a:fillRef idx="3">
+            <a:schemeClr val="accent1"/>
+          </a:fillRef>
+          <a:effectRef idx="2">
+            <a:schemeClr val="accent1"/>
+          </a:effectRef>
+          <a:fontRef idx="minor">
+            <a:schemeClr val="lt1"/>
+          </a:fontRef>
+        </p:style>
         <p:txBody>
-          <a:bodyPr anchorCtr="0" anchor="t" bIns="91425" lIns="91425" spcFirstLastPara="1" rIns="91425" wrap="square" tIns="91425">
-            <a:noAutofit/>
-          </a:bodyPr>
+          <a:bodyPr rtlCol="0" anchor="ctr" wrap="square" lIns="164592" rIns="73152"/>
           <a:lstStyle/>
           <a:p>
-            <a:pPr indent="0" lvl="0" marL="0" rtl="0" algn="l">
-              <a:lnSpc>
-                <a:spcPct val="157500"/>
-              </a:lnSpc>
-              <a:spcBef>
-                <a:spcPts val="0"/>
-              </a:spcBef>
-              <a:spcAft>
-                <a:spcPts val="0"/>
-              </a:spcAft>
-              <a:buNone/>
-            </a:pPr>
-            <a:r>
-              <a:rPr lang="en" sz="1000">
-                <a:solidFill>
-                  <a:srgbClr val="569CD6"/>
-                </a:solidFill>
-                <a:highlight>
-                  <a:srgbClr val="1F1F1F"/>
-                </a:highlight>
+            <a:pPr algn="l"/>
+            <a:r>
+              <a:rPr sz="1400" b="0">
+                <a:solidFill>
+                  <a:srgbClr val="DEE2E6"/>
+                </a:solidFill>
+              </a:rPr>
+              <a:t/>
+            </a:r>
+            <a:r>
+              <a:rPr sz="1300">
+                <a:solidFill>
+                  <a:srgbClr val="DEE2E6"/>
+                </a:solidFill>
                 <a:latin typeface="Consolas"/>
-                <a:ea typeface="Consolas"/>
-                <a:cs typeface="Consolas"/>
-                <a:sym typeface="Consolas"/>
-              </a:rPr>
-              <a:t>public</a:t>
-            </a:r>
-            <a:r>
-              <a:rPr lang="en" sz="1000">
-                <a:solidFill>
-                  <a:srgbClr val="CCCCCC"/>
-                </a:solidFill>
-                <a:highlight>
-                  <a:srgbClr val="1F1F1F"/>
-                </a:highlight>
+              </a:rPr>
+              <a:t>return boxA.Left &lt; boxB.Right &amp;&amp; boxA.Right &gt; boxB.Left      // overlap on x</a:t>
+            </a:r>
+          </a:p>
+          <a:p>
+            <a:pPr algn="l"/>
+            <a:r>
+              <a:rPr sz="1300">
+                <a:solidFill>
+                  <a:srgbClr val="DEE2E6"/>
+                </a:solidFill>
                 <a:latin typeface="Consolas"/>
-                <a:ea typeface="Consolas"/>
-                <a:cs typeface="Consolas"/>
-                <a:sym typeface="Consolas"/>
-              </a:rPr>
-              <a:t> </a:t>
-            </a:r>
-            <a:r>
-              <a:rPr lang="en" sz="1000">
-                <a:solidFill>
-                  <a:srgbClr val="569CD6"/>
-                </a:solidFill>
-                <a:highlight>
-                  <a:srgbClr val="1F1F1F"/>
-                </a:highlight>
-                <a:latin typeface="Consolas"/>
-                <a:ea typeface="Consolas"/>
-                <a:cs typeface="Consolas"/>
-                <a:sym typeface="Consolas"/>
-              </a:rPr>
-              <a:t>static</a:t>
-            </a:r>
-            <a:r>
-              <a:rPr lang="en" sz="1000">
-                <a:solidFill>
-                  <a:srgbClr val="CCCCCC"/>
-                </a:solidFill>
-                <a:highlight>
-                  <a:srgbClr val="1F1F1F"/>
-                </a:highlight>
-                <a:latin typeface="Consolas"/>
-                <a:ea typeface="Consolas"/>
-                <a:cs typeface="Consolas"/>
-                <a:sym typeface="Consolas"/>
-              </a:rPr>
-              <a:t> </a:t>
-            </a:r>
-            <a:r>
-              <a:rPr lang="en" sz="1000">
-                <a:solidFill>
-                  <a:srgbClr val="569CD6"/>
-                </a:solidFill>
-                <a:highlight>
-                  <a:srgbClr val="1F1F1F"/>
-                </a:highlight>
-                <a:latin typeface="Consolas"/>
-                <a:ea typeface="Consolas"/>
-                <a:cs typeface="Consolas"/>
-                <a:sym typeface="Consolas"/>
-              </a:rPr>
-              <a:t>bool</a:t>
-            </a:r>
-            <a:r>
-              <a:rPr lang="en" sz="1000">
-                <a:solidFill>
-                  <a:srgbClr val="CCCCCC"/>
-                </a:solidFill>
-                <a:highlight>
-                  <a:srgbClr val="1F1F1F"/>
-                </a:highlight>
-                <a:latin typeface="Consolas"/>
-                <a:ea typeface="Consolas"/>
-                <a:cs typeface="Consolas"/>
-                <a:sym typeface="Consolas"/>
-              </a:rPr>
-              <a:t> </a:t>
-            </a:r>
-            <a:r>
-              <a:rPr lang="en" sz="1000">
-                <a:solidFill>
-                  <a:srgbClr val="DCDCAA"/>
-                </a:solidFill>
-                <a:highlight>
-                  <a:srgbClr val="1F1F1F"/>
-                </a:highlight>
-                <a:latin typeface="Consolas"/>
-                <a:ea typeface="Consolas"/>
-                <a:cs typeface="Consolas"/>
-                <a:sym typeface="Consolas"/>
-              </a:rPr>
-              <a:t>AABB</a:t>
-            </a:r>
-            <a:r>
-              <a:rPr lang="en" sz="1000">
-                <a:solidFill>
-                  <a:srgbClr val="CCCCCC"/>
-                </a:solidFill>
-                <a:highlight>
-                  <a:srgbClr val="1F1F1F"/>
-                </a:highlight>
-                <a:latin typeface="Consolas"/>
-                <a:ea typeface="Consolas"/>
-                <a:cs typeface="Consolas"/>
-                <a:sym typeface="Consolas"/>
-              </a:rPr>
-              <a:t>(</a:t>
-            </a:r>
-            <a:r>
-              <a:rPr lang="en" sz="1000">
-                <a:solidFill>
-                  <a:srgbClr val="9CDCFE"/>
-                </a:solidFill>
-                <a:highlight>
-                  <a:srgbClr val="1F1F1F"/>
-                </a:highlight>
-                <a:latin typeface="Consolas"/>
-                <a:ea typeface="Consolas"/>
-                <a:cs typeface="Consolas"/>
-                <a:sym typeface="Consolas"/>
-              </a:rPr>
-              <a:t>Rectangle</a:t>
-            </a:r>
-            <a:r>
-              <a:rPr lang="en" sz="1000">
-                <a:solidFill>
-                  <a:srgbClr val="CCCCCC"/>
-                </a:solidFill>
-                <a:highlight>
-                  <a:srgbClr val="1F1F1F"/>
-                </a:highlight>
-                <a:latin typeface="Consolas"/>
-                <a:ea typeface="Consolas"/>
-                <a:cs typeface="Consolas"/>
-                <a:sym typeface="Consolas"/>
-              </a:rPr>
-              <a:t> </a:t>
-            </a:r>
-            <a:r>
-              <a:rPr lang="en" sz="1000">
-                <a:solidFill>
-                  <a:srgbClr val="9CDCFE"/>
-                </a:solidFill>
-                <a:highlight>
-                  <a:srgbClr val="1F1F1F"/>
-                </a:highlight>
-                <a:latin typeface="Consolas"/>
-                <a:ea typeface="Consolas"/>
-                <a:cs typeface="Consolas"/>
-                <a:sym typeface="Consolas"/>
-              </a:rPr>
-              <a:t>boxA</a:t>
-            </a:r>
-            <a:r>
-              <a:rPr lang="en" sz="1000">
-                <a:solidFill>
-                  <a:srgbClr val="CCCCCC"/>
-                </a:solidFill>
-                <a:highlight>
-                  <a:srgbClr val="1F1F1F"/>
-                </a:highlight>
-                <a:latin typeface="Consolas"/>
-                <a:ea typeface="Consolas"/>
-                <a:cs typeface="Consolas"/>
-                <a:sym typeface="Consolas"/>
-              </a:rPr>
-              <a:t>, </a:t>
-            </a:r>
-            <a:r>
-              <a:rPr lang="en" sz="1000">
-                <a:solidFill>
-                  <a:srgbClr val="9CDCFE"/>
-                </a:solidFill>
-                <a:highlight>
-                  <a:srgbClr val="1F1F1F"/>
-                </a:highlight>
-                <a:latin typeface="Consolas"/>
-                <a:ea typeface="Consolas"/>
-                <a:cs typeface="Consolas"/>
-                <a:sym typeface="Consolas"/>
-              </a:rPr>
-              <a:t>Rectangle</a:t>
-            </a:r>
-            <a:r>
-              <a:rPr lang="en" sz="1000">
-                <a:solidFill>
-                  <a:srgbClr val="CCCCCC"/>
-                </a:solidFill>
-                <a:highlight>
-                  <a:srgbClr val="1F1F1F"/>
-                </a:highlight>
-                <a:latin typeface="Consolas"/>
-                <a:ea typeface="Consolas"/>
-                <a:cs typeface="Consolas"/>
-                <a:sym typeface="Consolas"/>
-              </a:rPr>
-              <a:t> </a:t>
-            </a:r>
-            <a:r>
-              <a:rPr lang="en" sz="1000">
-                <a:solidFill>
-                  <a:srgbClr val="9CDCFE"/>
-                </a:solidFill>
-                <a:highlight>
-                  <a:srgbClr val="1F1F1F"/>
-                </a:highlight>
-                <a:latin typeface="Consolas"/>
-                <a:ea typeface="Consolas"/>
-                <a:cs typeface="Consolas"/>
-                <a:sym typeface="Consolas"/>
-              </a:rPr>
-              <a:t>boxB</a:t>
-            </a:r>
-            <a:r>
-              <a:rPr lang="en" sz="1000">
-                <a:solidFill>
-                  <a:srgbClr val="CCCCCC"/>
-                </a:solidFill>
-                <a:highlight>
-                  <a:srgbClr val="1F1F1F"/>
-                </a:highlight>
-                <a:latin typeface="Consolas"/>
-                <a:ea typeface="Consolas"/>
-                <a:cs typeface="Consolas"/>
-                <a:sym typeface="Consolas"/>
-              </a:rPr>
-              <a:t>)</a:t>
-            </a:r>
-            <a:endParaRPr sz="1000">
-              <a:solidFill>
-                <a:srgbClr val="CCCCCC"/>
-              </a:solidFill>
-              <a:highlight>
-                <a:srgbClr val="1F1F1F"/>
-              </a:highlight>
-              <a:latin typeface="Consolas"/>
-              <a:ea typeface="Consolas"/>
-              <a:cs typeface="Consolas"/>
-              <a:sym typeface="Consolas"/>
-            </a:endParaRPr>
-          </a:p>
-          <a:p>
-            <a:pPr indent="0" lvl="0" marL="0" rtl="0" algn="l">
-              <a:lnSpc>
-                <a:spcPct val="157500"/>
-              </a:lnSpc>
-              <a:spcBef>
-                <a:spcPts val="0"/>
-              </a:spcBef>
-              <a:spcAft>
-                <a:spcPts val="0"/>
-              </a:spcAft>
-              <a:buNone/>
-            </a:pPr>
-            <a:r>
-              <a:rPr lang="en" sz="1000">
-                <a:solidFill>
-                  <a:srgbClr val="CCCCCC"/>
-                </a:solidFill>
-                <a:highlight>
-                  <a:srgbClr val="1F1F1F"/>
-                </a:highlight>
-                <a:latin typeface="Consolas"/>
-                <a:ea typeface="Consolas"/>
-                <a:cs typeface="Consolas"/>
-                <a:sym typeface="Consolas"/>
-              </a:rPr>
-              <a:t>{</a:t>
-            </a:r>
-            <a:endParaRPr sz="1000">
-              <a:solidFill>
-                <a:srgbClr val="CCCCCC"/>
-              </a:solidFill>
-              <a:highlight>
-                <a:srgbClr val="1F1F1F"/>
-              </a:highlight>
-              <a:latin typeface="Consolas"/>
-              <a:ea typeface="Consolas"/>
-              <a:cs typeface="Consolas"/>
-              <a:sym typeface="Consolas"/>
-            </a:endParaRPr>
-          </a:p>
-          <a:p>
-            <a:pPr indent="0" lvl="0" marL="0" rtl="0" algn="l">
-              <a:lnSpc>
-                <a:spcPct val="157500"/>
-              </a:lnSpc>
-              <a:spcBef>
-                <a:spcPts val="0"/>
-              </a:spcBef>
-              <a:spcAft>
-                <a:spcPts val="0"/>
-              </a:spcAft>
-              <a:buNone/>
-            </a:pPr>
-            <a:r>
-              <a:rPr lang="en" sz="1000">
-                <a:solidFill>
-                  <a:srgbClr val="CCCCCC"/>
-                </a:solidFill>
-                <a:highlight>
-                  <a:srgbClr val="1F1F1F"/>
-                </a:highlight>
-                <a:latin typeface="Consolas"/>
-                <a:ea typeface="Consolas"/>
-                <a:cs typeface="Consolas"/>
-                <a:sym typeface="Consolas"/>
-              </a:rPr>
-              <a:t>    </a:t>
-            </a:r>
-            <a:r>
-              <a:rPr lang="en" sz="1000">
-                <a:solidFill>
-                  <a:srgbClr val="C586C0"/>
-                </a:solidFill>
-                <a:highlight>
-                  <a:srgbClr val="1F1F1F"/>
-                </a:highlight>
-                <a:latin typeface="Consolas"/>
-                <a:ea typeface="Consolas"/>
-                <a:cs typeface="Consolas"/>
-                <a:sym typeface="Consolas"/>
-              </a:rPr>
-              <a:t>return</a:t>
-            </a:r>
-            <a:r>
-              <a:rPr lang="en" sz="1000">
-                <a:solidFill>
-                  <a:srgbClr val="CCCCCC"/>
-                </a:solidFill>
-                <a:highlight>
-                  <a:srgbClr val="1F1F1F"/>
-                </a:highlight>
-                <a:latin typeface="Consolas"/>
-                <a:ea typeface="Consolas"/>
-                <a:cs typeface="Consolas"/>
-                <a:sym typeface="Consolas"/>
-              </a:rPr>
-              <a:t> </a:t>
-            </a:r>
-            <a:r>
-              <a:rPr lang="en" sz="1000">
-                <a:solidFill>
-                  <a:srgbClr val="9CDCFE"/>
-                </a:solidFill>
-                <a:highlight>
-                  <a:srgbClr val="1F1F1F"/>
-                </a:highlight>
-                <a:latin typeface="Consolas"/>
-                <a:ea typeface="Consolas"/>
-                <a:cs typeface="Consolas"/>
-                <a:sym typeface="Consolas"/>
-              </a:rPr>
-              <a:t>boxA</a:t>
-            </a:r>
-            <a:r>
-              <a:rPr lang="en" sz="1000">
-                <a:solidFill>
-                  <a:srgbClr val="D4D4D4"/>
-                </a:solidFill>
-                <a:highlight>
-                  <a:srgbClr val="1F1F1F"/>
-                </a:highlight>
-                <a:latin typeface="Consolas"/>
-                <a:ea typeface="Consolas"/>
-                <a:cs typeface="Consolas"/>
-                <a:sym typeface="Consolas"/>
-              </a:rPr>
-              <a:t>.</a:t>
-            </a:r>
-            <a:r>
-              <a:rPr lang="en" sz="1000">
-                <a:solidFill>
-                  <a:srgbClr val="9CDCFE"/>
-                </a:solidFill>
-                <a:highlight>
-                  <a:srgbClr val="1F1F1F"/>
-                </a:highlight>
-                <a:latin typeface="Consolas"/>
-                <a:ea typeface="Consolas"/>
-                <a:cs typeface="Consolas"/>
-                <a:sym typeface="Consolas"/>
-              </a:rPr>
-              <a:t>Left</a:t>
-            </a:r>
-            <a:r>
-              <a:rPr lang="en" sz="1000">
-                <a:solidFill>
-                  <a:srgbClr val="CCCCCC"/>
-                </a:solidFill>
-                <a:highlight>
-                  <a:srgbClr val="1F1F1F"/>
-                </a:highlight>
-                <a:latin typeface="Consolas"/>
-                <a:ea typeface="Consolas"/>
-                <a:cs typeface="Consolas"/>
-                <a:sym typeface="Consolas"/>
-              </a:rPr>
-              <a:t> </a:t>
-            </a:r>
-            <a:r>
-              <a:rPr lang="en" sz="1000">
-                <a:solidFill>
-                  <a:srgbClr val="D4D4D4"/>
-                </a:solidFill>
-                <a:highlight>
-                  <a:srgbClr val="1F1F1F"/>
-                </a:highlight>
-                <a:latin typeface="Consolas"/>
-                <a:ea typeface="Consolas"/>
-                <a:cs typeface="Consolas"/>
-                <a:sym typeface="Consolas"/>
-              </a:rPr>
-              <a:t>&lt;</a:t>
-            </a:r>
-            <a:r>
-              <a:rPr lang="en" sz="1000">
-                <a:solidFill>
-                  <a:srgbClr val="CCCCCC"/>
-                </a:solidFill>
-                <a:highlight>
-                  <a:srgbClr val="1F1F1F"/>
-                </a:highlight>
-                <a:latin typeface="Consolas"/>
-                <a:ea typeface="Consolas"/>
-                <a:cs typeface="Consolas"/>
-                <a:sym typeface="Consolas"/>
-              </a:rPr>
-              <a:t> </a:t>
-            </a:r>
-            <a:r>
-              <a:rPr lang="en" sz="1000">
-                <a:solidFill>
-                  <a:srgbClr val="9CDCFE"/>
-                </a:solidFill>
-                <a:highlight>
-                  <a:srgbClr val="1F1F1F"/>
-                </a:highlight>
-                <a:latin typeface="Consolas"/>
-                <a:ea typeface="Consolas"/>
-                <a:cs typeface="Consolas"/>
-                <a:sym typeface="Consolas"/>
-              </a:rPr>
-              <a:t>boxB</a:t>
-            </a:r>
-            <a:r>
-              <a:rPr lang="en" sz="1000">
-                <a:solidFill>
-                  <a:srgbClr val="D4D4D4"/>
-                </a:solidFill>
-                <a:highlight>
-                  <a:srgbClr val="1F1F1F"/>
-                </a:highlight>
-                <a:latin typeface="Consolas"/>
-                <a:ea typeface="Consolas"/>
-                <a:cs typeface="Consolas"/>
-                <a:sym typeface="Consolas"/>
-              </a:rPr>
-              <a:t>.</a:t>
-            </a:r>
-            <a:r>
-              <a:rPr lang="en" sz="1000">
-                <a:solidFill>
-                  <a:srgbClr val="9CDCFE"/>
-                </a:solidFill>
-                <a:highlight>
-                  <a:srgbClr val="1F1F1F"/>
-                </a:highlight>
-                <a:latin typeface="Consolas"/>
-                <a:ea typeface="Consolas"/>
-                <a:cs typeface="Consolas"/>
-                <a:sym typeface="Consolas"/>
-              </a:rPr>
-              <a:t>Right</a:t>
-            </a:r>
-            <a:r>
-              <a:rPr lang="en" sz="1000">
-                <a:solidFill>
-                  <a:srgbClr val="CCCCCC"/>
-                </a:solidFill>
-                <a:highlight>
-                  <a:srgbClr val="1F1F1F"/>
-                </a:highlight>
-                <a:latin typeface="Consolas"/>
-                <a:ea typeface="Consolas"/>
-                <a:cs typeface="Consolas"/>
-                <a:sym typeface="Consolas"/>
-              </a:rPr>
-              <a:t> </a:t>
-            </a:r>
-            <a:r>
-              <a:rPr lang="en" sz="1000">
-                <a:solidFill>
-                  <a:srgbClr val="D4D4D4"/>
-                </a:solidFill>
-                <a:highlight>
-                  <a:srgbClr val="1F1F1F"/>
-                </a:highlight>
-                <a:latin typeface="Consolas"/>
-                <a:ea typeface="Consolas"/>
-                <a:cs typeface="Consolas"/>
-                <a:sym typeface="Consolas"/>
-              </a:rPr>
-              <a:t>&amp;&amp;</a:t>
-            </a:r>
-            <a:endParaRPr sz="1000">
-              <a:solidFill>
-                <a:srgbClr val="D4D4D4"/>
-              </a:solidFill>
-              <a:highlight>
-                <a:srgbClr val="1F1F1F"/>
-              </a:highlight>
-              <a:latin typeface="Consolas"/>
-              <a:ea typeface="Consolas"/>
-              <a:cs typeface="Consolas"/>
-              <a:sym typeface="Consolas"/>
-            </a:endParaRPr>
-          </a:p>
-          <a:p>
-            <a:pPr indent="0" lvl="0" marL="0" rtl="0" algn="l">
-              <a:lnSpc>
-                <a:spcPct val="157500"/>
-              </a:lnSpc>
-              <a:spcBef>
-                <a:spcPts val="0"/>
-              </a:spcBef>
-              <a:spcAft>
-                <a:spcPts val="0"/>
-              </a:spcAft>
-              <a:buNone/>
-            </a:pPr>
-            <a:r>
-              <a:rPr lang="en" sz="1000">
-                <a:solidFill>
-                  <a:srgbClr val="CCCCCC"/>
-                </a:solidFill>
-                <a:highlight>
-                  <a:srgbClr val="1F1F1F"/>
-                </a:highlight>
-                <a:latin typeface="Consolas"/>
-                <a:ea typeface="Consolas"/>
-                <a:cs typeface="Consolas"/>
-                <a:sym typeface="Consolas"/>
-              </a:rPr>
-              <a:t>            </a:t>
-            </a:r>
-            <a:r>
-              <a:rPr lang="en" sz="1000">
-                <a:solidFill>
-                  <a:srgbClr val="9CDCFE"/>
-                </a:solidFill>
-                <a:highlight>
-                  <a:srgbClr val="1F1F1F"/>
-                </a:highlight>
-                <a:latin typeface="Consolas"/>
-                <a:ea typeface="Consolas"/>
-                <a:cs typeface="Consolas"/>
-                <a:sym typeface="Consolas"/>
-              </a:rPr>
-              <a:t>boxA</a:t>
-            </a:r>
-            <a:r>
-              <a:rPr lang="en" sz="1000">
-                <a:solidFill>
-                  <a:srgbClr val="D4D4D4"/>
-                </a:solidFill>
-                <a:highlight>
-                  <a:srgbClr val="1F1F1F"/>
-                </a:highlight>
-                <a:latin typeface="Consolas"/>
-                <a:ea typeface="Consolas"/>
-                <a:cs typeface="Consolas"/>
-                <a:sym typeface="Consolas"/>
-              </a:rPr>
-              <a:t>.</a:t>
-            </a:r>
-            <a:r>
-              <a:rPr lang="en" sz="1000">
-                <a:solidFill>
-                  <a:srgbClr val="9CDCFE"/>
-                </a:solidFill>
-                <a:highlight>
-                  <a:srgbClr val="1F1F1F"/>
-                </a:highlight>
-                <a:latin typeface="Consolas"/>
-                <a:ea typeface="Consolas"/>
-                <a:cs typeface="Consolas"/>
-                <a:sym typeface="Consolas"/>
-              </a:rPr>
-              <a:t>Right</a:t>
-            </a:r>
-            <a:r>
-              <a:rPr lang="en" sz="1000">
-                <a:solidFill>
-                  <a:srgbClr val="CCCCCC"/>
-                </a:solidFill>
-                <a:highlight>
-                  <a:srgbClr val="1F1F1F"/>
-                </a:highlight>
-                <a:latin typeface="Consolas"/>
-                <a:ea typeface="Consolas"/>
-                <a:cs typeface="Consolas"/>
-                <a:sym typeface="Consolas"/>
-              </a:rPr>
-              <a:t> </a:t>
-            </a:r>
-            <a:r>
-              <a:rPr lang="en" sz="1000">
-                <a:solidFill>
-                  <a:srgbClr val="D4D4D4"/>
-                </a:solidFill>
-                <a:highlight>
-                  <a:srgbClr val="1F1F1F"/>
-                </a:highlight>
-                <a:latin typeface="Consolas"/>
-                <a:ea typeface="Consolas"/>
-                <a:cs typeface="Consolas"/>
-                <a:sym typeface="Consolas"/>
-              </a:rPr>
-              <a:t>&gt;</a:t>
-            </a:r>
-            <a:r>
-              <a:rPr lang="en" sz="1000">
-                <a:solidFill>
-                  <a:srgbClr val="CCCCCC"/>
-                </a:solidFill>
-                <a:highlight>
-                  <a:srgbClr val="1F1F1F"/>
-                </a:highlight>
-                <a:latin typeface="Consolas"/>
-                <a:ea typeface="Consolas"/>
-                <a:cs typeface="Consolas"/>
-                <a:sym typeface="Consolas"/>
-              </a:rPr>
-              <a:t> </a:t>
-            </a:r>
-            <a:r>
-              <a:rPr lang="en" sz="1000">
-                <a:solidFill>
-                  <a:srgbClr val="9CDCFE"/>
-                </a:solidFill>
-                <a:highlight>
-                  <a:srgbClr val="1F1F1F"/>
-                </a:highlight>
-                <a:latin typeface="Consolas"/>
-                <a:ea typeface="Consolas"/>
-                <a:cs typeface="Consolas"/>
-                <a:sym typeface="Consolas"/>
-              </a:rPr>
-              <a:t>boxB</a:t>
-            </a:r>
-            <a:r>
-              <a:rPr lang="en" sz="1000">
-                <a:solidFill>
-                  <a:srgbClr val="D4D4D4"/>
-                </a:solidFill>
-                <a:highlight>
-                  <a:srgbClr val="1F1F1F"/>
-                </a:highlight>
-                <a:latin typeface="Consolas"/>
-                <a:ea typeface="Consolas"/>
-                <a:cs typeface="Consolas"/>
-                <a:sym typeface="Consolas"/>
-              </a:rPr>
-              <a:t>.</a:t>
-            </a:r>
-            <a:r>
-              <a:rPr lang="en" sz="1000">
-                <a:solidFill>
-                  <a:srgbClr val="9CDCFE"/>
-                </a:solidFill>
-                <a:highlight>
-                  <a:srgbClr val="1F1F1F"/>
-                </a:highlight>
-                <a:latin typeface="Consolas"/>
-                <a:ea typeface="Consolas"/>
-                <a:cs typeface="Consolas"/>
-                <a:sym typeface="Consolas"/>
-              </a:rPr>
-              <a:t>Left</a:t>
-            </a:r>
-            <a:r>
-              <a:rPr lang="en" sz="1000">
-                <a:solidFill>
-                  <a:srgbClr val="CCCCCC"/>
-                </a:solidFill>
-                <a:highlight>
-                  <a:srgbClr val="1F1F1F"/>
-                </a:highlight>
-                <a:latin typeface="Consolas"/>
-                <a:ea typeface="Consolas"/>
-                <a:cs typeface="Consolas"/>
-                <a:sym typeface="Consolas"/>
-              </a:rPr>
-              <a:t> </a:t>
-            </a:r>
-            <a:r>
-              <a:rPr lang="en" sz="1000">
-                <a:solidFill>
-                  <a:srgbClr val="D4D4D4"/>
-                </a:solidFill>
-                <a:highlight>
-                  <a:srgbClr val="1F1F1F"/>
-                </a:highlight>
-                <a:latin typeface="Consolas"/>
-                <a:ea typeface="Consolas"/>
-                <a:cs typeface="Consolas"/>
-                <a:sym typeface="Consolas"/>
-              </a:rPr>
-              <a:t>&amp;&amp;</a:t>
-            </a:r>
-            <a:endParaRPr sz="1000">
-              <a:solidFill>
-                <a:srgbClr val="D4D4D4"/>
-              </a:solidFill>
-              <a:highlight>
-                <a:srgbClr val="1F1F1F"/>
-              </a:highlight>
-              <a:latin typeface="Consolas"/>
-              <a:ea typeface="Consolas"/>
-              <a:cs typeface="Consolas"/>
-              <a:sym typeface="Consolas"/>
-            </a:endParaRPr>
-          </a:p>
-          <a:p>
-            <a:pPr indent="0" lvl="0" marL="0" rtl="0" algn="l">
-              <a:lnSpc>
-                <a:spcPct val="157500"/>
-              </a:lnSpc>
-              <a:spcBef>
-                <a:spcPts val="0"/>
-              </a:spcBef>
-              <a:spcAft>
-                <a:spcPts val="0"/>
-              </a:spcAft>
-              <a:buNone/>
-            </a:pPr>
-            <a:r>
-              <a:rPr lang="en" sz="1000">
-                <a:solidFill>
-                  <a:srgbClr val="CCCCCC"/>
-                </a:solidFill>
-                <a:highlight>
-                  <a:srgbClr val="1F1F1F"/>
-                </a:highlight>
-                <a:latin typeface="Consolas"/>
-                <a:ea typeface="Consolas"/>
-                <a:cs typeface="Consolas"/>
-                <a:sym typeface="Consolas"/>
-              </a:rPr>
-              <a:t>            </a:t>
-            </a:r>
-            <a:r>
-              <a:rPr lang="en" sz="1000">
-                <a:solidFill>
-                  <a:srgbClr val="9CDCFE"/>
-                </a:solidFill>
-                <a:highlight>
-                  <a:srgbClr val="1F1F1F"/>
-                </a:highlight>
-                <a:latin typeface="Consolas"/>
-                <a:ea typeface="Consolas"/>
-                <a:cs typeface="Consolas"/>
-                <a:sym typeface="Consolas"/>
-              </a:rPr>
-              <a:t>boxA</a:t>
-            </a:r>
-            <a:r>
-              <a:rPr lang="en" sz="1000">
-                <a:solidFill>
-                  <a:srgbClr val="D4D4D4"/>
-                </a:solidFill>
-                <a:highlight>
-                  <a:srgbClr val="1F1F1F"/>
-                </a:highlight>
-                <a:latin typeface="Consolas"/>
-                <a:ea typeface="Consolas"/>
-                <a:cs typeface="Consolas"/>
-                <a:sym typeface="Consolas"/>
-              </a:rPr>
-              <a:t>.</a:t>
-            </a:r>
-            <a:r>
-              <a:rPr lang="en" sz="1000">
-                <a:solidFill>
-                  <a:srgbClr val="9CDCFE"/>
-                </a:solidFill>
-                <a:highlight>
-                  <a:srgbClr val="1F1F1F"/>
-                </a:highlight>
-                <a:latin typeface="Consolas"/>
-                <a:ea typeface="Consolas"/>
-                <a:cs typeface="Consolas"/>
-                <a:sym typeface="Consolas"/>
-              </a:rPr>
-              <a:t>Top</a:t>
-            </a:r>
-            <a:r>
-              <a:rPr lang="en" sz="1000">
-                <a:solidFill>
-                  <a:srgbClr val="CCCCCC"/>
-                </a:solidFill>
-                <a:highlight>
-                  <a:srgbClr val="1F1F1F"/>
-                </a:highlight>
-                <a:latin typeface="Consolas"/>
-                <a:ea typeface="Consolas"/>
-                <a:cs typeface="Consolas"/>
-                <a:sym typeface="Consolas"/>
-              </a:rPr>
-              <a:t> </a:t>
-            </a:r>
-            <a:r>
-              <a:rPr lang="en" sz="1000">
-                <a:solidFill>
-                  <a:srgbClr val="D4D4D4"/>
-                </a:solidFill>
-                <a:highlight>
-                  <a:srgbClr val="1F1F1F"/>
-                </a:highlight>
-                <a:latin typeface="Consolas"/>
-                <a:ea typeface="Consolas"/>
-                <a:cs typeface="Consolas"/>
-                <a:sym typeface="Consolas"/>
-              </a:rPr>
-              <a:t>&lt;</a:t>
-            </a:r>
-            <a:r>
-              <a:rPr lang="en" sz="1000">
-                <a:solidFill>
-                  <a:srgbClr val="CCCCCC"/>
-                </a:solidFill>
-                <a:highlight>
-                  <a:srgbClr val="1F1F1F"/>
-                </a:highlight>
-                <a:latin typeface="Consolas"/>
-                <a:ea typeface="Consolas"/>
-                <a:cs typeface="Consolas"/>
-                <a:sym typeface="Consolas"/>
-              </a:rPr>
-              <a:t> </a:t>
-            </a:r>
-            <a:r>
-              <a:rPr lang="en" sz="1000">
-                <a:solidFill>
-                  <a:srgbClr val="9CDCFE"/>
-                </a:solidFill>
-                <a:highlight>
-                  <a:srgbClr val="1F1F1F"/>
-                </a:highlight>
-                <a:latin typeface="Consolas"/>
-                <a:ea typeface="Consolas"/>
-                <a:cs typeface="Consolas"/>
-                <a:sym typeface="Consolas"/>
-              </a:rPr>
-              <a:t>boxB</a:t>
-            </a:r>
-            <a:r>
-              <a:rPr lang="en" sz="1000">
-                <a:solidFill>
-                  <a:srgbClr val="D4D4D4"/>
-                </a:solidFill>
-                <a:highlight>
-                  <a:srgbClr val="1F1F1F"/>
-                </a:highlight>
-                <a:latin typeface="Consolas"/>
-                <a:ea typeface="Consolas"/>
-                <a:cs typeface="Consolas"/>
-                <a:sym typeface="Consolas"/>
-              </a:rPr>
-              <a:t>.</a:t>
-            </a:r>
-            <a:r>
-              <a:rPr lang="en" sz="1000">
-                <a:solidFill>
-                  <a:srgbClr val="9CDCFE"/>
-                </a:solidFill>
-                <a:highlight>
-                  <a:srgbClr val="1F1F1F"/>
-                </a:highlight>
-                <a:latin typeface="Consolas"/>
-                <a:ea typeface="Consolas"/>
-                <a:cs typeface="Consolas"/>
-                <a:sym typeface="Consolas"/>
-              </a:rPr>
-              <a:t>Bottom</a:t>
-            </a:r>
-            <a:r>
-              <a:rPr lang="en" sz="1000">
-                <a:solidFill>
-                  <a:srgbClr val="CCCCCC"/>
-                </a:solidFill>
-                <a:highlight>
-                  <a:srgbClr val="1F1F1F"/>
-                </a:highlight>
-                <a:latin typeface="Consolas"/>
-                <a:ea typeface="Consolas"/>
-                <a:cs typeface="Consolas"/>
-                <a:sym typeface="Consolas"/>
-              </a:rPr>
-              <a:t> </a:t>
-            </a:r>
-            <a:r>
-              <a:rPr lang="en" sz="1000">
-                <a:solidFill>
-                  <a:srgbClr val="D4D4D4"/>
-                </a:solidFill>
-                <a:highlight>
-                  <a:srgbClr val="1F1F1F"/>
-                </a:highlight>
-                <a:latin typeface="Consolas"/>
-                <a:ea typeface="Consolas"/>
-                <a:cs typeface="Consolas"/>
-                <a:sym typeface="Consolas"/>
-              </a:rPr>
-              <a:t>&amp;&amp;</a:t>
-            </a:r>
-            <a:endParaRPr sz="1000">
-              <a:solidFill>
-                <a:srgbClr val="D4D4D4"/>
-              </a:solidFill>
-              <a:highlight>
-                <a:srgbClr val="1F1F1F"/>
-              </a:highlight>
-              <a:latin typeface="Consolas"/>
-              <a:ea typeface="Consolas"/>
-              <a:cs typeface="Consolas"/>
-              <a:sym typeface="Consolas"/>
-            </a:endParaRPr>
-          </a:p>
-          <a:p>
-            <a:pPr indent="0" lvl="0" marL="0" rtl="0" algn="l">
-              <a:lnSpc>
-                <a:spcPct val="157500"/>
-              </a:lnSpc>
-              <a:spcBef>
-                <a:spcPts val="0"/>
-              </a:spcBef>
-              <a:spcAft>
-                <a:spcPts val="0"/>
-              </a:spcAft>
-              <a:buNone/>
-            </a:pPr>
-            <a:r>
-              <a:rPr lang="en" sz="1000">
-                <a:solidFill>
-                  <a:srgbClr val="CCCCCC"/>
-                </a:solidFill>
-                <a:highlight>
-                  <a:srgbClr val="1F1F1F"/>
-                </a:highlight>
-                <a:latin typeface="Consolas"/>
-                <a:ea typeface="Consolas"/>
-                <a:cs typeface="Consolas"/>
-                <a:sym typeface="Consolas"/>
-              </a:rPr>
-              <a:t>            </a:t>
-            </a:r>
-            <a:r>
-              <a:rPr lang="en" sz="1000">
-                <a:solidFill>
-                  <a:srgbClr val="9CDCFE"/>
-                </a:solidFill>
-                <a:highlight>
-                  <a:srgbClr val="1F1F1F"/>
-                </a:highlight>
-                <a:latin typeface="Consolas"/>
-                <a:ea typeface="Consolas"/>
-                <a:cs typeface="Consolas"/>
-                <a:sym typeface="Consolas"/>
-              </a:rPr>
-              <a:t>boxA</a:t>
-            </a:r>
-            <a:r>
-              <a:rPr lang="en" sz="1000">
-                <a:solidFill>
-                  <a:srgbClr val="D4D4D4"/>
-                </a:solidFill>
-                <a:highlight>
-                  <a:srgbClr val="1F1F1F"/>
-                </a:highlight>
-                <a:latin typeface="Consolas"/>
-                <a:ea typeface="Consolas"/>
-                <a:cs typeface="Consolas"/>
-                <a:sym typeface="Consolas"/>
-              </a:rPr>
-              <a:t>.</a:t>
-            </a:r>
-            <a:r>
-              <a:rPr lang="en" sz="1000">
-                <a:solidFill>
-                  <a:srgbClr val="9CDCFE"/>
-                </a:solidFill>
-                <a:highlight>
-                  <a:srgbClr val="1F1F1F"/>
-                </a:highlight>
-                <a:latin typeface="Consolas"/>
-                <a:ea typeface="Consolas"/>
-                <a:cs typeface="Consolas"/>
-                <a:sym typeface="Consolas"/>
-              </a:rPr>
-              <a:t>Bottom</a:t>
-            </a:r>
-            <a:r>
-              <a:rPr lang="en" sz="1000">
-                <a:solidFill>
-                  <a:srgbClr val="CCCCCC"/>
-                </a:solidFill>
-                <a:highlight>
-                  <a:srgbClr val="1F1F1F"/>
-                </a:highlight>
-                <a:latin typeface="Consolas"/>
-                <a:ea typeface="Consolas"/>
-                <a:cs typeface="Consolas"/>
-                <a:sym typeface="Consolas"/>
-              </a:rPr>
-              <a:t> </a:t>
-            </a:r>
-            <a:r>
-              <a:rPr lang="en" sz="1000">
-                <a:solidFill>
-                  <a:srgbClr val="D4D4D4"/>
-                </a:solidFill>
-                <a:highlight>
-                  <a:srgbClr val="1F1F1F"/>
-                </a:highlight>
-                <a:latin typeface="Consolas"/>
-                <a:ea typeface="Consolas"/>
-                <a:cs typeface="Consolas"/>
-                <a:sym typeface="Consolas"/>
-              </a:rPr>
-              <a:t>&gt;</a:t>
-            </a:r>
-            <a:r>
-              <a:rPr lang="en" sz="1000">
-                <a:solidFill>
-                  <a:srgbClr val="CCCCCC"/>
-                </a:solidFill>
-                <a:highlight>
-                  <a:srgbClr val="1F1F1F"/>
-                </a:highlight>
-                <a:latin typeface="Consolas"/>
-                <a:ea typeface="Consolas"/>
-                <a:cs typeface="Consolas"/>
-                <a:sym typeface="Consolas"/>
-              </a:rPr>
-              <a:t> </a:t>
-            </a:r>
-            <a:r>
-              <a:rPr lang="en" sz="1000">
-                <a:solidFill>
-                  <a:srgbClr val="9CDCFE"/>
-                </a:solidFill>
-                <a:highlight>
-                  <a:srgbClr val="1F1F1F"/>
-                </a:highlight>
-                <a:latin typeface="Consolas"/>
-                <a:ea typeface="Consolas"/>
-                <a:cs typeface="Consolas"/>
-                <a:sym typeface="Consolas"/>
-              </a:rPr>
-              <a:t>boxB</a:t>
-            </a:r>
-            <a:r>
-              <a:rPr lang="en" sz="1000">
-                <a:solidFill>
-                  <a:srgbClr val="D4D4D4"/>
-                </a:solidFill>
-                <a:highlight>
-                  <a:srgbClr val="1F1F1F"/>
-                </a:highlight>
-                <a:latin typeface="Consolas"/>
-                <a:ea typeface="Consolas"/>
-                <a:cs typeface="Consolas"/>
-                <a:sym typeface="Consolas"/>
-              </a:rPr>
-              <a:t>.</a:t>
-            </a:r>
-            <a:r>
-              <a:rPr lang="en" sz="1000">
-                <a:solidFill>
-                  <a:srgbClr val="9CDCFE"/>
-                </a:solidFill>
-                <a:highlight>
-                  <a:srgbClr val="1F1F1F"/>
-                </a:highlight>
-                <a:latin typeface="Consolas"/>
-                <a:ea typeface="Consolas"/>
-                <a:cs typeface="Consolas"/>
-                <a:sym typeface="Consolas"/>
-              </a:rPr>
-              <a:t>Top</a:t>
-            </a:r>
-            <a:r>
-              <a:rPr lang="en" sz="1000">
-                <a:solidFill>
-                  <a:srgbClr val="CCCCCC"/>
-                </a:solidFill>
-                <a:highlight>
-                  <a:srgbClr val="1F1F1F"/>
-                </a:highlight>
-                <a:latin typeface="Consolas"/>
-                <a:ea typeface="Consolas"/>
-                <a:cs typeface="Consolas"/>
-                <a:sym typeface="Consolas"/>
-              </a:rPr>
-              <a:t>;</a:t>
-            </a:r>
-            <a:endParaRPr sz="1000">
-              <a:solidFill>
-                <a:srgbClr val="CCCCCC"/>
-              </a:solidFill>
-              <a:highlight>
-                <a:srgbClr val="1F1F1F"/>
-              </a:highlight>
-              <a:latin typeface="Consolas"/>
-              <a:ea typeface="Consolas"/>
-              <a:cs typeface="Consolas"/>
-              <a:sym typeface="Consolas"/>
-            </a:endParaRPr>
-          </a:p>
-          <a:p>
-            <a:pPr indent="0" lvl="0" marL="0" rtl="0" algn="l">
-              <a:lnSpc>
-                <a:spcPct val="157500"/>
-              </a:lnSpc>
-              <a:spcBef>
-                <a:spcPts val="0"/>
-              </a:spcBef>
-              <a:spcAft>
-                <a:spcPts val="0"/>
-              </a:spcAft>
-              <a:buNone/>
-            </a:pPr>
-            <a:r>
-              <a:rPr lang="en" sz="1000">
-                <a:solidFill>
-                  <a:srgbClr val="CCCCCC"/>
-                </a:solidFill>
-                <a:highlight>
-                  <a:srgbClr val="1F1F1F"/>
-                </a:highlight>
-                <a:latin typeface="Consolas"/>
-                <a:ea typeface="Consolas"/>
-                <a:cs typeface="Consolas"/>
-                <a:sym typeface="Consolas"/>
-              </a:rPr>
-              <a:t>}</a:t>
-            </a:r>
-            <a:endParaRPr/>
+              </a:rPr>
+              <a:t>    &amp;&amp; boxA.Top &lt; boxB.Bottom &amp;&amp; boxA.Bottom &gt; boxB.Top;     // overlap on y</a:t>
+            </a:r>
           </a:p>
         </p:txBody>
       </p:sp>
@@ -18583,7 +17439,7 @@
             </a:pPr>
             <a:r>
               <a:rPr lang="en"/>
-              <a:t>Do Two Rectangles Overlap?</a:t>
+              <a:t>Where the Ball Hits Sets the Angle</a:t>
             </a:r>
             <a:endParaRPr/>
           </a:p>
@@ -18591,7 +17447,7 @@
       </p:sp>
       <p:pic>
         <p:nvPicPr>
-          <p:cNvPr id="3" name="Picture 2" descr="image.png"/>
+          <p:cNvPr id="3" name="Picture 2" descr="bounce.png"/>
           <p:cNvPicPr>
             <a:picLocks noChangeAspect="1"/>
           </p:cNvPicPr>
@@ -18605,8 +17461,8 @@
         </p:blipFill>
         <p:spPr>
           <a:xfrm>
-            <a:off x="594360" y="1051560"/>
-            <a:ext cx="7955279" cy="3977639"/>
+            <a:off x="360381" y="1051560"/>
+            <a:ext cx="8423237" cy="3977640"/>
           </a:xfrm>
           <a:prstGeom prst="rect">
             <a:avLst/>

</xml_diff>

<commit_message>
The Whole Game on pages and decks: one form for every diagram, and closing slides in every deck
Pages: every finished-game diagram starts at Game1 with its base class and
lists no members; Vampire Survivors shows Game1 and the state stack.
Decks: a slide of who holds what in the finished game, and a Summary slide of
the session's concerns and answers (Geometry Wars already had one).

Co-Authored-By: Claude Opus 5.5 <noreply@anthropic.com>
Claude-Session: https://claude.ai/code/session_012sjsUQBbC7zon57rWHoo9d
</commit_message>
<xml_diff>
--- a/slides/01 Pong.pptx
+++ b/slides/01 Pong.pptx
@@ -48,6 +48,8 @@
     <p:sldId id="298" r:id="rId48"/>
     <p:sldId id="299" r:id="rId49"/>
     <p:sldId id="309" r:id="rId15"/>
+    <p:sldId id="313" r:id="rId14"/>
+    <p:sldId id="314" r:id="rId13"/>
     <p:sldId id="306" r:id="rId65"/>
     <p:sldId id="304" r:id="rId63"/>
     <p:sldId id="300" r:id="rId50"/>
@@ -4450,6 +4452,127 @@
           <a:p>
             <a:r>
               <a:t>Today we build the parts that matter for the architecture.</a:t>
+            </a:r>
+          </a:p>
+        </p:txBody>
+      </p:sp>
+    </p:spTree>
+  </p:cSld>
+  <p:clrMapOvr>
+    <a:masterClrMapping/>
+  </p:clrMapOvr>
+</p:notes>
+</file>
+
+<file path=ppt/notesSlides/notesSlide8.xml><?xml version="1.0" encoding="utf-8"?>
+<p:notes xmlns:a="http://schemas.openxmlformats.org/drawingml/2006/main" xmlns:p="http://schemas.openxmlformats.org/presentationml/2006/main" xmlns:r="http://schemas.openxmlformats.org/officeDocument/2006/relationships">
+  <p:cSld>
+    <p:spTree>
+      <p:nvGrpSpPr>
+        <p:cNvPr id="1" name=""/>
+        <p:cNvGrpSpPr/>
+        <p:nvPr/>
+      </p:nvGrpSpPr>
+      <p:grpSpPr>
+        <a:xfrm>
+          <a:off x="0" y="0"/>
+          <a:ext cx="0" cy="0"/>
+          <a:chOff x="0" y="0"/>
+          <a:chExt cx="0" cy="0"/>
+        </a:xfrm>
+      </p:grpSpPr>
+      <p:sp>
+        <p:nvSpPr>
+          <p:cNvPr id="2" name="Slide Image Placeholder 1"/>
+          <p:cNvSpPr>
+            <a:spLocks noGrp="1"/>
+          </p:cNvSpPr>
+          <p:nvPr>
+            <p:ph type="sldImg" idx="2"/>
+          </p:nvPr>
+        </p:nvSpPr>
+        <p:spPr/>
+      </p:sp>
+      <p:sp>
+        <p:nvSpPr>
+          <p:cNvPr id="3" name="Notes Placeholder 2"/>
+          <p:cNvSpPr>
+            <a:spLocks noGrp="1"/>
+          </p:cNvSpPr>
+          <p:nvPr>
+            <p:ph type="body" idx="1"/>
+          </p:nvPr>
+        </p:nvSpPr>
+        <p:spPr/>
+        <p:txBody>
+          <a:bodyPr/>
+          <a:lstStyle/>
+          <a:p>
+            <a:r>
+              <a:t>The session in one slide. Read each concern aloud and let the class give the answer before pointing at it.</a:t>
+            </a:r>
+          </a:p>
+        </p:txBody>
+      </p:sp>
+    </p:spTree>
+  </p:cSld>
+  <p:clrMapOvr>
+    <a:masterClrMapping/>
+  </p:clrMapOvr>
+</p:notes>
+</file>
+
+<file path=ppt/notesSlides/notesSlide9.xml><?xml version="1.0" encoding="utf-8"?>
+<p:notes xmlns:a="http://schemas.openxmlformats.org/drawingml/2006/main" xmlns:p="http://schemas.openxmlformats.org/presentationml/2006/main" xmlns:r="http://schemas.openxmlformats.org/officeDocument/2006/relationships">
+  <p:cSld>
+    <p:spTree>
+      <p:nvGrpSpPr>
+        <p:cNvPr id="1" name=""/>
+        <p:cNvGrpSpPr/>
+        <p:nvPr/>
+      </p:nvGrpSpPr>
+      <p:grpSpPr>
+        <a:xfrm>
+          <a:off x="0" y="0"/>
+          <a:ext cx="0" cy="0"/>
+          <a:chOff x="0" y="0"/>
+          <a:chExt cx="0" cy="0"/>
+        </a:xfrm>
+      </p:grpSpPr>
+      <p:sp>
+        <p:nvSpPr>
+          <p:cNvPr id="2" name="Slide Image Placeholder 1"/>
+          <p:cNvSpPr>
+            <a:spLocks noGrp="1"/>
+          </p:cNvSpPr>
+          <p:nvPr>
+            <p:ph type="sldImg" idx="2"/>
+          </p:nvPr>
+        </p:nvSpPr>
+        <p:spPr/>
+      </p:sp>
+      <p:sp>
+        <p:nvSpPr>
+          <p:cNvPr id="3" name="Notes Placeholder 2"/>
+          <p:cNvSpPr>
+            <a:spLocks noGrp="1"/>
+          </p:cNvSpPr>
+          <p:nvPr>
+            <p:ph type="body" idx="1"/>
+          </p:nvPr>
+        </p:nvSpPr>
+        <p:spPr/>
+        <p:txBody>
+          <a:bodyPr/>
+          <a:lstStyle/>
+          <a:p>
+            <a:r>
+              <a:t>Who holds what in the finished Pong. Game1 holds the paddles and the ball, and every rule between them.</a:t>
+            </a:r>
+          </a:p>
+          <a:p>
+            <a:r>
+              <a:t>Ask: what would you move out of Game1 first? The next sessions each move something.</a:t>
             </a:r>
           </a:p>
         </p:txBody>
@@ -17511,6 +17634,875 @@
 </p:sld>
 </file>
 
+<file path=ppt/slides/slide44.xml><?xml version="1.0" encoding="utf-8"?>
+<p:sld xmlns:a="http://schemas.openxmlformats.org/drawingml/2006/main" xmlns:p="http://schemas.openxmlformats.org/presentationml/2006/main" xmlns:r="http://schemas.openxmlformats.org/officeDocument/2006/relationships">
+  <p:cSld>
+    <p:spTree>
+      <p:nvGrpSpPr>
+        <p:cNvPr id="1" name=""/>
+        <p:cNvGrpSpPr/>
+        <p:nvPr/>
+      </p:nvGrpSpPr>
+      <p:grpSpPr/>
+      <p:sp>
+        <p:nvSpPr>
+          <p:cNvPr id="2" name="Title 1"/>
+          <p:cNvSpPr>
+            <a:spLocks noGrp="1"/>
+          </p:cNvSpPr>
+          <p:nvPr>
+            <p:ph type="title"/>
+          </p:nvPr>
+        </p:nvSpPr>
+        <p:spPr/>
+        <p:txBody>
+          <a:bodyPr/>
+          <a:lstStyle/>
+          <a:p>
+            <a:pPr indent="0" lvl="0" marL="0" rtl="0" algn="l">
+              <a:spcBef>
+                <a:spcPts val="0"/>
+              </a:spcBef>
+              <a:spcAft>
+                <a:spcPts val="0"/>
+              </a:spcAft>
+              <a:buNone/>
+            </a:pPr>
+            <a:r>
+              <a:rPr lang="en"/>
+              <a:t>The Whole Game</a:t>
+            </a:r>
+            <a:endParaRPr/>
+          </a:p>
+        </p:txBody>
+      </p:sp>
+      <p:sp>
+        <p:nvSpPr>
+          <p:cNvPr id="3" name="Text Placeholder 2"/>
+          <p:cNvSpPr>
+            <a:spLocks noGrp="1"/>
+          </p:cNvSpPr>
+          <p:nvPr>
+            <p:ph type="body" idx="1"/>
+          </p:nvPr>
+        </p:nvSpPr>
+        <p:spPr>
+          <a:xfrm>
+            <a:off x="311700" y="885950"/>
+            <a:ext cx="8520600" cy="521208"/>
+          </a:xfrm>
+        </p:spPr>
+        <p:txBody>
+          <a:bodyPr/>
+          <a:lstStyle/>
+          <a:p>
+            <a:pPr indent="-330200" lvl="0" marL="457200" rtl="0" algn="l">
+              <a:spcBef>
+                <a:spcPts val="0"/>
+              </a:spcBef>
+              <a:spcAft>
+                <a:spcPts val="0"/>
+              </a:spcAft>
+              <a:buSzPts val="1600"/>
+              <a:buChar char="●"/>
+            </a:pPr>
+            <a:r>
+              <a:rPr lang="en" b="1"/>
+              <a:t>Pong11 is the finished game, and Game1 still runs all of it.</a:t>
+            </a:r>
+            <a:endParaRPr/>
+          </a:p>
+        </p:txBody>
+      </p:sp>
+      <p:sp>
+        <p:nvSpPr>
+          <p:cNvPr id="4" name="Rounded Rectangle 3"/>
+          <p:cNvSpPr/>
+          <p:nvPr/>
+        </p:nvSpPr>
+        <p:spPr>
+          <a:xfrm>
+            <a:off x="3429000" y="1481328"/>
+            <a:ext cx="2286000" cy="777240"/>
+          </a:xfrm>
+          <a:prstGeom prst="roundRect">
+            <a:avLst>
+              <a:gd name="adj" fmla="val 12000"/>
+            </a:avLst>
+          </a:prstGeom>
+          <a:solidFill>
+            <a:srgbClr val="2E3338"/>
+          </a:solidFill>
+          <a:ln w="25400">
+            <a:solidFill>
+              <a:srgbClr val="D45D35"/>
+            </a:solidFill>
+          </a:ln>
+          <a:effectLst/>
+        </p:spPr>
+        <p:style>
+          <a:lnRef idx="1">
+            <a:schemeClr val="accent1"/>
+          </a:lnRef>
+          <a:fillRef idx="3">
+            <a:schemeClr val="accent1"/>
+          </a:fillRef>
+          <a:effectRef idx="2">
+            <a:schemeClr val="accent1"/>
+          </a:effectRef>
+          <a:fontRef idx="minor">
+            <a:schemeClr val="lt1"/>
+          </a:fontRef>
+        </p:style>
+        <p:txBody>
+          <a:bodyPr rtlCol="0" anchor="ctr" wrap="square" lIns="73152" rIns="73152"/>
+          <a:lstStyle/>
+          <a:p>
+            <a:pPr algn="ctr"/>
+            <a:r>
+              <a:rPr sz="1500" b="1">
+                <a:solidFill>
+                  <a:srgbClr val="DEE2E6"/>
+                </a:solidFill>
+              </a:rPr>
+              <a:t>Game1</a:t>
+            </a:r>
+          </a:p>
+          <a:p>
+            <a:pPr algn="ctr"/>
+            <a:r>
+              <a:rPr sz="1300" b="0">
+                <a:solidFill>
+                  <a:srgbClr val="9AA3AB"/>
+                </a:solidFill>
+              </a:rPr>
+              <a:t>mode, scores, sounds, collisions</a:t>
+            </a:r>
+          </a:p>
+        </p:txBody>
+      </p:sp>
+      <p:sp>
+        <p:nvSpPr>
+          <p:cNvPr id="5" name="Rounded Rectangle 4"/>
+          <p:cNvSpPr/>
+          <p:nvPr/>
+        </p:nvSpPr>
+        <p:spPr>
+          <a:xfrm>
+            <a:off x="1303020" y="2807208"/>
+            <a:ext cx="2286000" cy="777240"/>
+          </a:xfrm>
+          <a:prstGeom prst="roundRect">
+            <a:avLst>
+              <a:gd name="adj" fmla="val 12000"/>
+            </a:avLst>
+          </a:prstGeom>
+          <a:solidFill>
+            <a:srgbClr val="2E3338"/>
+          </a:solidFill>
+          <a:ln>
+            <a:noFill/>
+          </a:ln>
+          <a:effectLst/>
+        </p:spPr>
+        <p:style>
+          <a:lnRef idx="1">
+            <a:schemeClr val="accent1"/>
+          </a:lnRef>
+          <a:fillRef idx="3">
+            <a:schemeClr val="accent1"/>
+          </a:fillRef>
+          <a:effectRef idx="2">
+            <a:schemeClr val="accent1"/>
+          </a:effectRef>
+          <a:fontRef idx="minor">
+            <a:schemeClr val="lt1"/>
+          </a:fontRef>
+        </p:style>
+        <p:txBody>
+          <a:bodyPr rtlCol="0" anchor="ctr" wrap="square" lIns="73152" rIns="73152"/>
+          <a:lstStyle/>
+          <a:p>
+            <a:pPr algn="ctr"/>
+            <a:r>
+              <a:rPr sz="1500" b="1">
+                <a:solidFill>
+                  <a:srgbClr val="DEE2E6"/>
+                </a:solidFill>
+              </a:rPr>
+              <a:t>Paddle</a:t>
+            </a:r>
+          </a:p>
+          <a:p>
+            <a:pPr algn="ctr"/>
+            <a:r>
+              <a:rPr sz="1300" b="0">
+                <a:solidFill>
+                  <a:srgbClr val="9AA3AB"/>
+                </a:solidFill>
+              </a:rPr>
+              <a:t>two of them</a:t>
+            </a:r>
+          </a:p>
+        </p:txBody>
+      </p:sp>
+      <p:cxnSp>
+        <p:nvCxnSpPr>
+          <p:cNvPr id="6" name="Connector 5"/>
+          <p:cNvCxnSpPr/>
+          <p:nvPr/>
+        </p:nvCxnSpPr>
+        <p:spPr>
+          <a:xfrm flipH="1">
+            <a:off x="2446020" y="2276856"/>
+            <a:ext cx="2125980" cy="512064"/>
+          </a:xfrm>
+          <a:prstGeom prst="line">
+            <a:avLst/>
+          </a:prstGeom>
+          <a:ln w="25400">
+            <a:solidFill>
+              <a:srgbClr val="9AA3AB"/>
+            </a:solidFill>
+            <a:tailEnd type="triangle"/>
+          </a:ln>
+        </p:spPr>
+        <p:style>
+          <a:lnRef idx="2">
+            <a:schemeClr val="accent1"/>
+          </a:lnRef>
+          <a:fillRef idx="0">
+            <a:schemeClr val="accent1"/>
+          </a:fillRef>
+          <a:effectRef idx="1">
+            <a:schemeClr val="accent1"/>
+          </a:effectRef>
+          <a:fontRef idx="minor">
+            <a:schemeClr val="tx1"/>
+          </a:fontRef>
+        </p:style>
+      </p:cxnSp>
+      <p:sp>
+        <p:nvSpPr>
+          <p:cNvPr id="7" name="Rounded Rectangle 6"/>
+          <p:cNvSpPr/>
+          <p:nvPr/>
+        </p:nvSpPr>
+        <p:spPr>
+          <a:xfrm>
+            <a:off x="5554980" y="2807208"/>
+            <a:ext cx="2286000" cy="777240"/>
+          </a:xfrm>
+          <a:prstGeom prst="roundRect">
+            <a:avLst>
+              <a:gd name="adj" fmla="val 12000"/>
+            </a:avLst>
+          </a:prstGeom>
+          <a:solidFill>
+            <a:srgbClr val="2E3338"/>
+          </a:solidFill>
+          <a:ln>
+            <a:noFill/>
+          </a:ln>
+          <a:effectLst/>
+        </p:spPr>
+        <p:style>
+          <a:lnRef idx="1">
+            <a:schemeClr val="accent1"/>
+          </a:lnRef>
+          <a:fillRef idx="3">
+            <a:schemeClr val="accent1"/>
+          </a:fillRef>
+          <a:effectRef idx="2">
+            <a:schemeClr val="accent1"/>
+          </a:effectRef>
+          <a:fontRef idx="minor">
+            <a:schemeClr val="lt1"/>
+          </a:fontRef>
+        </p:style>
+        <p:txBody>
+          <a:bodyPr rtlCol="0" anchor="ctr" wrap="square" lIns="73152" rIns="73152"/>
+          <a:lstStyle/>
+          <a:p>
+            <a:pPr algn="ctr"/>
+            <a:r>
+              <a:rPr sz="1500" b="1">
+                <a:solidFill>
+                  <a:srgbClr val="DEE2E6"/>
+                </a:solidFill>
+              </a:rPr>
+              <a:t>Ball</a:t>
+            </a:r>
+          </a:p>
+          <a:p>
+            <a:pPr algn="ctr"/>
+            <a:r>
+              <a:rPr sz="1300" b="0">
+                <a:solidFill>
+                  <a:srgbClr val="9AA3AB"/>
+                </a:solidFill>
+              </a:rPr>
+              <a:t>checked against each paddle</a:t>
+            </a:r>
+          </a:p>
+        </p:txBody>
+      </p:sp>
+      <p:cxnSp>
+        <p:nvCxnSpPr>
+          <p:cNvPr id="8" name="Connector 7"/>
+          <p:cNvCxnSpPr/>
+          <p:nvPr/>
+        </p:nvCxnSpPr>
+        <p:spPr>
+          <a:xfrm>
+            <a:off x="4572000" y="2276856"/>
+            <a:ext cx="2125980" cy="512064"/>
+          </a:xfrm>
+          <a:prstGeom prst="line">
+            <a:avLst/>
+          </a:prstGeom>
+          <a:ln w="25400">
+            <a:solidFill>
+              <a:srgbClr val="9AA3AB"/>
+            </a:solidFill>
+            <a:tailEnd type="triangle"/>
+          </a:ln>
+        </p:spPr>
+        <p:style>
+          <a:lnRef idx="2">
+            <a:schemeClr val="accent1"/>
+          </a:lnRef>
+          <a:fillRef idx="0">
+            <a:schemeClr val="accent1"/>
+          </a:fillRef>
+          <a:effectRef idx="1">
+            <a:schemeClr val="accent1"/>
+          </a:effectRef>
+          <a:fontRef idx="minor">
+            <a:schemeClr val="tx1"/>
+          </a:fontRef>
+        </p:style>
+      </p:cxnSp>
+      <p:sp>
+        <p:nvSpPr>
+          <p:cNvPr id="9" name="TextBox 8"/>
+          <p:cNvSpPr txBox="1"/>
+          <p:nvPr/>
+        </p:nvSpPr>
+        <p:spPr>
+          <a:xfrm>
+            <a:off x="457200" y="4462272"/>
+            <a:ext cx="8229600" cy="365760"/>
+          </a:xfrm>
+          <a:prstGeom prst="rect">
+            <a:avLst/>
+          </a:prstGeom>
+          <a:noFill/>
+        </p:spPr>
+        <p:txBody>
+          <a:bodyPr wrap="square">
+            <a:spAutoFit/>
+          </a:bodyPr>
+          <a:lstStyle/>
+          <a:p>
+            <a:pPr algn="ctr"/>
+            <a:r>
+              <a:rPr sz="1300" b="0" i="0">
+                <a:solidFill>
+                  <a:srgbClr val="9AA3AB"/>
+                </a:solidFill>
+              </a:rPr>
+              <a:t>The diagram is small because Game1 is big.</a:t>
+            </a:r>
+          </a:p>
+        </p:txBody>
+      </p:sp>
+    </p:spTree>
+  </p:cSld>
+  <p:clrMapOvr>
+    <a:masterClrMapping/>
+  </p:clrMapOvr>
+</p:sld>
+</file>
+
+<file path=ppt/slides/slide45.xml><?xml version="1.0" encoding="utf-8"?>
+<p:sld xmlns:a="http://schemas.openxmlformats.org/drawingml/2006/main" xmlns:p="http://schemas.openxmlformats.org/presentationml/2006/main" xmlns:r="http://schemas.openxmlformats.org/officeDocument/2006/relationships">
+  <p:cSld>
+    <p:spTree>
+      <p:nvGrpSpPr>
+        <p:cNvPr id="1" name=""/>
+        <p:cNvGrpSpPr/>
+        <p:nvPr/>
+      </p:nvGrpSpPr>
+      <p:grpSpPr/>
+      <p:sp>
+        <p:nvSpPr>
+          <p:cNvPr id="2" name="Title 1"/>
+          <p:cNvSpPr>
+            <a:spLocks noGrp="1"/>
+          </p:cNvSpPr>
+          <p:nvPr>
+            <p:ph type="title"/>
+          </p:nvPr>
+        </p:nvSpPr>
+        <p:spPr/>
+        <p:txBody>
+          <a:bodyPr/>
+          <a:lstStyle/>
+          <a:p>
+            <a:pPr indent="0" lvl="0" marL="0" rtl="0" algn="l">
+              <a:spcBef>
+                <a:spcPts val="0"/>
+              </a:spcBef>
+              <a:spcAft>
+                <a:spcPts val="0"/>
+              </a:spcAft>
+              <a:buNone/>
+            </a:pPr>
+            <a:r>
+              <a:rPr lang="en"/>
+              <a:t>Summary</a:t>
+            </a:r>
+            <a:endParaRPr/>
+          </a:p>
+        </p:txBody>
+      </p:sp>
+      <p:sp>
+        <p:nvSpPr>
+          <p:cNvPr id="3" name="Text Placeholder 2"/>
+          <p:cNvSpPr>
+            <a:spLocks noGrp="1"/>
+          </p:cNvSpPr>
+          <p:nvPr>
+            <p:ph type="body" idx="1"/>
+          </p:nvPr>
+        </p:nvSpPr>
+        <p:spPr>
+          <a:xfrm>
+            <a:off x="311700" y="885950"/>
+            <a:ext cx="8520600" cy="521208"/>
+          </a:xfrm>
+        </p:spPr>
+        <p:txBody>
+          <a:bodyPr/>
+          <a:lstStyle/>
+          <a:p>
+            <a:pPr indent="-330200" lvl="0" marL="457200" rtl="0" algn="l">
+              <a:spcBef>
+                <a:spcPts val="0"/>
+              </a:spcBef>
+              <a:spcAft>
+                <a:spcPts val="0"/>
+              </a:spcAft>
+              <a:buSzPts val="1600"/>
+              <a:buChar char="●"/>
+            </a:pPr>
+            <a:r>
+              <a:rPr lang="en" b="1"/>
+              <a:t>Six concerns, and this session’s answer to each.</a:t>
+            </a:r>
+            <a:endParaRPr/>
+          </a:p>
+        </p:txBody>
+      </p:sp>
+      <p:sp>
+        <p:nvSpPr>
+          <p:cNvPr id="4" name="Rounded Rectangle 3"/>
+          <p:cNvSpPr/>
+          <p:nvPr/>
+        </p:nvSpPr>
+        <p:spPr>
+          <a:xfrm>
+            <a:off x="548640" y="1417320"/>
+            <a:ext cx="2560320" cy="914400"/>
+          </a:xfrm>
+          <a:prstGeom prst="roundRect">
+            <a:avLst>
+              <a:gd name="adj" fmla="val 12000"/>
+            </a:avLst>
+          </a:prstGeom>
+          <a:solidFill>
+            <a:srgbClr val="2E3338"/>
+          </a:solidFill>
+          <a:ln>
+            <a:noFill/>
+          </a:ln>
+          <a:effectLst/>
+        </p:spPr>
+        <p:style>
+          <a:lnRef idx="1">
+            <a:schemeClr val="accent1"/>
+          </a:lnRef>
+          <a:fillRef idx="3">
+            <a:schemeClr val="accent1"/>
+          </a:fillRef>
+          <a:effectRef idx="2">
+            <a:schemeClr val="accent1"/>
+          </a:effectRef>
+          <a:fontRef idx="minor">
+            <a:schemeClr val="lt1"/>
+          </a:fontRef>
+        </p:style>
+        <p:txBody>
+          <a:bodyPr rtlCol="0" anchor="ctr" wrap="square" lIns="73152" rIns="73152"/>
+          <a:lstStyle/>
+          <a:p>
+            <a:pPr algn="ctr"/>
+            <a:r>
+              <a:rPr sz="1500" b="1">
+                <a:solidFill>
+                  <a:srgbClr val="DEE2E6"/>
+                </a:solidFill>
+              </a:rPr>
+              <a:t>What runs every frame</a:t>
+            </a:r>
+          </a:p>
+          <a:p>
+            <a:pPr algn="ctr"/>
+            <a:r>
+              <a:rPr sz="1300" b="0">
+                <a:solidFill>
+                  <a:srgbClr val="9AA3AB"/>
+                </a:solidFill>
+              </a:rPr>
+              <a:t>The game loop: Update, then Draw</a:t>
+            </a:r>
+          </a:p>
+        </p:txBody>
+      </p:sp>
+      <p:sp>
+        <p:nvSpPr>
+          <p:cNvPr id="5" name="Rounded Rectangle 4"/>
+          <p:cNvSpPr/>
+          <p:nvPr/>
+        </p:nvSpPr>
+        <p:spPr>
+          <a:xfrm>
+            <a:off x="3291840" y="1417320"/>
+            <a:ext cx="2560320" cy="914400"/>
+          </a:xfrm>
+          <a:prstGeom prst="roundRect">
+            <a:avLst>
+              <a:gd name="adj" fmla="val 12000"/>
+            </a:avLst>
+          </a:prstGeom>
+          <a:solidFill>
+            <a:srgbClr val="2E3338"/>
+          </a:solidFill>
+          <a:ln>
+            <a:noFill/>
+          </a:ln>
+          <a:effectLst/>
+        </p:spPr>
+        <p:style>
+          <a:lnRef idx="1">
+            <a:schemeClr val="accent1"/>
+          </a:lnRef>
+          <a:fillRef idx="3">
+            <a:schemeClr val="accent1"/>
+          </a:fillRef>
+          <a:effectRef idx="2">
+            <a:schemeClr val="accent1"/>
+          </a:effectRef>
+          <a:fontRef idx="minor">
+            <a:schemeClr val="lt1"/>
+          </a:fontRef>
+        </p:style>
+        <p:txBody>
+          <a:bodyPr rtlCol="0" anchor="ctr" wrap="square" lIns="73152" rIns="73152"/>
+          <a:lstStyle/>
+          <a:p>
+            <a:pPr algn="ctr"/>
+            <a:r>
+              <a:rPr sz="1500" b="1">
+                <a:solidFill>
+                  <a:srgbClr val="DEE2E6"/>
+                </a:solidFill>
+              </a:rPr>
+              <a:t>The same speed at any frame rate</a:t>
+            </a:r>
+          </a:p>
+          <a:p>
+            <a:pPr algn="ctr"/>
+            <a:r>
+              <a:rPr sz="1300" b="0">
+                <a:solidFill>
+                  <a:srgbClr val="9AA3AB"/>
+                </a:solidFill>
+              </a:rPr>
+              <a:t>Movement times delta time</a:t>
+            </a:r>
+          </a:p>
+        </p:txBody>
+      </p:sp>
+      <p:sp>
+        <p:nvSpPr>
+          <p:cNvPr id="6" name="Rounded Rectangle 5"/>
+          <p:cNvSpPr/>
+          <p:nvPr/>
+        </p:nvSpPr>
+        <p:spPr>
+          <a:xfrm>
+            <a:off x="6035040" y="1417320"/>
+            <a:ext cx="2560320" cy="914400"/>
+          </a:xfrm>
+          <a:prstGeom prst="roundRect">
+            <a:avLst>
+              <a:gd name="adj" fmla="val 12000"/>
+            </a:avLst>
+          </a:prstGeom>
+          <a:solidFill>
+            <a:srgbClr val="2E3338"/>
+          </a:solidFill>
+          <a:ln>
+            <a:noFill/>
+          </a:ln>
+          <a:effectLst/>
+        </p:spPr>
+        <p:style>
+          <a:lnRef idx="1">
+            <a:schemeClr val="accent1"/>
+          </a:lnRef>
+          <a:fillRef idx="3">
+            <a:schemeClr val="accent1"/>
+          </a:fillRef>
+          <a:effectRef idx="2">
+            <a:schemeClr val="accent1"/>
+          </a:effectRef>
+          <a:fontRef idx="minor">
+            <a:schemeClr val="lt1"/>
+          </a:fontRef>
+        </p:style>
+        <p:txBody>
+          <a:bodyPr rtlCol="0" anchor="ctr" wrap="square" lIns="73152" rIns="73152"/>
+          <a:lstStyle/>
+          <a:p>
+            <a:pPr algn="ctr"/>
+            <a:r>
+              <a:rPr sz="1500" b="1">
+                <a:solidFill>
+                  <a:srgbClr val="DEE2E6"/>
+                </a:solidFill>
+              </a:rPr>
+              <a:t>Who moves each object</a:t>
+            </a:r>
+          </a:p>
+          <a:p>
+            <a:pPr algn="ctr"/>
+            <a:r>
+              <a:rPr sz="1300" b="0">
+                <a:solidFill>
+                  <a:srgbClr val="9AA3AB"/>
+                </a:solidFill>
+              </a:rPr>
+              <a:t>Its own Update (Update Method)</a:t>
+            </a:r>
+          </a:p>
+        </p:txBody>
+      </p:sp>
+      <p:sp>
+        <p:nvSpPr>
+          <p:cNvPr id="7" name="Rounded Rectangle 6"/>
+          <p:cNvSpPr/>
+          <p:nvPr/>
+        </p:nvSpPr>
+        <p:spPr>
+          <a:xfrm>
+            <a:off x="548640" y="2468880"/>
+            <a:ext cx="2560320" cy="914400"/>
+          </a:xfrm>
+          <a:prstGeom prst="roundRect">
+            <a:avLst>
+              <a:gd name="adj" fmla="val 12000"/>
+            </a:avLst>
+          </a:prstGeom>
+          <a:solidFill>
+            <a:srgbClr val="2E3338"/>
+          </a:solidFill>
+          <a:ln>
+            <a:noFill/>
+          </a:ln>
+          <a:effectLst/>
+        </p:spPr>
+        <p:style>
+          <a:lnRef idx="1">
+            <a:schemeClr val="accent1"/>
+          </a:lnRef>
+          <a:fillRef idx="3">
+            <a:schemeClr val="accent1"/>
+          </a:fillRef>
+          <a:effectRef idx="2">
+            <a:schemeClr val="accent1"/>
+          </a:effectRef>
+          <a:fontRef idx="minor">
+            <a:schemeClr val="lt1"/>
+          </a:fontRef>
+        </p:style>
+        <p:txBody>
+          <a:bodyPr rtlCol="0" anchor="ctr" wrap="square" lIns="73152" rIns="73152"/>
+          <a:lstStyle/>
+          <a:p>
+            <a:pPr algn="ctr"/>
+            <a:r>
+              <a:rPr sz="1500" b="1">
+                <a:solidFill>
+                  <a:srgbClr val="DEE2E6"/>
+                </a:solidFill>
+              </a:rPr>
+              <a:t>Any window size</a:t>
+            </a:r>
+          </a:p>
+          <a:p>
+            <a:pPr algn="ctr"/>
+            <a:r>
+              <a:rPr sz="1300" b="0">
+                <a:solidFill>
+                  <a:srgbClr val="9AA3AB"/>
+                </a:solidFill>
+              </a:rPr>
+              <a:t>A virtual resolution and a matrix</a:t>
+            </a:r>
+          </a:p>
+        </p:txBody>
+      </p:sp>
+      <p:sp>
+        <p:nvSpPr>
+          <p:cNvPr id="8" name="Rounded Rectangle 7"/>
+          <p:cNvSpPr/>
+          <p:nvPr/>
+        </p:nvSpPr>
+        <p:spPr>
+          <a:xfrm>
+            <a:off x="3291840" y="2468880"/>
+            <a:ext cx="2560320" cy="914400"/>
+          </a:xfrm>
+          <a:prstGeom prst="roundRect">
+            <a:avLst>
+              <a:gd name="adj" fmla="val 12000"/>
+            </a:avLst>
+          </a:prstGeom>
+          <a:solidFill>
+            <a:srgbClr val="2E3338"/>
+          </a:solidFill>
+          <a:ln>
+            <a:noFill/>
+          </a:ln>
+          <a:effectLst/>
+        </p:spPr>
+        <p:style>
+          <a:lnRef idx="1">
+            <a:schemeClr val="accent1"/>
+          </a:lnRef>
+          <a:fillRef idx="3">
+            <a:schemeClr val="accent1"/>
+          </a:fillRef>
+          <a:effectRef idx="2">
+            <a:schemeClr val="accent1"/>
+          </a:effectRef>
+          <a:fontRef idx="minor">
+            <a:schemeClr val="lt1"/>
+          </a:fontRef>
+        </p:style>
+        <p:txBody>
+          <a:bodyPr rtlCol="0" anchor="ctr" wrap="square" lIns="73152" rIns="73152"/>
+          <a:lstStyle/>
+          <a:p>
+            <a:pPr algn="ctr"/>
+            <a:r>
+              <a:rPr sz="1500" b="1">
+                <a:solidFill>
+                  <a:srgbClr val="DEE2E6"/>
+                </a:solidFill>
+              </a:rPr>
+              <a:t>Whether two things touch</a:t>
+            </a:r>
+          </a:p>
+          <a:p>
+            <a:pPr algn="ctr"/>
+            <a:r>
+              <a:rPr sz="1300" b="0">
+                <a:solidFill>
+                  <a:srgbClr val="9AA3AB"/>
+                </a:solidFill>
+              </a:rPr>
+              <a:t>AABB</a:t>
+            </a:r>
+          </a:p>
+        </p:txBody>
+      </p:sp>
+      <p:sp>
+        <p:nvSpPr>
+          <p:cNvPr id="9" name="Rounded Rectangle 8"/>
+          <p:cNvSpPr/>
+          <p:nvPr/>
+        </p:nvSpPr>
+        <p:spPr>
+          <a:xfrm>
+            <a:off x="6035040" y="2468880"/>
+            <a:ext cx="2560320" cy="914400"/>
+          </a:xfrm>
+          <a:prstGeom prst="roundRect">
+            <a:avLst>
+              <a:gd name="adj" fmla="val 12000"/>
+            </a:avLst>
+          </a:prstGeom>
+          <a:solidFill>
+            <a:srgbClr val="2E3338"/>
+          </a:solidFill>
+          <a:ln>
+            <a:noFill/>
+          </a:ln>
+          <a:effectLst/>
+        </p:spPr>
+        <p:style>
+          <a:lnRef idx="1">
+            <a:schemeClr val="accent1"/>
+          </a:lnRef>
+          <a:fillRef idx="3">
+            <a:schemeClr val="accent1"/>
+          </a:fillRef>
+          <a:effectRef idx="2">
+            <a:schemeClr val="accent1"/>
+          </a:effectRef>
+          <a:fontRef idx="minor">
+            <a:schemeClr val="lt1"/>
+          </a:fontRef>
+        </p:style>
+        <p:txBody>
+          <a:bodyPr rtlCol="0" anchor="ctr" wrap="square" lIns="73152" rIns="73152"/>
+          <a:lstStyle/>
+          <a:p>
+            <a:pPr algn="ctr"/>
+            <a:r>
+              <a:rPr sz="1500" b="1">
+                <a:solidFill>
+                  <a:srgbClr val="DEE2E6"/>
+                </a:solidFill>
+              </a:rPr>
+              <a:t>Which phase the game is in</a:t>
+            </a:r>
+          </a:p>
+          <a:p>
+            <a:pPr algn="ctr"/>
+            <a:r>
+              <a:rPr sz="1300" b="0">
+                <a:solidFill>
+                  <a:srgbClr val="9AA3AB"/>
+                </a:solidFill>
+              </a:rPr>
+              <a:t>A string field</a:t>
+            </a:r>
+          </a:p>
+        </p:txBody>
+      </p:sp>
+    </p:spTree>
+  </p:cSld>
+  <p:clrMapOvr>
+    <a:masterClrMapping/>
+  </p:clrMapOvr>
+</p:sld>
+</file>
+
 <file path=ppt/slides/slide5.xml><?xml version="1.0" encoding="utf-8"?>
 <p:sld xmlns:a="http://schemas.openxmlformats.org/drawingml/2006/main" xmlns:r="http://schemas.openxmlformats.org/officeDocument/2006/relationships" xmlns:mc="http://schemas.openxmlformats.org/markup-compatibility/2006" xmlns:mv="urn:schemas-microsoft-com:mac:vml" xmlns:p="http://schemas.openxmlformats.org/presentationml/2006/main" xmlns:c="http://schemas.openxmlformats.org/drawingml/2006/chart" xmlns:dgm="http://schemas.openxmlformats.org/drawingml/2006/diagram" xmlns:o="urn:schemas-microsoft-com:office:office" xmlns:v="urn:schemas-microsoft-com:vml" xmlns:pvml="urn:schemas-microsoft-com:office:powerpoint" xmlns:com="http://schemas.openxmlformats.org/drawingml/2006/compatibility" xmlns:p14="http://schemas.microsoft.com/office/powerpoint/2010/main" xmlns:p15="http://schemas.microsoft.com/office/powerpoint/2012/main" xmlns:ahyp="http://schemas.microsoft.com/office/drawing/2018/hyperlinkcolor">
   <p:cSld>

</xml_diff>